<commit_message>
Polish pitch deck closing slide
</commit_message>
<xml_diff>
--- a/presentation/PennyPilot-hackathon-demo.pptx
+++ b/presentation/PennyPilot-hackathon-demo.pptx
@@ -2,17 +2,17 @@
 <file path=ppt/presentation.xml><?xml version="1.0" encoding="utf-8"?>
 <p:presentation xmlns:p="http://schemas.openxmlformats.org/presentationml/2006/main">
   <p:sldMasterIdLst>
-    <p:sldMasterId xmlns:r="http://schemas.openxmlformats.org/officeDocument/2006/relationships" id="2147483648" r:id="Rb0ef2861999e4259"/>
+    <p:sldMasterId xmlns:r="http://schemas.openxmlformats.org/officeDocument/2006/relationships" id="2147483648" r:id="R6b611d477f524f3f"/>
   </p:sldMasterIdLst>
   <p:notesMasterIdLst>
-    <p:notesMasterId xmlns:r="http://schemas.openxmlformats.org/officeDocument/2006/relationships" r:id="R41a1a64b507d41c0"/>
+    <p:notesMasterId xmlns:r="http://schemas.openxmlformats.org/officeDocument/2006/relationships" r:id="R69ebacc371de4037"/>
   </p:notesMasterIdLst>
   <p:sldIdLst>
-    <p:sldId xmlns:r="http://schemas.openxmlformats.org/officeDocument/2006/relationships" id="256" r:id="Rb31b724435f84d95"/>
-    <p:sldId xmlns:r="http://schemas.openxmlformats.org/officeDocument/2006/relationships" id="257" r:id="Re3135fd38074417e"/>
-    <p:sldId xmlns:r="http://schemas.openxmlformats.org/officeDocument/2006/relationships" id="258" r:id="R86cbda029c6348c3"/>
-    <p:sldId xmlns:r="http://schemas.openxmlformats.org/officeDocument/2006/relationships" id="259" r:id="Rc7718cd1b3814db6"/>
-    <p:sldId xmlns:r="http://schemas.openxmlformats.org/officeDocument/2006/relationships" id="260" r:id="R335783d57d184685"/>
+    <p:sldId xmlns:r="http://schemas.openxmlformats.org/officeDocument/2006/relationships" id="256" r:id="Rbc6613c0f31640a6"/>
+    <p:sldId xmlns:r="http://schemas.openxmlformats.org/officeDocument/2006/relationships" id="257" r:id="R86e67b9fa0ed486b"/>
+    <p:sldId xmlns:r="http://schemas.openxmlformats.org/officeDocument/2006/relationships" id="258" r:id="R308d113e2e4c464f"/>
+    <p:sldId xmlns:r="http://schemas.openxmlformats.org/officeDocument/2006/relationships" id="259" r:id="Rf89449b9a7c44257"/>
+    <p:sldId xmlns:r="http://schemas.openxmlformats.org/officeDocument/2006/relationships" id="260" r:id="R9f35ede8751b42f9"/>
   </p:sldIdLst>
   <p:sldSz cx="18288000" cy="10287000"/>
   <p:notesSz cx="6858000" cy="9144000"/>
@@ -823,7 +823,7 @@
   </p:cSld>
   <p:clrMap bg1="lt1" tx1="dk1" bg2="lt2" tx2="dk2" accent1="accent1" accent2="accent2" accent3="accent3" accent4="accent4" accent5="accent5" accent6="accent6" hlink="hlink" folHlink="folHlink"/>
   <p:sldLayoutIdLst>
-    <p:sldLayoutId xmlns:r="http://schemas.openxmlformats.org/officeDocument/2006/relationships" id="2147483649" r:id="R847442f15fe54478"/>
+    <p:sldLayoutId xmlns:r="http://schemas.openxmlformats.org/officeDocument/2006/relationships" id="2147483649" r:id="R0314ffc89eb9494a"/>
   </p:sldLayoutIdLst>
   <p:txStyles>
     <p:titleStyle>
@@ -1122,7 +1122,7 @@
           <p:cNvPr id="1" name="slide-background">
             <a:extLst xmlns:a="http://schemas.openxmlformats.org/drawingml/2006/main">
               <a:ext uri="{FF2B5EF4-FFF2-40B4-BE49-F238E27FC236}">
-                <a16:creationId xmlns:a16="http://schemas.microsoft.com/office/drawing/2014/main" id="{D5EE4A25-BD08-4478-A5F2-93641AF5D870}"/>
+                <a16:creationId xmlns:a16="http://schemas.microsoft.com/office/drawing/2014/main" id="{9130F13F-6111-45E3-B02E-5B9B787B46B0}"/>
               </a:ext>
             </a:extLst>
           </p:cNvPr>
@@ -1155,7 +1155,7 @@
           <p:cNvPr id="2" name="header-spacer">
             <a:extLst xmlns:a="http://schemas.openxmlformats.org/drawingml/2006/main">
               <a:ext uri="{FF2B5EF4-FFF2-40B4-BE49-F238E27FC236}">
-                <a16:creationId xmlns:a16="http://schemas.microsoft.com/office/drawing/2014/main" id="{796E9249-FF5F-4917-91BF-C21EE2569A76}"/>
+                <a16:creationId xmlns:a16="http://schemas.microsoft.com/office/drawing/2014/main" id="{8045C59B-DA73-4487-BBA5-01CB8A7E95A0}"/>
               </a:ext>
             </a:extLst>
           </p:cNvPr>
@@ -1188,7 +1188,7 @@
           <p:cNvPr id="3" name="cover-kicker">
             <a:extLst xmlns:a="http://schemas.openxmlformats.org/drawingml/2006/main">
               <a:ext uri="{FF2B5EF4-FFF2-40B4-BE49-F238E27FC236}">
-                <a16:creationId xmlns:a16="http://schemas.microsoft.com/office/drawing/2014/main" id="{BABCAAB4-1864-4B8E-911B-3BF92229DDB4}"/>
+                <a16:creationId xmlns:a16="http://schemas.microsoft.com/office/drawing/2014/main" id="{6337170E-3001-4687-8995-61A5A124B5B1}"/>
               </a:ext>
             </a:extLst>
           </p:cNvPr>
@@ -1233,7 +1233,7 @@
           <p:cNvPr id="4" name="cover-title">
             <a:extLst xmlns:a="http://schemas.openxmlformats.org/drawingml/2006/main">
               <a:ext uri="{FF2B5EF4-FFF2-40B4-BE49-F238E27FC236}">
-                <a16:creationId xmlns:a16="http://schemas.microsoft.com/office/drawing/2014/main" id="{A46596C4-A2C9-4863-9180-C24AD3D61759}"/>
+                <a16:creationId xmlns:a16="http://schemas.microsoft.com/office/drawing/2014/main" id="{9FE69D91-0BC0-4503-AFC0-F9B919D55AFB}"/>
               </a:ext>
             </a:extLst>
           </p:cNvPr>
@@ -1278,7 +1278,7 @@
           <p:cNvPr id="5" name="cover-subtitle">
             <a:extLst xmlns:a="http://schemas.openxmlformats.org/drawingml/2006/main">
               <a:ext uri="{FF2B5EF4-FFF2-40B4-BE49-F238E27FC236}">
-                <a16:creationId xmlns:a16="http://schemas.microsoft.com/office/drawing/2014/main" id="{14331B68-C3F4-400A-A87C-B3D25B0866D7}"/>
+                <a16:creationId xmlns:a16="http://schemas.microsoft.com/office/drawing/2014/main" id="{F8FD7AE0-2000-4C11-9D7D-6BA1615EEA3E}"/>
               </a:ext>
             </a:extLst>
           </p:cNvPr>
@@ -1323,7 +1323,7 @@
           <p:cNvPr id="6" name="badge-Gateway x402">
             <a:extLst xmlns:a="http://schemas.openxmlformats.org/drawingml/2006/main">
               <a:ext uri="{FF2B5EF4-FFF2-40B4-BE49-F238E27FC236}">
-                <a16:creationId xmlns:a16="http://schemas.microsoft.com/office/drawing/2014/main" id="{69E2680B-E37D-46BF-B79E-4622EFE3811A}"/>
+                <a16:creationId xmlns:a16="http://schemas.microsoft.com/office/drawing/2014/main" id="{CA935996-9FD7-4F54-BF3B-F0D6AAD383D8}"/>
               </a:ext>
             </a:extLst>
           </p:cNvPr>
@@ -1358,7 +1358,7 @@
           <p:cNvPr id="7" name="">
             <a:extLst xmlns:a="http://schemas.openxmlformats.org/drawingml/2006/main">
               <a:ext uri="{FF2B5EF4-FFF2-40B4-BE49-F238E27FC236}">
-                <a16:creationId xmlns:a16="http://schemas.microsoft.com/office/drawing/2014/main" id="{1255F724-2D05-43BD-A237-C6BBCC61D245}"/>
+                <a16:creationId xmlns:a16="http://schemas.microsoft.com/office/drawing/2014/main" id="{6B6755A4-F61E-470A-B7DE-3EA221630D6A}"/>
               </a:ext>
             </a:extLst>
           </p:cNvPr>
@@ -1391,7 +1391,7 @@
           <p:cNvPr id="8" name="badge-text-Gateway x402">
             <a:extLst xmlns:a="http://schemas.openxmlformats.org/drawingml/2006/main">
               <a:ext uri="{FF2B5EF4-FFF2-40B4-BE49-F238E27FC236}">
-                <a16:creationId xmlns:a16="http://schemas.microsoft.com/office/drawing/2014/main" id="{1BF30925-8422-421C-88C6-D05883E38D6A}"/>
+                <a16:creationId xmlns:a16="http://schemas.microsoft.com/office/drawing/2014/main" id="{F6B477B3-6679-4563-BEF5-FC617D419A95}"/>
               </a:ext>
             </a:extLst>
           </p:cNvPr>
@@ -1436,7 +1436,7 @@
           <p:cNvPr id="9" name="badge-Arc receipts">
             <a:extLst xmlns:a="http://schemas.openxmlformats.org/drawingml/2006/main">
               <a:ext uri="{FF2B5EF4-FFF2-40B4-BE49-F238E27FC236}">
-                <a16:creationId xmlns:a16="http://schemas.microsoft.com/office/drawing/2014/main" id="{C263D0D2-91F6-408E-8E45-E7D8166BE6C2}"/>
+                <a16:creationId xmlns:a16="http://schemas.microsoft.com/office/drawing/2014/main" id="{D7D93F21-C96E-4161-97B8-5BF89A7607B8}"/>
               </a:ext>
             </a:extLst>
           </p:cNvPr>
@@ -1471,7 +1471,7 @@
           <p:cNvPr id="10" name="">
             <a:extLst xmlns:a="http://schemas.openxmlformats.org/drawingml/2006/main">
               <a:ext uri="{FF2B5EF4-FFF2-40B4-BE49-F238E27FC236}">
-                <a16:creationId xmlns:a16="http://schemas.microsoft.com/office/drawing/2014/main" id="{356814B4-5DA6-4AEA-8254-9821A77EE9C6}"/>
+                <a16:creationId xmlns:a16="http://schemas.microsoft.com/office/drawing/2014/main" id="{86699E71-75B8-4CE0-8F31-E96DE476FB5C}"/>
               </a:ext>
             </a:extLst>
           </p:cNvPr>
@@ -1504,7 +1504,7 @@
           <p:cNvPr id="11" name="badge-text-Arc receipts">
             <a:extLst xmlns:a="http://schemas.openxmlformats.org/drawingml/2006/main">
               <a:ext uri="{FF2B5EF4-FFF2-40B4-BE49-F238E27FC236}">
-                <a16:creationId xmlns:a16="http://schemas.microsoft.com/office/drawing/2014/main" id="{F456341F-4F07-4F94-84D8-942BD2532643}"/>
+                <a16:creationId xmlns:a16="http://schemas.microsoft.com/office/drawing/2014/main" id="{62C19C5C-A18B-4CA0-99F0-0E5A7AF1F5A7}"/>
               </a:ext>
             </a:extLst>
           </p:cNvPr>
@@ -1549,7 +1549,7 @@
           <p:cNvPr id="12" name="badge-50 tx proof">
             <a:extLst xmlns:a="http://schemas.openxmlformats.org/drawingml/2006/main">
               <a:ext uri="{FF2B5EF4-FFF2-40B4-BE49-F238E27FC236}">
-                <a16:creationId xmlns:a16="http://schemas.microsoft.com/office/drawing/2014/main" id="{7010B6E4-4E95-4B38-9CD9-B53D3F1600BA}"/>
+                <a16:creationId xmlns:a16="http://schemas.microsoft.com/office/drawing/2014/main" id="{0EF5B8E5-924C-48EE-AECA-4116A451F701}"/>
               </a:ext>
             </a:extLst>
           </p:cNvPr>
@@ -1584,7 +1584,7 @@
           <p:cNvPr id="13" name="">
             <a:extLst xmlns:a="http://schemas.openxmlformats.org/drawingml/2006/main">
               <a:ext uri="{FF2B5EF4-FFF2-40B4-BE49-F238E27FC236}">
-                <a16:creationId xmlns:a16="http://schemas.microsoft.com/office/drawing/2014/main" id="{30DDCCD2-C440-43F9-A0AF-5649AF3847D6}"/>
+                <a16:creationId xmlns:a16="http://schemas.microsoft.com/office/drawing/2014/main" id="{AA1B77CE-E09B-4EE2-95A3-045A80A33E47}"/>
               </a:ext>
             </a:extLst>
           </p:cNvPr>
@@ -1617,7 +1617,7 @@
           <p:cNvPr id="14" name="badge-text-50 tx proof">
             <a:extLst xmlns:a="http://schemas.openxmlformats.org/drawingml/2006/main">
               <a:ext uri="{FF2B5EF4-FFF2-40B4-BE49-F238E27FC236}">
-                <a16:creationId xmlns:a16="http://schemas.microsoft.com/office/drawing/2014/main" id="{CC7FFC4B-6F96-487D-AB20-AE6E3AED8013}"/>
+                <a16:creationId xmlns:a16="http://schemas.microsoft.com/office/drawing/2014/main" id="{CB9799D6-7A00-4E9B-ADB1-C5BCB6A175AC}"/>
               </a:ext>
             </a:extLst>
           </p:cNvPr>
@@ -1662,7 +1662,7 @@
           <p:cNvPr id="15" name="cover-evidence-field">
             <a:extLst xmlns:a="http://schemas.openxmlformats.org/drawingml/2006/main">
               <a:ext uri="{FF2B5EF4-FFF2-40B4-BE49-F238E27FC236}">
-                <a16:creationId xmlns:a16="http://schemas.microsoft.com/office/drawing/2014/main" id="{9DF4F117-268A-4933-8621-D73751BC89F2}"/>
+                <a16:creationId xmlns:a16="http://schemas.microsoft.com/office/drawing/2014/main" id="{5B48D9F6-3005-477E-A583-D549BFD31998}"/>
               </a:ext>
             </a:extLst>
           </p:cNvPr>
@@ -1697,7 +1697,7 @@
           <p:cNvPr id="16" name="cover-number">
             <a:extLst xmlns:a="http://schemas.openxmlformats.org/drawingml/2006/main">
               <a:ext uri="{FF2B5EF4-FFF2-40B4-BE49-F238E27FC236}">
-                <a16:creationId xmlns:a16="http://schemas.microsoft.com/office/drawing/2014/main" id="{CB2C78A2-8206-47E4-9001-874F6FB663BE}"/>
+                <a16:creationId xmlns:a16="http://schemas.microsoft.com/office/drawing/2014/main" id="{AD55159E-5E0D-47D1-B5E6-C8F3D5E51B7C}"/>
               </a:ext>
             </a:extLst>
           </p:cNvPr>
@@ -1742,7 +1742,7 @@
           <p:cNvPr id="17" name="cover-number-label">
             <a:extLst xmlns:a="http://schemas.openxmlformats.org/drawingml/2006/main">
               <a:ext uri="{FF2B5EF4-FFF2-40B4-BE49-F238E27FC236}">
-                <a16:creationId xmlns:a16="http://schemas.microsoft.com/office/drawing/2014/main" id="{42717B62-AD81-4C8C-80AE-6323051B5530}"/>
+                <a16:creationId xmlns:a16="http://schemas.microsoft.com/office/drawing/2014/main" id="{EE1692E1-204B-4C3D-9450-9A7C653FB72F}"/>
               </a:ext>
             </a:extLst>
           </p:cNvPr>
@@ -1787,7 +1787,7 @@
           <p:cNvPr id="18" name="">
             <a:extLst xmlns:a="http://schemas.openxmlformats.org/drawingml/2006/main">
               <a:ext uri="{FF2B5EF4-FFF2-40B4-BE49-F238E27FC236}">
-                <a16:creationId xmlns:a16="http://schemas.microsoft.com/office/drawing/2014/main" id="{8A614D74-1166-4A98-AED5-91E415AFF8B5}"/>
+                <a16:creationId xmlns:a16="http://schemas.microsoft.com/office/drawing/2014/main" id="{DB92CC2C-29B8-4022-8991-203ACC8D84C2}"/>
               </a:ext>
             </a:extLst>
           </p:cNvPr>
@@ -1820,7 +1820,7 @@
           <p:cNvPr id="19" name="dark-metric-value-task budget">
             <a:extLst xmlns:a="http://schemas.openxmlformats.org/drawingml/2006/main">
               <a:ext uri="{FF2B5EF4-FFF2-40B4-BE49-F238E27FC236}">
-                <a16:creationId xmlns:a16="http://schemas.microsoft.com/office/drawing/2014/main" id="{9CCFDADD-CCEB-410B-9C73-0B0BCF966E1C}"/>
+                <a16:creationId xmlns:a16="http://schemas.microsoft.com/office/drawing/2014/main" id="{67A73B31-8CA7-4284-A95F-3FF0B356B611}"/>
               </a:ext>
             </a:extLst>
           </p:cNvPr>
@@ -1865,7 +1865,7 @@
           <p:cNvPr id="20" name="dark-metric-label-task budget">
             <a:extLst xmlns:a="http://schemas.openxmlformats.org/drawingml/2006/main">
               <a:ext uri="{FF2B5EF4-FFF2-40B4-BE49-F238E27FC236}">
-                <a16:creationId xmlns:a16="http://schemas.microsoft.com/office/drawing/2014/main" id="{89C1EF78-5371-4A56-9CF7-1BC9FB144B96}"/>
+                <a16:creationId xmlns:a16="http://schemas.microsoft.com/office/drawing/2014/main" id="{6F103B59-8178-44AB-9003-39DE2C2D64AE}"/>
               </a:ext>
             </a:extLst>
           </p:cNvPr>
@@ -1910,7 +1910,7 @@
           <p:cNvPr id="21" name="">
             <a:extLst xmlns:a="http://schemas.openxmlformats.org/drawingml/2006/main">
               <a:ext uri="{FF2B5EF4-FFF2-40B4-BE49-F238E27FC236}">
-                <a16:creationId xmlns:a16="http://schemas.microsoft.com/office/drawing/2014/main" id="{6456CD6B-4AB0-47AC-8FF4-0FD072F44F82}"/>
+                <a16:creationId xmlns:a16="http://schemas.microsoft.com/office/drawing/2014/main" id="{40D98F2D-D6B5-43C3-9B43-F0F28ED5124B}"/>
               </a:ext>
             </a:extLst>
           </p:cNvPr>
@@ -1943,7 +1943,7 @@
           <p:cNvPr id="22" name="dark-metric-value-max per call">
             <a:extLst xmlns:a="http://schemas.openxmlformats.org/drawingml/2006/main">
               <a:ext uri="{FF2B5EF4-FFF2-40B4-BE49-F238E27FC236}">
-                <a16:creationId xmlns:a16="http://schemas.microsoft.com/office/drawing/2014/main" id="{CAB213A0-D4D8-4978-9AFF-65F9AD3EFF52}"/>
+                <a16:creationId xmlns:a16="http://schemas.microsoft.com/office/drawing/2014/main" id="{AE69660B-D538-4632-94E1-BEE3694C62E8}"/>
               </a:ext>
             </a:extLst>
           </p:cNvPr>
@@ -1988,7 +1988,7 @@
           <p:cNvPr id="23" name="dark-metric-label-max per call">
             <a:extLst xmlns:a="http://schemas.openxmlformats.org/drawingml/2006/main">
               <a:ext uri="{FF2B5EF4-FFF2-40B4-BE49-F238E27FC236}">
-                <a16:creationId xmlns:a16="http://schemas.microsoft.com/office/drawing/2014/main" id="{B6E15216-BDD7-4BAB-9DC5-7FCAD58BE2E7}"/>
+                <a16:creationId xmlns:a16="http://schemas.microsoft.com/office/drawing/2014/main" id="{7813FEAE-547D-47FE-9A23-DF22559CDF2E}"/>
               </a:ext>
             </a:extLst>
           </p:cNvPr>
@@ -2033,7 +2033,7 @@
           <p:cNvPr id="24" name="">
             <a:extLst xmlns:a="http://schemas.openxmlformats.org/drawingml/2006/main">
               <a:ext uri="{FF2B5EF4-FFF2-40B4-BE49-F238E27FC236}">
-                <a16:creationId xmlns:a16="http://schemas.microsoft.com/office/drawing/2014/main" id="{A3266E4C-13AD-4A09-A184-6E482DF04B95}"/>
+                <a16:creationId xmlns:a16="http://schemas.microsoft.com/office/drawing/2014/main" id="{A24A276D-9F7B-4ACF-8110-893E20AAE92C}"/>
               </a:ext>
             </a:extLst>
           </p:cNvPr>
@@ -2066,7 +2066,7 @@
           <p:cNvPr id="25" name="dark-metric-value-receipt tx">
             <a:extLst xmlns:a="http://schemas.openxmlformats.org/drawingml/2006/main">
               <a:ext uri="{FF2B5EF4-FFF2-40B4-BE49-F238E27FC236}">
-                <a16:creationId xmlns:a16="http://schemas.microsoft.com/office/drawing/2014/main" id="{BF337915-42C1-459B-915B-55614E5BCFDE}"/>
+                <a16:creationId xmlns:a16="http://schemas.microsoft.com/office/drawing/2014/main" id="{081BB2FB-4C94-47C7-BE75-B6284D82AB73}"/>
               </a:ext>
             </a:extLst>
           </p:cNvPr>
@@ -2111,7 +2111,7 @@
           <p:cNvPr id="26" name="dark-metric-label-receipt tx">
             <a:extLst xmlns:a="http://schemas.openxmlformats.org/drawingml/2006/main">
               <a:ext uri="{FF2B5EF4-FFF2-40B4-BE49-F238E27FC236}">
-                <a16:creationId xmlns:a16="http://schemas.microsoft.com/office/drawing/2014/main" id="{9CFD3BBD-000E-4532-94DF-D8545BB572A6}"/>
+                <a16:creationId xmlns:a16="http://schemas.microsoft.com/office/drawing/2014/main" id="{5035A975-D72E-4053-8977-331C6AA770B8}"/>
               </a:ext>
             </a:extLst>
           </p:cNvPr>
@@ -2156,7 +2156,7 @@
           <p:cNvPr id="27" name="cover-app-url">
             <a:extLst xmlns:a="http://schemas.openxmlformats.org/drawingml/2006/main">
               <a:ext uri="{FF2B5EF4-FFF2-40B4-BE49-F238E27FC236}">
-                <a16:creationId xmlns:a16="http://schemas.microsoft.com/office/drawing/2014/main" id="{AD7ADCD5-CC21-4727-A5F8-7611FF4CF98D}"/>
+                <a16:creationId xmlns:a16="http://schemas.microsoft.com/office/drawing/2014/main" id="{63BCF189-3B6B-4EF8-B799-F868B1818F3F}"/>
               </a:ext>
             </a:extLst>
           </p:cNvPr>
@@ -2201,7 +2201,7 @@
           <p:cNvPr id="28" name="cover-contract">
             <a:extLst xmlns:a="http://schemas.openxmlformats.org/drawingml/2006/main">
               <a:ext uri="{FF2B5EF4-FFF2-40B4-BE49-F238E27FC236}">
-                <a16:creationId xmlns:a16="http://schemas.microsoft.com/office/drawing/2014/main" id="{BF07E084-9983-4FF0-8DA0-E81E20211C6C}"/>
+                <a16:creationId xmlns:a16="http://schemas.microsoft.com/office/drawing/2014/main" id="{5B96493E-AFB6-4CD8-97C0-57D1901C3BCF}"/>
               </a:ext>
             </a:extLst>
           </p:cNvPr>
@@ -2246,7 +2246,7 @@
           <p:cNvPr id="29" name="footer-left">
             <a:extLst xmlns:a="http://schemas.openxmlformats.org/drawingml/2006/main">
               <a:ext uri="{FF2B5EF4-FFF2-40B4-BE49-F238E27FC236}">
-                <a16:creationId xmlns:a16="http://schemas.microsoft.com/office/drawing/2014/main" id="{A1C8888C-6387-4F04-B981-9AAF2BBF1AC6}"/>
+                <a16:creationId xmlns:a16="http://schemas.microsoft.com/office/drawing/2014/main" id="{73E5C19C-B45C-4EB6-8949-C52FC2F21800}"/>
               </a:ext>
             </a:extLst>
           </p:cNvPr>
@@ -2291,7 +2291,7 @@
           <p:cNvPr id="30" name="footer-right">
             <a:extLst xmlns:a="http://schemas.openxmlformats.org/drawingml/2006/main">
               <a:ext uri="{FF2B5EF4-FFF2-40B4-BE49-F238E27FC236}">
-                <a16:creationId xmlns:a16="http://schemas.microsoft.com/office/drawing/2014/main" id="{317F09E9-E31C-4387-9E17-4271964EAA4C}"/>
+                <a16:creationId xmlns:a16="http://schemas.microsoft.com/office/drawing/2014/main" id="{A889A74D-C7A9-4DB4-A002-A7AAAE2B3B39}"/>
               </a:ext>
             </a:extLst>
           </p:cNvPr>
@@ -2334,7 +2334,7 @@
     </p:spTree>
     <p:extLst>
       <p:ext uri="{BB962C8B-B14F-4D97-AF65-F5344CB8AC3E}">
-        <p14:creationId xmlns:p14="http://schemas.microsoft.com/office/powerpoint/2010/main" val="1602726096"/>
+        <p14:creationId xmlns:p14="http://schemas.microsoft.com/office/powerpoint/2010/main" val="1013834501"/>
       </p:ext>
     </p:extLst>
   </p:cSld>
@@ -2358,7 +2358,7 @@
           <p:cNvPr id="1" name="slide-background">
             <a:extLst xmlns:a="http://schemas.openxmlformats.org/drawingml/2006/main">
               <a:ext uri="{FF2B5EF4-FFF2-40B4-BE49-F238E27FC236}">
-                <a16:creationId xmlns:a16="http://schemas.microsoft.com/office/drawing/2014/main" id="{258503BD-31B8-4BCA-8C14-6F3494805278}"/>
+                <a16:creationId xmlns:a16="http://schemas.microsoft.com/office/drawing/2014/main" id="{ABD5C74E-5D02-4230-885D-DC3433C695A7}"/>
               </a:ext>
             </a:extLst>
           </p:cNvPr>
@@ -2391,7 +2391,7 @@
           <p:cNvPr id="2" name="kicker">
             <a:extLst xmlns:a="http://schemas.openxmlformats.org/drawingml/2006/main">
               <a:ext uri="{FF2B5EF4-FFF2-40B4-BE49-F238E27FC236}">
-                <a16:creationId xmlns:a16="http://schemas.microsoft.com/office/drawing/2014/main" id="{D2437046-56E4-4690-8370-1DF6EEA0AAB9}"/>
+                <a16:creationId xmlns:a16="http://schemas.microsoft.com/office/drawing/2014/main" id="{ED39CD7E-B065-4067-AC69-426B856618E5}"/>
               </a:ext>
             </a:extLst>
           </p:cNvPr>
@@ -2436,7 +2436,7 @@
           <p:cNvPr id="3" name="slide-title">
             <a:extLst xmlns:a="http://schemas.openxmlformats.org/drawingml/2006/main">
               <a:ext uri="{FF2B5EF4-FFF2-40B4-BE49-F238E27FC236}">
-                <a16:creationId xmlns:a16="http://schemas.microsoft.com/office/drawing/2014/main" id="{1F4367F5-6307-41EC-B43C-5716C5A32304}"/>
+                <a16:creationId xmlns:a16="http://schemas.microsoft.com/office/drawing/2014/main" id="{6E046A58-644C-43B8-ADC3-C4CEB0C53DF4}"/>
               </a:ext>
             </a:extLst>
           </p:cNvPr>
@@ -2481,7 +2481,7 @@
           <p:cNvPr id="4" name="slide-subtitle">
             <a:extLst xmlns:a="http://schemas.openxmlformats.org/drawingml/2006/main">
               <a:ext uri="{FF2B5EF4-FFF2-40B4-BE49-F238E27FC236}">
-                <a16:creationId xmlns:a16="http://schemas.microsoft.com/office/drawing/2014/main" id="{44BFFA00-331D-4FC3-B423-4D30020F377A}"/>
+                <a16:creationId xmlns:a16="http://schemas.microsoft.com/office/drawing/2014/main" id="{144139B4-D4F7-4CF1-81EA-90C148BE6178}"/>
               </a:ext>
             </a:extLst>
           </p:cNvPr>
@@ -2526,7 +2526,7 @@
           <p:cNvPr id="5" name="problem-claim">
             <a:extLst xmlns:a="http://schemas.openxmlformats.org/drawingml/2006/main">
               <a:ext uri="{FF2B5EF4-FFF2-40B4-BE49-F238E27FC236}">
-                <a16:creationId xmlns:a16="http://schemas.microsoft.com/office/drawing/2014/main" id="{CA4ACE35-1129-433E-98C0-ECD0F436F782}"/>
+                <a16:creationId xmlns:a16="http://schemas.microsoft.com/office/drawing/2014/main" id="{EB94F80D-CFE3-4192-B121-5EBDAD344DDA}"/>
               </a:ext>
             </a:extLst>
           </p:cNvPr>
@@ -2571,7 +2571,7 @@
           <p:cNvPr id="6" name="problem-copy">
             <a:extLst xmlns:a="http://schemas.openxmlformats.org/drawingml/2006/main">
               <a:ext uri="{FF2B5EF4-FFF2-40B4-BE49-F238E27FC236}">
-                <a16:creationId xmlns:a16="http://schemas.microsoft.com/office/drawing/2014/main" id="{600E3FCF-02B0-43B4-BE48-C16C11A6E4CA}"/>
+                <a16:creationId xmlns:a16="http://schemas.microsoft.com/office/drawing/2014/main" id="{5D2CB6C5-ABE5-4CDC-8A18-7FE4D7B1B14D}"/>
               </a:ext>
             </a:extLst>
           </p:cNvPr>
@@ -2616,7 +2616,7 @@
           <p:cNvPr id="7" name="accent-rule">
             <a:extLst xmlns:a="http://schemas.openxmlformats.org/drawingml/2006/main">
               <a:ext uri="{FF2B5EF4-FFF2-40B4-BE49-F238E27FC236}">
-                <a16:creationId xmlns:a16="http://schemas.microsoft.com/office/drawing/2014/main" id="{4E4F8075-9694-4B2B-B693-804351E92359}"/>
+                <a16:creationId xmlns:a16="http://schemas.microsoft.com/office/drawing/2014/main" id="{486FE44B-183F-4412-8B2E-1AAC1AEC114D}"/>
               </a:ext>
             </a:extLst>
           </p:cNvPr>
@@ -2649,7 +2649,7 @@
           <p:cNvPr id="8" name="statement-title-Too small for cards">
             <a:extLst xmlns:a="http://schemas.openxmlformats.org/drawingml/2006/main">
               <a:ext uri="{FF2B5EF4-FFF2-40B4-BE49-F238E27FC236}">
-                <a16:creationId xmlns:a16="http://schemas.microsoft.com/office/drawing/2014/main" id="{38720F49-49D2-4995-9779-32F76A0ED73D}"/>
+                <a16:creationId xmlns:a16="http://schemas.microsoft.com/office/drawing/2014/main" id="{6A60FD43-CC35-451E-9796-FE2C4DBA7A14}"/>
               </a:ext>
             </a:extLst>
           </p:cNvPr>
@@ -2694,7 +2694,7 @@
           <p:cNvPr id="9" name="statement-body-Too small for cards">
             <a:extLst xmlns:a="http://schemas.openxmlformats.org/drawingml/2006/main">
               <a:ext uri="{FF2B5EF4-FFF2-40B4-BE49-F238E27FC236}">
-                <a16:creationId xmlns:a16="http://schemas.microsoft.com/office/drawing/2014/main" id="{86AC9AD3-FD42-481D-BF6A-B804E3BECDA9}"/>
+                <a16:creationId xmlns:a16="http://schemas.microsoft.com/office/drawing/2014/main" id="{001905C8-34B9-4C4D-97E8-5A2D6DF99800}"/>
               </a:ext>
             </a:extLst>
           </p:cNvPr>
@@ -2739,7 +2739,7 @@
           <p:cNvPr id="10" name="accent-rule">
             <a:extLst xmlns:a="http://schemas.openxmlformats.org/drawingml/2006/main">
               <a:ext uri="{FF2B5EF4-FFF2-40B4-BE49-F238E27FC236}">
-                <a16:creationId xmlns:a16="http://schemas.microsoft.com/office/drawing/2014/main" id="{2218FAD0-7223-41FB-BFE8-FFE1EB91CBB1}"/>
+                <a16:creationId xmlns:a16="http://schemas.microsoft.com/office/drawing/2014/main" id="{2EC3F29A-13B1-4C2F-B371-5CCD77656463}"/>
               </a:ext>
             </a:extLst>
           </p:cNvPr>
@@ -2772,7 +2772,7 @@
           <p:cNvPr id="11" name="statement-title-Too many to approve">
             <a:extLst xmlns:a="http://schemas.openxmlformats.org/drawingml/2006/main">
               <a:ext uri="{FF2B5EF4-FFF2-40B4-BE49-F238E27FC236}">
-                <a16:creationId xmlns:a16="http://schemas.microsoft.com/office/drawing/2014/main" id="{2E761472-F035-4015-9885-BE2E2E248080}"/>
+                <a16:creationId xmlns:a16="http://schemas.microsoft.com/office/drawing/2014/main" id="{04FF9591-E40F-45DF-9484-E6D5111DE80B}"/>
               </a:ext>
             </a:extLst>
           </p:cNvPr>
@@ -2817,7 +2817,7 @@
           <p:cNvPr id="12" name="statement-body-Too many to approve">
             <a:extLst xmlns:a="http://schemas.openxmlformats.org/drawingml/2006/main">
               <a:ext uri="{FF2B5EF4-FFF2-40B4-BE49-F238E27FC236}">
-                <a16:creationId xmlns:a16="http://schemas.microsoft.com/office/drawing/2014/main" id="{62CEEC2E-9A67-4E9A-A394-097D99516A41}"/>
+                <a16:creationId xmlns:a16="http://schemas.microsoft.com/office/drawing/2014/main" id="{7ED7CA44-0598-46D9-8D11-10695824CA69}"/>
               </a:ext>
             </a:extLst>
           </p:cNvPr>
@@ -2862,7 +2862,7 @@
           <p:cNvPr id="13" name="accent-rule">
             <a:extLst xmlns:a="http://schemas.openxmlformats.org/drawingml/2006/main">
               <a:ext uri="{FF2B5EF4-FFF2-40B4-BE49-F238E27FC236}">
-                <a16:creationId xmlns:a16="http://schemas.microsoft.com/office/drawing/2014/main" id="{A4D075C0-7E46-4A63-9AC9-1D43E666CE8A}"/>
+                <a16:creationId xmlns:a16="http://schemas.microsoft.com/office/drawing/2014/main" id="{52CAB053-222D-4D20-922E-1488B551440D}"/>
               </a:ext>
             </a:extLst>
           </p:cNvPr>
@@ -2895,7 +2895,7 @@
           <p:cNvPr id="14" name="statement-title-Too risky without receipts">
             <a:extLst xmlns:a="http://schemas.openxmlformats.org/drawingml/2006/main">
               <a:ext uri="{FF2B5EF4-FFF2-40B4-BE49-F238E27FC236}">
-                <a16:creationId xmlns:a16="http://schemas.microsoft.com/office/drawing/2014/main" id="{E886F64D-82FB-4F01-AF11-C7FC2A43FFF8}"/>
+                <a16:creationId xmlns:a16="http://schemas.microsoft.com/office/drawing/2014/main" id="{1FCFF0DC-1011-421D-8684-83305B6A96B0}"/>
               </a:ext>
             </a:extLst>
           </p:cNvPr>
@@ -2940,7 +2940,7 @@
           <p:cNvPr id="15" name="statement-body-Too risky without receipts">
             <a:extLst xmlns:a="http://schemas.openxmlformats.org/drawingml/2006/main">
               <a:ext uri="{FF2B5EF4-FFF2-40B4-BE49-F238E27FC236}">
-                <a16:creationId xmlns:a16="http://schemas.microsoft.com/office/drawing/2014/main" id="{32CF9281-B011-4398-ABCA-3859144042AE}"/>
+                <a16:creationId xmlns:a16="http://schemas.microsoft.com/office/drawing/2014/main" id="{6A7E5CA1-65AF-4320-AA9B-4F83153CF711}"/>
               </a:ext>
             </a:extLst>
           </p:cNvPr>
@@ -2985,7 +2985,7 @@
           <p:cNvPr id="16" name="footer-left">
             <a:extLst xmlns:a="http://schemas.openxmlformats.org/drawingml/2006/main">
               <a:ext uri="{FF2B5EF4-FFF2-40B4-BE49-F238E27FC236}">
-                <a16:creationId xmlns:a16="http://schemas.microsoft.com/office/drawing/2014/main" id="{1BCB7EED-3369-4B20-99D0-B6723CD01B55}"/>
+                <a16:creationId xmlns:a16="http://schemas.microsoft.com/office/drawing/2014/main" id="{D1D1884E-239A-45DB-AB6A-4DEA1FDA1AB1}"/>
               </a:ext>
             </a:extLst>
           </p:cNvPr>
@@ -3030,7 +3030,7 @@
           <p:cNvPr id="17" name="footer-right">
             <a:extLst xmlns:a="http://schemas.openxmlformats.org/drawingml/2006/main">
               <a:ext uri="{FF2B5EF4-FFF2-40B4-BE49-F238E27FC236}">
-                <a16:creationId xmlns:a16="http://schemas.microsoft.com/office/drawing/2014/main" id="{7BF0BE58-A82C-43C8-BBDC-C8B32B276835}"/>
+                <a16:creationId xmlns:a16="http://schemas.microsoft.com/office/drawing/2014/main" id="{CF294470-F43E-42D5-A8CE-82D89A2D03E9}"/>
               </a:ext>
             </a:extLst>
           </p:cNvPr>
@@ -3073,7 +3073,7 @@
     </p:spTree>
     <p:extLst>
       <p:ext uri="{BB962C8B-B14F-4D97-AF65-F5344CB8AC3E}">
-        <p14:creationId xmlns:p14="http://schemas.microsoft.com/office/powerpoint/2010/main" val="477687358"/>
+        <p14:creationId xmlns:p14="http://schemas.microsoft.com/office/powerpoint/2010/main" val="1076196968"/>
       </p:ext>
     </p:extLst>
   </p:cSld>
@@ -3097,7 +3097,7 @@
           <p:cNvPr id="1" name="slide-background">
             <a:extLst xmlns:a="http://schemas.openxmlformats.org/drawingml/2006/main">
               <a:ext uri="{FF2B5EF4-FFF2-40B4-BE49-F238E27FC236}">
-                <a16:creationId xmlns:a16="http://schemas.microsoft.com/office/drawing/2014/main" id="{D76E5931-14B3-4866-9F5A-5F314EBF21BE}"/>
+                <a16:creationId xmlns:a16="http://schemas.microsoft.com/office/drawing/2014/main" id="{3CA5731E-1DF3-46FB-9E4B-58F340B2602F}"/>
               </a:ext>
             </a:extLst>
           </p:cNvPr>
@@ -3130,7 +3130,7 @@
           <p:cNvPr id="2" name="kicker">
             <a:extLst xmlns:a="http://schemas.openxmlformats.org/drawingml/2006/main">
               <a:ext uri="{FF2B5EF4-FFF2-40B4-BE49-F238E27FC236}">
-                <a16:creationId xmlns:a16="http://schemas.microsoft.com/office/drawing/2014/main" id="{02D2F525-770E-4FEC-80A2-C186365D716F}"/>
+                <a16:creationId xmlns:a16="http://schemas.microsoft.com/office/drawing/2014/main" id="{33DB6C8E-36BB-48C2-8470-67D818C02C13}"/>
               </a:ext>
             </a:extLst>
           </p:cNvPr>
@@ -3175,7 +3175,7 @@
           <p:cNvPr id="3" name="slide-title">
             <a:extLst xmlns:a="http://schemas.openxmlformats.org/drawingml/2006/main">
               <a:ext uri="{FF2B5EF4-FFF2-40B4-BE49-F238E27FC236}">
-                <a16:creationId xmlns:a16="http://schemas.microsoft.com/office/drawing/2014/main" id="{E83CDA9B-0932-4817-81E9-595A035DDBA1}"/>
+                <a16:creationId xmlns:a16="http://schemas.microsoft.com/office/drawing/2014/main" id="{555E4FE3-60D2-4E20-A488-C4E7F156EAF3}"/>
               </a:ext>
             </a:extLst>
           </p:cNvPr>
@@ -3220,7 +3220,7 @@
           <p:cNvPr id="4" name="slide-subtitle">
             <a:extLst xmlns:a="http://schemas.openxmlformats.org/drawingml/2006/main">
               <a:ext uri="{FF2B5EF4-FFF2-40B4-BE49-F238E27FC236}">
-                <a16:creationId xmlns:a16="http://schemas.microsoft.com/office/drawing/2014/main" id="{2273F21E-79C2-4FB1-9396-713659707461}"/>
+                <a16:creationId xmlns:a16="http://schemas.microsoft.com/office/drawing/2014/main" id="{F341CC19-52DB-4D48-8174-E37CEBF6ED55}"/>
               </a:ext>
             </a:extLst>
           </p:cNvPr>
@@ -3265,7 +3265,7 @@
           <p:cNvPr id="5" name="solution-claim">
             <a:extLst xmlns:a="http://schemas.openxmlformats.org/drawingml/2006/main">
               <a:ext uri="{FF2B5EF4-FFF2-40B4-BE49-F238E27FC236}">
-                <a16:creationId xmlns:a16="http://schemas.microsoft.com/office/drawing/2014/main" id="{099F9BB0-4D67-4FC5-9791-CBD91863BF31}"/>
+                <a16:creationId xmlns:a16="http://schemas.microsoft.com/office/drawing/2014/main" id="{4F283D9B-B67A-41EB-A8C1-70AE237A55FF}"/>
               </a:ext>
             </a:extLst>
           </p:cNvPr>
@@ -3310,7 +3310,7 @@
           <p:cNvPr id="6" name="solution-copy">
             <a:extLst xmlns:a="http://schemas.openxmlformats.org/drawingml/2006/main">
               <a:ext uri="{FF2B5EF4-FFF2-40B4-BE49-F238E27FC236}">
-                <a16:creationId xmlns:a16="http://schemas.microsoft.com/office/drawing/2014/main" id="{8C277EE9-84B8-4A93-8E3D-D56E3220904B}"/>
+                <a16:creationId xmlns:a16="http://schemas.microsoft.com/office/drawing/2014/main" id="{A1F7111E-3A0F-48CF-B364-4572A1C96523}"/>
               </a:ext>
             </a:extLst>
           </p:cNvPr>
@@ -3355,7 +3355,7 @@
           <p:cNvPr id="7" name="">
             <a:extLst xmlns:a="http://schemas.openxmlformats.org/drawingml/2006/main">
               <a:ext uri="{FF2B5EF4-FFF2-40B4-BE49-F238E27FC236}">
-                <a16:creationId xmlns:a16="http://schemas.microsoft.com/office/drawing/2014/main" id="{E7652338-4AAE-4EE6-9204-F84F430F10AE}"/>
+                <a16:creationId xmlns:a16="http://schemas.microsoft.com/office/drawing/2014/main" id="{09D889EF-587B-4D95-A95D-D3947D919D9F}"/>
               </a:ext>
             </a:extLst>
           </p:cNvPr>
@@ -3388,7 +3388,7 @@
           <p:cNvPr id="8" name="policy-label-Task budget">
             <a:extLst xmlns:a="http://schemas.openxmlformats.org/drawingml/2006/main">
               <a:ext uri="{FF2B5EF4-FFF2-40B4-BE49-F238E27FC236}">
-                <a16:creationId xmlns:a16="http://schemas.microsoft.com/office/drawing/2014/main" id="{ADF36041-578F-49F7-BFA9-34CB942178C7}"/>
+                <a16:creationId xmlns:a16="http://schemas.microsoft.com/office/drawing/2014/main" id="{9F7E5E23-478F-414B-BC2F-CA0F7042C476}"/>
               </a:ext>
             </a:extLst>
           </p:cNvPr>
@@ -3433,7 +3433,7 @@
           <p:cNvPr id="9" name="policy-value-Task budget">
             <a:extLst xmlns:a="http://schemas.openxmlformats.org/drawingml/2006/main">
               <a:ext uri="{FF2B5EF4-FFF2-40B4-BE49-F238E27FC236}">
-                <a16:creationId xmlns:a16="http://schemas.microsoft.com/office/drawing/2014/main" id="{B22840C0-63C9-4A6A-8634-D840C2E91021}"/>
+                <a16:creationId xmlns:a16="http://schemas.microsoft.com/office/drawing/2014/main" id="{0E79B4AB-C790-4496-879F-B4C485F7B6BB}"/>
               </a:ext>
             </a:extLst>
           </p:cNvPr>
@@ -3478,7 +3478,7 @@
           <p:cNvPr id="10" name="">
             <a:extLst xmlns:a="http://schemas.openxmlformats.org/drawingml/2006/main">
               <a:ext uri="{FF2B5EF4-FFF2-40B4-BE49-F238E27FC236}">
-                <a16:creationId xmlns:a16="http://schemas.microsoft.com/office/drawing/2014/main" id="{9A545F2D-BDF4-4388-B2B3-C80839F1CCF6}"/>
+                <a16:creationId xmlns:a16="http://schemas.microsoft.com/office/drawing/2014/main" id="{19081776-DE62-48BC-BB28-E2ACBDD27842}"/>
               </a:ext>
             </a:extLst>
           </p:cNvPr>
@@ -3511,7 +3511,7 @@
           <p:cNvPr id="11" name="policy-label-Per-call cap">
             <a:extLst xmlns:a="http://schemas.openxmlformats.org/drawingml/2006/main">
               <a:ext uri="{FF2B5EF4-FFF2-40B4-BE49-F238E27FC236}">
-                <a16:creationId xmlns:a16="http://schemas.microsoft.com/office/drawing/2014/main" id="{F66730B9-4E4E-49BA-9EF4-F092ED1AB158}"/>
+                <a16:creationId xmlns:a16="http://schemas.microsoft.com/office/drawing/2014/main" id="{409200EF-6501-46A5-8DCC-4DBE9AB8391E}"/>
               </a:ext>
             </a:extLst>
           </p:cNvPr>
@@ -3556,7 +3556,7 @@
           <p:cNvPr id="12" name="policy-value-Per-call cap">
             <a:extLst xmlns:a="http://schemas.openxmlformats.org/drawingml/2006/main">
               <a:ext uri="{FF2B5EF4-FFF2-40B4-BE49-F238E27FC236}">
-                <a16:creationId xmlns:a16="http://schemas.microsoft.com/office/drawing/2014/main" id="{6333CCF4-D4E1-4A08-B1AC-42B729EE37DB}"/>
+                <a16:creationId xmlns:a16="http://schemas.microsoft.com/office/drawing/2014/main" id="{E4436069-D58B-452A-8755-BA1CE6545DCE}"/>
               </a:ext>
             </a:extLst>
           </p:cNvPr>
@@ -3601,7 +3601,7 @@
           <p:cNvPr id="13" name="">
             <a:extLst xmlns:a="http://schemas.openxmlformats.org/drawingml/2006/main">
               <a:ext uri="{FF2B5EF4-FFF2-40B4-BE49-F238E27FC236}">
-                <a16:creationId xmlns:a16="http://schemas.microsoft.com/office/drawing/2014/main" id="{AE0E9121-6FB0-47C3-9C85-ABA27B730990}"/>
+                <a16:creationId xmlns:a16="http://schemas.microsoft.com/office/drawing/2014/main" id="{B8069FAC-1811-477A-954B-BAD49F393A4B}"/>
               </a:ext>
             </a:extLst>
           </p:cNvPr>
@@ -3634,7 +3634,7 @@
           <p:cNvPr id="14" name="policy-label-Batch control">
             <a:extLst xmlns:a="http://schemas.openxmlformats.org/drawingml/2006/main">
               <a:ext uri="{FF2B5EF4-FFF2-40B4-BE49-F238E27FC236}">
-                <a16:creationId xmlns:a16="http://schemas.microsoft.com/office/drawing/2014/main" id="{EC7313EA-C294-4B25-89B2-7AE68F3A4396}"/>
+                <a16:creationId xmlns:a16="http://schemas.microsoft.com/office/drawing/2014/main" id="{43440E0F-F5A9-48E2-A9C8-70416EF3A59C}"/>
               </a:ext>
             </a:extLst>
           </p:cNvPr>
@@ -3679,7 +3679,7 @@
           <p:cNvPr id="15" name="policy-value-Batch control">
             <a:extLst xmlns:a="http://schemas.openxmlformats.org/drawingml/2006/main">
               <a:ext uri="{FF2B5EF4-FFF2-40B4-BE49-F238E27FC236}">
-                <a16:creationId xmlns:a16="http://schemas.microsoft.com/office/drawing/2014/main" id="{EE3CE256-8F94-4538-99AA-05ED8FBA084A}"/>
+                <a16:creationId xmlns:a16="http://schemas.microsoft.com/office/drawing/2014/main" id="{5A0AEB0B-80F9-4E60-ACA5-B545846E6157}"/>
               </a:ext>
             </a:extLst>
           </p:cNvPr>
@@ -3724,7 +3724,7 @@
           <p:cNvPr id="16" name="">
             <a:extLst xmlns:a="http://schemas.openxmlformats.org/drawingml/2006/main">
               <a:ext uri="{FF2B5EF4-FFF2-40B4-BE49-F238E27FC236}">
-                <a16:creationId xmlns:a16="http://schemas.microsoft.com/office/drawing/2014/main" id="{E2845B56-5208-4517-9AB6-3589726927ED}"/>
+                <a16:creationId xmlns:a16="http://schemas.microsoft.com/office/drawing/2014/main" id="{07BDD2AB-CA38-4F32-8A55-5BB4E84D37CC}"/>
               </a:ext>
             </a:extLst>
           </p:cNvPr>
@@ -3757,7 +3757,7 @@
           <p:cNvPr id="17" name="policy-label-Receipt anchor">
             <a:extLst xmlns:a="http://schemas.openxmlformats.org/drawingml/2006/main">
               <a:ext uri="{FF2B5EF4-FFF2-40B4-BE49-F238E27FC236}">
-                <a16:creationId xmlns:a16="http://schemas.microsoft.com/office/drawing/2014/main" id="{3C278541-2998-453E-AC41-06DA7A1CDE87}"/>
+                <a16:creationId xmlns:a16="http://schemas.microsoft.com/office/drawing/2014/main" id="{41BE2158-5DD2-4A22-B660-36A5AEB1DCBF}"/>
               </a:ext>
             </a:extLst>
           </p:cNvPr>
@@ -3802,7 +3802,7 @@
           <p:cNvPr id="18" name="policy-value-Receipt anchor">
             <a:extLst xmlns:a="http://schemas.openxmlformats.org/drawingml/2006/main">
               <a:ext uri="{FF2B5EF4-FFF2-40B4-BE49-F238E27FC236}">
-                <a16:creationId xmlns:a16="http://schemas.microsoft.com/office/drawing/2014/main" id="{65CDD131-7A5F-4B8B-BB6C-8B5B157B7A1E}"/>
+                <a16:creationId xmlns:a16="http://schemas.microsoft.com/office/drawing/2014/main" id="{3987C343-125A-4E26-9234-4DA54BC0992B}"/>
               </a:ext>
             </a:extLst>
           </p:cNvPr>
@@ -3847,7 +3847,7 @@
           <p:cNvPr id="19" name="solution-flow-surface">
             <a:extLst xmlns:a="http://schemas.openxmlformats.org/drawingml/2006/main">
               <a:ext uri="{FF2B5EF4-FFF2-40B4-BE49-F238E27FC236}">
-                <a16:creationId xmlns:a16="http://schemas.microsoft.com/office/drawing/2014/main" id="{BF3C778D-F014-43EC-9FAF-F7AA883DA6B9}"/>
+                <a16:creationId xmlns:a16="http://schemas.microsoft.com/office/drawing/2014/main" id="{75E7260F-C592-48D7-8EC1-3995948B743B}"/>
               </a:ext>
             </a:extLst>
           </p:cNvPr>
@@ -3882,7 +3882,7 @@
           <p:cNvPr id="20" name="signature-large">
             <a:extLst xmlns:a="http://schemas.openxmlformats.org/drawingml/2006/main">
               <a:ext uri="{FF2B5EF4-FFF2-40B4-BE49-F238E27FC236}">
-                <a16:creationId xmlns:a16="http://schemas.microsoft.com/office/drawing/2014/main" id="{06CAC297-FAC1-4D2B-8717-599E370EC69A}"/>
+                <a16:creationId xmlns:a16="http://schemas.microsoft.com/office/drawing/2014/main" id="{D49812A6-5BFD-405F-9CB4-7B6D4C569850}"/>
               </a:ext>
             </a:extLst>
           </p:cNvPr>
@@ -3927,7 +3927,7 @@
           <p:cNvPr id="21" name="flow-arrow">
             <a:extLst xmlns:a="http://schemas.openxmlformats.org/drawingml/2006/main">
               <a:ext uri="{FF2B5EF4-FFF2-40B4-BE49-F238E27FC236}">
-                <a16:creationId xmlns:a16="http://schemas.microsoft.com/office/drawing/2014/main" id="{525BF71B-BC44-4CA3-9C2B-E7E295E1FF56}"/>
+                <a16:creationId xmlns:a16="http://schemas.microsoft.com/office/drawing/2014/main" id="{62AE127B-05FF-4373-9D49-5AA7377DC43D}"/>
               </a:ext>
             </a:extLst>
           </p:cNvPr>
@@ -3972,7 +3972,7 @@
           <p:cNvPr id="22" name="proofs-large">
             <a:extLst xmlns:a="http://schemas.openxmlformats.org/drawingml/2006/main">
               <a:ext uri="{FF2B5EF4-FFF2-40B4-BE49-F238E27FC236}">
-                <a16:creationId xmlns:a16="http://schemas.microsoft.com/office/drawing/2014/main" id="{F4D34B94-0535-420B-822D-B27717FE3994}"/>
+                <a16:creationId xmlns:a16="http://schemas.microsoft.com/office/drawing/2014/main" id="{D757F68F-F539-492F-9388-EE1147970942}"/>
               </a:ext>
             </a:extLst>
           </p:cNvPr>
@@ -4017,7 +4017,7 @@
           <p:cNvPr id="23" name="review-label">
             <a:extLst xmlns:a="http://schemas.openxmlformats.org/drawingml/2006/main">
               <a:ext uri="{FF2B5EF4-FFF2-40B4-BE49-F238E27FC236}">
-                <a16:creationId xmlns:a16="http://schemas.microsoft.com/office/drawing/2014/main" id="{67E8EC6A-D374-4392-A06A-8FE32227B937}"/>
+                <a16:creationId xmlns:a16="http://schemas.microsoft.com/office/drawing/2014/main" id="{6705894E-714C-473F-B8B6-4CBE474D2C2F}"/>
               </a:ext>
             </a:extLst>
           </p:cNvPr>
@@ -4062,7 +4062,7 @@
           <p:cNvPr id="24" name="provider-ProofDesk">
             <a:extLst xmlns:a="http://schemas.openxmlformats.org/drawingml/2006/main">
               <a:ext uri="{FF2B5EF4-FFF2-40B4-BE49-F238E27FC236}">
-                <a16:creationId xmlns:a16="http://schemas.microsoft.com/office/drawing/2014/main" id="{EE704341-489F-49FF-A1F1-D460BB7595DB}"/>
+                <a16:creationId xmlns:a16="http://schemas.microsoft.com/office/drawing/2014/main" id="{1217D289-F68D-4AB1-B14C-464EDA3A5BC0}"/>
               </a:ext>
             </a:extLst>
           </p:cNvPr>
@@ -4097,7 +4097,7 @@
           <p:cNvPr id="25" name="">
             <a:extLst xmlns:a="http://schemas.openxmlformats.org/drawingml/2006/main">
               <a:ext uri="{FF2B5EF4-FFF2-40B4-BE49-F238E27FC236}">
-                <a16:creationId xmlns:a16="http://schemas.microsoft.com/office/drawing/2014/main" id="{CDD3F3A3-27B8-4EFE-94DF-90FBCF5888C9}"/>
+                <a16:creationId xmlns:a16="http://schemas.microsoft.com/office/drawing/2014/main" id="{308852BB-EAC6-4E30-B7B5-35DC52772241}"/>
               </a:ext>
             </a:extLst>
           </p:cNvPr>
@@ -4130,7 +4130,7 @@
           <p:cNvPr id="26" name="">
             <a:extLst xmlns:a="http://schemas.openxmlformats.org/drawingml/2006/main">
               <a:ext uri="{FF2B5EF4-FFF2-40B4-BE49-F238E27FC236}">
-                <a16:creationId xmlns:a16="http://schemas.microsoft.com/office/drawing/2014/main" id="{0EECC779-DB46-4AD5-A673-6695D2A0707A}"/>
+                <a16:creationId xmlns:a16="http://schemas.microsoft.com/office/drawing/2014/main" id="{CDDE5C27-A03E-49EE-957B-436A390D097B}"/>
               </a:ext>
             </a:extLst>
           </p:cNvPr>
@@ -4175,7 +4175,7 @@
           <p:cNvPr id="27" name="">
             <a:extLst xmlns:a="http://schemas.openxmlformats.org/drawingml/2006/main">
               <a:ext uri="{FF2B5EF4-FFF2-40B4-BE49-F238E27FC236}">
-                <a16:creationId xmlns:a16="http://schemas.microsoft.com/office/drawing/2014/main" id="{C3CAB49F-0039-4A88-986F-F07FEF5F40AD}"/>
+                <a16:creationId xmlns:a16="http://schemas.microsoft.com/office/drawing/2014/main" id="{E0DE54C2-A73E-48E3-ACA8-7381D2406AA5}"/>
               </a:ext>
             </a:extLst>
           </p:cNvPr>
@@ -4220,7 +4220,7 @@
           <p:cNvPr id="28" name="provider-KybTrail">
             <a:extLst xmlns:a="http://schemas.openxmlformats.org/drawingml/2006/main">
               <a:ext uri="{FF2B5EF4-FFF2-40B4-BE49-F238E27FC236}">
-                <a16:creationId xmlns:a16="http://schemas.microsoft.com/office/drawing/2014/main" id="{33DDE16D-D5EC-4B38-AC92-93FF114B6D42}"/>
+                <a16:creationId xmlns:a16="http://schemas.microsoft.com/office/drawing/2014/main" id="{B9D1C855-DFCD-4CCF-A7F8-A01D243200A6}"/>
               </a:ext>
             </a:extLst>
           </p:cNvPr>
@@ -4255,7 +4255,7 @@
           <p:cNvPr id="29" name="">
             <a:extLst xmlns:a="http://schemas.openxmlformats.org/drawingml/2006/main">
               <a:ext uri="{FF2B5EF4-FFF2-40B4-BE49-F238E27FC236}">
-                <a16:creationId xmlns:a16="http://schemas.microsoft.com/office/drawing/2014/main" id="{E314BE27-BA0B-4115-85AC-4FA5B65909C4}"/>
+                <a16:creationId xmlns:a16="http://schemas.microsoft.com/office/drawing/2014/main" id="{8054E6DB-FC74-4A81-9F6E-5902EECCD71B}"/>
               </a:ext>
             </a:extLst>
           </p:cNvPr>
@@ -4288,7 +4288,7 @@
           <p:cNvPr id="30" name="">
             <a:extLst xmlns:a="http://schemas.openxmlformats.org/drawingml/2006/main">
               <a:ext uri="{FF2B5EF4-FFF2-40B4-BE49-F238E27FC236}">
-                <a16:creationId xmlns:a16="http://schemas.microsoft.com/office/drawing/2014/main" id="{7D18AECC-5E24-473B-AC40-27BDECCD28F1}"/>
+                <a16:creationId xmlns:a16="http://schemas.microsoft.com/office/drawing/2014/main" id="{A5895B59-3F83-4625-9232-810F0E632BF3}"/>
               </a:ext>
             </a:extLst>
           </p:cNvPr>
@@ -4333,7 +4333,7 @@
           <p:cNvPr id="31" name="">
             <a:extLst xmlns:a="http://schemas.openxmlformats.org/drawingml/2006/main">
               <a:ext uri="{FF2B5EF4-FFF2-40B4-BE49-F238E27FC236}">
-                <a16:creationId xmlns:a16="http://schemas.microsoft.com/office/drawing/2014/main" id="{DA46C0D7-348E-4F59-8DCD-47CCDDE0D8B3}"/>
+                <a16:creationId xmlns:a16="http://schemas.microsoft.com/office/drawing/2014/main" id="{1996AA61-332B-4597-BCB4-4107343B1EFA}"/>
               </a:ext>
             </a:extLst>
           </p:cNvPr>
@@ -4378,7 +4378,7 @@
           <p:cNvPr id="32" name="provider-ClearList">
             <a:extLst xmlns:a="http://schemas.openxmlformats.org/drawingml/2006/main">
               <a:ext uri="{FF2B5EF4-FFF2-40B4-BE49-F238E27FC236}">
-                <a16:creationId xmlns:a16="http://schemas.microsoft.com/office/drawing/2014/main" id="{EA8D5606-9F2F-4228-87E7-3FD94A6DCA81}"/>
+                <a16:creationId xmlns:a16="http://schemas.microsoft.com/office/drawing/2014/main" id="{F77DB41A-370E-402D-9A99-98ADA2AA6D3C}"/>
               </a:ext>
             </a:extLst>
           </p:cNvPr>
@@ -4413,7 +4413,7 @@
           <p:cNvPr id="33" name="">
             <a:extLst xmlns:a="http://schemas.openxmlformats.org/drawingml/2006/main">
               <a:ext uri="{FF2B5EF4-FFF2-40B4-BE49-F238E27FC236}">
-                <a16:creationId xmlns:a16="http://schemas.microsoft.com/office/drawing/2014/main" id="{2FD5ED44-64DE-4B08-8CA6-243C895F607E}"/>
+                <a16:creationId xmlns:a16="http://schemas.microsoft.com/office/drawing/2014/main" id="{F40D1733-13F8-4901-93B2-DD2033D95E4F}"/>
               </a:ext>
             </a:extLst>
           </p:cNvPr>
@@ -4446,7 +4446,7 @@
           <p:cNvPr id="34" name="">
             <a:extLst xmlns:a="http://schemas.openxmlformats.org/drawingml/2006/main">
               <a:ext uri="{FF2B5EF4-FFF2-40B4-BE49-F238E27FC236}">
-                <a16:creationId xmlns:a16="http://schemas.microsoft.com/office/drawing/2014/main" id="{1FBFD489-1859-48EC-804C-3E9178695909}"/>
+                <a16:creationId xmlns:a16="http://schemas.microsoft.com/office/drawing/2014/main" id="{42843C94-C545-464A-AFA4-2DE883A56B93}"/>
               </a:ext>
             </a:extLst>
           </p:cNvPr>
@@ -4491,7 +4491,7 @@
           <p:cNvPr id="35" name="">
             <a:extLst xmlns:a="http://schemas.openxmlformats.org/drawingml/2006/main">
               <a:ext uri="{FF2B5EF4-FFF2-40B4-BE49-F238E27FC236}">
-                <a16:creationId xmlns:a16="http://schemas.microsoft.com/office/drawing/2014/main" id="{BB62FF5F-2455-4E92-AB1C-4B5CC1B2EE6A}"/>
+                <a16:creationId xmlns:a16="http://schemas.microsoft.com/office/drawing/2014/main" id="{C5925DDF-56BA-4964-A015-903FD76CE276}"/>
               </a:ext>
             </a:extLst>
           </p:cNvPr>
@@ -4536,7 +4536,7 @@
           <p:cNvPr id="36" name="provider-AccountLock">
             <a:extLst xmlns:a="http://schemas.openxmlformats.org/drawingml/2006/main">
               <a:ext uri="{FF2B5EF4-FFF2-40B4-BE49-F238E27FC236}">
-                <a16:creationId xmlns:a16="http://schemas.microsoft.com/office/drawing/2014/main" id="{4240A50B-1089-436F-BFAA-BA7813DE3CC5}"/>
+                <a16:creationId xmlns:a16="http://schemas.microsoft.com/office/drawing/2014/main" id="{3E3D72FF-CE06-4838-A892-8A589F5940C6}"/>
               </a:ext>
             </a:extLst>
           </p:cNvPr>
@@ -4571,7 +4571,7 @@
           <p:cNvPr id="37" name="">
             <a:extLst xmlns:a="http://schemas.openxmlformats.org/drawingml/2006/main">
               <a:ext uri="{FF2B5EF4-FFF2-40B4-BE49-F238E27FC236}">
-                <a16:creationId xmlns:a16="http://schemas.microsoft.com/office/drawing/2014/main" id="{B64D9EC8-9E1B-40E0-859E-6730D1326DFF}"/>
+                <a16:creationId xmlns:a16="http://schemas.microsoft.com/office/drawing/2014/main" id="{D01FE534-893D-408C-A7A7-B2D3B41CD2B5}"/>
               </a:ext>
             </a:extLst>
           </p:cNvPr>
@@ -4604,7 +4604,7 @@
           <p:cNvPr id="38" name="">
             <a:extLst xmlns:a="http://schemas.openxmlformats.org/drawingml/2006/main">
               <a:ext uri="{FF2B5EF4-FFF2-40B4-BE49-F238E27FC236}">
-                <a16:creationId xmlns:a16="http://schemas.microsoft.com/office/drawing/2014/main" id="{E0E8FF50-D594-4DA3-853C-A21FBF8D8E2A}"/>
+                <a16:creationId xmlns:a16="http://schemas.microsoft.com/office/drawing/2014/main" id="{BABBA4C3-CB33-430A-A993-859395748B49}"/>
               </a:ext>
             </a:extLst>
           </p:cNvPr>
@@ -4649,7 +4649,7 @@
           <p:cNvPr id="39" name="">
             <a:extLst xmlns:a="http://schemas.openxmlformats.org/drawingml/2006/main">
               <a:ext uri="{FF2B5EF4-FFF2-40B4-BE49-F238E27FC236}">
-                <a16:creationId xmlns:a16="http://schemas.microsoft.com/office/drawing/2014/main" id="{821D5E7C-9D32-45FC-85DD-CEAE13109A94}"/>
+                <a16:creationId xmlns:a16="http://schemas.microsoft.com/office/drawing/2014/main" id="{6F848CB6-F76F-4D49-A0D5-AC70B5DBCE52}"/>
               </a:ext>
             </a:extLst>
           </p:cNvPr>
@@ -4694,7 +4694,7 @@
           <p:cNvPr id="40" name="provider-FraudLens">
             <a:extLst xmlns:a="http://schemas.openxmlformats.org/drawingml/2006/main">
               <a:ext uri="{FF2B5EF4-FFF2-40B4-BE49-F238E27FC236}">
-                <a16:creationId xmlns:a16="http://schemas.microsoft.com/office/drawing/2014/main" id="{BBD15482-A19A-4DC3-86F9-197B2910FCBE}"/>
+                <a16:creationId xmlns:a16="http://schemas.microsoft.com/office/drawing/2014/main" id="{C6797F0F-5F23-497B-92DA-DE2D85EB124E}"/>
               </a:ext>
             </a:extLst>
           </p:cNvPr>
@@ -4729,7 +4729,7 @@
           <p:cNvPr id="41" name="">
             <a:extLst xmlns:a="http://schemas.openxmlformats.org/drawingml/2006/main">
               <a:ext uri="{FF2B5EF4-FFF2-40B4-BE49-F238E27FC236}">
-                <a16:creationId xmlns:a16="http://schemas.microsoft.com/office/drawing/2014/main" id="{5BDAF7F9-9778-458B-AC49-DE3FD33D70F6}"/>
+                <a16:creationId xmlns:a16="http://schemas.microsoft.com/office/drawing/2014/main" id="{4F6EA524-2EF7-43CC-B3AC-8551CC1E4154}"/>
               </a:ext>
             </a:extLst>
           </p:cNvPr>
@@ -4762,7 +4762,7 @@
           <p:cNvPr id="42" name="">
             <a:extLst xmlns:a="http://schemas.openxmlformats.org/drawingml/2006/main">
               <a:ext uri="{FF2B5EF4-FFF2-40B4-BE49-F238E27FC236}">
-                <a16:creationId xmlns:a16="http://schemas.microsoft.com/office/drawing/2014/main" id="{AC4F9771-4B5B-4D92-B1AB-7B6E1AB51C93}"/>
+                <a16:creationId xmlns:a16="http://schemas.microsoft.com/office/drawing/2014/main" id="{A00C9051-5602-46F9-804E-CFBE8055501D}"/>
               </a:ext>
             </a:extLst>
           </p:cNvPr>
@@ -4807,7 +4807,7 @@
           <p:cNvPr id="43" name="">
             <a:extLst xmlns:a="http://schemas.openxmlformats.org/drawingml/2006/main">
               <a:ext uri="{FF2B5EF4-FFF2-40B4-BE49-F238E27FC236}">
-                <a16:creationId xmlns:a16="http://schemas.microsoft.com/office/drawing/2014/main" id="{C2937EBA-E2B5-410A-B06E-CDCC392F680D}"/>
+                <a16:creationId xmlns:a16="http://schemas.microsoft.com/office/drawing/2014/main" id="{BBA60E7F-94B0-4D08-A3B5-2945817084D9}"/>
               </a:ext>
             </a:extLst>
           </p:cNvPr>
@@ -4852,7 +4852,7 @@
           <p:cNvPr id="44" name="provider-QuoteMesh">
             <a:extLst xmlns:a="http://schemas.openxmlformats.org/drawingml/2006/main">
               <a:ext uri="{FF2B5EF4-FFF2-40B4-BE49-F238E27FC236}">
-                <a16:creationId xmlns:a16="http://schemas.microsoft.com/office/drawing/2014/main" id="{93E49E63-E9D2-467D-BBD7-6AD8ED5E491A}"/>
+                <a16:creationId xmlns:a16="http://schemas.microsoft.com/office/drawing/2014/main" id="{4DB959C7-917E-4FDD-A238-89FC2443A1B6}"/>
               </a:ext>
             </a:extLst>
           </p:cNvPr>
@@ -4887,7 +4887,7 @@
           <p:cNvPr id="45" name="">
             <a:extLst xmlns:a="http://schemas.openxmlformats.org/drawingml/2006/main">
               <a:ext uri="{FF2B5EF4-FFF2-40B4-BE49-F238E27FC236}">
-                <a16:creationId xmlns:a16="http://schemas.microsoft.com/office/drawing/2014/main" id="{6964B61E-0E95-42C0-94A9-F994071A3133}"/>
+                <a16:creationId xmlns:a16="http://schemas.microsoft.com/office/drawing/2014/main" id="{80EFCFF8-3121-4F14-90A6-A1BE75F14D0C}"/>
               </a:ext>
             </a:extLst>
           </p:cNvPr>
@@ -4920,7 +4920,7 @@
           <p:cNvPr id="46" name="">
             <a:extLst xmlns:a="http://schemas.openxmlformats.org/drawingml/2006/main">
               <a:ext uri="{FF2B5EF4-FFF2-40B4-BE49-F238E27FC236}">
-                <a16:creationId xmlns:a16="http://schemas.microsoft.com/office/drawing/2014/main" id="{6F814F9F-46A4-4921-9FEB-2AC78947A884}"/>
+                <a16:creationId xmlns:a16="http://schemas.microsoft.com/office/drawing/2014/main" id="{939D6B91-2C7A-485A-ADB3-121B4C47A98C}"/>
               </a:ext>
             </a:extLst>
           </p:cNvPr>
@@ -4965,7 +4965,7 @@
           <p:cNvPr id="47" name="">
             <a:extLst xmlns:a="http://schemas.openxmlformats.org/drawingml/2006/main">
               <a:ext uri="{FF2B5EF4-FFF2-40B4-BE49-F238E27FC236}">
-                <a16:creationId xmlns:a16="http://schemas.microsoft.com/office/drawing/2014/main" id="{D0266F89-1153-4DF9-BB4C-6FC22917FE9F}"/>
+                <a16:creationId xmlns:a16="http://schemas.microsoft.com/office/drawing/2014/main" id="{CA4D8D8E-160D-4E9B-B2C6-72AD5805394C}"/>
               </a:ext>
             </a:extLst>
           </p:cNvPr>
@@ -5010,7 +5010,7 @@
           <p:cNvPr id="48" name="">
             <a:extLst xmlns:a="http://schemas.openxmlformats.org/drawingml/2006/main">
               <a:ext uri="{FF2B5EF4-FFF2-40B4-BE49-F238E27FC236}">
-                <a16:creationId xmlns:a16="http://schemas.microsoft.com/office/drawing/2014/main" id="{FF47F736-E94C-4469-BF74-2A5DEF25722A}"/>
+                <a16:creationId xmlns:a16="http://schemas.microsoft.com/office/drawing/2014/main" id="{4C64A2F5-7662-4FE0-A9D8-2893A9AD43D9}"/>
               </a:ext>
             </a:extLst>
           </p:cNvPr>
@@ -5043,7 +5043,7 @@
           <p:cNvPr id="49" name="metric-value-total batch spend">
             <a:extLst xmlns:a="http://schemas.openxmlformats.org/drawingml/2006/main">
               <a:ext uri="{FF2B5EF4-FFF2-40B4-BE49-F238E27FC236}">
-                <a16:creationId xmlns:a16="http://schemas.microsoft.com/office/drawing/2014/main" id="{83E49FC8-9BFC-4E4F-9E6E-11378BBC2802}"/>
+                <a16:creationId xmlns:a16="http://schemas.microsoft.com/office/drawing/2014/main" id="{EBE890F0-9D63-4B12-9809-789F0A7DBEBD}"/>
               </a:ext>
             </a:extLst>
           </p:cNvPr>
@@ -5088,7 +5088,7 @@
           <p:cNvPr id="50" name="metric-label-total batch spend">
             <a:extLst xmlns:a="http://schemas.openxmlformats.org/drawingml/2006/main">
               <a:ext uri="{FF2B5EF4-FFF2-40B4-BE49-F238E27FC236}">
-                <a16:creationId xmlns:a16="http://schemas.microsoft.com/office/drawing/2014/main" id="{61B9B213-388D-4DB5-8615-8B8D50F8D754}"/>
+                <a16:creationId xmlns:a16="http://schemas.microsoft.com/office/drawing/2014/main" id="{50F3EACC-AE0B-4739-9FC8-7F5C438F45F2}"/>
               </a:ext>
             </a:extLst>
           </p:cNvPr>
@@ -5133,7 +5133,7 @@
           <p:cNvPr id="51" name="metric-note-total batch spend">
             <a:extLst xmlns:a="http://schemas.openxmlformats.org/drawingml/2006/main">
               <a:ext uri="{FF2B5EF4-FFF2-40B4-BE49-F238E27FC236}">
-                <a16:creationId xmlns:a16="http://schemas.microsoft.com/office/drawing/2014/main" id="{274ADA05-B2D7-4A84-A4BB-6FA33BD1E7D7}"/>
+                <a16:creationId xmlns:a16="http://schemas.microsoft.com/office/drawing/2014/main" id="{5B16E7FE-F5B4-460A-978C-1B52E09D65B2}"/>
               </a:ext>
             </a:extLst>
           </p:cNvPr>
@@ -5178,7 +5178,7 @@
           <p:cNvPr id="52" name="">
             <a:extLst xmlns:a="http://schemas.openxmlformats.org/drawingml/2006/main">
               <a:ext uri="{FF2B5EF4-FFF2-40B4-BE49-F238E27FC236}">
-                <a16:creationId xmlns:a16="http://schemas.microsoft.com/office/drawing/2014/main" id="{FA7245C9-ACE8-403E-88BA-8518520939A9}"/>
+                <a16:creationId xmlns:a16="http://schemas.microsoft.com/office/drawing/2014/main" id="{3F89B012-87D7-48AE-9514-E27EAE3BB6CC}"/>
               </a:ext>
             </a:extLst>
           </p:cNvPr>
@@ -5211,7 +5211,7 @@
           <p:cNvPr id="53" name="metric-value-avg paid action">
             <a:extLst xmlns:a="http://schemas.openxmlformats.org/drawingml/2006/main">
               <a:ext uri="{FF2B5EF4-FFF2-40B4-BE49-F238E27FC236}">
-                <a16:creationId xmlns:a16="http://schemas.microsoft.com/office/drawing/2014/main" id="{EFC8041C-98E0-403B-930F-E36F257E4EF6}"/>
+                <a16:creationId xmlns:a16="http://schemas.microsoft.com/office/drawing/2014/main" id="{33D792A3-6482-470C-9BD2-9C679EC61C32}"/>
               </a:ext>
             </a:extLst>
           </p:cNvPr>
@@ -5256,7 +5256,7 @@
           <p:cNvPr id="54" name="metric-label-avg paid action">
             <a:extLst xmlns:a="http://schemas.openxmlformats.org/drawingml/2006/main">
               <a:ext uri="{FF2B5EF4-FFF2-40B4-BE49-F238E27FC236}">
-                <a16:creationId xmlns:a16="http://schemas.microsoft.com/office/drawing/2014/main" id="{410412B0-697B-48B8-8573-54BF442A5E5C}"/>
+                <a16:creationId xmlns:a16="http://schemas.microsoft.com/office/drawing/2014/main" id="{AB611791-E2E5-46B0-B46A-BDA42467E39B}"/>
               </a:ext>
             </a:extLst>
           </p:cNvPr>
@@ -5301,7 +5301,7 @@
           <p:cNvPr id="55" name="metric-note-avg paid action">
             <a:extLst xmlns:a="http://schemas.openxmlformats.org/drawingml/2006/main">
               <a:ext uri="{FF2B5EF4-FFF2-40B4-BE49-F238E27FC236}">
-                <a16:creationId xmlns:a16="http://schemas.microsoft.com/office/drawing/2014/main" id="{E296B98A-8B60-41B0-8F0B-9D8EBADA1AD9}"/>
+                <a16:creationId xmlns:a16="http://schemas.microsoft.com/office/drawing/2014/main" id="{49D8FC5E-D96A-42A5-97A5-035B3E177541}"/>
               </a:ext>
             </a:extLst>
           </p:cNvPr>
@@ -5346,7 +5346,7 @@
           <p:cNvPr id="56" name="footer-left">
             <a:extLst xmlns:a="http://schemas.openxmlformats.org/drawingml/2006/main">
               <a:ext uri="{FF2B5EF4-FFF2-40B4-BE49-F238E27FC236}">
-                <a16:creationId xmlns:a16="http://schemas.microsoft.com/office/drawing/2014/main" id="{A3210CB5-E6F9-41E9-B2E7-9BB2ABFD7981}"/>
+                <a16:creationId xmlns:a16="http://schemas.microsoft.com/office/drawing/2014/main" id="{FEC3F1E1-3BBD-4A7F-8525-4C9156AA6797}"/>
               </a:ext>
             </a:extLst>
           </p:cNvPr>
@@ -5391,7 +5391,7 @@
           <p:cNvPr id="57" name="footer-right">
             <a:extLst xmlns:a="http://schemas.openxmlformats.org/drawingml/2006/main">
               <a:ext uri="{FF2B5EF4-FFF2-40B4-BE49-F238E27FC236}">
-                <a16:creationId xmlns:a16="http://schemas.microsoft.com/office/drawing/2014/main" id="{7C885C35-2D96-466D-8503-CF983ADB371A}"/>
+                <a16:creationId xmlns:a16="http://schemas.microsoft.com/office/drawing/2014/main" id="{814F8B44-5E11-461E-B336-E10B3324AFC1}"/>
               </a:ext>
             </a:extLst>
           </p:cNvPr>
@@ -5434,7 +5434,7 @@
     </p:spTree>
     <p:extLst>
       <p:ext uri="{BB962C8B-B14F-4D97-AF65-F5344CB8AC3E}">
-        <p14:creationId xmlns:p14="http://schemas.microsoft.com/office/powerpoint/2010/main" val="1171008523"/>
+        <p14:creationId xmlns:p14="http://schemas.microsoft.com/office/powerpoint/2010/main" val="2121379843"/>
       </p:ext>
     </p:extLst>
   </p:cSld>
@@ -5458,7 +5458,7 @@
           <p:cNvPr id="1" name="slide-background">
             <a:extLst xmlns:a="http://schemas.openxmlformats.org/drawingml/2006/main">
               <a:ext uri="{FF2B5EF4-FFF2-40B4-BE49-F238E27FC236}">
-                <a16:creationId xmlns:a16="http://schemas.microsoft.com/office/drawing/2014/main" id="{18549D2F-B932-4D8D-9940-929C71C0DD81}"/>
+                <a16:creationId xmlns:a16="http://schemas.microsoft.com/office/drawing/2014/main" id="{1CB87969-C39C-461F-85C2-2E9762625B55}"/>
               </a:ext>
             </a:extLst>
           </p:cNvPr>
@@ -5491,7 +5491,7 @@
           <p:cNvPr id="2" name="kicker">
             <a:extLst xmlns:a="http://schemas.openxmlformats.org/drawingml/2006/main">
               <a:ext uri="{FF2B5EF4-FFF2-40B4-BE49-F238E27FC236}">
-                <a16:creationId xmlns:a16="http://schemas.microsoft.com/office/drawing/2014/main" id="{0D655D6D-3ADC-4EBA-8267-8425B10FB35B}"/>
+                <a16:creationId xmlns:a16="http://schemas.microsoft.com/office/drawing/2014/main" id="{639725CB-E2D9-4499-8FED-EA09EB268937}"/>
               </a:ext>
             </a:extLst>
           </p:cNvPr>
@@ -5536,7 +5536,7 @@
           <p:cNvPr id="3" name="slide-title">
             <a:extLst xmlns:a="http://schemas.openxmlformats.org/drawingml/2006/main">
               <a:ext uri="{FF2B5EF4-FFF2-40B4-BE49-F238E27FC236}">
-                <a16:creationId xmlns:a16="http://schemas.microsoft.com/office/drawing/2014/main" id="{6B403380-9A50-4C50-B344-12943370F5FA}"/>
+                <a16:creationId xmlns:a16="http://schemas.microsoft.com/office/drawing/2014/main" id="{E9432FB6-1825-4492-AD69-33EC41CB43FB}"/>
               </a:ext>
             </a:extLst>
           </p:cNvPr>
@@ -5581,7 +5581,7 @@
           <p:cNvPr id="4" name="slide-subtitle">
             <a:extLst xmlns:a="http://schemas.openxmlformats.org/drawingml/2006/main">
               <a:ext uri="{FF2B5EF4-FFF2-40B4-BE49-F238E27FC236}">
-                <a16:creationId xmlns:a16="http://schemas.microsoft.com/office/drawing/2014/main" id="{110E580C-EB79-4857-9BE2-C1441850984B}"/>
+                <a16:creationId xmlns:a16="http://schemas.microsoft.com/office/drawing/2014/main" id="{018BA4E9-05D5-46C8-812A-6C2DD3E2DF24}"/>
               </a:ext>
             </a:extLst>
           </p:cNvPr>
@@ -5626,7 +5626,7 @@
           <p:cNvPr id="5" name="">
             <a:extLst xmlns:a="http://schemas.openxmlformats.org/drawingml/2006/main">
               <a:ext uri="{FF2B5EF4-FFF2-40B4-BE49-F238E27FC236}">
-                <a16:creationId xmlns:a16="http://schemas.microsoft.com/office/drawing/2014/main" id="{2153780B-3FC3-4870-BB87-0AC6F3824454}"/>
+                <a16:creationId xmlns:a16="http://schemas.microsoft.com/office/drawing/2014/main" id="{D634D9A5-2268-44C4-B1E2-E56F0E899ABF}"/>
               </a:ext>
             </a:extLst>
           </p:cNvPr>
@@ -5659,7 +5659,7 @@
           <p:cNvPr id="6" name="lane-label-Policy">
             <a:extLst xmlns:a="http://schemas.openxmlformats.org/drawingml/2006/main">
               <a:ext uri="{FF2B5EF4-FFF2-40B4-BE49-F238E27FC236}">
-                <a16:creationId xmlns:a16="http://schemas.microsoft.com/office/drawing/2014/main" id="{491FBC7B-2A2A-4073-AAC2-58ABCD354E77}"/>
+                <a16:creationId xmlns:a16="http://schemas.microsoft.com/office/drawing/2014/main" id="{538AA0D0-2741-4356-89EB-32A38029C273}"/>
               </a:ext>
             </a:extLst>
           </p:cNvPr>
@@ -5704,7 +5704,7 @@
           <p:cNvPr id="7" name="">
             <a:extLst xmlns:a="http://schemas.openxmlformats.org/drawingml/2006/main">
               <a:ext uri="{FF2B5EF4-FFF2-40B4-BE49-F238E27FC236}">
-                <a16:creationId xmlns:a16="http://schemas.microsoft.com/office/drawing/2014/main" id="{42045942-2A05-4B35-AD6A-63CFE1008993}"/>
+                <a16:creationId xmlns:a16="http://schemas.microsoft.com/office/drawing/2014/main" id="{912DC69A-043F-4152-8611-96FED5CA1808}"/>
               </a:ext>
             </a:extLst>
           </p:cNvPr>
@@ -5737,7 +5737,7 @@
           <p:cNvPr id="8" name="lane-detail-Policy">
             <a:extLst xmlns:a="http://schemas.openxmlformats.org/drawingml/2006/main">
               <a:ext uri="{FF2B5EF4-FFF2-40B4-BE49-F238E27FC236}">
-                <a16:creationId xmlns:a16="http://schemas.microsoft.com/office/drawing/2014/main" id="{7F085ED3-5EB7-42F0-A000-757D1F59EF74}"/>
+                <a16:creationId xmlns:a16="http://schemas.microsoft.com/office/drawing/2014/main" id="{45A53F9E-3A06-4385-BB92-017119F1C2EC}"/>
               </a:ext>
             </a:extLst>
           </p:cNvPr>
@@ -5782,7 +5782,7 @@
           <p:cNvPr id="9" name="flow-arrow">
             <a:extLst xmlns:a="http://schemas.openxmlformats.org/drawingml/2006/main">
               <a:ext uri="{FF2B5EF4-FFF2-40B4-BE49-F238E27FC236}">
-                <a16:creationId xmlns:a16="http://schemas.microsoft.com/office/drawing/2014/main" id="{CB818074-7A1E-458F-ABAC-D58B898359F3}"/>
+                <a16:creationId xmlns:a16="http://schemas.microsoft.com/office/drawing/2014/main" id="{1141171C-18F7-4CB5-82B1-B2F02B3E95F4}"/>
               </a:ext>
             </a:extLst>
           </p:cNvPr>
@@ -5827,7 +5827,7 @@
           <p:cNvPr id="10" name="">
             <a:extLst xmlns:a="http://schemas.openxmlformats.org/drawingml/2006/main">
               <a:ext uri="{FF2B5EF4-FFF2-40B4-BE49-F238E27FC236}">
-                <a16:creationId xmlns:a16="http://schemas.microsoft.com/office/drawing/2014/main" id="{B9ED22DB-0FB5-493E-AF48-749B3779D26A}"/>
+                <a16:creationId xmlns:a16="http://schemas.microsoft.com/office/drawing/2014/main" id="{0902AC24-0A4F-4FFA-9540-F22885788665}"/>
               </a:ext>
             </a:extLst>
           </p:cNvPr>
@@ -5860,7 +5860,7 @@
           <p:cNvPr id="11" name="lane-label-x402">
             <a:extLst xmlns:a="http://schemas.openxmlformats.org/drawingml/2006/main">
               <a:ext uri="{FF2B5EF4-FFF2-40B4-BE49-F238E27FC236}">
-                <a16:creationId xmlns:a16="http://schemas.microsoft.com/office/drawing/2014/main" id="{362BA579-55B0-4B9A-B972-8C79B9BB5398}"/>
+                <a16:creationId xmlns:a16="http://schemas.microsoft.com/office/drawing/2014/main" id="{49E26B3D-E7B1-4CCC-9BDE-D3E084915084}"/>
               </a:ext>
             </a:extLst>
           </p:cNvPr>
@@ -5905,7 +5905,7 @@
           <p:cNvPr id="12" name="">
             <a:extLst xmlns:a="http://schemas.openxmlformats.org/drawingml/2006/main">
               <a:ext uri="{FF2B5EF4-FFF2-40B4-BE49-F238E27FC236}">
-                <a16:creationId xmlns:a16="http://schemas.microsoft.com/office/drawing/2014/main" id="{69AE7E00-4A03-4A58-ACF9-B9258BAA56B5}"/>
+                <a16:creationId xmlns:a16="http://schemas.microsoft.com/office/drawing/2014/main" id="{55842B33-BD7E-4D83-8554-B0DC57D8B724}"/>
               </a:ext>
             </a:extLst>
           </p:cNvPr>
@@ -5938,7 +5938,7 @@
           <p:cNvPr id="13" name="lane-detail-x402">
             <a:extLst xmlns:a="http://schemas.openxmlformats.org/drawingml/2006/main">
               <a:ext uri="{FF2B5EF4-FFF2-40B4-BE49-F238E27FC236}">
-                <a16:creationId xmlns:a16="http://schemas.microsoft.com/office/drawing/2014/main" id="{A24DDD5B-03D0-4713-99A4-45BCC203F1E8}"/>
+                <a16:creationId xmlns:a16="http://schemas.microsoft.com/office/drawing/2014/main" id="{462A2484-B9D0-4E5D-A45D-B56618969535}"/>
               </a:ext>
             </a:extLst>
           </p:cNvPr>
@@ -5983,7 +5983,7 @@
           <p:cNvPr id="14" name="flow-arrow">
             <a:extLst xmlns:a="http://schemas.openxmlformats.org/drawingml/2006/main">
               <a:ext uri="{FF2B5EF4-FFF2-40B4-BE49-F238E27FC236}">
-                <a16:creationId xmlns:a16="http://schemas.microsoft.com/office/drawing/2014/main" id="{FB9C62F9-F318-4DC9-8B0F-238081F656F7}"/>
+                <a16:creationId xmlns:a16="http://schemas.microsoft.com/office/drawing/2014/main" id="{D0C0BA72-BA2E-42DA-9E39-CF51E65DE4A1}"/>
               </a:ext>
             </a:extLst>
           </p:cNvPr>
@@ -6028,7 +6028,7 @@
           <p:cNvPr id="15" name="">
             <a:extLst xmlns:a="http://schemas.openxmlformats.org/drawingml/2006/main">
               <a:ext uri="{FF2B5EF4-FFF2-40B4-BE49-F238E27FC236}">
-                <a16:creationId xmlns:a16="http://schemas.microsoft.com/office/drawing/2014/main" id="{EC1C05C2-C0A8-4376-B21C-641214A0B718}"/>
+                <a16:creationId xmlns:a16="http://schemas.microsoft.com/office/drawing/2014/main" id="{705BD517-6FE5-4D1C-AB36-767AF88B6B80}"/>
               </a:ext>
             </a:extLst>
           </p:cNvPr>
@@ -6061,7 +6061,7 @@
           <p:cNvPr id="16" name="lane-label-Gateway">
             <a:extLst xmlns:a="http://schemas.openxmlformats.org/drawingml/2006/main">
               <a:ext uri="{FF2B5EF4-FFF2-40B4-BE49-F238E27FC236}">
-                <a16:creationId xmlns:a16="http://schemas.microsoft.com/office/drawing/2014/main" id="{38ABCBDF-20EE-48D8-9A79-2B52505EE522}"/>
+                <a16:creationId xmlns:a16="http://schemas.microsoft.com/office/drawing/2014/main" id="{6C229977-5C88-4135-82F2-0C3F6A3BB8B5}"/>
               </a:ext>
             </a:extLst>
           </p:cNvPr>
@@ -6106,7 +6106,7 @@
           <p:cNvPr id="17" name="">
             <a:extLst xmlns:a="http://schemas.openxmlformats.org/drawingml/2006/main">
               <a:ext uri="{FF2B5EF4-FFF2-40B4-BE49-F238E27FC236}">
-                <a16:creationId xmlns:a16="http://schemas.microsoft.com/office/drawing/2014/main" id="{D78E67E9-CF22-4E4E-A162-9D1B5C75950F}"/>
+                <a16:creationId xmlns:a16="http://schemas.microsoft.com/office/drawing/2014/main" id="{E892188A-14FE-4C7F-9939-EE310CBE6EB7}"/>
               </a:ext>
             </a:extLst>
           </p:cNvPr>
@@ -6139,7 +6139,7 @@
           <p:cNvPr id="18" name="lane-detail-Gateway">
             <a:extLst xmlns:a="http://schemas.openxmlformats.org/drawingml/2006/main">
               <a:ext uri="{FF2B5EF4-FFF2-40B4-BE49-F238E27FC236}">
-                <a16:creationId xmlns:a16="http://schemas.microsoft.com/office/drawing/2014/main" id="{FADF4259-803B-4E54-B5FB-E77666450908}"/>
+                <a16:creationId xmlns:a16="http://schemas.microsoft.com/office/drawing/2014/main" id="{F12ADD3B-F175-4280-9F00-F2C3B0816F99}"/>
               </a:ext>
             </a:extLst>
           </p:cNvPr>
@@ -6184,7 +6184,7 @@
           <p:cNvPr id="19" name="flow-arrow">
             <a:extLst xmlns:a="http://schemas.openxmlformats.org/drawingml/2006/main">
               <a:ext uri="{FF2B5EF4-FFF2-40B4-BE49-F238E27FC236}">
-                <a16:creationId xmlns:a16="http://schemas.microsoft.com/office/drawing/2014/main" id="{F24AB604-4EF7-4733-AF8F-849B5B9F4A5B}"/>
+                <a16:creationId xmlns:a16="http://schemas.microsoft.com/office/drawing/2014/main" id="{FBC70BF8-D876-44CB-B45D-C12D2967D839}"/>
               </a:ext>
             </a:extLst>
           </p:cNvPr>
@@ -6229,7 +6229,7 @@
           <p:cNvPr id="20" name="">
             <a:extLst xmlns:a="http://schemas.openxmlformats.org/drawingml/2006/main">
               <a:ext uri="{FF2B5EF4-FFF2-40B4-BE49-F238E27FC236}">
-                <a16:creationId xmlns:a16="http://schemas.microsoft.com/office/drawing/2014/main" id="{F055A3D2-774D-4A53-B1F1-41CC41032D34}"/>
+                <a16:creationId xmlns:a16="http://schemas.microsoft.com/office/drawing/2014/main" id="{94165449-1146-42B8-B5E5-09F134529584}"/>
               </a:ext>
             </a:extLst>
           </p:cNvPr>
@@ -6262,7 +6262,7 @@
           <p:cNvPr id="21" name="lane-label-Provider">
             <a:extLst xmlns:a="http://schemas.openxmlformats.org/drawingml/2006/main">
               <a:ext uri="{FF2B5EF4-FFF2-40B4-BE49-F238E27FC236}">
-                <a16:creationId xmlns:a16="http://schemas.microsoft.com/office/drawing/2014/main" id="{50AA43F8-D873-4C74-A196-D5F4306C6D18}"/>
+                <a16:creationId xmlns:a16="http://schemas.microsoft.com/office/drawing/2014/main" id="{C65FEC6B-67C5-44E7-A8ED-F2193D699C02}"/>
               </a:ext>
             </a:extLst>
           </p:cNvPr>
@@ -6307,7 +6307,7 @@
           <p:cNvPr id="22" name="">
             <a:extLst xmlns:a="http://schemas.openxmlformats.org/drawingml/2006/main">
               <a:ext uri="{FF2B5EF4-FFF2-40B4-BE49-F238E27FC236}">
-                <a16:creationId xmlns:a16="http://schemas.microsoft.com/office/drawing/2014/main" id="{7D58A5B1-A70B-4EFA-B8E8-DF25B968A83F}"/>
+                <a16:creationId xmlns:a16="http://schemas.microsoft.com/office/drawing/2014/main" id="{C6BFC9F8-DAA1-4A68-B8E3-5506D39E55F7}"/>
               </a:ext>
             </a:extLst>
           </p:cNvPr>
@@ -6340,7 +6340,7 @@
           <p:cNvPr id="23" name="lane-detail-Provider">
             <a:extLst xmlns:a="http://schemas.openxmlformats.org/drawingml/2006/main">
               <a:ext uri="{FF2B5EF4-FFF2-40B4-BE49-F238E27FC236}">
-                <a16:creationId xmlns:a16="http://schemas.microsoft.com/office/drawing/2014/main" id="{E4F86878-C3E0-4C90-8972-4AADB6D37FDE}"/>
+                <a16:creationId xmlns:a16="http://schemas.microsoft.com/office/drawing/2014/main" id="{53A971F3-FF9F-49A1-8D08-4A59DA11CDA7}"/>
               </a:ext>
             </a:extLst>
           </p:cNvPr>
@@ -6385,7 +6385,7 @@
           <p:cNvPr id="24" name="flow-arrow">
             <a:extLst xmlns:a="http://schemas.openxmlformats.org/drawingml/2006/main">
               <a:ext uri="{FF2B5EF4-FFF2-40B4-BE49-F238E27FC236}">
-                <a16:creationId xmlns:a16="http://schemas.microsoft.com/office/drawing/2014/main" id="{D2612F6A-E3A6-4975-A9CF-8EF812D4ED85}"/>
+                <a16:creationId xmlns:a16="http://schemas.microsoft.com/office/drawing/2014/main" id="{E8FB6BD3-A8FF-4230-B9BA-02788116612B}"/>
               </a:ext>
             </a:extLst>
           </p:cNvPr>
@@ -6430,7 +6430,7 @@
           <p:cNvPr id="25" name="">
             <a:extLst xmlns:a="http://schemas.openxmlformats.org/drawingml/2006/main">
               <a:ext uri="{FF2B5EF4-FFF2-40B4-BE49-F238E27FC236}">
-                <a16:creationId xmlns:a16="http://schemas.microsoft.com/office/drawing/2014/main" id="{3A4C2E74-2B3C-46F7-8947-0076519D247C}"/>
+                <a16:creationId xmlns:a16="http://schemas.microsoft.com/office/drawing/2014/main" id="{5ED50915-A228-4B64-B34A-1893547B9067}"/>
               </a:ext>
             </a:extLst>
           </p:cNvPr>
@@ -6463,7 +6463,7 @@
           <p:cNvPr id="26" name="lane-label-Arc">
             <a:extLst xmlns:a="http://schemas.openxmlformats.org/drawingml/2006/main">
               <a:ext uri="{FF2B5EF4-FFF2-40B4-BE49-F238E27FC236}">
-                <a16:creationId xmlns:a16="http://schemas.microsoft.com/office/drawing/2014/main" id="{93CB446E-4BBB-4055-8848-844186404B95}"/>
+                <a16:creationId xmlns:a16="http://schemas.microsoft.com/office/drawing/2014/main" id="{916B3DD6-5BEF-4EA8-8023-8EF13FC2FA1C}"/>
               </a:ext>
             </a:extLst>
           </p:cNvPr>
@@ -6508,7 +6508,7 @@
           <p:cNvPr id="27" name="">
             <a:extLst xmlns:a="http://schemas.openxmlformats.org/drawingml/2006/main">
               <a:ext uri="{FF2B5EF4-FFF2-40B4-BE49-F238E27FC236}">
-                <a16:creationId xmlns:a16="http://schemas.microsoft.com/office/drawing/2014/main" id="{7568DB1A-9624-4293-A561-76DB011D536D}"/>
+                <a16:creationId xmlns:a16="http://schemas.microsoft.com/office/drawing/2014/main" id="{5B6C02B1-9044-4E06-8031-F03442DD0938}"/>
               </a:ext>
             </a:extLst>
           </p:cNvPr>
@@ -6541,7 +6541,7 @@
           <p:cNvPr id="28" name="lane-detail-Arc">
             <a:extLst xmlns:a="http://schemas.openxmlformats.org/drawingml/2006/main">
               <a:ext uri="{FF2B5EF4-FFF2-40B4-BE49-F238E27FC236}">
-                <a16:creationId xmlns:a16="http://schemas.microsoft.com/office/drawing/2014/main" id="{3D482C85-4532-4C59-A324-4D4DBE054A4D}"/>
+                <a16:creationId xmlns:a16="http://schemas.microsoft.com/office/drawing/2014/main" id="{A246666C-9B1E-4282-BAC1-054C0B71CEBD}"/>
               </a:ext>
             </a:extLst>
           </p:cNvPr>
@@ -6586,7 +6586,7 @@
           <p:cNvPr id="29" name="payment-flow-proof-note">
             <a:extLst xmlns:a="http://schemas.openxmlformats.org/drawingml/2006/main">
               <a:ext uri="{FF2B5EF4-FFF2-40B4-BE49-F238E27FC236}">
-                <a16:creationId xmlns:a16="http://schemas.microsoft.com/office/drawing/2014/main" id="{20BC9BC1-7395-4122-B8C7-0701D0923AE8}"/>
+                <a16:creationId xmlns:a16="http://schemas.microsoft.com/office/drawing/2014/main" id="{77BCD088-6233-4BF1-A45D-EE95787E1A72}"/>
               </a:ext>
             </a:extLst>
           </p:cNvPr>
@@ -6621,7 +6621,7 @@
           <p:cNvPr id="30" name="watch-label">
             <a:extLst xmlns:a="http://schemas.openxmlformats.org/drawingml/2006/main">
               <a:ext uri="{FF2B5EF4-FFF2-40B4-BE49-F238E27FC236}">
-                <a16:creationId xmlns:a16="http://schemas.microsoft.com/office/drawing/2014/main" id="{2D7EDDD4-97BF-4B72-83EE-FB310F6E6A0A}"/>
+                <a16:creationId xmlns:a16="http://schemas.microsoft.com/office/drawing/2014/main" id="{13653694-C3CE-434A-BB3E-1BE0C979926F}"/>
               </a:ext>
             </a:extLst>
           </p:cNvPr>
@@ -6666,7 +6666,7 @@
           <p:cNvPr id="31" name="watch-copy">
             <a:extLst xmlns:a="http://schemas.openxmlformats.org/drawingml/2006/main">
               <a:ext uri="{FF2B5EF4-FFF2-40B4-BE49-F238E27FC236}">
-                <a16:creationId xmlns:a16="http://schemas.microsoft.com/office/drawing/2014/main" id="{F9600ACE-2725-4E90-9809-F14AE40C84BF}"/>
+                <a16:creationId xmlns:a16="http://schemas.microsoft.com/office/drawing/2014/main" id="{50ED0D87-2A5D-4311-BF4F-B4D9F0584577}"/>
               </a:ext>
             </a:extLst>
           </p:cNvPr>
@@ -6711,7 +6711,7 @@
           <p:cNvPr id="32" name="contract-function">
             <a:extLst xmlns:a="http://schemas.openxmlformats.org/drawingml/2006/main">
               <a:ext uri="{FF2B5EF4-FFF2-40B4-BE49-F238E27FC236}">
-                <a16:creationId xmlns:a16="http://schemas.microsoft.com/office/drawing/2014/main" id="{6D34C012-85FA-438F-9121-1FC960F5B439}"/>
+                <a16:creationId xmlns:a16="http://schemas.microsoft.com/office/drawing/2014/main" id="{68444B85-86EA-435D-857A-3A3A5482FE05}"/>
               </a:ext>
             </a:extLst>
           </p:cNvPr>
@@ -6756,7 +6756,7 @@
           <p:cNvPr id="33" name="footer-left">
             <a:extLst xmlns:a="http://schemas.openxmlformats.org/drawingml/2006/main">
               <a:ext uri="{FF2B5EF4-FFF2-40B4-BE49-F238E27FC236}">
-                <a16:creationId xmlns:a16="http://schemas.microsoft.com/office/drawing/2014/main" id="{B7F11CF0-3797-4FED-AD1A-84A963CE724B}"/>
+                <a16:creationId xmlns:a16="http://schemas.microsoft.com/office/drawing/2014/main" id="{12B1C198-8674-45FA-9D44-D266314AC6FE}"/>
               </a:ext>
             </a:extLst>
           </p:cNvPr>
@@ -6801,7 +6801,7 @@
           <p:cNvPr id="34" name="footer-right">
             <a:extLst xmlns:a="http://schemas.openxmlformats.org/drawingml/2006/main">
               <a:ext uri="{FF2B5EF4-FFF2-40B4-BE49-F238E27FC236}">
-                <a16:creationId xmlns:a16="http://schemas.microsoft.com/office/drawing/2014/main" id="{491F8188-91DF-45E8-B5E8-F53FED7F02CA}"/>
+                <a16:creationId xmlns:a16="http://schemas.microsoft.com/office/drawing/2014/main" id="{4FF72E96-D364-4FF5-B206-AF2382455914}"/>
               </a:ext>
             </a:extLst>
           </p:cNvPr>
@@ -6844,7 +6844,7 @@
     </p:spTree>
     <p:extLst>
       <p:ext uri="{BB962C8B-B14F-4D97-AF65-F5344CB8AC3E}">
-        <p14:creationId xmlns:p14="http://schemas.microsoft.com/office/powerpoint/2010/main" val="1297708329"/>
+        <p14:creationId xmlns:p14="http://schemas.microsoft.com/office/powerpoint/2010/main" val="1495746510"/>
       </p:ext>
     </p:extLst>
   </p:cSld>
@@ -6868,7 +6868,7 @@
           <p:cNvPr id="1" name="slide-background">
             <a:extLst xmlns:a="http://schemas.openxmlformats.org/drawingml/2006/main">
               <a:ext uri="{FF2B5EF4-FFF2-40B4-BE49-F238E27FC236}">
-                <a16:creationId xmlns:a16="http://schemas.microsoft.com/office/drawing/2014/main" id="{EE6460C8-0584-4C4C-BA9C-2F3AEFACBF13}"/>
+                <a16:creationId xmlns:a16="http://schemas.microsoft.com/office/drawing/2014/main" id="{74F1B6D4-AE91-4409-B43B-F32351FD7962}"/>
               </a:ext>
             </a:extLst>
           </p:cNvPr>
@@ -6901,7 +6901,7 @@
           <p:cNvPr id="2" name="kicker">
             <a:extLst xmlns:a="http://schemas.openxmlformats.org/drawingml/2006/main">
               <a:ext uri="{FF2B5EF4-FFF2-40B4-BE49-F238E27FC236}">
-                <a16:creationId xmlns:a16="http://schemas.microsoft.com/office/drawing/2014/main" id="{362FD533-DC47-4E61-9A78-1C75D551F710}"/>
+                <a16:creationId xmlns:a16="http://schemas.microsoft.com/office/drawing/2014/main" id="{AF41E46A-F5EA-47F7-A32D-C6294E59E24A}"/>
               </a:ext>
             </a:extLst>
           </p:cNvPr>
@@ -6946,7 +6946,7 @@
           <p:cNvPr id="3" name="slide-title">
             <a:extLst xmlns:a="http://schemas.openxmlformats.org/drawingml/2006/main">
               <a:ext uri="{FF2B5EF4-FFF2-40B4-BE49-F238E27FC236}">
-                <a16:creationId xmlns:a16="http://schemas.microsoft.com/office/drawing/2014/main" id="{EF80CC63-9718-4C66-8733-1B33FA77E52E}"/>
+                <a16:creationId xmlns:a16="http://schemas.microsoft.com/office/drawing/2014/main" id="{60345466-477D-4361-AD7F-45F4D65C3F8E}"/>
               </a:ext>
             </a:extLst>
           </p:cNvPr>
@@ -6981,7 +6981,7 @@
                   <a:srgbClr val="0B1220"/>
                 </a:solidFill>
               </a:rPr>
-              <a:t>Proof package for the judges</a:t>
+              <a:t>Agentic commerce with guardrails</a:t>
             </a:r>
           </a:p>
         </p:txBody>
@@ -6991,7 +6991,7 @@
           <p:cNvPr id="4" name="slide-subtitle">
             <a:extLst xmlns:a="http://schemas.openxmlformats.org/drawingml/2006/main">
               <a:ext uri="{FF2B5EF4-FFF2-40B4-BE49-F238E27FC236}">
-                <a16:creationId xmlns:a16="http://schemas.microsoft.com/office/drawing/2014/main" id="{B8934AA6-9159-4BB4-A781-6B7B6C84C10B}"/>
+                <a16:creationId xmlns:a16="http://schemas.microsoft.com/office/drawing/2014/main" id="{188C25B6-01AC-4C3D-B11D-AC8B606FE9ED}"/>
               </a:ext>
             </a:extLst>
           </p:cNvPr>
@@ -7026,119 +7026,119 @@
                   <a:srgbClr val="596473"/>
                 </a:solidFill>
               </a:rPr>
-              <a:t>A short video can show the live app, Circle flow, Arc explorer proof, and verifier commands.</a:t>
-            </a:r>
-          </a:p>
-        </p:txBody>
-      </p:sp>
-      <p:sp>
-        <p:nvSpPr>
-          <p:cNvPr id="5" name="proof-claim">
-            <a:extLst xmlns:a="http://schemas.openxmlformats.org/drawingml/2006/main">
-              <a:ext uri="{FF2B5EF4-FFF2-40B4-BE49-F238E27FC236}">
-                <a16:creationId xmlns:a16="http://schemas.microsoft.com/office/drawing/2014/main" id="{5F81625E-7DC4-443C-ABA8-1C44CB1B7B6F}"/>
-              </a:ext>
-            </a:extLst>
-          </p:cNvPr>
-          <p:cNvSpPr>
-            <a:spLocks xmlns:a="http://schemas.openxmlformats.org/drawingml/2006/main" noGrp="1"/>
-          </p:cNvSpPr>
-          <p:nvPr/>
-        </p:nvSpPr>
-        <p:spPr>
-          <a:xfrm xmlns:a="http://schemas.openxmlformats.org/drawingml/2006/main">
-            <a:off x="819150" y="4191000"/>
-            <a:ext cx="8362950" cy="533400"/>
-          </a:xfrm>
-          <a:prstGeom xmlns:a="http://schemas.openxmlformats.org/drawingml/2006/main" prst="rect">
-            <a:avLst/>
-          </a:prstGeom>
-        </p:spPr>
-        <p:txBody>
-          <a:bodyPr xmlns:a="http://schemas.openxmlformats.org/drawingml/2006/main" lIns="0" tIns="0" rIns="0" bIns="0"/>
-          <a:lstStyle xmlns:a="http://schemas.openxmlformats.org/drawingml/2006/main"/>
-          <a:p xmlns:a="http://schemas.openxmlformats.org/drawingml/2006/main">
-            <a:pPr>
-              <a:defRPr sz="4125" b="1">
+              <a:t>A reusable payment pattern for AI agents that need to buy many small paid facts safely.</a:t>
+            </a:r>
+          </a:p>
+        </p:txBody>
+      </p:sp>
+      <p:sp>
+        <p:nvSpPr>
+          <p:cNvPr id="5" name="closing-claim">
+            <a:extLst xmlns:a="http://schemas.openxmlformats.org/drawingml/2006/main">
+              <a:ext uri="{FF2B5EF4-FFF2-40B4-BE49-F238E27FC236}">
+                <a16:creationId xmlns:a16="http://schemas.microsoft.com/office/drawing/2014/main" id="{134D3A10-925B-4AF4-901B-3670664B0C09}"/>
+              </a:ext>
+            </a:extLst>
+          </p:cNvPr>
+          <p:cNvSpPr>
+            <a:spLocks xmlns:a="http://schemas.openxmlformats.org/drawingml/2006/main" noGrp="1"/>
+          </p:cNvSpPr>
+          <p:nvPr/>
+        </p:nvSpPr>
+        <p:spPr>
+          <a:xfrm xmlns:a="http://schemas.openxmlformats.org/drawingml/2006/main">
+            <a:off x="819150" y="3333750"/>
+            <a:ext cx="8667750" cy="1104900"/>
+          </a:xfrm>
+          <a:prstGeom xmlns:a="http://schemas.openxmlformats.org/drawingml/2006/main" prst="rect">
+            <a:avLst/>
+          </a:prstGeom>
+        </p:spPr>
+        <p:txBody>
+          <a:bodyPr xmlns:a="http://schemas.openxmlformats.org/drawingml/2006/main" lIns="0" tIns="0" rIns="0" bIns="0"/>
+          <a:lstStyle xmlns:a="http://schemas.openxmlformats.org/drawingml/2006/main"/>
+          <a:p xmlns:a="http://schemas.openxmlformats.org/drawingml/2006/main">
+            <a:pPr>
+              <a:defRPr sz="4350" b="1">
                 <a:solidFill>
                   <a:srgbClr val="0B1220"/>
                 </a:solidFill>
               </a:defRPr>
             </a:pPr>
             <a:r>
-              <a:rPr sz="4125" b="1">
+              <a:rPr sz="4350" b="1">
                 <a:solidFill>
                   <a:srgbClr val="0B1220"/>
                 </a:solidFill>
               </a:rPr>
-              <a:t>Live, deployed, and verifier-backed.</a:t>
-            </a:r>
-          </a:p>
-        </p:txBody>
-      </p:sp>
-      <p:sp>
-        <p:nvSpPr>
-          <p:cNvPr id="6" name="proof-copy">
-            <a:extLst xmlns:a="http://schemas.openxmlformats.org/drawingml/2006/main">
-              <a:ext uri="{FF2B5EF4-FFF2-40B4-BE49-F238E27FC236}">
-                <a16:creationId xmlns:a16="http://schemas.microsoft.com/office/drawing/2014/main" id="{4F06F43A-16B3-467B-BF5B-7FFAC1015529}"/>
-              </a:ext>
-            </a:extLst>
-          </p:cNvPr>
-          <p:cNvSpPr>
-            <a:spLocks xmlns:a="http://schemas.openxmlformats.org/drawingml/2006/main" noGrp="1"/>
-          </p:cNvSpPr>
-          <p:nvPr/>
-        </p:nvSpPr>
-        <p:spPr>
-          <a:xfrm xmlns:a="http://schemas.openxmlformats.org/drawingml/2006/main">
-            <a:off x="819150" y="4953000"/>
-            <a:ext cx="8362950" cy="781050"/>
-          </a:xfrm>
-          <a:prstGeom xmlns:a="http://schemas.openxmlformats.org/drawingml/2006/main" prst="rect">
-            <a:avLst/>
-          </a:prstGeom>
-        </p:spPr>
-        <p:txBody>
-          <a:bodyPr xmlns:a="http://schemas.openxmlformats.org/drawingml/2006/main" lIns="0" tIns="0" rIns="0" bIns="0"/>
-          <a:lstStyle xmlns:a="http://schemas.openxmlformats.org/drawingml/2006/main"/>
-          <a:p xmlns:a="http://schemas.openxmlformats.org/drawingml/2006/main">
-            <a:pPr>
-              <a:defRPr sz="2025">
+              <a:t>Let agents spend without letting spend go dark.</a:t>
+            </a:r>
+          </a:p>
+        </p:txBody>
+      </p:sp>
+      <p:sp>
+        <p:nvSpPr>
+          <p:cNvPr id="6" name="closing-copy">
+            <a:extLst xmlns:a="http://schemas.openxmlformats.org/drawingml/2006/main">
+              <a:ext uri="{FF2B5EF4-FFF2-40B4-BE49-F238E27FC236}">
+                <a16:creationId xmlns:a16="http://schemas.microsoft.com/office/drawing/2014/main" id="{C4017FB1-9672-49B4-BA23-991F97B51311}"/>
+              </a:ext>
+            </a:extLst>
+          </p:cNvPr>
+          <p:cNvSpPr>
+            <a:spLocks xmlns:a="http://schemas.openxmlformats.org/drawingml/2006/main" noGrp="1"/>
+          </p:cNvSpPr>
+          <p:nvPr/>
+        </p:nvSpPr>
+        <p:spPr>
+          <a:xfrm xmlns:a="http://schemas.openxmlformats.org/drawingml/2006/main">
+            <a:off x="819150" y="4686300"/>
+            <a:ext cx="8667750" cy="533400"/>
+          </a:xfrm>
+          <a:prstGeom xmlns:a="http://schemas.openxmlformats.org/drawingml/2006/main" prst="rect">
+            <a:avLst/>
+          </a:prstGeom>
+        </p:spPr>
+        <p:txBody>
+          <a:bodyPr xmlns:a="http://schemas.openxmlformats.org/drawingml/2006/main" lIns="0" tIns="0" rIns="0" bIns="0"/>
+          <a:lstStyle xmlns:a="http://schemas.openxmlformats.org/drawingml/2006/main"/>
+          <a:p xmlns:a="http://schemas.openxmlformats.org/drawingml/2006/main">
+            <a:pPr>
+              <a:defRPr sz="2100">
                 <a:solidFill>
                   <a:srgbClr val="596473"/>
                 </a:solidFill>
               </a:defRPr>
             </a:pPr>
             <a:r>
-              <a:rPr sz="2025">
+              <a:rPr sz="2100">
                 <a:solidFill>
                   <a:srgbClr val="596473"/>
                 </a:solidFill>
               </a:rPr>
-              <a:t>The submission is not just a mock UI: the repo includes proof scripts that read Arc Testnet and confirm bytecode, policy caps, receipt replay protection, provider spend, and digest equality.</a:t>
-            </a:r>
-          </a:p>
-        </p:txBody>
-      </p:sp>
-      <p:sp>
-        <p:nvSpPr>
-          <p:cNvPr id="7" name="">
-            <a:extLst xmlns:a="http://schemas.openxmlformats.org/drawingml/2006/main">
-              <a:ext uri="{FF2B5EF4-FFF2-40B4-BE49-F238E27FC236}">
-                <a16:creationId xmlns:a16="http://schemas.microsoft.com/office/drawing/2014/main" id="{77CEDB77-9EB7-4B22-8791-8A0D91517FF4}"/>
-              </a:ext>
-            </a:extLst>
-          </p:cNvPr>
-          <p:cNvSpPr>
-            <a:spLocks xmlns:a="http://schemas.openxmlformats.org/drawingml/2006/main" noGrp="1"/>
-          </p:cNvSpPr>
-          <p:nvPr/>
-        </p:nvSpPr>
-        <p:spPr>
-          <a:xfrm xmlns:a="http://schemas.openxmlformats.org/drawingml/2006/main">
-            <a:off x="819150" y="5981700"/>
-            <a:ext cx="133350" cy="133350"/>
+              <a:t>PennyPilot turns paid API calls into governed agent procurement: a user sets policy, the agent buys only approved facts, and every receipt remains traceable.</a:t>
+            </a:r>
+          </a:p>
+        </p:txBody>
+      </p:sp>
+      <p:sp>
+        <p:nvSpPr>
+          <p:cNvPr id="7" name="accent-rule">
+            <a:extLst xmlns:a="http://schemas.openxmlformats.org/drawingml/2006/main">
+              <a:ext uri="{FF2B5EF4-FFF2-40B4-BE49-F238E27FC236}">
+                <a16:creationId xmlns:a16="http://schemas.microsoft.com/office/drawing/2014/main" id="{6CDD1736-C8D7-487C-BCE8-19536582E248}"/>
+              </a:ext>
+            </a:extLst>
+          </p:cNvPr>
+          <p:cNvSpPr>
+            <a:spLocks xmlns:a="http://schemas.openxmlformats.org/drawingml/2006/main" noGrp="1"/>
+          </p:cNvSpPr>
+          <p:nvPr/>
+        </p:nvSpPr>
+        <p:spPr>
+          <a:xfrm xmlns:a="http://schemas.openxmlformats.org/drawingml/2006/main">
+            <a:off x="819150" y="5467350"/>
+            <a:ext cx="2190750" cy="47625"/>
           </a:xfrm>
           <a:prstGeom xmlns:a="http://schemas.openxmlformats.org/drawingml/2006/main" prst="rect">
             <a:avLst/>
@@ -7156,112 +7156,112 @@
       </p:sp>
       <p:sp>
         <p:nvSpPr>
-          <p:cNvPr id="8" name="proof-label-Live app">
-            <a:extLst xmlns:a="http://schemas.openxmlformats.org/drawingml/2006/main">
-              <a:ext uri="{FF2B5EF4-FFF2-40B4-BE49-F238E27FC236}">
-                <a16:creationId xmlns:a16="http://schemas.microsoft.com/office/drawing/2014/main" id="{CE809A21-301F-4572-B29D-A43544294847}"/>
-              </a:ext>
-            </a:extLst>
-          </p:cNvPr>
-          <p:cNvSpPr>
-            <a:spLocks xmlns:a="http://schemas.openxmlformats.org/drawingml/2006/main" noGrp="1"/>
-          </p:cNvSpPr>
-          <p:nvPr/>
-        </p:nvSpPr>
-        <p:spPr>
-          <a:xfrm xmlns:a="http://schemas.openxmlformats.org/drawingml/2006/main">
-            <a:off x="1104900" y="5943600"/>
-            <a:ext cx="2000250" cy="190500"/>
-          </a:xfrm>
-          <a:prstGeom xmlns:a="http://schemas.openxmlformats.org/drawingml/2006/main" prst="rect">
-            <a:avLst/>
-          </a:prstGeom>
-        </p:spPr>
-        <p:txBody>
-          <a:bodyPr xmlns:a="http://schemas.openxmlformats.org/drawingml/2006/main" lIns="0" tIns="0" rIns="0" bIns="0"/>
-          <a:lstStyle xmlns:a="http://schemas.openxmlformats.org/drawingml/2006/main"/>
-          <a:p xmlns:a="http://schemas.openxmlformats.org/drawingml/2006/main">
-            <a:pPr>
-              <a:defRPr sz="1500" b="1">
+          <p:cNvPr id="8" name="statement-title-Controlled">
+            <a:extLst xmlns:a="http://schemas.openxmlformats.org/drawingml/2006/main">
+              <a:ext uri="{FF2B5EF4-FFF2-40B4-BE49-F238E27FC236}">
+                <a16:creationId xmlns:a16="http://schemas.microsoft.com/office/drawing/2014/main" id="{70A85C18-E7CD-4C5A-8803-FF069D10157C}"/>
+              </a:ext>
+            </a:extLst>
+          </p:cNvPr>
+          <p:cNvSpPr>
+            <a:spLocks xmlns:a="http://schemas.openxmlformats.org/drawingml/2006/main" noGrp="1"/>
+          </p:cNvSpPr>
+          <p:nvPr/>
+        </p:nvSpPr>
+        <p:spPr>
+          <a:xfrm xmlns:a="http://schemas.openxmlformats.org/drawingml/2006/main">
+            <a:off x="819150" y="5676900"/>
+            <a:ext cx="4191000" cy="361950"/>
+          </a:xfrm>
+          <a:prstGeom xmlns:a="http://schemas.openxmlformats.org/drawingml/2006/main" prst="rect">
+            <a:avLst/>
+          </a:prstGeom>
+        </p:spPr>
+        <p:txBody>
+          <a:bodyPr xmlns:a="http://schemas.openxmlformats.org/drawingml/2006/main" lIns="0" tIns="0" rIns="0" bIns="0"/>
+          <a:lstStyle xmlns:a="http://schemas.openxmlformats.org/drawingml/2006/main"/>
+          <a:p xmlns:a="http://schemas.openxmlformats.org/drawingml/2006/main">
+            <a:pPr>
+              <a:defRPr sz="2850" b="1">
                 <a:solidFill>
                   <a:srgbClr val="0B1220"/>
                 </a:solidFill>
               </a:defRPr>
             </a:pPr>
             <a:r>
-              <a:rPr sz="1500" b="1">
+              <a:rPr sz="2850" b="1">
                 <a:solidFill>
                   <a:srgbClr val="0B1220"/>
                 </a:solidFill>
               </a:rPr>
-              <a:t>Live app</a:t>
-            </a:r>
-          </a:p>
-        </p:txBody>
-      </p:sp>
-      <p:sp>
-        <p:nvSpPr>
-          <p:cNvPr id="9" name="proof-value-Live app">
-            <a:extLst xmlns:a="http://schemas.openxmlformats.org/drawingml/2006/main">
-              <a:ext uri="{FF2B5EF4-FFF2-40B4-BE49-F238E27FC236}">
-                <a16:creationId xmlns:a16="http://schemas.microsoft.com/office/drawing/2014/main" id="{541B8D2F-A032-493B-B557-F158EDD619E8}"/>
-              </a:ext>
-            </a:extLst>
-          </p:cNvPr>
-          <p:cNvSpPr>
-            <a:spLocks xmlns:a="http://schemas.openxmlformats.org/drawingml/2006/main" noGrp="1"/>
-          </p:cNvSpPr>
-          <p:nvPr/>
-        </p:nvSpPr>
-        <p:spPr>
-          <a:xfrm xmlns:a="http://schemas.openxmlformats.org/drawingml/2006/main">
-            <a:off x="3257550" y="5943600"/>
-            <a:ext cx="5924550" cy="190500"/>
-          </a:xfrm>
-          <a:prstGeom xmlns:a="http://schemas.openxmlformats.org/drawingml/2006/main" prst="rect">
-            <a:avLst/>
-          </a:prstGeom>
-        </p:spPr>
-        <p:txBody>
-          <a:bodyPr xmlns:a="http://schemas.openxmlformats.org/drawingml/2006/main" lIns="0" tIns="0" rIns="0" bIns="0"/>
-          <a:lstStyle xmlns:a="http://schemas.openxmlformats.org/drawingml/2006/main"/>
-          <a:p xmlns:a="http://schemas.openxmlformats.org/drawingml/2006/main">
-            <a:pPr>
-              <a:defRPr sz="1350">
-                <a:solidFill>
-                  <a:srgbClr val="384150"/>
-                </a:solidFill>
-              </a:defRPr>
-            </a:pPr>
-            <a:r>
-              <a:rPr sz="1350">
-                <a:solidFill>
-                  <a:srgbClr val="384150"/>
-                </a:solidFill>
-              </a:rPr>
-              <a:t>pennypilot-five.vercel.app</a:t>
-            </a:r>
-          </a:p>
-        </p:txBody>
-      </p:sp>
-      <p:sp>
-        <p:nvSpPr>
-          <p:cNvPr id="10" name="">
-            <a:extLst xmlns:a="http://schemas.openxmlformats.org/drawingml/2006/main">
-              <a:ext uri="{FF2B5EF4-FFF2-40B4-BE49-F238E27FC236}">
-                <a16:creationId xmlns:a16="http://schemas.microsoft.com/office/drawing/2014/main" id="{01A55F5F-DD8F-4441-870A-A647417CF560}"/>
-              </a:ext>
-            </a:extLst>
-          </p:cNvPr>
-          <p:cNvSpPr>
-            <a:spLocks xmlns:a="http://schemas.openxmlformats.org/drawingml/2006/main" noGrp="1"/>
-          </p:cNvSpPr>
-          <p:nvPr/>
-        </p:nvSpPr>
-        <p:spPr>
-          <a:xfrm xmlns:a="http://schemas.openxmlformats.org/drawingml/2006/main">
-            <a:off x="819150" y="6324600"/>
-            <a:ext cx="133350" cy="133350"/>
+              <a:t>Controlled</a:t>
+            </a:r>
+          </a:p>
+        </p:txBody>
+      </p:sp>
+      <p:sp>
+        <p:nvSpPr>
+          <p:cNvPr id="9" name="statement-body-Controlled">
+            <a:extLst xmlns:a="http://schemas.openxmlformats.org/drawingml/2006/main">
+              <a:ext uri="{FF2B5EF4-FFF2-40B4-BE49-F238E27FC236}">
+                <a16:creationId xmlns:a16="http://schemas.microsoft.com/office/drawing/2014/main" id="{BA10A649-45DD-4DAD-8573-EA39CDE788B4}"/>
+              </a:ext>
+            </a:extLst>
+          </p:cNvPr>
+          <p:cNvSpPr>
+            <a:spLocks xmlns:a="http://schemas.openxmlformats.org/drawingml/2006/main" noGrp="1"/>
+          </p:cNvSpPr>
+          <p:nvPr/>
+        </p:nvSpPr>
+        <p:spPr>
+          <a:xfrm xmlns:a="http://schemas.openxmlformats.org/drawingml/2006/main">
+            <a:off x="819150" y="6191250"/>
+            <a:ext cx="4191000" cy="457200"/>
+          </a:xfrm>
+          <a:prstGeom xmlns:a="http://schemas.openxmlformats.org/drawingml/2006/main" prst="rect">
+            <a:avLst/>
+          </a:prstGeom>
+        </p:spPr>
+        <p:txBody>
+          <a:bodyPr xmlns:a="http://schemas.openxmlformats.org/drawingml/2006/main" lIns="0" tIns="0" rIns="0" bIns="0"/>
+          <a:lstStyle xmlns:a="http://schemas.openxmlformats.org/drawingml/2006/main"/>
+          <a:p xmlns:a="http://schemas.openxmlformats.org/drawingml/2006/main">
+            <a:pPr>
+              <a:defRPr sz="1800">
+                <a:solidFill>
+                  <a:srgbClr val="596473"/>
+                </a:solidFill>
+              </a:defRPr>
+            </a:pPr>
+            <a:r>
+              <a:rPr sz="1800">
+                <a:solidFill>
+                  <a:srgbClr val="596473"/>
+                </a:solidFill>
+              </a:rPr>
+              <a:t>Budget, per-call cap, provider allowlist, and batch size are defined before spend.</a:t>
+            </a:r>
+          </a:p>
+        </p:txBody>
+      </p:sp>
+      <p:sp>
+        <p:nvSpPr>
+          <p:cNvPr id="10" name="accent-rule">
+            <a:extLst xmlns:a="http://schemas.openxmlformats.org/drawingml/2006/main">
+              <a:ext uri="{FF2B5EF4-FFF2-40B4-BE49-F238E27FC236}">
+                <a16:creationId xmlns:a16="http://schemas.microsoft.com/office/drawing/2014/main" id="{125F8D1C-4EC2-4A22-A0CE-25924C224FB5}"/>
+              </a:ext>
+            </a:extLst>
+          </p:cNvPr>
+          <p:cNvSpPr>
+            <a:spLocks xmlns:a="http://schemas.openxmlformats.org/drawingml/2006/main" noGrp="1"/>
+          </p:cNvSpPr>
+          <p:nvPr/>
+        </p:nvSpPr>
+        <p:spPr>
+          <a:xfrm xmlns:a="http://schemas.openxmlformats.org/drawingml/2006/main">
+            <a:off x="5314950" y="5467350"/>
+            <a:ext cx="2190750" cy="47625"/>
           </a:xfrm>
           <a:prstGeom xmlns:a="http://schemas.openxmlformats.org/drawingml/2006/main" prst="rect">
             <a:avLst/>
@@ -7279,112 +7279,483 @@
       </p:sp>
       <p:sp>
         <p:nvSpPr>
-          <p:cNvPr id="11" name="proof-label-GitHub">
-            <a:extLst xmlns:a="http://schemas.openxmlformats.org/drawingml/2006/main">
-              <a:ext uri="{FF2B5EF4-FFF2-40B4-BE49-F238E27FC236}">
-                <a16:creationId xmlns:a16="http://schemas.microsoft.com/office/drawing/2014/main" id="{2203513A-4F9C-4BE1-BB96-FA78B84FB954}"/>
-              </a:ext>
-            </a:extLst>
-          </p:cNvPr>
-          <p:cNvSpPr>
-            <a:spLocks xmlns:a="http://schemas.openxmlformats.org/drawingml/2006/main" noGrp="1"/>
-          </p:cNvSpPr>
-          <p:nvPr/>
-        </p:nvSpPr>
-        <p:spPr>
-          <a:xfrm xmlns:a="http://schemas.openxmlformats.org/drawingml/2006/main">
-            <a:off x="1104900" y="6305550"/>
-            <a:ext cx="2000250" cy="190500"/>
-          </a:xfrm>
-          <a:prstGeom xmlns:a="http://schemas.openxmlformats.org/drawingml/2006/main" prst="rect">
-            <a:avLst/>
-          </a:prstGeom>
-        </p:spPr>
-        <p:txBody>
-          <a:bodyPr xmlns:a="http://schemas.openxmlformats.org/drawingml/2006/main" lIns="0" tIns="0" rIns="0" bIns="0"/>
-          <a:lstStyle xmlns:a="http://schemas.openxmlformats.org/drawingml/2006/main"/>
-          <a:p xmlns:a="http://schemas.openxmlformats.org/drawingml/2006/main">
-            <a:pPr>
-              <a:defRPr sz="1500" b="1">
+          <p:cNvPr id="11" name="statement-title-API-native">
+            <a:extLst xmlns:a="http://schemas.openxmlformats.org/drawingml/2006/main">
+              <a:ext uri="{FF2B5EF4-FFF2-40B4-BE49-F238E27FC236}">
+                <a16:creationId xmlns:a16="http://schemas.microsoft.com/office/drawing/2014/main" id="{5E4AD49B-3155-4668-BE2D-8FE3C9AD18AF}"/>
+              </a:ext>
+            </a:extLst>
+          </p:cNvPr>
+          <p:cNvSpPr>
+            <a:spLocks xmlns:a="http://schemas.openxmlformats.org/drawingml/2006/main" noGrp="1"/>
+          </p:cNvSpPr>
+          <p:nvPr/>
+        </p:nvSpPr>
+        <p:spPr>
+          <a:xfrm xmlns:a="http://schemas.openxmlformats.org/drawingml/2006/main">
+            <a:off x="5314950" y="5676900"/>
+            <a:ext cx="4191000" cy="361950"/>
+          </a:xfrm>
+          <a:prstGeom xmlns:a="http://schemas.openxmlformats.org/drawingml/2006/main" prst="rect">
+            <a:avLst/>
+          </a:prstGeom>
+        </p:spPr>
+        <p:txBody>
+          <a:bodyPr xmlns:a="http://schemas.openxmlformats.org/drawingml/2006/main" lIns="0" tIns="0" rIns="0" bIns="0"/>
+          <a:lstStyle xmlns:a="http://schemas.openxmlformats.org/drawingml/2006/main"/>
+          <a:p xmlns:a="http://schemas.openxmlformats.org/drawingml/2006/main">
+            <a:pPr>
+              <a:defRPr sz="2850" b="1">
                 <a:solidFill>
                   <a:srgbClr val="0B1220"/>
                 </a:solidFill>
               </a:defRPr>
             </a:pPr>
             <a:r>
-              <a:rPr sz="1500" b="1">
+              <a:rPr sz="2850" b="1">
                 <a:solidFill>
                   <a:srgbClr val="0B1220"/>
                 </a:solidFill>
               </a:rPr>
-              <a:t>GitHub</a:t>
-            </a:r>
-          </a:p>
-        </p:txBody>
-      </p:sp>
-      <p:sp>
-        <p:nvSpPr>
-          <p:cNvPr id="12" name="proof-value-GitHub">
-            <a:extLst xmlns:a="http://schemas.openxmlformats.org/drawingml/2006/main">
-              <a:ext uri="{FF2B5EF4-FFF2-40B4-BE49-F238E27FC236}">
-                <a16:creationId xmlns:a16="http://schemas.microsoft.com/office/drawing/2014/main" id="{FBC2A2CE-8A25-4D09-AEA0-9865D04A1C94}"/>
-              </a:ext>
-            </a:extLst>
-          </p:cNvPr>
-          <p:cNvSpPr>
-            <a:spLocks xmlns:a="http://schemas.openxmlformats.org/drawingml/2006/main" noGrp="1"/>
-          </p:cNvSpPr>
-          <p:nvPr/>
-        </p:nvSpPr>
-        <p:spPr>
-          <a:xfrm xmlns:a="http://schemas.openxmlformats.org/drawingml/2006/main">
-            <a:off x="3257550" y="6305550"/>
-            <a:ext cx="5924550" cy="190500"/>
-          </a:xfrm>
-          <a:prstGeom xmlns:a="http://schemas.openxmlformats.org/drawingml/2006/main" prst="rect">
-            <a:avLst/>
-          </a:prstGeom>
-        </p:spPr>
-        <p:txBody>
-          <a:bodyPr xmlns:a="http://schemas.openxmlformats.org/drawingml/2006/main" lIns="0" tIns="0" rIns="0" bIns="0"/>
-          <a:lstStyle xmlns:a="http://schemas.openxmlformats.org/drawingml/2006/main"/>
-          <a:p xmlns:a="http://schemas.openxmlformats.org/drawingml/2006/main">
-            <a:pPr>
-              <a:defRPr sz="1350">
-                <a:solidFill>
-                  <a:srgbClr val="384150"/>
-                </a:solidFill>
-              </a:defRPr>
-            </a:pPr>
-            <a:r>
-              <a:rPr sz="1350">
-                <a:solidFill>
-                  <a:srgbClr val="384150"/>
-                </a:solidFill>
-              </a:rPr>
-              <a:t>github.com/Kxazar/pennypilot</a:t>
-            </a:r>
-          </a:p>
-        </p:txBody>
-      </p:sp>
-      <p:sp>
-        <p:nvSpPr>
-          <p:cNvPr id="13" name="">
-            <a:extLst xmlns:a="http://schemas.openxmlformats.org/drawingml/2006/main">
-              <a:ext uri="{FF2B5EF4-FFF2-40B4-BE49-F238E27FC236}">
-                <a16:creationId xmlns:a16="http://schemas.microsoft.com/office/drawing/2014/main" id="{64318E44-111C-48C7-A99F-C3572CDDA13A}"/>
-              </a:ext>
-            </a:extLst>
-          </p:cNvPr>
-          <p:cNvSpPr>
-            <a:spLocks xmlns:a="http://schemas.openxmlformats.org/drawingml/2006/main" noGrp="1"/>
-          </p:cNvSpPr>
-          <p:nvPr/>
-        </p:nvSpPr>
-        <p:spPr>
-          <a:xfrm xmlns:a="http://schemas.openxmlformats.org/drawingml/2006/main">
-            <a:off x="819150" y="6686550"/>
-            <a:ext cx="133350" cy="133350"/>
+              <a:t>API-native</a:t>
+            </a:r>
+          </a:p>
+        </p:txBody>
+      </p:sp>
+      <p:sp>
+        <p:nvSpPr>
+          <p:cNvPr id="12" name="statement-body-API-native">
+            <a:extLst xmlns:a="http://schemas.openxmlformats.org/drawingml/2006/main">
+              <a:ext uri="{FF2B5EF4-FFF2-40B4-BE49-F238E27FC236}">
+                <a16:creationId xmlns:a16="http://schemas.microsoft.com/office/drawing/2014/main" id="{59B1DDE9-40FB-4A0F-A23C-C5C3D44C3105}"/>
+              </a:ext>
+            </a:extLst>
+          </p:cNvPr>
+          <p:cNvSpPr>
+            <a:spLocks xmlns:a="http://schemas.openxmlformats.org/drawingml/2006/main" noGrp="1"/>
+          </p:cNvSpPr>
+          <p:nvPr/>
+        </p:nvSpPr>
+        <p:spPr>
+          <a:xfrm xmlns:a="http://schemas.openxmlformats.org/drawingml/2006/main">
+            <a:off x="5314950" y="6191250"/>
+            <a:ext cx="4191000" cy="457200"/>
+          </a:xfrm>
+          <a:prstGeom xmlns:a="http://schemas.openxmlformats.org/drawingml/2006/main" prst="rect">
+            <a:avLst/>
+          </a:prstGeom>
+        </p:spPr>
+        <p:txBody>
+          <a:bodyPr xmlns:a="http://schemas.openxmlformats.org/drawingml/2006/main" lIns="0" tIns="0" rIns="0" bIns="0"/>
+          <a:lstStyle xmlns:a="http://schemas.openxmlformats.org/drawingml/2006/main"/>
+          <a:p xmlns:a="http://schemas.openxmlformats.org/drawingml/2006/main">
+            <a:pPr>
+              <a:defRPr sz="1800">
+                <a:solidFill>
+                  <a:srgbClr val="596473"/>
+                </a:solidFill>
+              </a:defRPr>
+            </a:pPr>
+            <a:r>
+              <a:rPr sz="1800">
+                <a:solidFill>
+                  <a:srgbClr val="596473"/>
+                </a:solidFill>
+              </a:rPr>
+              <a:t>Circle Gateway x402 lets providers monetize tiny proof calls below one cent.</a:t>
+            </a:r>
+          </a:p>
+        </p:txBody>
+      </p:sp>
+      <p:sp>
+        <p:nvSpPr>
+          <p:cNvPr id="13" name="accent-rule">
+            <a:extLst xmlns:a="http://schemas.openxmlformats.org/drawingml/2006/main">
+              <a:ext uri="{FF2B5EF4-FFF2-40B4-BE49-F238E27FC236}">
+                <a16:creationId xmlns:a16="http://schemas.microsoft.com/office/drawing/2014/main" id="{8E7AC4FC-5DB2-48F3-93CB-51EDA26F632C}"/>
+              </a:ext>
+            </a:extLst>
+          </p:cNvPr>
+          <p:cNvSpPr>
+            <a:spLocks xmlns:a="http://schemas.openxmlformats.org/drawingml/2006/main" noGrp="1"/>
+          </p:cNvSpPr>
+          <p:nvPr/>
+        </p:nvSpPr>
+        <p:spPr>
+          <a:xfrm xmlns:a="http://schemas.openxmlformats.org/drawingml/2006/main">
+            <a:off x="819150" y="6877050"/>
+            <a:ext cx="2190750" cy="47625"/>
+          </a:xfrm>
+          <a:prstGeom xmlns:a="http://schemas.openxmlformats.org/drawingml/2006/main" prst="rect">
+            <a:avLst/>
+          </a:prstGeom>
+          <a:solidFill xmlns:a="http://schemas.openxmlformats.org/drawingml/2006/main">
+            <a:srgbClr val="E04F43"/>
+          </a:solidFill>
+          <a:ln xmlns:a="http://schemas.openxmlformats.org/drawingml/2006/main" w="0">
+            <a:solidFill>
+              <a:srgbClr val="E04F43"/>
+            </a:solidFill>
+            <a:prstDash val="solid"/>
+          </a:ln>
+        </p:spPr>
+      </p:sp>
+      <p:sp>
+        <p:nvSpPr>
+          <p:cNvPr id="14" name="statement-title-Auditable">
+            <a:extLst xmlns:a="http://schemas.openxmlformats.org/drawingml/2006/main">
+              <a:ext uri="{FF2B5EF4-FFF2-40B4-BE49-F238E27FC236}">
+                <a16:creationId xmlns:a16="http://schemas.microsoft.com/office/drawing/2014/main" id="{5E95284D-8FA6-4C5B-AE4D-7EAC62F8D3D5}"/>
+              </a:ext>
+            </a:extLst>
+          </p:cNvPr>
+          <p:cNvSpPr>
+            <a:spLocks xmlns:a="http://schemas.openxmlformats.org/drawingml/2006/main" noGrp="1"/>
+          </p:cNvSpPr>
+          <p:nvPr/>
+        </p:nvSpPr>
+        <p:spPr>
+          <a:xfrm xmlns:a="http://schemas.openxmlformats.org/drawingml/2006/main">
+            <a:off x="819150" y="7067550"/>
+            <a:ext cx="4191000" cy="361950"/>
+          </a:xfrm>
+          <a:prstGeom xmlns:a="http://schemas.openxmlformats.org/drawingml/2006/main" prst="rect">
+            <a:avLst/>
+          </a:prstGeom>
+        </p:spPr>
+        <p:txBody>
+          <a:bodyPr xmlns:a="http://schemas.openxmlformats.org/drawingml/2006/main" lIns="0" tIns="0" rIns="0" bIns="0"/>
+          <a:lstStyle xmlns:a="http://schemas.openxmlformats.org/drawingml/2006/main"/>
+          <a:p xmlns:a="http://schemas.openxmlformats.org/drawingml/2006/main">
+            <a:pPr>
+              <a:defRPr sz="2850" b="1">
+                <a:solidFill>
+                  <a:srgbClr val="0B1220"/>
+                </a:solidFill>
+              </a:defRPr>
+            </a:pPr>
+            <a:r>
+              <a:rPr sz="2850" b="1">
+                <a:solidFill>
+                  <a:srgbClr val="0B1220"/>
+                </a:solidFill>
+              </a:rPr>
+              <a:t>Auditable</a:t>
+            </a:r>
+          </a:p>
+        </p:txBody>
+      </p:sp>
+      <p:sp>
+        <p:nvSpPr>
+          <p:cNvPr id="15" name="statement-body-Auditable">
+            <a:extLst xmlns:a="http://schemas.openxmlformats.org/drawingml/2006/main">
+              <a:ext uri="{FF2B5EF4-FFF2-40B4-BE49-F238E27FC236}">
+                <a16:creationId xmlns:a16="http://schemas.microsoft.com/office/drawing/2014/main" id="{69810855-30B0-47B8-80F4-0E16F1F2EBD2}"/>
+              </a:ext>
+            </a:extLst>
+          </p:cNvPr>
+          <p:cNvSpPr>
+            <a:spLocks xmlns:a="http://schemas.openxmlformats.org/drawingml/2006/main" noGrp="1"/>
+          </p:cNvSpPr>
+          <p:nvPr/>
+        </p:nvSpPr>
+        <p:spPr>
+          <a:xfrm xmlns:a="http://schemas.openxmlformats.org/drawingml/2006/main">
+            <a:off x="819150" y="7581900"/>
+            <a:ext cx="4191000" cy="457200"/>
+          </a:xfrm>
+          <a:prstGeom xmlns:a="http://schemas.openxmlformats.org/drawingml/2006/main" prst="rect">
+            <a:avLst/>
+          </a:prstGeom>
+        </p:spPr>
+        <p:txBody>
+          <a:bodyPr xmlns:a="http://schemas.openxmlformats.org/drawingml/2006/main" lIns="0" tIns="0" rIns="0" bIns="0"/>
+          <a:lstStyle xmlns:a="http://schemas.openxmlformats.org/drawingml/2006/main"/>
+          <a:p xmlns:a="http://schemas.openxmlformats.org/drawingml/2006/main">
+            <a:pPr>
+              <a:defRPr sz="1800">
+                <a:solidFill>
+                  <a:srgbClr val="596473"/>
+                </a:solidFill>
+              </a:defRPr>
+            </a:pPr>
+            <a:r>
+              <a:rPr sz="1800">
+                <a:solidFill>
+                  <a:srgbClr val="596473"/>
+                </a:solidFill>
+              </a:rPr>
+              <a:t>Provider signatures and Arc anchors make the spend trail independently checkable.</a:t>
+            </a:r>
+          </a:p>
+        </p:txBody>
+      </p:sp>
+      <p:sp>
+        <p:nvSpPr>
+          <p:cNvPr id="16" name="accent-rule">
+            <a:extLst xmlns:a="http://schemas.openxmlformats.org/drawingml/2006/main">
+              <a:ext uri="{FF2B5EF4-FFF2-40B4-BE49-F238E27FC236}">
+                <a16:creationId xmlns:a16="http://schemas.microsoft.com/office/drawing/2014/main" id="{D828F6A3-4C68-4406-A5CC-90DA7792F0D2}"/>
+              </a:ext>
+            </a:extLst>
+          </p:cNvPr>
+          <p:cNvSpPr>
+            <a:spLocks xmlns:a="http://schemas.openxmlformats.org/drawingml/2006/main" noGrp="1"/>
+          </p:cNvSpPr>
+          <p:nvPr/>
+        </p:nvSpPr>
+        <p:spPr>
+          <a:xfrm xmlns:a="http://schemas.openxmlformats.org/drawingml/2006/main">
+            <a:off x="5314950" y="6877050"/>
+            <a:ext cx="2190750" cy="47625"/>
+          </a:xfrm>
+          <a:prstGeom xmlns:a="http://schemas.openxmlformats.org/drawingml/2006/main" prst="rect">
+            <a:avLst/>
+          </a:prstGeom>
+          <a:solidFill xmlns:a="http://schemas.openxmlformats.org/drawingml/2006/main">
+            <a:srgbClr val="2878B8"/>
+          </a:solidFill>
+          <a:ln xmlns:a="http://schemas.openxmlformats.org/drawingml/2006/main" w="0">
+            <a:solidFill>
+              <a:srgbClr val="2878B8"/>
+            </a:solidFill>
+            <a:prstDash val="solid"/>
+          </a:ln>
+        </p:spPr>
+      </p:sp>
+      <p:sp>
+        <p:nvSpPr>
+          <p:cNvPr id="17" name="statement-title-Reusable">
+            <a:extLst xmlns:a="http://schemas.openxmlformats.org/drawingml/2006/main">
+              <a:ext uri="{FF2B5EF4-FFF2-40B4-BE49-F238E27FC236}">
+                <a16:creationId xmlns:a16="http://schemas.microsoft.com/office/drawing/2014/main" id="{7ACDCD6B-8AA5-4AB0-88B0-DFA097756381}"/>
+              </a:ext>
+            </a:extLst>
+          </p:cNvPr>
+          <p:cNvSpPr>
+            <a:spLocks xmlns:a="http://schemas.openxmlformats.org/drawingml/2006/main" noGrp="1"/>
+          </p:cNvSpPr>
+          <p:nvPr/>
+        </p:nvSpPr>
+        <p:spPr>
+          <a:xfrm xmlns:a="http://schemas.openxmlformats.org/drawingml/2006/main">
+            <a:off x="5314950" y="7067550"/>
+            <a:ext cx="4191000" cy="361950"/>
+          </a:xfrm>
+          <a:prstGeom xmlns:a="http://schemas.openxmlformats.org/drawingml/2006/main" prst="rect">
+            <a:avLst/>
+          </a:prstGeom>
+        </p:spPr>
+        <p:txBody>
+          <a:bodyPr xmlns:a="http://schemas.openxmlformats.org/drawingml/2006/main" lIns="0" tIns="0" rIns="0" bIns="0"/>
+          <a:lstStyle xmlns:a="http://schemas.openxmlformats.org/drawingml/2006/main"/>
+          <a:p xmlns:a="http://schemas.openxmlformats.org/drawingml/2006/main">
+            <a:pPr>
+              <a:defRPr sz="2850" b="1">
+                <a:solidFill>
+                  <a:srgbClr val="0B1220"/>
+                </a:solidFill>
+              </a:defRPr>
+            </a:pPr>
+            <a:r>
+              <a:rPr sz="2850" b="1">
+                <a:solidFill>
+                  <a:srgbClr val="0B1220"/>
+                </a:solidFill>
+              </a:rPr>
+              <a:t>Reusable</a:t>
+            </a:r>
+          </a:p>
+        </p:txBody>
+      </p:sp>
+      <p:sp>
+        <p:nvSpPr>
+          <p:cNvPr id="18" name="statement-body-Reusable">
+            <a:extLst xmlns:a="http://schemas.openxmlformats.org/drawingml/2006/main">
+              <a:ext uri="{FF2B5EF4-FFF2-40B4-BE49-F238E27FC236}">
+                <a16:creationId xmlns:a16="http://schemas.microsoft.com/office/drawing/2014/main" id="{643970A9-8E38-48D3-A582-656070EC2917}"/>
+              </a:ext>
+            </a:extLst>
+          </p:cNvPr>
+          <p:cNvSpPr>
+            <a:spLocks xmlns:a="http://schemas.openxmlformats.org/drawingml/2006/main" noGrp="1"/>
+          </p:cNvSpPr>
+          <p:nvPr/>
+        </p:nvSpPr>
+        <p:spPr>
+          <a:xfrm xmlns:a="http://schemas.openxmlformats.org/drawingml/2006/main">
+            <a:off x="5314950" y="7581900"/>
+            <a:ext cx="4191000" cy="457200"/>
+          </a:xfrm>
+          <a:prstGeom xmlns:a="http://schemas.openxmlformats.org/drawingml/2006/main" prst="rect">
+            <a:avLst/>
+          </a:prstGeom>
+        </p:spPr>
+        <p:txBody>
+          <a:bodyPr xmlns:a="http://schemas.openxmlformats.org/drawingml/2006/main" lIns="0" tIns="0" rIns="0" bIns="0"/>
+          <a:lstStyle xmlns:a="http://schemas.openxmlformats.org/drawingml/2006/main"/>
+          <a:p xmlns:a="http://schemas.openxmlformats.org/drawingml/2006/main">
+            <a:pPr>
+              <a:defRPr sz="1800">
+                <a:solidFill>
+                  <a:srgbClr val="596473"/>
+                </a:solidFill>
+              </a:defRPr>
+            </a:pPr>
+            <a:r>
+              <a:rPr sz="1800">
+                <a:solidFill>
+                  <a:srgbClr val="596473"/>
+                </a:solidFill>
+              </a:rPr>
+              <a:t>The same loop fits KYB, sanctions, invoice, FX, risk, and identity checks.</a:t>
+            </a:r>
+          </a:p>
+        </p:txBody>
+      </p:sp>
+      <p:sp>
+        <p:nvSpPr>
+          <p:cNvPr id="19" name="closing-proof-field">
+            <a:extLst xmlns:a="http://schemas.openxmlformats.org/drawingml/2006/main">
+              <a:ext uri="{FF2B5EF4-FFF2-40B4-BE49-F238E27FC236}">
+                <a16:creationId xmlns:a16="http://schemas.microsoft.com/office/drawing/2014/main" id="{0928234C-40D3-4B65-A3E9-275A516B2930}"/>
+              </a:ext>
+            </a:extLst>
+          </p:cNvPr>
+          <p:cNvSpPr>
+            <a:spLocks xmlns:a="http://schemas.openxmlformats.org/drawingml/2006/main" noGrp="1"/>
+          </p:cNvSpPr>
+          <p:nvPr/>
+        </p:nvSpPr>
+        <p:spPr>
+          <a:xfrm xmlns:a="http://schemas.openxmlformats.org/drawingml/2006/main">
+            <a:off x="10081641" y="3028950"/>
+            <a:ext cx="7387209" cy="5334000"/>
+          </a:xfrm>
+          <a:prstGeom xmlns:a="http://schemas.openxmlformats.org/drawingml/2006/main" prst="roundRect">
+            <a:avLst>
+              <a:gd name="adj" fmla="val 1429"/>
+            </a:avLst>
+          </a:prstGeom>
+          <a:solidFill xmlns:a="http://schemas.openxmlformats.org/drawingml/2006/main">
+            <a:srgbClr val="0E1116"/>
+          </a:solidFill>
+          <a:ln xmlns:a="http://schemas.openxmlformats.org/drawingml/2006/main" w="0">
+            <a:solidFill>
+              <a:srgbClr val="0E1116"/>
+            </a:solidFill>
+            <a:prstDash val="solid"/>
+          </a:ln>
+        </p:spPr>
+      </p:sp>
+      <p:sp>
+        <p:nvSpPr>
+          <p:cNvPr id="20" name="closing-proof-label">
+            <a:extLst xmlns:a="http://schemas.openxmlformats.org/drawingml/2006/main">
+              <a:ext uri="{FF2B5EF4-FFF2-40B4-BE49-F238E27FC236}">
+                <a16:creationId xmlns:a16="http://schemas.microsoft.com/office/drawing/2014/main" id="{E84AD640-5992-4553-8B34-B1342380E079}"/>
+              </a:ext>
+            </a:extLst>
+          </p:cNvPr>
+          <p:cNvSpPr>
+            <a:spLocks xmlns:a="http://schemas.openxmlformats.org/drawingml/2006/main" noGrp="1"/>
+          </p:cNvSpPr>
+          <p:nvPr/>
+        </p:nvSpPr>
+        <p:spPr>
+          <a:xfrm xmlns:a="http://schemas.openxmlformats.org/drawingml/2006/main">
+            <a:off x="10477500" y="3390900"/>
+            <a:ext cx="6591300" cy="190500"/>
+          </a:xfrm>
+          <a:prstGeom xmlns:a="http://schemas.openxmlformats.org/drawingml/2006/main" prst="rect">
+            <a:avLst/>
+          </a:prstGeom>
+        </p:spPr>
+        <p:txBody>
+          <a:bodyPr xmlns:a="http://schemas.openxmlformats.org/drawingml/2006/main" lIns="0" tIns="0" rIns="0" bIns="0"/>
+          <a:lstStyle xmlns:a="http://schemas.openxmlformats.org/drawingml/2006/main"/>
+          <a:p xmlns:a="http://schemas.openxmlformats.org/drawingml/2006/main">
+            <a:pPr>
+              <a:defRPr sz="1425" b="1">
+                <a:solidFill>
+                  <a:srgbClr val="B8C2CC"/>
+                </a:solidFill>
+              </a:defRPr>
+            </a:pPr>
+            <a:r>
+              <a:rPr sz="1425" b="1">
+                <a:solidFill>
+                  <a:srgbClr val="B8C2CC"/>
+                </a:solidFill>
+              </a:rPr>
+              <a:t>Operational proof</a:t>
+            </a:r>
+          </a:p>
+        </p:txBody>
+      </p:sp>
+      <p:sp>
+        <p:nvSpPr>
+          <p:cNvPr id="21" name="closing-proof-headline">
+            <a:extLst xmlns:a="http://schemas.openxmlformats.org/drawingml/2006/main">
+              <a:ext uri="{FF2B5EF4-FFF2-40B4-BE49-F238E27FC236}">
+                <a16:creationId xmlns:a16="http://schemas.microsoft.com/office/drawing/2014/main" id="{162F2242-96CC-4495-B869-B1CD35F2C30A}"/>
+              </a:ext>
+            </a:extLst>
+          </p:cNvPr>
+          <p:cNvSpPr>
+            <a:spLocks xmlns:a="http://schemas.openxmlformats.org/drawingml/2006/main" noGrp="1"/>
+          </p:cNvSpPr>
+          <p:nvPr/>
+        </p:nvSpPr>
+        <p:spPr>
+          <a:xfrm xmlns:a="http://schemas.openxmlformats.org/drawingml/2006/main">
+            <a:off x="10477500" y="3733800"/>
+            <a:ext cx="6591300" cy="800100"/>
+          </a:xfrm>
+          <a:prstGeom xmlns:a="http://schemas.openxmlformats.org/drawingml/2006/main" prst="rect">
+            <a:avLst/>
+          </a:prstGeom>
+        </p:spPr>
+        <p:txBody>
+          <a:bodyPr xmlns:a="http://schemas.openxmlformats.org/drawingml/2006/main" lIns="0" tIns="0" rIns="0" bIns="0"/>
+          <a:lstStyle xmlns:a="http://schemas.openxmlformats.org/drawingml/2006/main"/>
+          <a:p xmlns:a="http://schemas.openxmlformats.org/drawingml/2006/main">
+            <a:pPr>
+              <a:defRPr sz="3150" b="1">
+                <a:solidFill>
+                  <a:srgbClr val="FFFFFF"/>
+                </a:solidFill>
+              </a:defRPr>
+            </a:pPr>
+            <a:r>
+              <a:rPr sz="3150" b="1">
+                <a:solidFill>
+                  <a:srgbClr val="FFFFFF"/>
+                </a:solidFill>
+              </a:rPr>
+              <a:t>Deployed app. Public repo. Arc receipts. 50+ transaction proof.</a:t>
+            </a:r>
+          </a:p>
+        </p:txBody>
+      </p:sp>
+      <p:sp>
+        <p:nvSpPr>
+          <p:cNvPr id="22" name="">
+            <a:extLst xmlns:a="http://schemas.openxmlformats.org/drawingml/2006/main">
+              <a:ext uri="{FF2B5EF4-FFF2-40B4-BE49-F238E27FC236}">
+                <a16:creationId xmlns:a16="http://schemas.microsoft.com/office/drawing/2014/main" id="{A7D0BEFF-8905-47F9-B713-7119871CDB57}"/>
+              </a:ext>
+            </a:extLst>
+          </p:cNvPr>
+          <p:cNvSpPr>
+            <a:spLocks xmlns:a="http://schemas.openxmlformats.org/drawingml/2006/main" noGrp="1"/>
+          </p:cNvSpPr>
+          <p:nvPr/>
+        </p:nvSpPr>
+        <p:spPr>
+          <a:xfrm xmlns:a="http://schemas.openxmlformats.org/drawingml/2006/main">
+            <a:off x="10477500" y="5105400"/>
+            <a:ext cx="3181350" cy="57150"/>
           </a:xfrm>
           <a:prstGeom xmlns:a="http://schemas.openxmlformats.org/drawingml/2006/main" prst="rect">
             <a:avLst/>
@@ -7402,67 +7773,67 @@
       </p:sp>
       <p:sp>
         <p:nvSpPr>
-          <p:cNvPr id="14" name="proof-label-Contract">
-            <a:extLst xmlns:a="http://schemas.openxmlformats.org/drawingml/2006/main">
-              <a:ext uri="{FF2B5EF4-FFF2-40B4-BE49-F238E27FC236}">
-                <a16:creationId xmlns:a16="http://schemas.microsoft.com/office/drawing/2014/main" id="{2EEF69C6-35F7-43B4-92C5-75E3BBEE6049}"/>
-              </a:ext>
-            </a:extLst>
-          </p:cNvPr>
-          <p:cNvSpPr>
-            <a:spLocks xmlns:a="http://schemas.openxmlformats.org/drawingml/2006/main" noGrp="1"/>
-          </p:cNvSpPr>
-          <p:nvPr/>
-        </p:nvSpPr>
-        <p:spPr>
-          <a:xfrm xmlns:a="http://schemas.openxmlformats.org/drawingml/2006/main">
-            <a:off x="1104900" y="6648450"/>
-            <a:ext cx="2000250" cy="190500"/>
-          </a:xfrm>
-          <a:prstGeom xmlns:a="http://schemas.openxmlformats.org/drawingml/2006/main" prst="rect">
-            <a:avLst/>
-          </a:prstGeom>
-        </p:spPr>
-        <p:txBody>
-          <a:bodyPr xmlns:a="http://schemas.openxmlformats.org/drawingml/2006/main" lIns="0" tIns="0" rIns="0" bIns="0"/>
-          <a:lstStyle xmlns:a="http://schemas.openxmlformats.org/drawingml/2006/main"/>
-          <a:p xmlns:a="http://schemas.openxmlformats.org/drawingml/2006/main">
-            <a:pPr>
-              <a:defRPr sz="1500" b="1">
-                <a:solidFill>
-                  <a:srgbClr val="0B1220"/>
-                </a:solidFill>
-              </a:defRPr>
-            </a:pPr>
-            <a:r>
-              <a:rPr sz="1500" b="1">
-                <a:solidFill>
-                  <a:srgbClr val="0B1220"/>
-                </a:solidFill>
-              </a:rPr>
-              <a:t>Contract</a:t>
-            </a:r>
-          </a:p>
-        </p:txBody>
-      </p:sp>
-      <p:sp>
-        <p:nvSpPr>
-          <p:cNvPr id="15" name="proof-value-Contract">
-            <a:extLst xmlns:a="http://schemas.openxmlformats.org/drawingml/2006/main">
-              <a:ext uri="{FF2B5EF4-FFF2-40B4-BE49-F238E27FC236}">
-                <a16:creationId xmlns:a16="http://schemas.microsoft.com/office/drawing/2014/main" id="{AC6D419F-4331-42D3-8112-2A064005C5A1}"/>
-              </a:ext>
-            </a:extLst>
-          </p:cNvPr>
-          <p:cNvSpPr>
-            <a:spLocks xmlns:a="http://schemas.openxmlformats.org/drawingml/2006/main" noGrp="1"/>
-          </p:cNvSpPr>
-          <p:nvPr/>
-        </p:nvSpPr>
-        <p:spPr>
-          <a:xfrm xmlns:a="http://schemas.openxmlformats.org/drawingml/2006/main">
-            <a:off x="3257550" y="6648450"/>
-            <a:ext cx="5924550" cy="190500"/>
+          <p:cNvPr id="23" name="dark-metric-value-max proofs per batch">
+            <a:extLst xmlns:a="http://schemas.openxmlformats.org/drawingml/2006/main">
+              <a:ext uri="{FF2B5EF4-FFF2-40B4-BE49-F238E27FC236}">
+                <a16:creationId xmlns:a16="http://schemas.microsoft.com/office/drawing/2014/main" id="{24C6ED54-3C09-4749-AEB9-02FF92957C4A}"/>
+              </a:ext>
+            </a:extLst>
+          </p:cNvPr>
+          <p:cNvSpPr>
+            <a:spLocks xmlns:a="http://schemas.openxmlformats.org/drawingml/2006/main" noGrp="1"/>
+          </p:cNvSpPr>
+          <p:nvPr/>
+        </p:nvSpPr>
+        <p:spPr>
+          <a:xfrm xmlns:a="http://schemas.openxmlformats.org/drawingml/2006/main">
+            <a:off x="10477500" y="5257800"/>
+            <a:ext cx="3181350" cy="400050"/>
+          </a:xfrm>
+          <a:prstGeom xmlns:a="http://schemas.openxmlformats.org/drawingml/2006/main" prst="rect">
+            <a:avLst/>
+          </a:prstGeom>
+        </p:spPr>
+        <p:txBody>
+          <a:bodyPr xmlns:a="http://schemas.openxmlformats.org/drawingml/2006/main" lIns="0" tIns="0" rIns="0" bIns="0"/>
+          <a:lstStyle xmlns:a="http://schemas.openxmlformats.org/drawingml/2006/main"/>
+          <a:p xmlns:a="http://schemas.openxmlformats.org/drawingml/2006/main">
+            <a:pPr>
+              <a:defRPr sz="3150" b="1">
+                <a:solidFill>
+                  <a:srgbClr val="FFFFFF"/>
+                </a:solidFill>
+              </a:defRPr>
+            </a:pPr>
+            <a:r>
+              <a:rPr sz="3150" b="1">
+                <a:solidFill>
+                  <a:srgbClr val="FFFFFF"/>
+                </a:solidFill>
+              </a:rPr>
+              <a:t>60</a:t>
+            </a:r>
+          </a:p>
+        </p:txBody>
+      </p:sp>
+      <p:sp>
+        <p:nvSpPr>
+          <p:cNvPr id="24" name="dark-metric-label-max proofs per batch">
+            <a:extLst xmlns:a="http://schemas.openxmlformats.org/drawingml/2006/main">
+              <a:ext uri="{FF2B5EF4-FFF2-40B4-BE49-F238E27FC236}">
+                <a16:creationId xmlns:a16="http://schemas.microsoft.com/office/drawing/2014/main" id="{75C31158-9C33-403E-81EE-D17ACD1573CD}"/>
+              </a:ext>
+            </a:extLst>
+          </p:cNvPr>
+          <p:cNvSpPr>
+            <a:spLocks xmlns:a="http://schemas.openxmlformats.org/drawingml/2006/main" noGrp="1"/>
+          </p:cNvSpPr>
+          <p:nvPr/>
+        </p:nvSpPr>
+        <p:spPr>
+          <a:xfrm xmlns:a="http://schemas.openxmlformats.org/drawingml/2006/main">
+            <a:off x="10477500" y="5753100"/>
+            <a:ext cx="3181350" cy="171450"/>
           </a:xfrm>
           <a:prstGeom xmlns:a="http://schemas.openxmlformats.org/drawingml/2006/main" prst="rect">
             <a:avLst/>
@@ -7475,39 +7846,39 @@
             <a:pPr>
               <a:defRPr sz="1350">
                 <a:solidFill>
-                  <a:srgbClr val="384150"/>
+                  <a:srgbClr val="B8C2CC"/>
                 </a:solidFill>
               </a:defRPr>
             </a:pPr>
             <a:r>
               <a:rPr sz="1350">
                 <a:solidFill>
-                  <a:srgbClr val="384150"/>
-                </a:solidFill>
-              </a:rPr>
-              <a:t>0x4c8E...3047</a:t>
-            </a:r>
-          </a:p>
-        </p:txBody>
-      </p:sp>
-      <p:sp>
-        <p:nvSpPr>
-          <p:cNvPr id="16" name="">
-            <a:extLst xmlns:a="http://schemas.openxmlformats.org/drawingml/2006/main">
-              <a:ext uri="{FF2B5EF4-FFF2-40B4-BE49-F238E27FC236}">
-                <a16:creationId xmlns:a16="http://schemas.microsoft.com/office/drawing/2014/main" id="{47D3A9C0-F6E3-44D4-BB2F-552AA765236E}"/>
-              </a:ext>
-            </a:extLst>
-          </p:cNvPr>
-          <p:cNvSpPr>
-            <a:spLocks xmlns:a="http://schemas.openxmlformats.org/drawingml/2006/main" noGrp="1"/>
-          </p:cNvSpPr>
-          <p:nvPr/>
-        </p:nvSpPr>
-        <p:spPr>
-          <a:xfrm xmlns:a="http://schemas.openxmlformats.org/drawingml/2006/main">
-            <a:off x="819150" y="7029450"/>
-            <a:ext cx="133350" cy="133350"/>
+                  <a:srgbClr val="B8C2CC"/>
+                </a:solidFill>
+              </a:rPr>
+              <a:t>max proofs per batch</a:t>
+            </a:r>
+          </a:p>
+        </p:txBody>
+      </p:sp>
+      <p:sp>
+        <p:nvSpPr>
+          <p:cNvPr id="25" name="">
+            <a:extLst xmlns:a="http://schemas.openxmlformats.org/drawingml/2006/main">
+              <a:ext uri="{FF2B5EF4-FFF2-40B4-BE49-F238E27FC236}">
+                <a16:creationId xmlns:a16="http://schemas.microsoft.com/office/drawing/2014/main" id="{99CEFBD3-60ED-4C6C-8581-25EDCBF8CA96}"/>
+              </a:ext>
+            </a:extLst>
+          </p:cNvPr>
+          <p:cNvSpPr>
+            <a:spLocks xmlns:a="http://schemas.openxmlformats.org/drawingml/2006/main" noGrp="1"/>
+          </p:cNvSpPr>
+          <p:nvPr/>
+        </p:nvSpPr>
+        <p:spPr>
+          <a:xfrm xmlns:a="http://schemas.openxmlformats.org/drawingml/2006/main">
+            <a:off x="13887450" y="5105400"/>
+            <a:ext cx="3181350" cy="57150"/>
           </a:xfrm>
           <a:prstGeom xmlns:a="http://schemas.openxmlformats.org/drawingml/2006/main" prst="rect">
             <a:avLst/>
@@ -7525,67 +7896,67 @@
       </p:sp>
       <p:sp>
         <p:nvSpPr>
-          <p:cNvPr id="17" name="proof-label-50 tx proof">
-            <a:extLst xmlns:a="http://schemas.openxmlformats.org/drawingml/2006/main">
-              <a:ext uri="{FF2B5EF4-FFF2-40B4-BE49-F238E27FC236}">
-                <a16:creationId xmlns:a16="http://schemas.microsoft.com/office/drawing/2014/main" id="{07A0FC04-AFC3-4126-80D1-26658F5B5E8F}"/>
-              </a:ext>
-            </a:extLst>
-          </p:cNvPr>
-          <p:cNvSpPr>
-            <a:spLocks xmlns:a="http://schemas.openxmlformats.org/drawingml/2006/main" noGrp="1"/>
-          </p:cNvSpPr>
-          <p:nvPr/>
-        </p:nvSpPr>
-        <p:spPr>
-          <a:xfrm xmlns:a="http://schemas.openxmlformats.org/drawingml/2006/main">
-            <a:off x="1104900" y="7010400"/>
-            <a:ext cx="2000250" cy="190500"/>
-          </a:xfrm>
-          <a:prstGeom xmlns:a="http://schemas.openxmlformats.org/drawingml/2006/main" prst="rect">
-            <a:avLst/>
-          </a:prstGeom>
-        </p:spPr>
-        <p:txBody>
-          <a:bodyPr xmlns:a="http://schemas.openxmlformats.org/drawingml/2006/main" lIns="0" tIns="0" rIns="0" bIns="0"/>
-          <a:lstStyle xmlns:a="http://schemas.openxmlformats.org/drawingml/2006/main"/>
-          <a:p xmlns:a="http://schemas.openxmlformats.org/drawingml/2006/main">
-            <a:pPr>
-              <a:defRPr sz="1500" b="1">
-                <a:solidFill>
-                  <a:srgbClr val="0B1220"/>
-                </a:solidFill>
-              </a:defRPr>
-            </a:pPr>
-            <a:r>
-              <a:rPr sz="1500" b="1">
-                <a:solidFill>
-                  <a:srgbClr val="0B1220"/>
-                </a:solidFill>
-              </a:rPr>
-              <a:t>50 tx proof</a:t>
-            </a:r>
-          </a:p>
-        </p:txBody>
-      </p:sp>
-      <p:sp>
-        <p:nvSpPr>
-          <p:cNvPr id="18" name="proof-value-50 tx proof">
-            <a:extLst xmlns:a="http://schemas.openxmlformats.org/drawingml/2006/main">
-              <a:ext uri="{FF2B5EF4-FFF2-40B4-BE49-F238E27FC236}">
-                <a16:creationId xmlns:a16="http://schemas.microsoft.com/office/drawing/2014/main" id="{58DF9DB8-D91E-460A-8EBA-41E056C82F60}"/>
-              </a:ext>
-            </a:extLst>
-          </p:cNvPr>
-          <p:cNvSpPr>
-            <a:spLocks xmlns:a="http://schemas.openxmlformats.org/drawingml/2006/main" noGrp="1"/>
-          </p:cNvSpPr>
-          <p:nvPr/>
-        </p:nvSpPr>
-        <p:spPr>
-          <a:xfrm xmlns:a="http://schemas.openxmlformats.org/drawingml/2006/main">
-            <a:off x="3257550" y="7010400"/>
-            <a:ext cx="5924550" cy="190500"/>
+          <p:cNvPr id="26" name="dark-metric-value-verified receipt tx">
+            <a:extLst xmlns:a="http://schemas.openxmlformats.org/drawingml/2006/main">
+              <a:ext uri="{FF2B5EF4-FFF2-40B4-BE49-F238E27FC236}">
+                <a16:creationId xmlns:a16="http://schemas.microsoft.com/office/drawing/2014/main" id="{ECAF3EC1-B37B-4E0E-B2A3-D02705F46DF9}"/>
+              </a:ext>
+            </a:extLst>
+          </p:cNvPr>
+          <p:cNvSpPr>
+            <a:spLocks xmlns:a="http://schemas.openxmlformats.org/drawingml/2006/main" noGrp="1"/>
+          </p:cNvSpPr>
+          <p:nvPr/>
+        </p:nvSpPr>
+        <p:spPr>
+          <a:xfrm xmlns:a="http://schemas.openxmlformats.org/drawingml/2006/main">
+            <a:off x="13887450" y="5257800"/>
+            <a:ext cx="3181350" cy="400050"/>
+          </a:xfrm>
+          <a:prstGeom xmlns:a="http://schemas.openxmlformats.org/drawingml/2006/main" prst="rect">
+            <a:avLst/>
+          </a:prstGeom>
+        </p:spPr>
+        <p:txBody>
+          <a:bodyPr xmlns:a="http://schemas.openxmlformats.org/drawingml/2006/main" lIns="0" tIns="0" rIns="0" bIns="0"/>
+          <a:lstStyle xmlns:a="http://schemas.openxmlformats.org/drawingml/2006/main"/>
+          <a:p xmlns:a="http://schemas.openxmlformats.org/drawingml/2006/main">
+            <a:pPr>
+              <a:defRPr sz="3150" b="1">
+                <a:solidFill>
+                  <a:srgbClr val="FFFFFF"/>
+                </a:solidFill>
+              </a:defRPr>
+            </a:pPr>
+            <a:r>
+              <a:rPr sz="3150" b="1">
+                <a:solidFill>
+                  <a:srgbClr val="FFFFFF"/>
+                </a:solidFill>
+              </a:rPr>
+              <a:t>50+</a:t>
+            </a:r>
+          </a:p>
+        </p:txBody>
+      </p:sp>
+      <p:sp>
+        <p:nvSpPr>
+          <p:cNvPr id="27" name="dark-metric-label-verified receipt tx">
+            <a:extLst xmlns:a="http://schemas.openxmlformats.org/drawingml/2006/main">
+              <a:ext uri="{FF2B5EF4-FFF2-40B4-BE49-F238E27FC236}">
+                <a16:creationId xmlns:a16="http://schemas.microsoft.com/office/drawing/2014/main" id="{11A64B88-D80C-4EFE-BC59-60CFBFF90913}"/>
+              </a:ext>
+            </a:extLst>
+          </p:cNvPr>
+          <p:cNvSpPr>
+            <a:spLocks xmlns:a="http://schemas.openxmlformats.org/drawingml/2006/main" noGrp="1"/>
+          </p:cNvSpPr>
+          <p:nvPr/>
+        </p:nvSpPr>
+        <p:spPr>
+          <a:xfrm xmlns:a="http://schemas.openxmlformats.org/drawingml/2006/main">
+            <a:off x="13887450" y="5753100"/>
+            <a:ext cx="3181350" cy="171450"/>
           </a:xfrm>
           <a:prstGeom xmlns:a="http://schemas.openxmlformats.org/drawingml/2006/main" prst="rect">
             <a:avLst/>
@@ -7598,375 +7969,39 @@
             <a:pPr>
               <a:defRPr sz="1350">
                 <a:solidFill>
-                  <a:srgbClr val="384150"/>
+                  <a:srgbClr val="B8C2CC"/>
                 </a:solidFill>
               </a:defRPr>
             </a:pPr>
             <a:r>
               <a:rPr sz="1350">
                 <a:solidFill>
-                  <a:srgbClr val="384150"/>
-                </a:solidFill>
-              </a:rPr>
-              <a:t>0x9f65...8ee7</a:t>
-            </a:r>
-          </a:p>
-        </p:txBody>
-      </p:sp>
-      <p:sp>
-        <p:nvSpPr>
-          <p:cNvPr id="19" name="">
-            <a:extLst xmlns:a="http://schemas.openxmlformats.org/drawingml/2006/main">
-              <a:ext uri="{FF2B5EF4-FFF2-40B4-BE49-F238E27FC236}">
-                <a16:creationId xmlns:a16="http://schemas.microsoft.com/office/drawing/2014/main" id="{BE84D3F2-74B3-422E-838B-6F68BD9797F3}"/>
-              </a:ext>
-            </a:extLst>
-          </p:cNvPr>
-          <p:cNvSpPr>
-            <a:spLocks xmlns:a="http://schemas.openxmlformats.org/drawingml/2006/main" noGrp="1"/>
-          </p:cNvSpPr>
-          <p:nvPr/>
-        </p:nvSpPr>
-        <p:spPr>
-          <a:xfrm xmlns:a="http://schemas.openxmlformats.org/drawingml/2006/main">
-            <a:off x="9772650" y="3429000"/>
-            <a:ext cx="7696200" cy="57150"/>
-          </a:xfrm>
-          <a:prstGeom xmlns:a="http://schemas.openxmlformats.org/drawingml/2006/main" prst="rect">
-            <a:avLst/>
-          </a:prstGeom>
-          <a:solidFill xmlns:a="http://schemas.openxmlformats.org/drawingml/2006/main">
-            <a:srgbClr val="E04F43"/>
-          </a:solidFill>
-          <a:ln xmlns:a="http://schemas.openxmlformats.org/drawingml/2006/main" w="0">
-            <a:solidFill>
-              <a:srgbClr val="E04F43"/>
-            </a:solidFill>
-            <a:prstDash val="solid"/>
-          </a:ln>
-        </p:spPr>
-      </p:sp>
-      <p:sp>
-        <p:nvSpPr>
-          <p:cNvPr id="20" name="metric-value-verified receipt transactions">
-            <a:extLst xmlns:a="http://schemas.openxmlformats.org/drawingml/2006/main">
-              <a:ext uri="{FF2B5EF4-FFF2-40B4-BE49-F238E27FC236}">
-                <a16:creationId xmlns:a16="http://schemas.microsoft.com/office/drawing/2014/main" id="{9442255F-355A-444E-A883-94C488BE69FD}"/>
-              </a:ext>
-            </a:extLst>
-          </p:cNvPr>
-          <p:cNvSpPr>
-            <a:spLocks xmlns:a="http://schemas.openxmlformats.org/drawingml/2006/main" noGrp="1"/>
-          </p:cNvSpPr>
-          <p:nvPr/>
-        </p:nvSpPr>
-        <p:spPr>
-          <a:xfrm xmlns:a="http://schemas.openxmlformats.org/drawingml/2006/main">
-            <a:off x="9772650" y="3581400"/>
-            <a:ext cx="7696200" cy="476250"/>
-          </a:xfrm>
-          <a:prstGeom xmlns:a="http://schemas.openxmlformats.org/drawingml/2006/main" prst="rect">
-            <a:avLst/>
-          </a:prstGeom>
-        </p:spPr>
-        <p:txBody>
-          <a:bodyPr xmlns:a="http://schemas.openxmlformats.org/drawingml/2006/main" lIns="0" tIns="0" rIns="0" bIns="0"/>
-          <a:lstStyle xmlns:a="http://schemas.openxmlformats.org/drawingml/2006/main"/>
-          <a:p xmlns:a="http://schemas.openxmlformats.org/drawingml/2006/main">
-            <a:pPr>
-              <a:defRPr sz="3750" b="1">
-                <a:solidFill>
-                  <a:srgbClr val="0B1220"/>
-                </a:solidFill>
-              </a:defRPr>
-            </a:pPr>
-            <a:r>
-              <a:rPr sz="3750" b="1">
-                <a:solidFill>
-                  <a:srgbClr val="0B1220"/>
-                </a:solidFill>
-              </a:rPr>
-              <a:t>50</a:t>
-            </a:r>
-          </a:p>
-        </p:txBody>
-      </p:sp>
-      <p:sp>
-        <p:nvSpPr>
-          <p:cNvPr id="21" name="metric-label-verified receipt transactions">
-            <a:extLst xmlns:a="http://schemas.openxmlformats.org/drawingml/2006/main">
-              <a:ext uri="{FF2B5EF4-FFF2-40B4-BE49-F238E27FC236}">
-                <a16:creationId xmlns:a16="http://schemas.microsoft.com/office/drawing/2014/main" id="{79863A65-116C-48D2-B242-0741787E3984}"/>
-              </a:ext>
-            </a:extLst>
-          </p:cNvPr>
-          <p:cNvSpPr>
-            <a:spLocks xmlns:a="http://schemas.openxmlformats.org/drawingml/2006/main" noGrp="1"/>
-          </p:cNvSpPr>
-          <p:nvPr/>
-        </p:nvSpPr>
-        <p:spPr>
-          <a:xfrm xmlns:a="http://schemas.openxmlformats.org/drawingml/2006/main">
-            <a:off x="9772650" y="4133850"/>
-            <a:ext cx="7696200" cy="209550"/>
-          </a:xfrm>
-          <a:prstGeom xmlns:a="http://schemas.openxmlformats.org/drawingml/2006/main" prst="rect">
-            <a:avLst/>
-          </a:prstGeom>
-        </p:spPr>
-        <p:txBody>
-          <a:bodyPr xmlns:a="http://schemas.openxmlformats.org/drawingml/2006/main" lIns="0" tIns="0" rIns="0" bIns="0"/>
-          <a:lstStyle xmlns:a="http://schemas.openxmlformats.org/drawingml/2006/main"/>
-          <a:p xmlns:a="http://schemas.openxmlformats.org/drawingml/2006/main">
-            <a:pPr>
-              <a:defRPr sz="1575">
-                <a:solidFill>
-                  <a:srgbClr val="596473"/>
-                </a:solidFill>
-              </a:defRPr>
-            </a:pPr>
-            <a:r>
-              <a:rPr sz="1575">
-                <a:solidFill>
-                  <a:srgbClr val="596473"/>
-                </a:solidFill>
-              </a:rPr>
-              <a:t>verified receipt transactions</a:t>
-            </a:r>
-          </a:p>
-        </p:txBody>
-      </p:sp>
-      <p:sp>
-        <p:nvSpPr>
-          <p:cNvPr id="22" name="metric-note-verified receipt transactions">
-            <a:extLst xmlns:a="http://schemas.openxmlformats.org/drawingml/2006/main">
-              <a:ext uri="{FF2B5EF4-FFF2-40B4-BE49-F238E27FC236}">
-                <a16:creationId xmlns:a16="http://schemas.microsoft.com/office/drawing/2014/main" id="{97468244-64CD-4704-98D6-F692DF972D41}"/>
-              </a:ext>
-            </a:extLst>
-          </p:cNvPr>
-          <p:cNvSpPr>
-            <a:spLocks xmlns:a="http://schemas.openxmlformats.org/drawingml/2006/main" noGrp="1"/>
-          </p:cNvSpPr>
-          <p:nvPr/>
-        </p:nvSpPr>
-        <p:spPr>
-          <a:xfrm xmlns:a="http://schemas.openxmlformats.org/drawingml/2006/main">
-            <a:off x="9772650" y="4419600"/>
-            <a:ext cx="7696200" cy="152400"/>
-          </a:xfrm>
-          <a:prstGeom xmlns:a="http://schemas.openxmlformats.org/drawingml/2006/main" prst="rect">
-            <a:avLst/>
-          </a:prstGeom>
-        </p:spPr>
-        <p:txBody>
-          <a:bodyPr xmlns:a="http://schemas.openxmlformats.org/drawingml/2006/main" lIns="0" tIns="0" rIns="0" bIns="0"/>
-          <a:lstStyle xmlns:a="http://schemas.openxmlformats.org/drawingml/2006/main"/>
-          <a:p xmlns:a="http://schemas.openxmlformats.org/drawingml/2006/main">
-            <a:pPr>
-              <a:defRPr sz="1200">
-                <a:solidFill>
-                  <a:srgbClr val="8490A0"/>
-                </a:solidFill>
-              </a:defRPr>
-            </a:pPr>
-            <a:r>
-              <a:rPr sz="1200">
-                <a:solidFill>
-                  <a:srgbClr val="8490A0"/>
-                </a:solidFill>
-              </a:rPr>
-              <a:t>Arc Testnet proof</a:t>
-            </a:r>
-          </a:p>
-        </p:txBody>
-      </p:sp>
-      <p:sp>
-        <p:nvSpPr>
-          <p:cNvPr id="23" name="">
-            <a:extLst xmlns:a="http://schemas.openxmlformats.org/drawingml/2006/main">
-              <a:ext uri="{FF2B5EF4-FFF2-40B4-BE49-F238E27FC236}">
-                <a16:creationId xmlns:a16="http://schemas.microsoft.com/office/drawing/2014/main" id="{121F59D8-0666-467E-BB9C-56BA771396CC}"/>
-              </a:ext>
-            </a:extLst>
-          </p:cNvPr>
-          <p:cNvSpPr>
-            <a:spLocks xmlns:a="http://schemas.openxmlformats.org/drawingml/2006/main" noGrp="1"/>
-          </p:cNvSpPr>
-          <p:nvPr/>
-        </p:nvSpPr>
-        <p:spPr>
-          <a:xfrm xmlns:a="http://schemas.openxmlformats.org/drawingml/2006/main">
-            <a:off x="9772650" y="4819650"/>
-            <a:ext cx="7696200" cy="57150"/>
-          </a:xfrm>
-          <a:prstGeom xmlns:a="http://schemas.openxmlformats.org/drawingml/2006/main" prst="rect">
-            <a:avLst/>
-          </a:prstGeom>
-          <a:solidFill xmlns:a="http://schemas.openxmlformats.org/drawingml/2006/main">
-            <a:srgbClr val="007A58"/>
-          </a:solidFill>
-          <a:ln xmlns:a="http://schemas.openxmlformats.org/drawingml/2006/main" w="0">
-            <a:solidFill>
-              <a:srgbClr val="007A58"/>
-            </a:solidFill>
-            <a:prstDash val="solid"/>
-          </a:ln>
-        </p:spPr>
-      </p:sp>
-      <p:sp>
-        <p:nvSpPr>
-          <p:cNvPr id="24" name="metric-value-paid action requirement">
-            <a:extLst xmlns:a="http://schemas.openxmlformats.org/drawingml/2006/main">
-              <a:ext uri="{FF2B5EF4-FFF2-40B4-BE49-F238E27FC236}">
-                <a16:creationId xmlns:a16="http://schemas.microsoft.com/office/drawing/2014/main" id="{145A43DF-6CD1-4B96-B7E8-AC12A1446871}"/>
-              </a:ext>
-            </a:extLst>
-          </p:cNvPr>
-          <p:cNvSpPr>
-            <a:spLocks xmlns:a="http://schemas.openxmlformats.org/drawingml/2006/main" noGrp="1"/>
-          </p:cNvSpPr>
-          <p:nvPr/>
-        </p:nvSpPr>
-        <p:spPr>
-          <a:xfrm xmlns:a="http://schemas.openxmlformats.org/drawingml/2006/main">
-            <a:off x="9772650" y="4972050"/>
-            <a:ext cx="7696200" cy="476250"/>
-          </a:xfrm>
-          <a:prstGeom xmlns:a="http://schemas.openxmlformats.org/drawingml/2006/main" prst="rect">
-            <a:avLst/>
-          </a:prstGeom>
-        </p:spPr>
-        <p:txBody>
-          <a:bodyPr xmlns:a="http://schemas.openxmlformats.org/drawingml/2006/main" lIns="0" tIns="0" rIns="0" bIns="0"/>
-          <a:lstStyle xmlns:a="http://schemas.openxmlformats.org/drawingml/2006/main"/>
-          <a:p xmlns:a="http://schemas.openxmlformats.org/drawingml/2006/main">
-            <a:pPr>
-              <a:defRPr sz="3750" b="1">
-                <a:solidFill>
-                  <a:srgbClr val="0B1220"/>
-                </a:solidFill>
-              </a:defRPr>
-            </a:pPr>
-            <a:r>
-              <a:rPr sz="3750" b="1">
-                <a:solidFill>
-                  <a:srgbClr val="0B1220"/>
-                </a:solidFill>
-              </a:rPr>
-              <a:t>&lt;= $0.01</a:t>
-            </a:r>
-          </a:p>
-        </p:txBody>
-      </p:sp>
-      <p:sp>
-        <p:nvSpPr>
-          <p:cNvPr id="25" name="metric-label-paid action requirement">
-            <a:extLst xmlns:a="http://schemas.openxmlformats.org/drawingml/2006/main">
-              <a:ext uri="{FF2B5EF4-FFF2-40B4-BE49-F238E27FC236}">
-                <a16:creationId xmlns:a16="http://schemas.microsoft.com/office/drawing/2014/main" id="{B32441B0-47E7-4324-9DC0-AE0978FBF9C6}"/>
-              </a:ext>
-            </a:extLst>
-          </p:cNvPr>
-          <p:cNvSpPr>
-            <a:spLocks xmlns:a="http://schemas.openxmlformats.org/drawingml/2006/main" noGrp="1"/>
-          </p:cNvSpPr>
-          <p:nvPr/>
-        </p:nvSpPr>
-        <p:spPr>
-          <a:xfrm xmlns:a="http://schemas.openxmlformats.org/drawingml/2006/main">
-            <a:off x="9772650" y="5524500"/>
-            <a:ext cx="7696200" cy="209550"/>
-          </a:xfrm>
-          <a:prstGeom xmlns:a="http://schemas.openxmlformats.org/drawingml/2006/main" prst="rect">
-            <a:avLst/>
-          </a:prstGeom>
-        </p:spPr>
-        <p:txBody>
-          <a:bodyPr xmlns:a="http://schemas.openxmlformats.org/drawingml/2006/main" lIns="0" tIns="0" rIns="0" bIns="0"/>
-          <a:lstStyle xmlns:a="http://schemas.openxmlformats.org/drawingml/2006/main"/>
-          <a:p xmlns:a="http://schemas.openxmlformats.org/drawingml/2006/main">
-            <a:pPr>
-              <a:defRPr sz="1575">
-                <a:solidFill>
-                  <a:srgbClr val="596473"/>
-                </a:solidFill>
-              </a:defRPr>
-            </a:pPr>
-            <a:r>
-              <a:rPr sz="1575">
-                <a:solidFill>
-                  <a:srgbClr val="596473"/>
-                </a:solidFill>
-              </a:rPr>
-              <a:t>paid action requirement</a:t>
-            </a:r>
-          </a:p>
-        </p:txBody>
-      </p:sp>
-      <p:sp>
-        <p:nvSpPr>
-          <p:cNvPr id="26" name="metric-note-paid action requirement">
-            <a:extLst xmlns:a="http://schemas.openxmlformats.org/drawingml/2006/main">
-              <a:ext uri="{FF2B5EF4-FFF2-40B4-BE49-F238E27FC236}">
-                <a16:creationId xmlns:a16="http://schemas.microsoft.com/office/drawing/2014/main" id="{A3BA1826-A11D-4B6A-9EC9-6C51A86FD6BE}"/>
-              </a:ext>
-            </a:extLst>
-          </p:cNvPr>
-          <p:cNvSpPr>
-            <a:spLocks xmlns:a="http://schemas.openxmlformats.org/drawingml/2006/main" noGrp="1"/>
-          </p:cNvSpPr>
-          <p:nvPr/>
-        </p:nvSpPr>
-        <p:spPr>
-          <a:xfrm xmlns:a="http://schemas.openxmlformats.org/drawingml/2006/main">
-            <a:off x="9772650" y="5810250"/>
-            <a:ext cx="7696200" cy="152400"/>
-          </a:xfrm>
-          <a:prstGeom xmlns:a="http://schemas.openxmlformats.org/drawingml/2006/main" prst="rect">
-            <a:avLst/>
-          </a:prstGeom>
-        </p:spPr>
-        <p:txBody>
-          <a:bodyPr xmlns:a="http://schemas.openxmlformats.org/drawingml/2006/main" lIns="0" tIns="0" rIns="0" bIns="0"/>
-          <a:lstStyle xmlns:a="http://schemas.openxmlformats.org/drawingml/2006/main"/>
-          <a:p xmlns:a="http://schemas.openxmlformats.org/drawingml/2006/main">
-            <a:pPr>
-              <a:defRPr sz="1200">
-                <a:solidFill>
-                  <a:srgbClr val="8490A0"/>
-                </a:solidFill>
-              </a:defRPr>
-            </a:pPr>
-            <a:r>
-              <a:rPr sz="1200">
-                <a:solidFill>
-                  <a:srgbClr val="8490A0"/>
-                </a:solidFill>
-              </a:rPr>
-              <a:t>provider prices stay below the cap</a:t>
-            </a:r>
-          </a:p>
-        </p:txBody>
-      </p:sp>
-      <p:sp>
-        <p:nvSpPr>
-          <p:cNvPr id="27" name="">
-            <a:extLst xmlns:a="http://schemas.openxmlformats.org/drawingml/2006/main">
-              <a:ext uri="{FF2B5EF4-FFF2-40B4-BE49-F238E27FC236}">
-                <a16:creationId xmlns:a16="http://schemas.microsoft.com/office/drawing/2014/main" id="{8E2F2DAB-122F-4688-B91A-C149467E80E1}"/>
-              </a:ext>
-            </a:extLst>
-          </p:cNvPr>
-          <p:cNvSpPr>
-            <a:spLocks xmlns:a="http://schemas.openxmlformats.org/drawingml/2006/main" noGrp="1"/>
-          </p:cNvSpPr>
-          <p:nvPr/>
-        </p:nvSpPr>
-        <p:spPr>
-          <a:xfrm xmlns:a="http://schemas.openxmlformats.org/drawingml/2006/main">
-            <a:off x="9772650" y="6210300"/>
-            <a:ext cx="7696200" cy="57150"/>
+                  <a:srgbClr val="B8C2CC"/>
+                </a:solidFill>
+              </a:rPr>
+              <a:t>verified receipt tx</a:t>
+            </a:r>
+          </a:p>
+        </p:txBody>
+      </p:sp>
+      <p:sp>
+        <p:nvSpPr>
+          <p:cNvPr id="28" name="">
+            <a:extLst xmlns:a="http://schemas.openxmlformats.org/drawingml/2006/main">
+              <a:ext uri="{FF2B5EF4-FFF2-40B4-BE49-F238E27FC236}">
+                <a16:creationId xmlns:a16="http://schemas.microsoft.com/office/drawing/2014/main" id="{AFB74BD1-1E41-46CC-A323-422562F098D9}"/>
+              </a:ext>
+            </a:extLst>
+          </p:cNvPr>
+          <p:cNvSpPr>
+            <a:spLocks xmlns:a="http://schemas.openxmlformats.org/drawingml/2006/main" noGrp="1"/>
+          </p:cNvSpPr>
+          <p:nvPr/>
+        </p:nvSpPr>
+        <p:spPr>
+          <a:xfrm xmlns:a="http://schemas.openxmlformats.org/drawingml/2006/main">
+            <a:off x="10477500" y="6172200"/>
+            <a:ext cx="3181350" cy="57150"/>
           </a:xfrm>
           <a:prstGeom xmlns:a="http://schemas.openxmlformats.org/drawingml/2006/main" prst="rect">
             <a:avLst/>
@@ -7984,169 +8019,122 @@
       </p:sp>
       <p:sp>
         <p:nvSpPr>
-          <p:cNvPr id="28" name="metric-value-batch user authorization">
-            <a:extLst xmlns:a="http://schemas.openxmlformats.org/drawingml/2006/main">
-              <a:ext uri="{FF2B5EF4-FFF2-40B4-BE49-F238E27FC236}">
-                <a16:creationId xmlns:a16="http://schemas.microsoft.com/office/drawing/2014/main" id="{1A05E34B-4CC5-413C-A766-CE98AE5A677A}"/>
-              </a:ext>
-            </a:extLst>
-          </p:cNvPr>
-          <p:cNvSpPr>
-            <a:spLocks xmlns:a="http://schemas.openxmlformats.org/drawingml/2006/main" noGrp="1"/>
-          </p:cNvSpPr>
-          <p:nvPr/>
-        </p:nvSpPr>
-        <p:spPr>
-          <a:xfrm xmlns:a="http://schemas.openxmlformats.org/drawingml/2006/main">
-            <a:off x="9772650" y="6362700"/>
-            <a:ext cx="7696200" cy="476250"/>
-          </a:xfrm>
-          <a:prstGeom xmlns:a="http://schemas.openxmlformats.org/drawingml/2006/main" prst="rect">
-            <a:avLst/>
-          </a:prstGeom>
-        </p:spPr>
-        <p:txBody>
-          <a:bodyPr xmlns:a="http://schemas.openxmlformats.org/drawingml/2006/main" lIns="0" tIns="0" rIns="0" bIns="0"/>
-          <a:lstStyle xmlns:a="http://schemas.openxmlformats.org/drawingml/2006/main"/>
-          <a:p xmlns:a="http://schemas.openxmlformats.org/drawingml/2006/main">
-            <a:pPr>
-              <a:defRPr sz="3750" b="1">
-                <a:solidFill>
-                  <a:srgbClr val="0B1220"/>
-                </a:solidFill>
-              </a:defRPr>
-            </a:pPr>
-            <a:r>
-              <a:rPr sz="3750" b="1">
-                <a:solidFill>
-                  <a:srgbClr val="0B1220"/>
-                </a:solidFill>
-              </a:rPr>
-              <a:t>1</a:t>
-            </a:r>
-          </a:p>
-        </p:txBody>
-      </p:sp>
-      <p:sp>
-        <p:nvSpPr>
-          <p:cNvPr id="29" name="metric-label-batch user authorization">
-            <a:extLst xmlns:a="http://schemas.openxmlformats.org/drawingml/2006/main">
-              <a:ext uri="{FF2B5EF4-FFF2-40B4-BE49-F238E27FC236}">
-                <a16:creationId xmlns:a16="http://schemas.microsoft.com/office/drawing/2014/main" id="{3C2A8FA1-4723-4F95-AA03-D37DA3ECFF3C}"/>
-              </a:ext>
-            </a:extLst>
-          </p:cNvPr>
-          <p:cNvSpPr>
-            <a:spLocks xmlns:a="http://schemas.openxmlformats.org/drawingml/2006/main" noGrp="1"/>
-          </p:cNvSpPr>
-          <p:nvPr/>
-        </p:nvSpPr>
-        <p:spPr>
-          <a:xfrm xmlns:a="http://schemas.openxmlformats.org/drawingml/2006/main">
-            <a:off x="9772650" y="6915150"/>
-            <a:ext cx="7696200" cy="209550"/>
-          </a:xfrm>
-          <a:prstGeom xmlns:a="http://schemas.openxmlformats.org/drawingml/2006/main" prst="rect">
-            <a:avLst/>
-          </a:prstGeom>
-        </p:spPr>
-        <p:txBody>
-          <a:bodyPr xmlns:a="http://schemas.openxmlformats.org/drawingml/2006/main" lIns="0" tIns="0" rIns="0" bIns="0"/>
-          <a:lstStyle xmlns:a="http://schemas.openxmlformats.org/drawingml/2006/main"/>
-          <a:p xmlns:a="http://schemas.openxmlformats.org/drawingml/2006/main">
-            <a:pPr>
-              <a:defRPr sz="1575">
-                <a:solidFill>
-                  <a:srgbClr val="596473"/>
-                </a:solidFill>
-              </a:defRPr>
-            </a:pPr>
-            <a:r>
-              <a:rPr sz="1575">
-                <a:solidFill>
-                  <a:srgbClr val="596473"/>
-                </a:solidFill>
-              </a:rPr>
-              <a:t>batch user authorization</a:t>
-            </a:r>
-          </a:p>
-        </p:txBody>
-      </p:sp>
-      <p:sp>
-        <p:nvSpPr>
-          <p:cNvPr id="30" name="metric-note-batch user authorization">
-            <a:extLst xmlns:a="http://schemas.openxmlformats.org/drawingml/2006/main">
-              <a:ext uri="{FF2B5EF4-FFF2-40B4-BE49-F238E27FC236}">
-                <a16:creationId xmlns:a16="http://schemas.microsoft.com/office/drawing/2014/main" id="{B7CB9331-C53E-43DC-807E-C4904B66BAFF}"/>
-              </a:ext>
-            </a:extLst>
-          </p:cNvPr>
-          <p:cNvSpPr>
-            <a:spLocks xmlns:a="http://schemas.openxmlformats.org/drawingml/2006/main" noGrp="1"/>
-          </p:cNvSpPr>
-          <p:nvPr/>
-        </p:nvSpPr>
-        <p:spPr>
-          <a:xfrm xmlns:a="http://schemas.openxmlformats.org/drawingml/2006/main">
-            <a:off x="9772650" y="7200900"/>
-            <a:ext cx="7696200" cy="152400"/>
-          </a:xfrm>
-          <a:prstGeom xmlns:a="http://schemas.openxmlformats.org/drawingml/2006/main" prst="rect">
-            <a:avLst/>
-          </a:prstGeom>
-        </p:spPr>
-        <p:txBody>
-          <a:bodyPr xmlns:a="http://schemas.openxmlformats.org/drawingml/2006/main" lIns="0" tIns="0" rIns="0" bIns="0"/>
-          <a:lstStyle xmlns:a="http://schemas.openxmlformats.org/drawingml/2006/main"/>
-          <a:p xmlns:a="http://schemas.openxmlformats.org/drawingml/2006/main">
-            <a:pPr>
-              <a:defRPr sz="1200">
-                <a:solidFill>
-                  <a:srgbClr val="8490A0"/>
-                </a:solidFill>
-              </a:defRPr>
-            </a:pPr>
-            <a:r>
-              <a:rPr sz="1200">
-                <a:solidFill>
-                  <a:srgbClr val="8490A0"/>
-                </a:solidFill>
-              </a:rPr>
-              <a:t>selected proof count, one signature</a:t>
-            </a:r>
-          </a:p>
-        </p:txBody>
-      </p:sp>
-      <p:sp>
-        <p:nvSpPr>
-          <p:cNvPr id="31" name="badge-test">
-            <a:extLst xmlns:a="http://schemas.openxmlformats.org/drawingml/2006/main">
-              <a:ext uri="{FF2B5EF4-FFF2-40B4-BE49-F238E27FC236}">
-                <a16:creationId xmlns:a16="http://schemas.microsoft.com/office/drawing/2014/main" id="{30F0B278-EC60-40E2-AAD3-1DB6EC75C241}"/>
-              </a:ext>
-            </a:extLst>
-          </p:cNvPr>
-          <p:cNvSpPr>
-            <a:spLocks xmlns:a="http://schemas.openxmlformats.org/drawingml/2006/main" noGrp="1"/>
-          </p:cNvSpPr>
-          <p:nvPr/>
-        </p:nvSpPr>
-        <p:spPr>
-          <a:xfrm xmlns:a="http://schemas.openxmlformats.org/drawingml/2006/main">
-            <a:off x="9773841" y="7600950"/>
-            <a:ext cx="1323975" cy="371475"/>
-          </a:xfrm>
-          <a:prstGeom xmlns:a="http://schemas.openxmlformats.org/drawingml/2006/main" prst="roundRect">
-            <a:avLst>
-              <a:gd name="adj" fmla="val 15385"/>
-            </a:avLst>
+          <p:cNvPr id="29" name="dark-metric-value-per paid action">
+            <a:extLst xmlns:a="http://schemas.openxmlformats.org/drawingml/2006/main">
+              <a:ext uri="{FF2B5EF4-FFF2-40B4-BE49-F238E27FC236}">
+                <a16:creationId xmlns:a16="http://schemas.microsoft.com/office/drawing/2014/main" id="{C18E1CC1-B72A-4A04-B23C-89F389F4C851}"/>
+              </a:ext>
+            </a:extLst>
+          </p:cNvPr>
+          <p:cNvSpPr>
+            <a:spLocks xmlns:a="http://schemas.openxmlformats.org/drawingml/2006/main" noGrp="1"/>
+          </p:cNvSpPr>
+          <p:nvPr/>
+        </p:nvSpPr>
+        <p:spPr>
+          <a:xfrm xmlns:a="http://schemas.openxmlformats.org/drawingml/2006/main">
+            <a:off x="10477500" y="6324600"/>
+            <a:ext cx="3181350" cy="400050"/>
+          </a:xfrm>
+          <a:prstGeom xmlns:a="http://schemas.openxmlformats.org/drawingml/2006/main" prst="rect">
+            <a:avLst/>
+          </a:prstGeom>
+        </p:spPr>
+        <p:txBody>
+          <a:bodyPr xmlns:a="http://schemas.openxmlformats.org/drawingml/2006/main" lIns="0" tIns="0" rIns="0" bIns="0"/>
+          <a:lstStyle xmlns:a="http://schemas.openxmlformats.org/drawingml/2006/main"/>
+          <a:p xmlns:a="http://schemas.openxmlformats.org/drawingml/2006/main">
+            <a:pPr>
+              <a:defRPr sz="3150" b="1">
+                <a:solidFill>
+                  <a:srgbClr val="FFFFFF"/>
+                </a:solidFill>
+              </a:defRPr>
+            </a:pPr>
+            <a:r>
+              <a:rPr sz="3150" b="1">
+                <a:solidFill>
+                  <a:srgbClr val="FFFFFF"/>
+                </a:solidFill>
+              </a:rPr>
+              <a:t>&lt; $0.01</a:t>
+            </a:r>
+          </a:p>
+        </p:txBody>
+      </p:sp>
+      <p:sp>
+        <p:nvSpPr>
+          <p:cNvPr id="30" name="dark-metric-label-per paid action">
+            <a:extLst xmlns:a="http://schemas.openxmlformats.org/drawingml/2006/main">
+              <a:ext uri="{FF2B5EF4-FFF2-40B4-BE49-F238E27FC236}">
+                <a16:creationId xmlns:a16="http://schemas.microsoft.com/office/drawing/2014/main" id="{6B637C33-DD08-4A95-A15E-2E3199BC277B}"/>
+              </a:ext>
+            </a:extLst>
+          </p:cNvPr>
+          <p:cNvSpPr>
+            <a:spLocks xmlns:a="http://schemas.openxmlformats.org/drawingml/2006/main" noGrp="1"/>
+          </p:cNvSpPr>
+          <p:nvPr/>
+        </p:nvSpPr>
+        <p:spPr>
+          <a:xfrm xmlns:a="http://schemas.openxmlformats.org/drawingml/2006/main">
+            <a:off x="10477500" y="6819900"/>
+            <a:ext cx="3181350" cy="171450"/>
+          </a:xfrm>
+          <a:prstGeom xmlns:a="http://schemas.openxmlformats.org/drawingml/2006/main" prst="rect">
+            <a:avLst/>
+          </a:prstGeom>
+        </p:spPr>
+        <p:txBody>
+          <a:bodyPr xmlns:a="http://schemas.openxmlformats.org/drawingml/2006/main" lIns="0" tIns="0" rIns="0" bIns="0"/>
+          <a:lstStyle xmlns:a="http://schemas.openxmlformats.org/drawingml/2006/main"/>
+          <a:p xmlns:a="http://schemas.openxmlformats.org/drawingml/2006/main">
+            <a:pPr>
+              <a:defRPr sz="1350">
+                <a:solidFill>
+                  <a:srgbClr val="B8C2CC"/>
+                </a:solidFill>
+              </a:defRPr>
+            </a:pPr>
+            <a:r>
+              <a:rPr sz="1350">
+                <a:solidFill>
+                  <a:srgbClr val="B8C2CC"/>
+                </a:solidFill>
+              </a:rPr>
+              <a:t>per paid action</a:t>
+            </a:r>
+          </a:p>
+        </p:txBody>
+      </p:sp>
+      <p:sp>
+        <p:nvSpPr>
+          <p:cNvPr id="31" name="">
+            <a:extLst xmlns:a="http://schemas.openxmlformats.org/drawingml/2006/main">
+              <a:ext uri="{FF2B5EF4-FFF2-40B4-BE49-F238E27FC236}">
+                <a16:creationId xmlns:a16="http://schemas.microsoft.com/office/drawing/2014/main" id="{192AF2C9-BC12-426B-8B7E-23EA32630C2C}"/>
+              </a:ext>
+            </a:extLst>
+          </p:cNvPr>
+          <p:cNvSpPr>
+            <a:spLocks xmlns:a="http://schemas.openxmlformats.org/drawingml/2006/main" noGrp="1"/>
+          </p:cNvSpPr>
+          <p:nvPr/>
+        </p:nvSpPr>
+        <p:spPr>
+          <a:xfrm xmlns:a="http://schemas.openxmlformats.org/drawingml/2006/main">
+            <a:off x="13887450" y="6172200"/>
+            <a:ext cx="3181350" cy="57150"/>
+          </a:xfrm>
+          <a:prstGeom xmlns:a="http://schemas.openxmlformats.org/drawingml/2006/main" prst="rect">
+            <a:avLst/>
           </a:prstGeom>
           <a:solidFill xmlns:a="http://schemas.openxmlformats.org/drawingml/2006/main">
-            <a:srgbClr val="FFFFFF"/>
+            <a:srgbClr val="2878B8"/>
           </a:solidFill>
-          <a:ln xmlns:a="http://schemas.openxmlformats.org/drawingml/2006/main" w="13335">
+          <a:ln xmlns:a="http://schemas.openxmlformats.org/drawingml/2006/main" w="0">
             <a:solidFill>
-              <a:srgbClr val="007A58"/>
+              <a:srgbClr val="2878B8"/>
             </a:solidFill>
             <a:prstDash val="solid"/>
           </a:ln>
@@ -8154,314 +8142,190 @@
       </p:sp>
       <p:sp>
         <p:nvSpPr>
-          <p:cNvPr id="32" name="">
-            <a:extLst xmlns:a="http://schemas.openxmlformats.org/drawingml/2006/main">
-              <a:ext uri="{FF2B5EF4-FFF2-40B4-BE49-F238E27FC236}">
-                <a16:creationId xmlns:a16="http://schemas.microsoft.com/office/drawing/2014/main" id="{5BC3855C-9121-4096-896A-B77443FC8EE9}"/>
-              </a:ext>
-            </a:extLst>
-          </p:cNvPr>
-          <p:cNvSpPr>
-            <a:spLocks xmlns:a="http://schemas.openxmlformats.org/drawingml/2006/main" noGrp="1"/>
-          </p:cNvSpPr>
-          <p:nvPr/>
-        </p:nvSpPr>
-        <p:spPr>
-          <a:xfrm xmlns:a="http://schemas.openxmlformats.org/drawingml/2006/main">
-            <a:off x="9944100" y="7734300"/>
-            <a:ext cx="123825" cy="123825"/>
-          </a:xfrm>
-          <a:prstGeom xmlns:a="http://schemas.openxmlformats.org/drawingml/2006/main" prst="rect">
-            <a:avLst/>
-          </a:prstGeom>
-          <a:solidFill xmlns:a="http://schemas.openxmlformats.org/drawingml/2006/main">
-            <a:srgbClr val="007A58"/>
-          </a:solidFill>
-          <a:ln xmlns:a="http://schemas.openxmlformats.org/drawingml/2006/main" w="0">
-            <a:solidFill>
-              <a:srgbClr val="007A58"/>
-            </a:solidFill>
-            <a:prstDash val="solid"/>
-          </a:ln>
-        </p:spPr>
-      </p:sp>
-      <p:sp>
-        <p:nvSpPr>
-          <p:cNvPr id="33" name="badge-text-test">
-            <a:extLst xmlns:a="http://schemas.openxmlformats.org/drawingml/2006/main">
-              <a:ext uri="{FF2B5EF4-FFF2-40B4-BE49-F238E27FC236}">
-                <a16:creationId xmlns:a16="http://schemas.microsoft.com/office/drawing/2014/main" id="{C2BD986D-53E3-4540-9E1F-0D0A7262FD4C}"/>
-              </a:ext>
-            </a:extLst>
-          </p:cNvPr>
-          <p:cNvSpPr>
-            <a:spLocks xmlns:a="http://schemas.openxmlformats.org/drawingml/2006/main" noGrp="1"/>
-          </p:cNvSpPr>
-          <p:nvPr/>
-        </p:nvSpPr>
-        <p:spPr>
-          <a:xfrm xmlns:a="http://schemas.openxmlformats.org/drawingml/2006/main">
-            <a:off x="10191750" y="7715250"/>
-            <a:ext cx="742950" cy="152400"/>
-          </a:xfrm>
-          <a:prstGeom xmlns:a="http://schemas.openxmlformats.org/drawingml/2006/main" prst="rect">
-            <a:avLst/>
-          </a:prstGeom>
-        </p:spPr>
-        <p:txBody>
-          <a:bodyPr xmlns:a="http://schemas.openxmlformats.org/drawingml/2006/main" lIns="0" tIns="0" rIns="0" bIns="0"/>
-          <a:lstStyle xmlns:a="http://schemas.openxmlformats.org/drawingml/2006/main"/>
-          <a:p xmlns:a="http://schemas.openxmlformats.org/drawingml/2006/main">
-            <a:pPr>
-              <a:defRPr sz="1275" b="1">
-                <a:solidFill>
-                  <a:srgbClr val="0B1220"/>
-                </a:solidFill>
-              </a:defRPr>
-            </a:pPr>
-            <a:r>
-              <a:rPr sz="1275" b="1">
-                <a:solidFill>
-                  <a:srgbClr val="0B1220"/>
-                </a:solidFill>
-              </a:rPr>
-              <a:t>test</a:t>
-            </a:r>
-          </a:p>
-        </p:txBody>
-      </p:sp>
-      <p:sp>
-        <p:nvSpPr>
-          <p:cNvPr id="34" name="badge-arc proof">
-            <a:extLst xmlns:a="http://schemas.openxmlformats.org/drawingml/2006/main">
-              <a:ext uri="{FF2B5EF4-FFF2-40B4-BE49-F238E27FC236}">
-                <a16:creationId xmlns:a16="http://schemas.microsoft.com/office/drawing/2014/main" id="{42F62485-4B73-48FA-BE1F-D27F960457CD}"/>
-              </a:ext>
-            </a:extLst>
-          </p:cNvPr>
-          <p:cNvSpPr>
-            <a:spLocks xmlns:a="http://schemas.openxmlformats.org/drawingml/2006/main" noGrp="1"/>
-          </p:cNvSpPr>
-          <p:nvPr/>
-        </p:nvSpPr>
-        <p:spPr>
-          <a:xfrm xmlns:a="http://schemas.openxmlformats.org/drawingml/2006/main">
-            <a:off x="11269266" y="7600950"/>
-            <a:ext cx="1771650" cy="371475"/>
-          </a:xfrm>
-          <a:prstGeom xmlns:a="http://schemas.openxmlformats.org/drawingml/2006/main" prst="roundRect">
-            <a:avLst>
-              <a:gd name="adj" fmla="val 15385"/>
-            </a:avLst>
-          </a:prstGeom>
-          <a:solidFill xmlns:a="http://schemas.openxmlformats.org/drawingml/2006/main">
-            <a:srgbClr val="FFFFFF"/>
-          </a:solidFill>
-          <a:ln xmlns:a="http://schemas.openxmlformats.org/drawingml/2006/main" w="13335">
-            <a:solidFill>
-              <a:srgbClr val="0D9488"/>
-            </a:solidFill>
-            <a:prstDash val="solid"/>
-          </a:ln>
-        </p:spPr>
-      </p:sp>
-      <p:sp>
-        <p:nvSpPr>
-          <p:cNvPr id="35" name="">
-            <a:extLst xmlns:a="http://schemas.openxmlformats.org/drawingml/2006/main">
-              <a:ext uri="{FF2B5EF4-FFF2-40B4-BE49-F238E27FC236}">
-                <a16:creationId xmlns:a16="http://schemas.microsoft.com/office/drawing/2014/main" id="{1E9E4674-03C9-4A48-AE05-BBC31464FD27}"/>
-              </a:ext>
-            </a:extLst>
-          </p:cNvPr>
-          <p:cNvSpPr>
-            <a:spLocks xmlns:a="http://schemas.openxmlformats.org/drawingml/2006/main" noGrp="1"/>
-          </p:cNvSpPr>
-          <p:nvPr/>
-        </p:nvSpPr>
-        <p:spPr>
-          <a:xfrm xmlns:a="http://schemas.openxmlformats.org/drawingml/2006/main">
-            <a:off x="11449050" y="7734300"/>
-            <a:ext cx="123825" cy="123825"/>
-          </a:xfrm>
-          <a:prstGeom xmlns:a="http://schemas.openxmlformats.org/drawingml/2006/main" prst="rect">
-            <a:avLst/>
-          </a:prstGeom>
-          <a:solidFill xmlns:a="http://schemas.openxmlformats.org/drawingml/2006/main">
-            <a:srgbClr val="0D9488"/>
-          </a:solidFill>
-          <a:ln xmlns:a="http://schemas.openxmlformats.org/drawingml/2006/main" w="0">
-            <a:solidFill>
-              <a:srgbClr val="0D9488"/>
-            </a:solidFill>
-            <a:prstDash val="solid"/>
-          </a:ln>
-        </p:spPr>
-      </p:sp>
-      <p:sp>
-        <p:nvSpPr>
-          <p:cNvPr id="36" name="badge-text-arc proof">
-            <a:extLst xmlns:a="http://schemas.openxmlformats.org/drawingml/2006/main">
-              <a:ext uri="{FF2B5EF4-FFF2-40B4-BE49-F238E27FC236}">
-                <a16:creationId xmlns:a16="http://schemas.microsoft.com/office/drawing/2014/main" id="{6E79E221-E421-430F-9D23-DDD5AE30029F}"/>
-              </a:ext>
-            </a:extLst>
-          </p:cNvPr>
-          <p:cNvSpPr>
-            <a:spLocks xmlns:a="http://schemas.openxmlformats.org/drawingml/2006/main" noGrp="1"/>
-          </p:cNvSpPr>
-          <p:nvPr/>
-        </p:nvSpPr>
-        <p:spPr>
-          <a:xfrm xmlns:a="http://schemas.openxmlformats.org/drawingml/2006/main">
-            <a:off x="11677650" y="7715250"/>
-            <a:ext cx="1190625" cy="152400"/>
-          </a:xfrm>
-          <a:prstGeom xmlns:a="http://schemas.openxmlformats.org/drawingml/2006/main" prst="rect">
-            <a:avLst/>
-          </a:prstGeom>
-        </p:spPr>
-        <p:txBody>
-          <a:bodyPr xmlns:a="http://schemas.openxmlformats.org/drawingml/2006/main" lIns="0" tIns="0" rIns="0" bIns="0"/>
-          <a:lstStyle xmlns:a="http://schemas.openxmlformats.org/drawingml/2006/main"/>
-          <a:p xmlns:a="http://schemas.openxmlformats.org/drawingml/2006/main">
-            <a:pPr>
-              <a:defRPr sz="1275" b="1">
-                <a:solidFill>
-                  <a:srgbClr val="0B1220"/>
-                </a:solidFill>
-              </a:defRPr>
-            </a:pPr>
-            <a:r>
-              <a:rPr sz="1275" b="1">
-                <a:solidFill>
-                  <a:srgbClr val="0B1220"/>
-                </a:solidFill>
-              </a:rPr>
-              <a:t>arc proof</a:t>
-            </a:r>
-          </a:p>
-        </p:txBody>
-      </p:sp>
-      <p:sp>
-        <p:nvSpPr>
-          <p:cNvPr id="37" name="badge-50 tx proof">
-            <a:extLst xmlns:a="http://schemas.openxmlformats.org/drawingml/2006/main">
-              <a:ext uri="{FF2B5EF4-FFF2-40B4-BE49-F238E27FC236}">
-                <a16:creationId xmlns:a16="http://schemas.microsoft.com/office/drawing/2014/main" id="{8D96026F-79B6-4D5F-98F7-E24CD7B2146E}"/>
-              </a:ext>
-            </a:extLst>
-          </p:cNvPr>
-          <p:cNvSpPr>
-            <a:spLocks xmlns:a="http://schemas.openxmlformats.org/drawingml/2006/main" noGrp="1"/>
-          </p:cNvSpPr>
-          <p:nvPr/>
-        </p:nvSpPr>
-        <p:spPr>
-          <a:xfrm xmlns:a="http://schemas.openxmlformats.org/drawingml/2006/main">
-            <a:off x="13212366" y="7600950"/>
-            <a:ext cx="1981200" cy="371475"/>
-          </a:xfrm>
-          <a:prstGeom xmlns:a="http://schemas.openxmlformats.org/drawingml/2006/main" prst="roundRect">
-            <a:avLst>
-              <a:gd name="adj" fmla="val 15385"/>
-            </a:avLst>
-          </a:prstGeom>
-          <a:solidFill xmlns:a="http://schemas.openxmlformats.org/drawingml/2006/main">
-            <a:srgbClr val="FFFFFF"/>
-          </a:solidFill>
-          <a:ln xmlns:a="http://schemas.openxmlformats.org/drawingml/2006/main" w="13335">
-            <a:solidFill>
-              <a:srgbClr val="E04F43"/>
-            </a:solidFill>
-            <a:prstDash val="solid"/>
-          </a:ln>
-        </p:spPr>
-      </p:sp>
-      <p:sp>
-        <p:nvSpPr>
-          <p:cNvPr id="38" name="">
-            <a:extLst xmlns:a="http://schemas.openxmlformats.org/drawingml/2006/main">
-              <a:ext uri="{FF2B5EF4-FFF2-40B4-BE49-F238E27FC236}">
-                <a16:creationId xmlns:a16="http://schemas.microsoft.com/office/drawing/2014/main" id="{55306E83-FF2C-43B9-AFC7-B6465F064848}"/>
-              </a:ext>
-            </a:extLst>
-          </p:cNvPr>
-          <p:cNvSpPr>
-            <a:spLocks xmlns:a="http://schemas.openxmlformats.org/drawingml/2006/main" noGrp="1"/>
-          </p:cNvSpPr>
-          <p:nvPr/>
-        </p:nvSpPr>
-        <p:spPr>
-          <a:xfrm xmlns:a="http://schemas.openxmlformats.org/drawingml/2006/main">
-            <a:off x="13392150" y="7734300"/>
-            <a:ext cx="123825" cy="123825"/>
-          </a:xfrm>
-          <a:prstGeom xmlns:a="http://schemas.openxmlformats.org/drawingml/2006/main" prst="rect">
-            <a:avLst/>
-          </a:prstGeom>
-          <a:solidFill xmlns:a="http://schemas.openxmlformats.org/drawingml/2006/main">
-            <a:srgbClr val="E04F43"/>
-          </a:solidFill>
-          <a:ln xmlns:a="http://schemas.openxmlformats.org/drawingml/2006/main" w="0">
-            <a:solidFill>
-              <a:srgbClr val="E04F43"/>
-            </a:solidFill>
-            <a:prstDash val="solid"/>
-          </a:ln>
-        </p:spPr>
-      </p:sp>
-      <p:sp>
-        <p:nvSpPr>
-          <p:cNvPr id="39" name="badge-text-50 tx proof">
-            <a:extLst xmlns:a="http://schemas.openxmlformats.org/drawingml/2006/main">
-              <a:ext uri="{FF2B5EF4-FFF2-40B4-BE49-F238E27FC236}">
-                <a16:creationId xmlns:a16="http://schemas.microsoft.com/office/drawing/2014/main" id="{CBEC7578-8EB7-4627-A953-39A6B39BDD67}"/>
-              </a:ext>
-            </a:extLst>
-          </p:cNvPr>
-          <p:cNvSpPr>
-            <a:spLocks xmlns:a="http://schemas.openxmlformats.org/drawingml/2006/main" noGrp="1"/>
-          </p:cNvSpPr>
-          <p:nvPr/>
-        </p:nvSpPr>
-        <p:spPr>
-          <a:xfrm xmlns:a="http://schemas.openxmlformats.org/drawingml/2006/main">
-            <a:off x="13620750" y="7715250"/>
-            <a:ext cx="1400175" cy="152400"/>
-          </a:xfrm>
-          <a:prstGeom xmlns:a="http://schemas.openxmlformats.org/drawingml/2006/main" prst="rect">
-            <a:avLst/>
-          </a:prstGeom>
-        </p:spPr>
-        <p:txBody>
-          <a:bodyPr xmlns:a="http://schemas.openxmlformats.org/drawingml/2006/main" lIns="0" tIns="0" rIns="0" bIns="0"/>
-          <a:lstStyle xmlns:a="http://schemas.openxmlformats.org/drawingml/2006/main"/>
-          <a:p xmlns:a="http://schemas.openxmlformats.org/drawingml/2006/main">
-            <a:pPr>
-              <a:defRPr sz="1275" b="1">
-                <a:solidFill>
-                  <a:srgbClr val="0B1220"/>
-                </a:solidFill>
-              </a:defRPr>
-            </a:pPr>
-            <a:r>
-              <a:rPr sz="1275" b="1">
-                <a:solidFill>
-                  <a:srgbClr val="0B1220"/>
-                </a:solidFill>
-              </a:rPr>
-              <a:t>50 tx proof</a:t>
-            </a:r>
-          </a:p>
-        </p:txBody>
-      </p:sp>
-      <p:sp>
-        <p:nvSpPr>
-          <p:cNvPr id="40" name="footer-left">
-            <a:extLst xmlns:a="http://schemas.openxmlformats.org/drawingml/2006/main">
-              <a:ext uri="{FF2B5EF4-FFF2-40B4-BE49-F238E27FC236}">
-                <a16:creationId xmlns:a16="http://schemas.microsoft.com/office/drawing/2014/main" id="{2B10328F-187B-49E1-BAB0-BB03B3765B1D}"/>
+          <p:cNvPr id="32" name="dark-metric-value-batch authorization">
+            <a:extLst xmlns:a="http://schemas.openxmlformats.org/drawingml/2006/main">
+              <a:ext uri="{FF2B5EF4-FFF2-40B4-BE49-F238E27FC236}">
+                <a16:creationId xmlns:a16="http://schemas.microsoft.com/office/drawing/2014/main" id="{3450FF6E-0307-487A-9DC2-9C709CB850DD}"/>
+              </a:ext>
+            </a:extLst>
+          </p:cNvPr>
+          <p:cNvSpPr>
+            <a:spLocks xmlns:a="http://schemas.openxmlformats.org/drawingml/2006/main" noGrp="1"/>
+          </p:cNvSpPr>
+          <p:nvPr/>
+        </p:nvSpPr>
+        <p:spPr>
+          <a:xfrm xmlns:a="http://schemas.openxmlformats.org/drawingml/2006/main">
+            <a:off x="13887450" y="6324600"/>
+            <a:ext cx="3181350" cy="400050"/>
+          </a:xfrm>
+          <a:prstGeom xmlns:a="http://schemas.openxmlformats.org/drawingml/2006/main" prst="rect">
+            <a:avLst/>
+          </a:prstGeom>
+        </p:spPr>
+        <p:txBody>
+          <a:bodyPr xmlns:a="http://schemas.openxmlformats.org/drawingml/2006/main" lIns="0" tIns="0" rIns="0" bIns="0"/>
+          <a:lstStyle xmlns:a="http://schemas.openxmlformats.org/drawingml/2006/main"/>
+          <a:p xmlns:a="http://schemas.openxmlformats.org/drawingml/2006/main">
+            <a:pPr>
+              <a:defRPr sz="3150" b="1">
+                <a:solidFill>
+                  <a:srgbClr val="FFFFFF"/>
+                </a:solidFill>
+              </a:defRPr>
+            </a:pPr>
+            <a:r>
+              <a:rPr sz="3150" b="1">
+                <a:solidFill>
+                  <a:srgbClr val="FFFFFF"/>
+                </a:solidFill>
+              </a:rPr>
+              <a:t>1</a:t>
+            </a:r>
+          </a:p>
+        </p:txBody>
+      </p:sp>
+      <p:sp>
+        <p:nvSpPr>
+          <p:cNvPr id="33" name="dark-metric-label-batch authorization">
+            <a:extLst xmlns:a="http://schemas.openxmlformats.org/drawingml/2006/main">
+              <a:ext uri="{FF2B5EF4-FFF2-40B4-BE49-F238E27FC236}">
+                <a16:creationId xmlns:a16="http://schemas.microsoft.com/office/drawing/2014/main" id="{36087837-402E-479A-A65B-F0858DFB7A2B}"/>
+              </a:ext>
+            </a:extLst>
+          </p:cNvPr>
+          <p:cNvSpPr>
+            <a:spLocks xmlns:a="http://schemas.openxmlformats.org/drawingml/2006/main" noGrp="1"/>
+          </p:cNvSpPr>
+          <p:nvPr/>
+        </p:nvSpPr>
+        <p:spPr>
+          <a:xfrm xmlns:a="http://schemas.openxmlformats.org/drawingml/2006/main">
+            <a:off x="13887450" y="6819900"/>
+            <a:ext cx="3181350" cy="171450"/>
+          </a:xfrm>
+          <a:prstGeom xmlns:a="http://schemas.openxmlformats.org/drawingml/2006/main" prst="rect">
+            <a:avLst/>
+          </a:prstGeom>
+        </p:spPr>
+        <p:txBody>
+          <a:bodyPr xmlns:a="http://schemas.openxmlformats.org/drawingml/2006/main" lIns="0" tIns="0" rIns="0" bIns="0"/>
+          <a:lstStyle xmlns:a="http://schemas.openxmlformats.org/drawingml/2006/main"/>
+          <a:p xmlns:a="http://schemas.openxmlformats.org/drawingml/2006/main">
+            <a:pPr>
+              <a:defRPr sz="1350">
+                <a:solidFill>
+                  <a:srgbClr val="B8C2CC"/>
+                </a:solidFill>
+              </a:defRPr>
+            </a:pPr>
+            <a:r>
+              <a:rPr sz="1350">
+                <a:solidFill>
+                  <a:srgbClr val="B8C2CC"/>
+                </a:solidFill>
+              </a:rPr>
+              <a:t>batch authorization</a:t>
+            </a:r>
+          </a:p>
+        </p:txBody>
+      </p:sp>
+      <p:sp>
+        <p:nvSpPr>
+          <p:cNvPr id="34" name="closing-app-url">
+            <a:extLst xmlns:a="http://schemas.openxmlformats.org/drawingml/2006/main">
+              <a:ext uri="{FF2B5EF4-FFF2-40B4-BE49-F238E27FC236}">
+                <a16:creationId xmlns:a16="http://schemas.microsoft.com/office/drawing/2014/main" id="{1C792924-8B12-4D6D-B6A5-75239024CA1C}"/>
+              </a:ext>
+            </a:extLst>
+          </p:cNvPr>
+          <p:cNvSpPr>
+            <a:spLocks xmlns:a="http://schemas.openxmlformats.org/drawingml/2006/main" noGrp="1"/>
+          </p:cNvSpPr>
+          <p:nvPr/>
+        </p:nvSpPr>
+        <p:spPr>
+          <a:xfrm xmlns:a="http://schemas.openxmlformats.org/drawingml/2006/main">
+            <a:off x="10477500" y="7562850"/>
+            <a:ext cx="6591300" cy="209550"/>
+          </a:xfrm>
+          <a:prstGeom xmlns:a="http://schemas.openxmlformats.org/drawingml/2006/main" prst="rect">
+            <a:avLst/>
+          </a:prstGeom>
+        </p:spPr>
+        <p:txBody>
+          <a:bodyPr xmlns:a="http://schemas.openxmlformats.org/drawingml/2006/main" lIns="0" tIns="0" rIns="0" bIns="0"/>
+          <a:lstStyle xmlns:a="http://schemas.openxmlformats.org/drawingml/2006/main"/>
+          <a:p xmlns:a="http://schemas.openxmlformats.org/drawingml/2006/main">
+            <a:pPr>
+              <a:defRPr sz="1575" b="1">
+                <a:solidFill>
+                  <a:srgbClr val="FFFFFF"/>
+                </a:solidFill>
+              </a:defRPr>
+            </a:pPr>
+            <a:r>
+              <a:rPr sz="1575" b="1">
+                <a:solidFill>
+                  <a:srgbClr val="FFFFFF"/>
+                </a:solidFill>
+              </a:rPr>
+              <a:t>pennypilot-five.vercel.app</a:t>
+            </a:r>
+          </a:p>
+        </p:txBody>
+      </p:sp>
+      <p:sp>
+        <p:nvSpPr>
+          <p:cNvPr id="35" name="closing-proof-links">
+            <a:extLst xmlns:a="http://schemas.openxmlformats.org/drawingml/2006/main">
+              <a:ext uri="{FF2B5EF4-FFF2-40B4-BE49-F238E27FC236}">
+                <a16:creationId xmlns:a16="http://schemas.microsoft.com/office/drawing/2014/main" id="{889BB70D-BBC5-4B6F-AD74-486A903B0996}"/>
+              </a:ext>
+            </a:extLst>
+          </p:cNvPr>
+          <p:cNvSpPr>
+            <a:spLocks xmlns:a="http://schemas.openxmlformats.org/drawingml/2006/main" noGrp="1"/>
+          </p:cNvSpPr>
+          <p:nvPr/>
+        </p:nvSpPr>
+        <p:spPr>
+          <a:xfrm xmlns:a="http://schemas.openxmlformats.org/drawingml/2006/main">
+            <a:off x="10477500" y="7867650"/>
+            <a:ext cx="6591300" cy="152400"/>
+          </a:xfrm>
+          <a:prstGeom xmlns:a="http://schemas.openxmlformats.org/drawingml/2006/main" prst="rect">
+            <a:avLst/>
+          </a:prstGeom>
+        </p:spPr>
+        <p:txBody>
+          <a:bodyPr xmlns:a="http://schemas.openxmlformats.org/drawingml/2006/main" lIns="0" tIns="0" rIns="0" bIns="0"/>
+          <a:lstStyle xmlns:a="http://schemas.openxmlformats.org/drawingml/2006/main"/>
+          <a:p xmlns:a="http://schemas.openxmlformats.org/drawingml/2006/main">
+            <a:pPr>
+              <a:defRPr sz="1125">
+                <a:solidFill>
+                  <a:srgbClr val="B8C2CC"/>
+                </a:solidFill>
+              </a:defRPr>
+            </a:pPr>
+            <a:r>
+              <a:rPr sz="1125">
+                <a:solidFill>
+                  <a:srgbClr val="B8C2CC"/>
+                </a:solidFill>
+              </a:rPr>
+              <a:t>github.com/Kxazar/pennypilot   /   Arc contract 0x4c8E...3047   /   50 tx 0x9f65...8ee7</a:t>
+            </a:r>
+          </a:p>
+        </p:txBody>
+      </p:sp>
+      <p:sp>
+        <p:nvSpPr>
+          <p:cNvPr id="36" name="footer-left">
+            <a:extLst xmlns:a="http://schemas.openxmlformats.org/drawingml/2006/main">
+              <a:ext uri="{FF2B5EF4-FFF2-40B4-BE49-F238E27FC236}">
+                <a16:creationId xmlns:a16="http://schemas.microsoft.com/office/drawing/2014/main" id="{747FD5CA-32D6-4731-A1EC-21526E76CDDC}"/>
               </a:ext>
             </a:extLst>
           </p:cNvPr>
@@ -8473,7 +8337,7 @@
         <p:spPr>
           <a:xfrm xmlns:a="http://schemas.openxmlformats.org/drawingml/2006/main">
             <a:off x="819150" y="9525000"/>
-            <a:ext cx="1466850" cy="152400"/>
+            <a:ext cx="819150" cy="152400"/>
           </a:xfrm>
           <a:prstGeom xmlns:a="http://schemas.openxmlformats.org/drawingml/2006/main" prst="rect">
             <a:avLst/>
@@ -8496,17 +8360,17 @@
                   <a:srgbClr val="8490A0"/>
                 </a:solidFill>
               </a:rPr>
-              <a:t>Final submission package</a:t>
-            </a:r>
-          </a:p>
-        </p:txBody>
-      </p:sp>
-      <p:sp>
-        <p:nvSpPr>
-          <p:cNvPr id="41" name="footer-right">
-            <a:extLst xmlns:a="http://schemas.openxmlformats.org/drawingml/2006/main">
-              <a:ext uri="{FF2B5EF4-FFF2-40B4-BE49-F238E27FC236}">
-                <a16:creationId xmlns:a16="http://schemas.microsoft.com/office/drawing/2014/main" id="{C4E225C6-9D99-4BCC-ACD6-FE1E917E542E}"/>
+              <a:t>Product thesis</a:t>
+            </a:r>
+          </a:p>
+        </p:txBody>
+      </p:sp>
+      <p:sp>
+        <p:nvSpPr>
+          <p:cNvPr id="37" name="footer-right">
+            <a:extLst xmlns:a="http://schemas.openxmlformats.org/drawingml/2006/main">
+              <a:ext uri="{FF2B5EF4-FFF2-40B4-BE49-F238E27FC236}">
+                <a16:creationId xmlns:a16="http://schemas.microsoft.com/office/drawing/2014/main" id="{5AF6AA73-A077-41DA-837F-620BC872BC49}"/>
               </a:ext>
             </a:extLst>
           </p:cNvPr>
@@ -8549,7 +8413,7 @@
     </p:spTree>
     <p:extLst>
       <p:ext uri="{BB962C8B-B14F-4D97-AF65-F5344CB8AC3E}">
-        <p14:creationId xmlns:p14="http://schemas.microsoft.com/office/powerpoint/2010/main" val="157719555"/>
+        <p14:creationId xmlns:p14="http://schemas.microsoft.com/office/powerpoint/2010/main" val="1895527598"/>
       </p:ext>
     </p:extLst>
   </p:cSld>

</xml_diff>

<commit_message>
Remove internal pitch deck prompts
</commit_message>
<xml_diff>
--- a/presentation/PennyPilot-hackathon-demo.pptx
+++ b/presentation/PennyPilot-hackathon-demo.pptx
@@ -2,17 +2,17 @@
 <file path=ppt/presentation.xml><?xml version="1.0" encoding="utf-8"?>
 <p:presentation xmlns:p="http://schemas.openxmlformats.org/presentationml/2006/main">
   <p:sldMasterIdLst>
-    <p:sldMasterId xmlns:r="http://schemas.openxmlformats.org/officeDocument/2006/relationships" id="2147483648" r:id="R6b611d477f524f3f"/>
+    <p:sldMasterId xmlns:r="http://schemas.openxmlformats.org/officeDocument/2006/relationships" id="2147483648" r:id="R848dd092d1594e29"/>
   </p:sldMasterIdLst>
   <p:notesMasterIdLst>
-    <p:notesMasterId xmlns:r="http://schemas.openxmlformats.org/officeDocument/2006/relationships" r:id="R69ebacc371de4037"/>
+    <p:notesMasterId xmlns:r="http://schemas.openxmlformats.org/officeDocument/2006/relationships" r:id="R0aa65fb2dded4c9a"/>
   </p:notesMasterIdLst>
   <p:sldIdLst>
-    <p:sldId xmlns:r="http://schemas.openxmlformats.org/officeDocument/2006/relationships" id="256" r:id="Rbc6613c0f31640a6"/>
-    <p:sldId xmlns:r="http://schemas.openxmlformats.org/officeDocument/2006/relationships" id="257" r:id="R86e67b9fa0ed486b"/>
-    <p:sldId xmlns:r="http://schemas.openxmlformats.org/officeDocument/2006/relationships" id="258" r:id="R308d113e2e4c464f"/>
-    <p:sldId xmlns:r="http://schemas.openxmlformats.org/officeDocument/2006/relationships" id="259" r:id="Rf89449b9a7c44257"/>
-    <p:sldId xmlns:r="http://schemas.openxmlformats.org/officeDocument/2006/relationships" id="260" r:id="R9f35ede8751b42f9"/>
+    <p:sldId xmlns:r="http://schemas.openxmlformats.org/officeDocument/2006/relationships" id="256" r:id="R71af9553fbd5466d"/>
+    <p:sldId xmlns:r="http://schemas.openxmlformats.org/officeDocument/2006/relationships" id="257" r:id="Racd75de18b18492f"/>
+    <p:sldId xmlns:r="http://schemas.openxmlformats.org/officeDocument/2006/relationships" id="258" r:id="R1110c4a519b149f1"/>
+    <p:sldId xmlns:r="http://schemas.openxmlformats.org/officeDocument/2006/relationships" id="259" r:id="R460efe034d0041ea"/>
+    <p:sldId xmlns:r="http://schemas.openxmlformats.org/officeDocument/2006/relationships" id="260" r:id="Rd71b55aa452d494b"/>
   </p:sldIdLst>
   <p:sldSz cx="18288000" cy="10287000"/>
   <p:notesSz cx="6858000" cy="9144000"/>
@@ -823,7 +823,7 @@
   </p:cSld>
   <p:clrMap bg1="lt1" tx1="dk1" bg2="lt2" tx2="dk2" accent1="accent1" accent2="accent2" accent3="accent3" accent4="accent4" accent5="accent5" accent6="accent6" hlink="hlink" folHlink="folHlink"/>
   <p:sldLayoutIdLst>
-    <p:sldLayoutId xmlns:r="http://schemas.openxmlformats.org/officeDocument/2006/relationships" id="2147483649" r:id="R0314ffc89eb9494a"/>
+    <p:sldLayoutId xmlns:r="http://schemas.openxmlformats.org/officeDocument/2006/relationships" id="2147483649" r:id="R4816a618ad83454f"/>
   </p:sldLayoutIdLst>
   <p:txStyles>
     <p:titleStyle>
@@ -1122,7 +1122,7 @@
           <p:cNvPr id="1" name="slide-background">
             <a:extLst xmlns:a="http://schemas.openxmlformats.org/drawingml/2006/main">
               <a:ext uri="{FF2B5EF4-FFF2-40B4-BE49-F238E27FC236}">
-                <a16:creationId xmlns:a16="http://schemas.microsoft.com/office/drawing/2014/main" id="{9130F13F-6111-45E3-B02E-5B9B787B46B0}"/>
+                <a16:creationId xmlns:a16="http://schemas.microsoft.com/office/drawing/2014/main" id="{F10259D7-A1B8-437B-9BA2-C68DC31101F7}"/>
               </a:ext>
             </a:extLst>
           </p:cNvPr>
@@ -1155,7 +1155,7 @@
           <p:cNvPr id="2" name="header-spacer">
             <a:extLst xmlns:a="http://schemas.openxmlformats.org/drawingml/2006/main">
               <a:ext uri="{FF2B5EF4-FFF2-40B4-BE49-F238E27FC236}">
-                <a16:creationId xmlns:a16="http://schemas.microsoft.com/office/drawing/2014/main" id="{8045C59B-DA73-4487-BBA5-01CB8A7E95A0}"/>
+                <a16:creationId xmlns:a16="http://schemas.microsoft.com/office/drawing/2014/main" id="{F5708A92-AC0E-42A4-92D9-0A5FE2571E91}"/>
               </a:ext>
             </a:extLst>
           </p:cNvPr>
@@ -1188,18 +1188,18 @@
           <p:cNvPr id="3" name="cover-kicker">
             <a:extLst xmlns:a="http://schemas.openxmlformats.org/drawingml/2006/main">
               <a:ext uri="{FF2B5EF4-FFF2-40B4-BE49-F238E27FC236}">
-                <a16:creationId xmlns:a16="http://schemas.microsoft.com/office/drawing/2014/main" id="{6337170E-3001-4687-8995-61A5A124B5B1}"/>
-              </a:ext>
-            </a:extLst>
-          </p:cNvPr>
-          <p:cNvSpPr>
-            <a:spLocks xmlns:a="http://schemas.openxmlformats.org/drawingml/2006/main" noGrp="1"/>
-          </p:cNvSpPr>
-          <p:nvPr/>
-        </p:nvSpPr>
-        <p:spPr>
-          <a:xfrm xmlns:a="http://schemas.openxmlformats.org/drawingml/2006/main">
-            <a:off x="819150" y="3505200"/>
+                <a16:creationId xmlns:a16="http://schemas.microsoft.com/office/drawing/2014/main" id="{BB49D782-2F26-4D50-A9E9-B008015C4289}"/>
+              </a:ext>
+            </a:extLst>
+          </p:cNvPr>
+          <p:cNvSpPr>
+            <a:spLocks xmlns:a="http://schemas.openxmlformats.org/drawingml/2006/main" noGrp="1"/>
+          </p:cNvSpPr>
+          <p:nvPr/>
+        </p:nvSpPr>
+        <p:spPr>
+          <a:xfrm xmlns:a="http://schemas.openxmlformats.org/drawingml/2006/main">
+            <a:off x="819150" y="3581400"/>
             <a:ext cx="8286750" cy="228600"/>
           </a:xfrm>
           <a:prstGeom xmlns:a="http://schemas.openxmlformats.org/drawingml/2006/main" prst="rect">
@@ -1233,18 +1233,18 @@
           <p:cNvPr id="4" name="cover-title">
             <a:extLst xmlns:a="http://schemas.openxmlformats.org/drawingml/2006/main">
               <a:ext uri="{FF2B5EF4-FFF2-40B4-BE49-F238E27FC236}">
-                <a16:creationId xmlns:a16="http://schemas.microsoft.com/office/drawing/2014/main" id="{9FE69D91-0BC0-4503-AFC0-F9B919D55AFB}"/>
-              </a:ext>
-            </a:extLst>
-          </p:cNvPr>
-          <p:cNvSpPr>
-            <a:spLocks xmlns:a="http://schemas.openxmlformats.org/drawingml/2006/main" noGrp="1"/>
-          </p:cNvSpPr>
-          <p:nvPr/>
-        </p:nvSpPr>
-        <p:spPr>
-          <a:xfrm xmlns:a="http://schemas.openxmlformats.org/drawingml/2006/main">
-            <a:off x="819150" y="4000500"/>
+                <a16:creationId xmlns:a16="http://schemas.microsoft.com/office/drawing/2014/main" id="{1919B756-F518-4599-B70A-241EE7A3033D}"/>
+              </a:ext>
+            </a:extLst>
+          </p:cNvPr>
+          <p:cNvSpPr>
+            <a:spLocks xmlns:a="http://schemas.openxmlformats.org/drawingml/2006/main" noGrp="1"/>
+          </p:cNvSpPr>
+          <p:nvPr/>
+        </p:nvSpPr>
+        <p:spPr>
+          <a:xfrm xmlns:a="http://schemas.openxmlformats.org/drawingml/2006/main">
+            <a:off x="819150" y="4076700"/>
             <a:ext cx="8286750" cy="1066800"/>
           </a:xfrm>
           <a:prstGeom xmlns:a="http://schemas.openxmlformats.org/drawingml/2006/main" prst="rect">
@@ -1278,18 +1278,18 @@
           <p:cNvPr id="5" name="cover-subtitle">
             <a:extLst xmlns:a="http://schemas.openxmlformats.org/drawingml/2006/main">
               <a:ext uri="{FF2B5EF4-FFF2-40B4-BE49-F238E27FC236}">
-                <a16:creationId xmlns:a16="http://schemas.microsoft.com/office/drawing/2014/main" id="{F8FD7AE0-2000-4C11-9D7D-6BA1615EEA3E}"/>
-              </a:ext>
-            </a:extLst>
-          </p:cNvPr>
-          <p:cNvSpPr>
-            <a:spLocks xmlns:a="http://schemas.openxmlformats.org/drawingml/2006/main" noGrp="1"/>
-          </p:cNvSpPr>
-          <p:nvPr/>
-        </p:nvSpPr>
-        <p:spPr>
-          <a:xfrm xmlns:a="http://schemas.openxmlformats.org/drawingml/2006/main">
-            <a:off x="819150" y="5314950"/>
+                <a16:creationId xmlns:a16="http://schemas.microsoft.com/office/drawing/2014/main" id="{8F63EFC6-441F-4D81-9988-42DC7A4C0ECF}"/>
+              </a:ext>
+            </a:extLst>
+          </p:cNvPr>
+          <p:cNvSpPr>
+            <a:spLocks xmlns:a="http://schemas.openxmlformats.org/drawingml/2006/main" noGrp="1"/>
+          </p:cNvSpPr>
+          <p:nvPr/>
+        </p:nvSpPr>
+        <p:spPr>
+          <a:xfrm xmlns:a="http://schemas.openxmlformats.org/drawingml/2006/main">
+            <a:off x="819150" y="5391150"/>
             <a:ext cx="7924800" cy="571500"/>
           </a:xfrm>
           <a:prstGeom xmlns:a="http://schemas.openxmlformats.org/drawingml/2006/main" prst="rect">
@@ -1323,18 +1323,18 @@
           <p:cNvPr id="6" name="badge-Gateway x402">
             <a:extLst xmlns:a="http://schemas.openxmlformats.org/drawingml/2006/main">
               <a:ext uri="{FF2B5EF4-FFF2-40B4-BE49-F238E27FC236}">
-                <a16:creationId xmlns:a16="http://schemas.microsoft.com/office/drawing/2014/main" id="{CA935996-9FD7-4F54-BF3B-F0D6AAD383D8}"/>
-              </a:ext>
-            </a:extLst>
-          </p:cNvPr>
-          <p:cNvSpPr>
-            <a:spLocks xmlns:a="http://schemas.openxmlformats.org/drawingml/2006/main" noGrp="1"/>
-          </p:cNvSpPr>
-          <p:nvPr/>
-        </p:nvSpPr>
-        <p:spPr>
-          <a:xfrm xmlns:a="http://schemas.openxmlformats.org/drawingml/2006/main">
-            <a:off x="819150" y="6143625"/>
+                <a16:creationId xmlns:a16="http://schemas.microsoft.com/office/drawing/2014/main" id="{E830FD14-BBF4-4CDB-8EBE-0B4C33867DA8}"/>
+              </a:ext>
+            </a:extLst>
+          </p:cNvPr>
+          <p:cNvSpPr>
+            <a:spLocks xmlns:a="http://schemas.openxmlformats.org/drawingml/2006/main" noGrp="1"/>
+          </p:cNvSpPr>
+          <p:nvPr/>
+        </p:nvSpPr>
+        <p:spPr>
+          <a:xfrm xmlns:a="http://schemas.openxmlformats.org/drawingml/2006/main">
+            <a:off x="819150" y="6219825"/>
             <a:ext cx="2085975" cy="371475"/>
           </a:xfrm>
           <a:prstGeom xmlns:a="http://schemas.openxmlformats.org/drawingml/2006/main" prst="roundRect">
@@ -1358,18 +1358,18 @@
           <p:cNvPr id="7" name="">
             <a:extLst xmlns:a="http://schemas.openxmlformats.org/drawingml/2006/main">
               <a:ext uri="{FF2B5EF4-FFF2-40B4-BE49-F238E27FC236}">
-                <a16:creationId xmlns:a16="http://schemas.microsoft.com/office/drawing/2014/main" id="{6B6755A4-F61E-470A-B7DE-3EA221630D6A}"/>
-              </a:ext>
-            </a:extLst>
-          </p:cNvPr>
-          <p:cNvSpPr>
-            <a:spLocks xmlns:a="http://schemas.openxmlformats.org/drawingml/2006/main" noGrp="1"/>
-          </p:cNvSpPr>
-          <p:nvPr/>
-        </p:nvSpPr>
-        <p:spPr>
-          <a:xfrm xmlns:a="http://schemas.openxmlformats.org/drawingml/2006/main">
-            <a:off x="990600" y="6267450"/>
+                <a16:creationId xmlns:a16="http://schemas.microsoft.com/office/drawing/2014/main" id="{E1A897D1-81A5-4339-AD94-E1A6C10595E2}"/>
+              </a:ext>
+            </a:extLst>
+          </p:cNvPr>
+          <p:cNvSpPr>
+            <a:spLocks xmlns:a="http://schemas.openxmlformats.org/drawingml/2006/main" noGrp="1"/>
+          </p:cNvSpPr>
+          <p:nvPr/>
+        </p:nvSpPr>
+        <p:spPr>
+          <a:xfrm xmlns:a="http://schemas.openxmlformats.org/drawingml/2006/main">
+            <a:off x="990600" y="6343650"/>
             <a:ext cx="123825" cy="123825"/>
           </a:xfrm>
           <a:prstGeom xmlns:a="http://schemas.openxmlformats.org/drawingml/2006/main" prst="rect">
@@ -1391,18 +1391,18 @@
           <p:cNvPr id="8" name="badge-text-Gateway x402">
             <a:extLst xmlns:a="http://schemas.openxmlformats.org/drawingml/2006/main">
               <a:ext uri="{FF2B5EF4-FFF2-40B4-BE49-F238E27FC236}">
-                <a16:creationId xmlns:a16="http://schemas.microsoft.com/office/drawing/2014/main" id="{F6B477B3-6679-4563-BEF5-FC617D419A95}"/>
-              </a:ext>
-            </a:extLst>
-          </p:cNvPr>
-          <p:cNvSpPr>
-            <a:spLocks xmlns:a="http://schemas.openxmlformats.org/drawingml/2006/main" noGrp="1"/>
-          </p:cNvSpPr>
-          <p:nvPr/>
-        </p:nvSpPr>
-        <p:spPr>
-          <a:xfrm xmlns:a="http://schemas.openxmlformats.org/drawingml/2006/main">
-            <a:off x="1238250" y="6248400"/>
+                <a16:creationId xmlns:a16="http://schemas.microsoft.com/office/drawing/2014/main" id="{97FDFB3B-06E4-44F7-8488-E084AE095DDD}"/>
+              </a:ext>
+            </a:extLst>
+          </p:cNvPr>
+          <p:cNvSpPr>
+            <a:spLocks xmlns:a="http://schemas.openxmlformats.org/drawingml/2006/main" noGrp="1"/>
+          </p:cNvSpPr>
+          <p:nvPr/>
+        </p:nvSpPr>
+        <p:spPr>
+          <a:xfrm xmlns:a="http://schemas.openxmlformats.org/drawingml/2006/main">
+            <a:off x="1238250" y="6324600"/>
             <a:ext cx="1504950" cy="152400"/>
           </a:xfrm>
           <a:prstGeom xmlns:a="http://schemas.openxmlformats.org/drawingml/2006/main" prst="rect">
@@ -1436,18 +1436,18 @@
           <p:cNvPr id="9" name="badge-Arc receipts">
             <a:extLst xmlns:a="http://schemas.openxmlformats.org/drawingml/2006/main">
               <a:ext uri="{FF2B5EF4-FFF2-40B4-BE49-F238E27FC236}">
-                <a16:creationId xmlns:a16="http://schemas.microsoft.com/office/drawing/2014/main" id="{D7D93F21-C96E-4161-97B8-5BF89A7607B8}"/>
-              </a:ext>
-            </a:extLst>
-          </p:cNvPr>
-          <p:cNvSpPr>
-            <a:spLocks xmlns:a="http://schemas.openxmlformats.org/drawingml/2006/main" noGrp="1"/>
-          </p:cNvSpPr>
-          <p:nvPr/>
-        </p:nvSpPr>
-        <p:spPr>
-          <a:xfrm xmlns:a="http://schemas.openxmlformats.org/drawingml/2006/main">
-            <a:off x="3095625" y="6143625"/>
+                <a16:creationId xmlns:a16="http://schemas.microsoft.com/office/drawing/2014/main" id="{89FF5073-7F32-4DC1-9ED0-1030B7071891}"/>
+              </a:ext>
+            </a:extLst>
+          </p:cNvPr>
+          <p:cNvSpPr>
+            <a:spLocks xmlns:a="http://schemas.openxmlformats.org/drawingml/2006/main" noGrp="1"/>
+          </p:cNvSpPr>
+          <p:nvPr/>
+        </p:nvSpPr>
+        <p:spPr>
+          <a:xfrm xmlns:a="http://schemas.openxmlformats.org/drawingml/2006/main">
+            <a:off x="3095625" y="6219825"/>
             <a:ext cx="2085975" cy="371475"/>
           </a:xfrm>
           <a:prstGeom xmlns:a="http://schemas.openxmlformats.org/drawingml/2006/main" prst="roundRect">
@@ -1471,18 +1471,18 @@
           <p:cNvPr id="10" name="">
             <a:extLst xmlns:a="http://schemas.openxmlformats.org/drawingml/2006/main">
               <a:ext uri="{FF2B5EF4-FFF2-40B4-BE49-F238E27FC236}">
-                <a16:creationId xmlns:a16="http://schemas.microsoft.com/office/drawing/2014/main" id="{86699E71-75B8-4CE0-8F31-E96DE476FB5C}"/>
-              </a:ext>
-            </a:extLst>
-          </p:cNvPr>
-          <p:cNvSpPr>
-            <a:spLocks xmlns:a="http://schemas.openxmlformats.org/drawingml/2006/main" noGrp="1"/>
-          </p:cNvSpPr>
-          <p:nvPr/>
-        </p:nvSpPr>
-        <p:spPr>
-          <a:xfrm xmlns:a="http://schemas.openxmlformats.org/drawingml/2006/main">
-            <a:off x="3276600" y="6267450"/>
+                <a16:creationId xmlns:a16="http://schemas.microsoft.com/office/drawing/2014/main" id="{36D30094-072F-4250-97DB-F8207B804805}"/>
+              </a:ext>
+            </a:extLst>
+          </p:cNvPr>
+          <p:cNvSpPr>
+            <a:spLocks xmlns:a="http://schemas.openxmlformats.org/drawingml/2006/main" noGrp="1"/>
+          </p:cNvSpPr>
+          <p:nvPr/>
+        </p:nvSpPr>
+        <p:spPr>
+          <a:xfrm xmlns:a="http://schemas.openxmlformats.org/drawingml/2006/main">
+            <a:off x="3276600" y="6343650"/>
             <a:ext cx="123825" cy="123825"/>
           </a:xfrm>
           <a:prstGeom xmlns:a="http://schemas.openxmlformats.org/drawingml/2006/main" prst="rect">
@@ -1504,18 +1504,18 @@
           <p:cNvPr id="11" name="badge-text-Arc receipts">
             <a:extLst xmlns:a="http://schemas.openxmlformats.org/drawingml/2006/main">
               <a:ext uri="{FF2B5EF4-FFF2-40B4-BE49-F238E27FC236}">
-                <a16:creationId xmlns:a16="http://schemas.microsoft.com/office/drawing/2014/main" id="{62C19C5C-A18B-4CA0-99F0-0E5A7AF1F5A7}"/>
-              </a:ext>
-            </a:extLst>
-          </p:cNvPr>
-          <p:cNvSpPr>
-            <a:spLocks xmlns:a="http://schemas.openxmlformats.org/drawingml/2006/main" noGrp="1"/>
-          </p:cNvSpPr>
-          <p:nvPr/>
-        </p:nvSpPr>
-        <p:spPr>
-          <a:xfrm xmlns:a="http://schemas.openxmlformats.org/drawingml/2006/main">
-            <a:off x="3505200" y="6248400"/>
+                <a16:creationId xmlns:a16="http://schemas.microsoft.com/office/drawing/2014/main" id="{9FB09C68-67F8-4557-A9C5-9EF55B34E430}"/>
+              </a:ext>
+            </a:extLst>
+          </p:cNvPr>
+          <p:cNvSpPr>
+            <a:spLocks xmlns:a="http://schemas.openxmlformats.org/drawingml/2006/main" noGrp="1"/>
+          </p:cNvSpPr>
+          <p:nvPr/>
+        </p:nvSpPr>
+        <p:spPr>
+          <a:xfrm xmlns:a="http://schemas.openxmlformats.org/drawingml/2006/main">
+            <a:off x="3505200" y="6324600"/>
             <a:ext cx="1504950" cy="152400"/>
           </a:xfrm>
           <a:prstGeom xmlns:a="http://schemas.openxmlformats.org/drawingml/2006/main" prst="rect">
@@ -1549,18 +1549,18 @@
           <p:cNvPr id="12" name="badge-50 tx proof">
             <a:extLst xmlns:a="http://schemas.openxmlformats.org/drawingml/2006/main">
               <a:ext uri="{FF2B5EF4-FFF2-40B4-BE49-F238E27FC236}">
-                <a16:creationId xmlns:a16="http://schemas.microsoft.com/office/drawing/2014/main" id="{0EF5B8E5-924C-48EE-AECA-4116A451F701}"/>
-              </a:ext>
-            </a:extLst>
-          </p:cNvPr>
-          <p:cNvSpPr>
-            <a:spLocks xmlns:a="http://schemas.openxmlformats.org/drawingml/2006/main" noGrp="1"/>
-          </p:cNvSpPr>
-          <p:nvPr/>
-        </p:nvSpPr>
-        <p:spPr>
-          <a:xfrm xmlns:a="http://schemas.openxmlformats.org/drawingml/2006/main">
-            <a:off x="5372100" y="6143625"/>
+                <a16:creationId xmlns:a16="http://schemas.microsoft.com/office/drawing/2014/main" id="{E5F0EE75-2B09-4B53-BA4E-098F066A5AA5}"/>
+              </a:ext>
+            </a:extLst>
+          </p:cNvPr>
+          <p:cNvSpPr>
+            <a:spLocks xmlns:a="http://schemas.openxmlformats.org/drawingml/2006/main" noGrp="1"/>
+          </p:cNvSpPr>
+          <p:nvPr/>
+        </p:nvSpPr>
+        <p:spPr>
+          <a:xfrm xmlns:a="http://schemas.openxmlformats.org/drawingml/2006/main">
+            <a:off x="5372100" y="6219825"/>
             <a:ext cx="1981200" cy="371475"/>
           </a:xfrm>
           <a:prstGeom xmlns:a="http://schemas.openxmlformats.org/drawingml/2006/main" prst="roundRect">
@@ -1584,18 +1584,18 @@
           <p:cNvPr id="13" name="">
             <a:extLst xmlns:a="http://schemas.openxmlformats.org/drawingml/2006/main">
               <a:ext uri="{FF2B5EF4-FFF2-40B4-BE49-F238E27FC236}">
-                <a16:creationId xmlns:a16="http://schemas.microsoft.com/office/drawing/2014/main" id="{AA1B77CE-E09B-4EE2-95A3-045A80A33E47}"/>
-              </a:ext>
-            </a:extLst>
-          </p:cNvPr>
-          <p:cNvSpPr>
-            <a:spLocks xmlns:a="http://schemas.openxmlformats.org/drawingml/2006/main" noGrp="1"/>
-          </p:cNvSpPr>
-          <p:nvPr/>
-        </p:nvSpPr>
-        <p:spPr>
-          <a:xfrm xmlns:a="http://schemas.openxmlformats.org/drawingml/2006/main">
-            <a:off x="5543550" y="6267450"/>
+                <a16:creationId xmlns:a16="http://schemas.microsoft.com/office/drawing/2014/main" id="{B9393510-9078-4CE5-ACEC-FB5C73B964C1}"/>
+              </a:ext>
+            </a:extLst>
+          </p:cNvPr>
+          <p:cNvSpPr>
+            <a:spLocks xmlns:a="http://schemas.openxmlformats.org/drawingml/2006/main" noGrp="1"/>
+          </p:cNvSpPr>
+          <p:nvPr/>
+        </p:nvSpPr>
+        <p:spPr>
+          <a:xfrm xmlns:a="http://schemas.openxmlformats.org/drawingml/2006/main">
+            <a:off x="5543550" y="6343650"/>
             <a:ext cx="123825" cy="123825"/>
           </a:xfrm>
           <a:prstGeom xmlns:a="http://schemas.openxmlformats.org/drawingml/2006/main" prst="rect">
@@ -1617,18 +1617,18 @@
           <p:cNvPr id="14" name="badge-text-50 tx proof">
             <a:extLst xmlns:a="http://schemas.openxmlformats.org/drawingml/2006/main">
               <a:ext uri="{FF2B5EF4-FFF2-40B4-BE49-F238E27FC236}">
-                <a16:creationId xmlns:a16="http://schemas.microsoft.com/office/drawing/2014/main" id="{CB9799D6-7A00-4E9B-ADB1-C5BCB6A175AC}"/>
-              </a:ext>
-            </a:extLst>
-          </p:cNvPr>
-          <p:cNvSpPr>
-            <a:spLocks xmlns:a="http://schemas.openxmlformats.org/drawingml/2006/main" noGrp="1"/>
-          </p:cNvSpPr>
-          <p:nvPr/>
-        </p:nvSpPr>
-        <p:spPr>
-          <a:xfrm xmlns:a="http://schemas.openxmlformats.org/drawingml/2006/main">
-            <a:off x="5791200" y="6248400"/>
+                <a16:creationId xmlns:a16="http://schemas.microsoft.com/office/drawing/2014/main" id="{141F2DCA-4F4C-44A1-9342-85F60BE80B6D}"/>
+              </a:ext>
+            </a:extLst>
+          </p:cNvPr>
+          <p:cNvSpPr>
+            <a:spLocks xmlns:a="http://schemas.openxmlformats.org/drawingml/2006/main" noGrp="1"/>
+          </p:cNvSpPr>
+          <p:nvPr/>
+        </p:nvSpPr>
+        <p:spPr>
+          <a:xfrm xmlns:a="http://schemas.openxmlformats.org/drawingml/2006/main">
+            <a:off x="5791200" y="6324600"/>
             <a:ext cx="1400175" cy="152400"/>
           </a:xfrm>
           <a:prstGeom xmlns:a="http://schemas.openxmlformats.org/drawingml/2006/main" prst="rect">
@@ -1662,18 +1662,18 @@
           <p:cNvPr id="15" name="cover-evidence-field">
             <a:extLst xmlns:a="http://schemas.openxmlformats.org/drawingml/2006/main">
               <a:ext uri="{FF2B5EF4-FFF2-40B4-BE49-F238E27FC236}">
-                <a16:creationId xmlns:a16="http://schemas.microsoft.com/office/drawing/2014/main" id="{5B48D9F6-3005-477E-A583-D549BFD31998}"/>
-              </a:ext>
-            </a:extLst>
-          </p:cNvPr>
-          <p:cNvSpPr>
-            <a:spLocks xmlns:a="http://schemas.openxmlformats.org/drawingml/2006/main" noGrp="1"/>
-          </p:cNvSpPr>
-          <p:nvPr/>
-        </p:nvSpPr>
-        <p:spPr>
-          <a:xfrm xmlns:a="http://schemas.openxmlformats.org/drawingml/2006/main">
-            <a:off x="9824466" y="2076450"/>
+                <a16:creationId xmlns:a16="http://schemas.microsoft.com/office/drawing/2014/main" id="{444C09C4-F110-4A93-9305-F3FE12F8C6D8}"/>
+              </a:ext>
+            </a:extLst>
+          </p:cNvPr>
+          <p:cNvSpPr>
+            <a:spLocks xmlns:a="http://schemas.openxmlformats.org/drawingml/2006/main" noGrp="1"/>
+          </p:cNvSpPr>
+          <p:nvPr/>
+        </p:nvSpPr>
+        <p:spPr>
+          <a:xfrm xmlns:a="http://schemas.openxmlformats.org/drawingml/2006/main">
+            <a:off x="9824466" y="2152650"/>
             <a:ext cx="7644384" cy="5857875"/>
           </a:xfrm>
           <a:prstGeom xmlns:a="http://schemas.openxmlformats.org/drawingml/2006/main" prst="roundRect">
@@ -1697,18 +1697,18 @@
           <p:cNvPr id="16" name="cover-number">
             <a:extLst xmlns:a="http://schemas.openxmlformats.org/drawingml/2006/main">
               <a:ext uri="{FF2B5EF4-FFF2-40B4-BE49-F238E27FC236}">
-                <a16:creationId xmlns:a16="http://schemas.microsoft.com/office/drawing/2014/main" id="{AD55159E-5E0D-47D1-B5E6-C8F3D5E51B7C}"/>
-              </a:ext>
-            </a:extLst>
-          </p:cNvPr>
-          <p:cNvSpPr>
-            <a:spLocks xmlns:a="http://schemas.openxmlformats.org/drawingml/2006/main" noGrp="1"/>
-          </p:cNvSpPr>
-          <p:nvPr/>
-        </p:nvSpPr>
-        <p:spPr>
-          <a:xfrm xmlns:a="http://schemas.openxmlformats.org/drawingml/2006/main">
-            <a:off x="10248900" y="2476500"/>
+                <a16:creationId xmlns:a16="http://schemas.microsoft.com/office/drawing/2014/main" id="{29ECCE23-F7AD-4C29-9000-02D4AFE9D12C}"/>
+              </a:ext>
+            </a:extLst>
+          </p:cNvPr>
+          <p:cNvSpPr>
+            <a:spLocks xmlns:a="http://schemas.openxmlformats.org/drawingml/2006/main" noGrp="1"/>
+          </p:cNvSpPr>
+          <p:nvPr/>
+        </p:nvSpPr>
+        <p:spPr>
+          <a:xfrm xmlns:a="http://schemas.openxmlformats.org/drawingml/2006/main">
+            <a:off x="10248900" y="2552700"/>
             <a:ext cx="6800850" cy="781050"/>
           </a:xfrm>
           <a:prstGeom xmlns:a="http://schemas.openxmlformats.org/drawingml/2006/main" prst="rect">
@@ -1742,18 +1742,18 @@
           <p:cNvPr id="17" name="cover-number-label">
             <a:extLst xmlns:a="http://schemas.openxmlformats.org/drawingml/2006/main">
               <a:ext uri="{FF2B5EF4-FFF2-40B4-BE49-F238E27FC236}">
-                <a16:creationId xmlns:a16="http://schemas.microsoft.com/office/drawing/2014/main" id="{EE1692E1-204B-4C3D-9450-9A7C653FB72F}"/>
-              </a:ext>
-            </a:extLst>
-          </p:cNvPr>
-          <p:cNvSpPr>
-            <a:spLocks xmlns:a="http://schemas.openxmlformats.org/drawingml/2006/main" noGrp="1"/>
-          </p:cNvSpPr>
-          <p:nvPr/>
-        </p:nvSpPr>
-        <p:spPr>
-          <a:xfrm xmlns:a="http://schemas.openxmlformats.org/drawingml/2006/main">
-            <a:off x="10248900" y="3429000"/>
+                <a16:creationId xmlns:a16="http://schemas.microsoft.com/office/drawing/2014/main" id="{43CA4159-2847-4D4E-83D5-21AB4391F7F5}"/>
+              </a:ext>
+            </a:extLst>
+          </p:cNvPr>
+          <p:cNvSpPr>
+            <a:spLocks xmlns:a="http://schemas.openxmlformats.org/drawingml/2006/main" noGrp="1"/>
+          </p:cNvSpPr>
+          <p:nvPr/>
+        </p:nvSpPr>
+        <p:spPr>
+          <a:xfrm xmlns:a="http://schemas.openxmlformats.org/drawingml/2006/main">
+            <a:off x="10248900" y="3505200"/>
             <a:ext cx="3924300" cy="228600"/>
           </a:xfrm>
           <a:prstGeom xmlns:a="http://schemas.openxmlformats.org/drawingml/2006/main" prst="rect">
@@ -1787,18 +1787,18 @@
           <p:cNvPr id="18" name="">
             <a:extLst xmlns:a="http://schemas.openxmlformats.org/drawingml/2006/main">
               <a:ext uri="{FF2B5EF4-FFF2-40B4-BE49-F238E27FC236}">
-                <a16:creationId xmlns:a16="http://schemas.microsoft.com/office/drawing/2014/main" id="{DB92CC2C-29B8-4022-8991-203ACC8D84C2}"/>
-              </a:ext>
-            </a:extLst>
-          </p:cNvPr>
-          <p:cNvSpPr>
-            <a:spLocks xmlns:a="http://schemas.openxmlformats.org/drawingml/2006/main" noGrp="1"/>
-          </p:cNvSpPr>
-          <p:nvPr/>
-        </p:nvSpPr>
-        <p:spPr>
-          <a:xfrm xmlns:a="http://schemas.openxmlformats.org/drawingml/2006/main">
-            <a:off x="10248900" y="4953000"/>
+                <a16:creationId xmlns:a16="http://schemas.microsoft.com/office/drawing/2014/main" id="{1D532F56-0A35-494C-B446-805B9DCDDB15}"/>
+              </a:ext>
+            </a:extLst>
+          </p:cNvPr>
+          <p:cNvSpPr>
+            <a:spLocks xmlns:a="http://schemas.openxmlformats.org/drawingml/2006/main" noGrp="1"/>
+          </p:cNvSpPr>
+          <p:nvPr/>
+        </p:nvSpPr>
+        <p:spPr>
+          <a:xfrm xmlns:a="http://schemas.openxmlformats.org/drawingml/2006/main">
+            <a:off x="10248900" y="5029200"/>
             <a:ext cx="2133600" cy="57150"/>
           </a:xfrm>
           <a:prstGeom xmlns:a="http://schemas.openxmlformats.org/drawingml/2006/main" prst="rect">
@@ -1820,18 +1820,18 @@
           <p:cNvPr id="19" name="dark-metric-value-task budget">
             <a:extLst xmlns:a="http://schemas.openxmlformats.org/drawingml/2006/main">
               <a:ext uri="{FF2B5EF4-FFF2-40B4-BE49-F238E27FC236}">
-                <a16:creationId xmlns:a16="http://schemas.microsoft.com/office/drawing/2014/main" id="{67A73B31-8CA7-4284-A95F-3FF0B356B611}"/>
-              </a:ext>
-            </a:extLst>
-          </p:cNvPr>
-          <p:cNvSpPr>
-            <a:spLocks xmlns:a="http://schemas.openxmlformats.org/drawingml/2006/main" noGrp="1"/>
-          </p:cNvSpPr>
-          <p:nvPr/>
-        </p:nvSpPr>
-        <p:spPr>
-          <a:xfrm xmlns:a="http://schemas.openxmlformats.org/drawingml/2006/main">
-            <a:off x="10248900" y="5105400"/>
+                <a16:creationId xmlns:a16="http://schemas.microsoft.com/office/drawing/2014/main" id="{7A1E52B3-A096-4B62-917D-DEE20B0FD145}"/>
+              </a:ext>
+            </a:extLst>
+          </p:cNvPr>
+          <p:cNvSpPr>
+            <a:spLocks xmlns:a="http://schemas.openxmlformats.org/drawingml/2006/main" noGrp="1"/>
+          </p:cNvSpPr>
+          <p:nvPr/>
+        </p:nvSpPr>
+        <p:spPr>
+          <a:xfrm xmlns:a="http://schemas.openxmlformats.org/drawingml/2006/main">
+            <a:off x="10248900" y="5181600"/>
             <a:ext cx="2133600" cy="400050"/>
           </a:xfrm>
           <a:prstGeom xmlns:a="http://schemas.openxmlformats.org/drawingml/2006/main" prst="rect">
@@ -1865,18 +1865,18 @@
           <p:cNvPr id="20" name="dark-metric-label-task budget">
             <a:extLst xmlns:a="http://schemas.openxmlformats.org/drawingml/2006/main">
               <a:ext uri="{FF2B5EF4-FFF2-40B4-BE49-F238E27FC236}">
-                <a16:creationId xmlns:a16="http://schemas.microsoft.com/office/drawing/2014/main" id="{6F103B59-8178-44AB-9003-39DE2C2D64AE}"/>
-              </a:ext>
-            </a:extLst>
-          </p:cNvPr>
-          <p:cNvSpPr>
-            <a:spLocks xmlns:a="http://schemas.openxmlformats.org/drawingml/2006/main" noGrp="1"/>
-          </p:cNvSpPr>
-          <p:nvPr/>
-        </p:nvSpPr>
-        <p:spPr>
-          <a:xfrm xmlns:a="http://schemas.openxmlformats.org/drawingml/2006/main">
-            <a:off x="10248900" y="5600700"/>
+                <a16:creationId xmlns:a16="http://schemas.microsoft.com/office/drawing/2014/main" id="{300763EE-0834-4D7F-AABB-4F21E1B914DE}"/>
+              </a:ext>
+            </a:extLst>
+          </p:cNvPr>
+          <p:cNvSpPr>
+            <a:spLocks xmlns:a="http://schemas.openxmlformats.org/drawingml/2006/main" noGrp="1"/>
+          </p:cNvSpPr>
+          <p:nvPr/>
+        </p:nvSpPr>
+        <p:spPr>
+          <a:xfrm xmlns:a="http://schemas.openxmlformats.org/drawingml/2006/main">
+            <a:off x="10248900" y="5676900"/>
             <a:ext cx="2133600" cy="171450"/>
           </a:xfrm>
           <a:prstGeom xmlns:a="http://schemas.openxmlformats.org/drawingml/2006/main" prst="rect">
@@ -1910,18 +1910,18 @@
           <p:cNvPr id="21" name="">
             <a:extLst xmlns:a="http://schemas.openxmlformats.org/drawingml/2006/main">
               <a:ext uri="{FF2B5EF4-FFF2-40B4-BE49-F238E27FC236}">
-                <a16:creationId xmlns:a16="http://schemas.microsoft.com/office/drawing/2014/main" id="{40D98F2D-D6B5-43C3-9B43-F0F28ED5124B}"/>
-              </a:ext>
-            </a:extLst>
-          </p:cNvPr>
-          <p:cNvSpPr>
-            <a:spLocks xmlns:a="http://schemas.openxmlformats.org/drawingml/2006/main" noGrp="1"/>
-          </p:cNvSpPr>
-          <p:nvPr/>
-        </p:nvSpPr>
-        <p:spPr>
-          <a:xfrm xmlns:a="http://schemas.openxmlformats.org/drawingml/2006/main">
-            <a:off x="12573000" y="4953000"/>
+                <a16:creationId xmlns:a16="http://schemas.microsoft.com/office/drawing/2014/main" id="{41B879AA-D57C-4D02-9045-ABC20196A286}"/>
+              </a:ext>
+            </a:extLst>
+          </p:cNvPr>
+          <p:cNvSpPr>
+            <a:spLocks xmlns:a="http://schemas.openxmlformats.org/drawingml/2006/main" noGrp="1"/>
+          </p:cNvSpPr>
+          <p:nvPr/>
+        </p:nvSpPr>
+        <p:spPr>
+          <a:xfrm xmlns:a="http://schemas.openxmlformats.org/drawingml/2006/main">
+            <a:off x="12573000" y="5029200"/>
             <a:ext cx="2133600" cy="57150"/>
           </a:xfrm>
           <a:prstGeom xmlns:a="http://schemas.openxmlformats.org/drawingml/2006/main" prst="rect">
@@ -1943,18 +1943,18 @@
           <p:cNvPr id="22" name="dark-metric-value-max per call">
             <a:extLst xmlns:a="http://schemas.openxmlformats.org/drawingml/2006/main">
               <a:ext uri="{FF2B5EF4-FFF2-40B4-BE49-F238E27FC236}">
-                <a16:creationId xmlns:a16="http://schemas.microsoft.com/office/drawing/2014/main" id="{AE69660B-D538-4632-94E1-BEE3694C62E8}"/>
-              </a:ext>
-            </a:extLst>
-          </p:cNvPr>
-          <p:cNvSpPr>
-            <a:spLocks xmlns:a="http://schemas.openxmlformats.org/drawingml/2006/main" noGrp="1"/>
-          </p:cNvSpPr>
-          <p:nvPr/>
-        </p:nvSpPr>
-        <p:spPr>
-          <a:xfrm xmlns:a="http://schemas.openxmlformats.org/drawingml/2006/main">
-            <a:off x="12573000" y="5105400"/>
+                <a16:creationId xmlns:a16="http://schemas.microsoft.com/office/drawing/2014/main" id="{8757A128-BEE6-426E-A4BD-593C81F15754}"/>
+              </a:ext>
+            </a:extLst>
+          </p:cNvPr>
+          <p:cNvSpPr>
+            <a:spLocks xmlns:a="http://schemas.openxmlformats.org/drawingml/2006/main" noGrp="1"/>
+          </p:cNvSpPr>
+          <p:nvPr/>
+        </p:nvSpPr>
+        <p:spPr>
+          <a:xfrm xmlns:a="http://schemas.openxmlformats.org/drawingml/2006/main">
+            <a:off x="12573000" y="5181600"/>
             <a:ext cx="2133600" cy="400050"/>
           </a:xfrm>
           <a:prstGeom xmlns:a="http://schemas.openxmlformats.org/drawingml/2006/main" prst="rect">
@@ -1988,18 +1988,18 @@
           <p:cNvPr id="23" name="dark-metric-label-max per call">
             <a:extLst xmlns:a="http://schemas.openxmlformats.org/drawingml/2006/main">
               <a:ext uri="{FF2B5EF4-FFF2-40B4-BE49-F238E27FC236}">
-                <a16:creationId xmlns:a16="http://schemas.microsoft.com/office/drawing/2014/main" id="{7813FEAE-547D-47FE-9A23-DF22559CDF2E}"/>
-              </a:ext>
-            </a:extLst>
-          </p:cNvPr>
-          <p:cNvSpPr>
-            <a:spLocks xmlns:a="http://schemas.openxmlformats.org/drawingml/2006/main" noGrp="1"/>
-          </p:cNvSpPr>
-          <p:nvPr/>
-        </p:nvSpPr>
-        <p:spPr>
-          <a:xfrm xmlns:a="http://schemas.openxmlformats.org/drawingml/2006/main">
-            <a:off x="12573000" y="5600700"/>
+                <a16:creationId xmlns:a16="http://schemas.microsoft.com/office/drawing/2014/main" id="{2DB66385-53D0-4E21-8E1D-EA85085E56A8}"/>
+              </a:ext>
+            </a:extLst>
+          </p:cNvPr>
+          <p:cNvSpPr>
+            <a:spLocks xmlns:a="http://schemas.openxmlformats.org/drawingml/2006/main" noGrp="1"/>
+          </p:cNvSpPr>
+          <p:nvPr/>
+        </p:nvSpPr>
+        <p:spPr>
+          <a:xfrm xmlns:a="http://schemas.openxmlformats.org/drawingml/2006/main">
+            <a:off x="12573000" y="5676900"/>
             <a:ext cx="2133600" cy="171450"/>
           </a:xfrm>
           <a:prstGeom xmlns:a="http://schemas.openxmlformats.org/drawingml/2006/main" prst="rect">
@@ -2033,18 +2033,18 @@
           <p:cNvPr id="24" name="">
             <a:extLst xmlns:a="http://schemas.openxmlformats.org/drawingml/2006/main">
               <a:ext uri="{FF2B5EF4-FFF2-40B4-BE49-F238E27FC236}">
-                <a16:creationId xmlns:a16="http://schemas.microsoft.com/office/drawing/2014/main" id="{A24A276D-9F7B-4ACF-8110-893E20AAE92C}"/>
-              </a:ext>
-            </a:extLst>
-          </p:cNvPr>
-          <p:cNvSpPr>
-            <a:spLocks xmlns:a="http://schemas.openxmlformats.org/drawingml/2006/main" noGrp="1"/>
-          </p:cNvSpPr>
-          <p:nvPr/>
-        </p:nvSpPr>
-        <p:spPr>
-          <a:xfrm xmlns:a="http://schemas.openxmlformats.org/drawingml/2006/main">
-            <a:off x="14916150" y="4953000"/>
+                <a16:creationId xmlns:a16="http://schemas.microsoft.com/office/drawing/2014/main" id="{0AA52603-AD1E-4405-8ABC-C0CCF2F4F935}"/>
+              </a:ext>
+            </a:extLst>
+          </p:cNvPr>
+          <p:cNvSpPr>
+            <a:spLocks xmlns:a="http://schemas.openxmlformats.org/drawingml/2006/main" noGrp="1"/>
+          </p:cNvSpPr>
+          <p:nvPr/>
+        </p:nvSpPr>
+        <p:spPr>
+          <a:xfrm xmlns:a="http://schemas.openxmlformats.org/drawingml/2006/main">
+            <a:off x="14916150" y="5029200"/>
             <a:ext cx="2133600" cy="57150"/>
           </a:xfrm>
           <a:prstGeom xmlns:a="http://schemas.openxmlformats.org/drawingml/2006/main" prst="rect">
@@ -2066,18 +2066,18 @@
           <p:cNvPr id="25" name="dark-metric-value-receipt tx">
             <a:extLst xmlns:a="http://schemas.openxmlformats.org/drawingml/2006/main">
               <a:ext uri="{FF2B5EF4-FFF2-40B4-BE49-F238E27FC236}">
-                <a16:creationId xmlns:a16="http://schemas.microsoft.com/office/drawing/2014/main" id="{081BB2FB-4C94-47C7-BE75-B6284D82AB73}"/>
-              </a:ext>
-            </a:extLst>
-          </p:cNvPr>
-          <p:cNvSpPr>
-            <a:spLocks xmlns:a="http://schemas.openxmlformats.org/drawingml/2006/main" noGrp="1"/>
-          </p:cNvSpPr>
-          <p:nvPr/>
-        </p:nvSpPr>
-        <p:spPr>
-          <a:xfrm xmlns:a="http://schemas.openxmlformats.org/drawingml/2006/main">
-            <a:off x="14916150" y="5105400"/>
+                <a16:creationId xmlns:a16="http://schemas.microsoft.com/office/drawing/2014/main" id="{A7789A5C-2AFE-401B-854D-C948257D280C}"/>
+              </a:ext>
+            </a:extLst>
+          </p:cNvPr>
+          <p:cNvSpPr>
+            <a:spLocks xmlns:a="http://schemas.openxmlformats.org/drawingml/2006/main" noGrp="1"/>
+          </p:cNvSpPr>
+          <p:nvPr/>
+        </p:nvSpPr>
+        <p:spPr>
+          <a:xfrm xmlns:a="http://schemas.openxmlformats.org/drawingml/2006/main">
+            <a:off x="14916150" y="5181600"/>
             <a:ext cx="2133600" cy="400050"/>
           </a:xfrm>
           <a:prstGeom xmlns:a="http://schemas.openxmlformats.org/drawingml/2006/main" prst="rect">
@@ -2111,18 +2111,18 @@
           <p:cNvPr id="26" name="dark-metric-label-receipt tx">
             <a:extLst xmlns:a="http://schemas.openxmlformats.org/drawingml/2006/main">
               <a:ext uri="{FF2B5EF4-FFF2-40B4-BE49-F238E27FC236}">
-                <a16:creationId xmlns:a16="http://schemas.microsoft.com/office/drawing/2014/main" id="{5035A975-D72E-4053-8977-331C6AA770B8}"/>
-              </a:ext>
-            </a:extLst>
-          </p:cNvPr>
-          <p:cNvSpPr>
-            <a:spLocks xmlns:a="http://schemas.openxmlformats.org/drawingml/2006/main" noGrp="1"/>
-          </p:cNvSpPr>
-          <p:nvPr/>
-        </p:nvSpPr>
-        <p:spPr>
-          <a:xfrm xmlns:a="http://schemas.openxmlformats.org/drawingml/2006/main">
-            <a:off x="14916150" y="5600700"/>
+                <a16:creationId xmlns:a16="http://schemas.microsoft.com/office/drawing/2014/main" id="{C5CF6E0F-D187-4FC3-8063-2F0CB82E731D}"/>
+              </a:ext>
+            </a:extLst>
+          </p:cNvPr>
+          <p:cNvSpPr>
+            <a:spLocks xmlns:a="http://schemas.openxmlformats.org/drawingml/2006/main" noGrp="1"/>
+          </p:cNvSpPr>
+          <p:nvPr/>
+        </p:nvSpPr>
+        <p:spPr>
+          <a:xfrm xmlns:a="http://schemas.openxmlformats.org/drawingml/2006/main">
+            <a:off x="14916150" y="5676900"/>
             <a:ext cx="2133600" cy="171450"/>
           </a:xfrm>
           <a:prstGeom xmlns:a="http://schemas.openxmlformats.org/drawingml/2006/main" prst="rect">
@@ -2156,18 +2156,18 @@
           <p:cNvPr id="27" name="cover-app-url">
             <a:extLst xmlns:a="http://schemas.openxmlformats.org/drawingml/2006/main">
               <a:ext uri="{FF2B5EF4-FFF2-40B4-BE49-F238E27FC236}">
-                <a16:creationId xmlns:a16="http://schemas.microsoft.com/office/drawing/2014/main" id="{63BCF189-3B6B-4EF8-B799-F868B1818F3F}"/>
-              </a:ext>
-            </a:extLst>
-          </p:cNvPr>
-          <p:cNvSpPr>
-            <a:spLocks xmlns:a="http://schemas.openxmlformats.org/drawingml/2006/main" noGrp="1"/>
-          </p:cNvSpPr>
-          <p:nvPr/>
-        </p:nvSpPr>
-        <p:spPr>
-          <a:xfrm xmlns:a="http://schemas.openxmlformats.org/drawingml/2006/main">
-            <a:off x="10248900" y="7048500"/>
+                <a16:creationId xmlns:a16="http://schemas.microsoft.com/office/drawing/2014/main" id="{9195055B-D8A6-40DD-8C9D-87D4A5E66F17}"/>
+              </a:ext>
+            </a:extLst>
+          </p:cNvPr>
+          <p:cNvSpPr>
+            <a:spLocks xmlns:a="http://schemas.openxmlformats.org/drawingml/2006/main" noGrp="1"/>
+          </p:cNvSpPr>
+          <p:nvPr/>
+        </p:nvSpPr>
+        <p:spPr>
+          <a:xfrm xmlns:a="http://schemas.openxmlformats.org/drawingml/2006/main">
+            <a:off x="10248900" y="7124700"/>
             <a:ext cx="6800850" cy="209550"/>
           </a:xfrm>
           <a:prstGeom xmlns:a="http://schemas.openxmlformats.org/drawingml/2006/main" prst="rect">
@@ -2201,18 +2201,18 @@
           <p:cNvPr id="28" name="cover-contract">
             <a:extLst xmlns:a="http://schemas.openxmlformats.org/drawingml/2006/main">
               <a:ext uri="{FF2B5EF4-FFF2-40B4-BE49-F238E27FC236}">
-                <a16:creationId xmlns:a16="http://schemas.microsoft.com/office/drawing/2014/main" id="{5B96493E-AFB6-4CD8-97C0-57D1901C3BCF}"/>
-              </a:ext>
-            </a:extLst>
-          </p:cNvPr>
-          <p:cNvSpPr>
-            <a:spLocks xmlns:a="http://schemas.openxmlformats.org/drawingml/2006/main" noGrp="1"/>
-          </p:cNvSpPr>
-          <p:nvPr/>
-        </p:nvSpPr>
-        <p:spPr>
-          <a:xfrm xmlns:a="http://schemas.openxmlformats.org/drawingml/2006/main">
-            <a:off x="10248900" y="7372350"/>
+                <a16:creationId xmlns:a16="http://schemas.microsoft.com/office/drawing/2014/main" id="{00C62C5D-68E8-4659-9827-E71A677270A1}"/>
+              </a:ext>
+            </a:extLst>
+          </p:cNvPr>
+          <p:cNvSpPr>
+            <a:spLocks xmlns:a="http://schemas.openxmlformats.org/drawingml/2006/main" noGrp="1"/>
+          </p:cNvSpPr>
+          <p:nvPr/>
+        </p:nvSpPr>
+        <p:spPr>
+          <a:xfrm xmlns:a="http://schemas.openxmlformats.org/drawingml/2006/main">
+            <a:off x="10248900" y="7448550"/>
             <a:ext cx="6800850" cy="171450"/>
           </a:xfrm>
           <a:prstGeom xmlns:a="http://schemas.openxmlformats.org/drawingml/2006/main" prst="rect">
@@ -2246,19 +2246,19 @@
           <p:cNvPr id="29" name="footer-left">
             <a:extLst xmlns:a="http://schemas.openxmlformats.org/drawingml/2006/main">
               <a:ext uri="{FF2B5EF4-FFF2-40B4-BE49-F238E27FC236}">
-                <a16:creationId xmlns:a16="http://schemas.microsoft.com/office/drawing/2014/main" id="{73E5C19C-B45C-4EB6-8949-C52FC2F21800}"/>
-              </a:ext>
-            </a:extLst>
-          </p:cNvPr>
-          <p:cNvSpPr>
-            <a:spLocks xmlns:a="http://schemas.openxmlformats.org/drawingml/2006/main" noGrp="1"/>
-          </p:cNvSpPr>
-          <p:nvPr/>
-        </p:nvSpPr>
-        <p:spPr>
-          <a:xfrm xmlns:a="http://schemas.openxmlformats.org/drawingml/2006/main">
-            <a:off x="819150" y="9391650"/>
-            <a:ext cx="1924050" cy="304800"/>
+                <a16:creationId xmlns:a16="http://schemas.microsoft.com/office/drawing/2014/main" id="{500ACA5D-DB19-4B85-AFCB-D5F1B33CFD5C}"/>
+              </a:ext>
+            </a:extLst>
+          </p:cNvPr>
+          <p:cNvSpPr>
+            <a:spLocks xmlns:a="http://schemas.openxmlformats.org/drawingml/2006/main" noGrp="1"/>
+          </p:cNvSpPr>
+          <p:nvPr/>
+        </p:nvSpPr>
+        <p:spPr>
+          <a:xfrm xmlns:a="http://schemas.openxmlformats.org/drawingml/2006/main">
+            <a:off x="819150" y="9525000"/>
+            <a:ext cx="2000250" cy="152400"/>
           </a:xfrm>
           <a:prstGeom xmlns:a="http://schemas.openxmlformats.org/drawingml/2006/main" prst="rect">
             <a:avLst/>
@@ -2281,7 +2281,7 @@
                   <a:srgbClr val="8490A0"/>
                 </a:solidFill>
               </a:rPr>
-              <a:t>Live demo and Arc proof package</a:t>
+              <a:t>Product demo + verifiable receipts</a:t>
             </a:r>
           </a:p>
         </p:txBody>
@@ -2291,18 +2291,18 @@
           <p:cNvPr id="30" name="footer-right">
             <a:extLst xmlns:a="http://schemas.openxmlformats.org/drawingml/2006/main">
               <a:ext uri="{FF2B5EF4-FFF2-40B4-BE49-F238E27FC236}">
-                <a16:creationId xmlns:a16="http://schemas.microsoft.com/office/drawing/2014/main" id="{A889A74D-C7A9-4DB4-A002-A7AAAE2B3B39}"/>
-              </a:ext>
-            </a:extLst>
-          </p:cNvPr>
-          <p:cNvSpPr>
-            <a:spLocks xmlns:a="http://schemas.openxmlformats.org/drawingml/2006/main" noGrp="1"/>
-          </p:cNvSpPr>
-          <p:nvPr/>
-        </p:nvSpPr>
-        <p:spPr>
-          <a:xfrm xmlns:a="http://schemas.openxmlformats.org/drawingml/2006/main">
-            <a:off x="13373100" y="9467850"/>
+                <a16:creationId xmlns:a16="http://schemas.microsoft.com/office/drawing/2014/main" id="{1DA6D94E-B4F2-4C8B-90AC-FB707433692C}"/>
+              </a:ext>
+            </a:extLst>
+          </p:cNvPr>
+          <p:cNvSpPr>
+            <a:spLocks xmlns:a="http://schemas.openxmlformats.org/drawingml/2006/main" noGrp="1"/>
+          </p:cNvSpPr>
+          <p:nvPr/>
+        </p:nvSpPr>
+        <p:spPr>
+          <a:xfrm xmlns:a="http://schemas.openxmlformats.org/drawingml/2006/main">
+            <a:off x="13373100" y="9525000"/>
             <a:ext cx="4095750" cy="152400"/>
           </a:xfrm>
           <a:prstGeom xmlns:a="http://schemas.openxmlformats.org/drawingml/2006/main" prst="rect">
@@ -2334,7 +2334,7 @@
     </p:spTree>
     <p:extLst>
       <p:ext uri="{BB962C8B-B14F-4D97-AF65-F5344CB8AC3E}">
-        <p14:creationId xmlns:p14="http://schemas.microsoft.com/office/powerpoint/2010/main" val="1013834501"/>
+        <p14:creationId xmlns:p14="http://schemas.microsoft.com/office/powerpoint/2010/main" val="592129517"/>
       </p:ext>
     </p:extLst>
   </p:cSld>
@@ -2358,7 +2358,7 @@
           <p:cNvPr id="1" name="slide-background">
             <a:extLst xmlns:a="http://schemas.openxmlformats.org/drawingml/2006/main">
               <a:ext uri="{FF2B5EF4-FFF2-40B4-BE49-F238E27FC236}">
-                <a16:creationId xmlns:a16="http://schemas.microsoft.com/office/drawing/2014/main" id="{ABD5C74E-5D02-4230-885D-DC3433C695A7}"/>
+                <a16:creationId xmlns:a16="http://schemas.microsoft.com/office/drawing/2014/main" id="{CF1CC84A-7D2B-4572-9121-E3C1EE4A5534}"/>
               </a:ext>
             </a:extLst>
           </p:cNvPr>
@@ -2391,7 +2391,7 @@
           <p:cNvPr id="2" name="kicker">
             <a:extLst xmlns:a="http://schemas.openxmlformats.org/drawingml/2006/main">
               <a:ext uri="{FF2B5EF4-FFF2-40B4-BE49-F238E27FC236}">
-                <a16:creationId xmlns:a16="http://schemas.microsoft.com/office/drawing/2014/main" id="{ED39CD7E-B065-4067-AC69-426B856618E5}"/>
+                <a16:creationId xmlns:a16="http://schemas.microsoft.com/office/drawing/2014/main" id="{F8DE3BC9-9303-4491-98AD-354FBF6ACFB0}"/>
               </a:ext>
             </a:extLst>
           </p:cNvPr>
@@ -2436,7 +2436,7 @@
           <p:cNvPr id="3" name="slide-title">
             <a:extLst xmlns:a="http://schemas.openxmlformats.org/drawingml/2006/main">
               <a:ext uri="{FF2B5EF4-FFF2-40B4-BE49-F238E27FC236}">
-                <a16:creationId xmlns:a16="http://schemas.microsoft.com/office/drawing/2014/main" id="{6E046A58-644C-43B8-ADC3-C4CEB0C53DF4}"/>
+                <a16:creationId xmlns:a16="http://schemas.microsoft.com/office/drawing/2014/main" id="{EFBB115F-DDB0-4058-81DD-07FD1A072267}"/>
               </a:ext>
             </a:extLst>
           </p:cNvPr>
@@ -2481,7 +2481,7 @@
           <p:cNvPr id="4" name="slide-subtitle">
             <a:extLst xmlns:a="http://schemas.openxmlformats.org/drawingml/2006/main">
               <a:ext uri="{FF2B5EF4-FFF2-40B4-BE49-F238E27FC236}">
-                <a16:creationId xmlns:a16="http://schemas.microsoft.com/office/drawing/2014/main" id="{144139B4-D4F7-4CF1-81EA-90C148BE6178}"/>
+                <a16:creationId xmlns:a16="http://schemas.microsoft.com/office/drawing/2014/main" id="{A4794964-744D-4A3B-A89E-CB6410841BAF}"/>
               </a:ext>
             </a:extLst>
           </p:cNvPr>
@@ -2526,7 +2526,7 @@
           <p:cNvPr id="5" name="problem-claim">
             <a:extLst xmlns:a="http://schemas.openxmlformats.org/drawingml/2006/main">
               <a:ext uri="{FF2B5EF4-FFF2-40B4-BE49-F238E27FC236}">
-                <a16:creationId xmlns:a16="http://schemas.microsoft.com/office/drawing/2014/main" id="{EB94F80D-CFE3-4192-B121-5EBDAD344DDA}"/>
+                <a16:creationId xmlns:a16="http://schemas.microsoft.com/office/drawing/2014/main" id="{8D89635B-22C8-4936-99ED-97B9D56E4D4E}"/>
               </a:ext>
             </a:extLst>
           </p:cNvPr>
@@ -2571,7 +2571,7 @@
           <p:cNvPr id="6" name="problem-copy">
             <a:extLst xmlns:a="http://schemas.openxmlformats.org/drawingml/2006/main">
               <a:ext uri="{FF2B5EF4-FFF2-40B4-BE49-F238E27FC236}">
-                <a16:creationId xmlns:a16="http://schemas.microsoft.com/office/drawing/2014/main" id="{5D2CB6C5-ABE5-4CDC-8A18-7FE4D7B1B14D}"/>
+                <a16:creationId xmlns:a16="http://schemas.microsoft.com/office/drawing/2014/main" id="{2BC2482F-3FFF-4EBA-BC20-5ECBD57E6358}"/>
               </a:ext>
             </a:extLst>
           </p:cNvPr>
@@ -2616,7 +2616,7 @@
           <p:cNvPr id="7" name="accent-rule">
             <a:extLst xmlns:a="http://schemas.openxmlformats.org/drawingml/2006/main">
               <a:ext uri="{FF2B5EF4-FFF2-40B4-BE49-F238E27FC236}">
-                <a16:creationId xmlns:a16="http://schemas.microsoft.com/office/drawing/2014/main" id="{486FE44B-183F-4412-8B2E-1AAC1AEC114D}"/>
+                <a16:creationId xmlns:a16="http://schemas.microsoft.com/office/drawing/2014/main" id="{0818E09D-4B44-4113-AC02-4B89A14B8076}"/>
               </a:ext>
             </a:extLst>
           </p:cNvPr>
@@ -2649,7 +2649,7 @@
           <p:cNvPr id="8" name="statement-title-Too small for cards">
             <a:extLst xmlns:a="http://schemas.openxmlformats.org/drawingml/2006/main">
               <a:ext uri="{FF2B5EF4-FFF2-40B4-BE49-F238E27FC236}">
-                <a16:creationId xmlns:a16="http://schemas.microsoft.com/office/drawing/2014/main" id="{6A60FD43-CC35-451E-9796-FE2C4DBA7A14}"/>
+                <a16:creationId xmlns:a16="http://schemas.microsoft.com/office/drawing/2014/main" id="{B660EC7A-7695-41BB-853B-7A92255F04B0}"/>
               </a:ext>
             </a:extLst>
           </p:cNvPr>
@@ -2694,7 +2694,7 @@
           <p:cNvPr id="9" name="statement-body-Too small for cards">
             <a:extLst xmlns:a="http://schemas.openxmlformats.org/drawingml/2006/main">
               <a:ext uri="{FF2B5EF4-FFF2-40B4-BE49-F238E27FC236}">
-                <a16:creationId xmlns:a16="http://schemas.microsoft.com/office/drawing/2014/main" id="{001905C8-34B9-4C4D-97E8-5A2D6DF99800}"/>
+                <a16:creationId xmlns:a16="http://schemas.microsoft.com/office/drawing/2014/main" id="{692AD7CF-1957-44B2-BCE0-6770B5D711B2}"/>
               </a:ext>
             </a:extLst>
           </p:cNvPr>
@@ -2739,7 +2739,7 @@
           <p:cNvPr id="10" name="accent-rule">
             <a:extLst xmlns:a="http://schemas.openxmlformats.org/drawingml/2006/main">
               <a:ext uri="{FF2B5EF4-FFF2-40B4-BE49-F238E27FC236}">
-                <a16:creationId xmlns:a16="http://schemas.microsoft.com/office/drawing/2014/main" id="{2EC3F29A-13B1-4C2F-B371-5CCD77656463}"/>
+                <a16:creationId xmlns:a16="http://schemas.microsoft.com/office/drawing/2014/main" id="{B303B6DC-2830-4D5F-9D54-BA21E558642B}"/>
               </a:ext>
             </a:extLst>
           </p:cNvPr>
@@ -2772,7 +2772,7 @@
           <p:cNvPr id="11" name="statement-title-Too many to approve">
             <a:extLst xmlns:a="http://schemas.openxmlformats.org/drawingml/2006/main">
               <a:ext uri="{FF2B5EF4-FFF2-40B4-BE49-F238E27FC236}">
-                <a16:creationId xmlns:a16="http://schemas.microsoft.com/office/drawing/2014/main" id="{04FF9591-E40F-45DF-9484-E6D5111DE80B}"/>
+                <a16:creationId xmlns:a16="http://schemas.microsoft.com/office/drawing/2014/main" id="{20718874-3B1A-44BE-BCB9-118386F98C6F}"/>
               </a:ext>
             </a:extLst>
           </p:cNvPr>
@@ -2817,7 +2817,7 @@
           <p:cNvPr id="12" name="statement-body-Too many to approve">
             <a:extLst xmlns:a="http://schemas.openxmlformats.org/drawingml/2006/main">
               <a:ext uri="{FF2B5EF4-FFF2-40B4-BE49-F238E27FC236}">
-                <a16:creationId xmlns:a16="http://schemas.microsoft.com/office/drawing/2014/main" id="{7ED7CA44-0598-46D9-8D11-10695824CA69}"/>
+                <a16:creationId xmlns:a16="http://schemas.microsoft.com/office/drawing/2014/main" id="{0D98C6C3-3C87-4B0B-B3D6-2D9C4D881487}"/>
               </a:ext>
             </a:extLst>
           </p:cNvPr>
@@ -2862,7 +2862,7 @@
           <p:cNvPr id="13" name="accent-rule">
             <a:extLst xmlns:a="http://schemas.openxmlformats.org/drawingml/2006/main">
               <a:ext uri="{FF2B5EF4-FFF2-40B4-BE49-F238E27FC236}">
-                <a16:creationId xmlns:a16="http://schemas.microsoft.com/office/drawing/2014/main" id="{52CAB053-222D-4D20-922E-1488B551440D}"/>
+                <a16:creationId xmlns:a16="http://schemas.microsoft.com/office/drawing/2014/main" id="{F0936245-6752-4C1D-9DA2-E38E30F3A6D1}"/>
               </a:ext>
             </a:extLst>
           </p:cNvPr>
@@ -2895,7 +2895,7 @@
           <p:cNvPr id="14" name="statement-title-Too risky without receipts">
             <a:extLst xmlns:a="http://schemas.openxmlformats.org/drawingml/2006/main">
               <a:ext uri="{FF2B5EF4-FFF2-40B4-BE49-F238E27FC236}">
-                <a16:creationId xmlns:a16="http://schemas.microsoft.com/office/drawing/2014/main" id="{1FCFF0DC-1011-421D-8684-83305B6A96B0}"/>
+                <a16:creationId xmlns:a16="http://schemas.microsoft.com/office/drawing/2014/main" id="{0D5ADCEB-7CA6-43BF-A41C-2991877531AB}"/>
               </a:ext>
             </a:extLst>
           </p:cNvPr>
@@ -2940,7 +2940,7 @@
           <p:cNvPr id="15" name="statement-body-Too risky without receipts">
             <a:extLst xmlns:a="http://schemas.openxmlformats.org/drawingml/2006/main">
               <a:ext uri="{FF2B5EF4-FFF2-40B4-BE49-F238E27FC236}">
-                <a16:creationId xmlns:a16="http://schemas.microsoft.com/office/drawing/2014/main" id="{6A7E5CA1-65AF-4320-AA9B-4F83153CF711}"/>
+                <a16:creationId xmlns:a16="http://schemas.microsoft.com/office/drawing/2014/main" id="{B8BE3CFF-0690-48EF-B46E-FF5A12F1D988}"/>
               </a:ext>
             </a:extLst>
           </p:cNvPr>
@@ -2985,7 +2985,7 @@
           <p:cNvPr id="16" name="footer-left">
             <a:extLst xmlns:a="http://schemas.openxmlformats.org/drawingml/2006/main">
               <a:ext uri="{FF2B5EF4-FFF2-40B4-BE49-F238E27FC236}">
-                <a16:creationId xmlns:a16="http://schemas.microsoft.com/office/drawing/2014/main" id="{D1D1884E-239A-45DB-AB6A-4DEA1FDA1AB1}"/>
+                <a16:creationId xmlns:a16="http://schemas.microsoft.com/office/drawing/2014/main" id="{5BBA8947-13E7-4059-9C7F-061216602593}"/>
               </a:ext>
             </a:extLst>
           </p:cNvPr>
@@ -3030,7 +3030,7 @@
           <p:cNvPr id="17" name="footer-right">
             <a:extLst xmlns:a="http://schemas.openxmlformats.org/drawingml/2006/main">
               <a:ext uri="{FF2B5EF4-FFF2-40B4-BE49-F238E27FC236}">
-                <a16:creationId xmlns:a16="http://schemas.microsoft.com/office/drawing/2014/main" id="{CF294470-F43E-42D5-A8CE-82D89A2D03E9}"/>
+                <a16:creationId xmlns:a16="http://schemas.microsoft.com/office/drawing/2014/main" id="{4B9359FE-47A0-435F-BA0E-80340E5AF6BC}"/>
               </a:ext>
             </a:extLst>
           </p:cNvPr>
@@ -3073,7 +3073,7 @@
     </p:spTree>
     <p:extLst>
       <p:ext uri="{BB962C8B-B14F-4D97-AF65-F5344CB8AC3E}">
-        <p14:creationId xmlns:p14="http://schemas.microsoft.com/office/powerpoint/2010/main" val="1076196968"/>
+        <p14:creationId xmlns:p14="http://schemas.microsoft.com/office/powerpoint/2010/main" val="528691257"/>
       </p:ext>
     </p:extLst>
   </p:cSld>
@@ -3097,7 +3097,7 @@
           <p:cNvPr id="1" name="slide-background">
             <a:extLst xmlns:a="http://schemas.openxmlformats.org/drawingml/2006/main">
               <a:ext uri="{FF2B5EF4-FFF2-40B4-BE49-F238E27FC236}">
-                <a16:creationId xmlns:a16="http://schemas.microsoft.com/office/drawing/2014/main" id="{3CA5731E-1DF3-46FB-9E4B-58F340B2602F}"/>
+                <a16:creationId xmlns:a16="http://schemas.microsoft.com/office/drawing/2014/main" id="{47CF5746-DDF2-4C50-86E7-942B3AC54FF8}"/>
               </a:ext>
             </a:extLst>
           </p:cNvPr>
@@ -3130,7 +3130,7 @@
           <p:cNvPr id="2" name="kicker">
             <a:extLst xmlns:a="http://schemas.openxmlformats.org/drawingml/2006/main">
               <a:ext uri="{FF2B5EF4-FFF2-40B4-BE49-F238E27FC236}">
-                <a16:creationId xmlns:a16="http://schemas.microsoft.com/office/drawing/2014/main" id="{33DB6C8E-36BB-48C2-8470-67D818C02C13}"/>
+                <a16:creationId xmlns:a16="http://schemas.microsoft.com/office/drawing/2014/main" id="{A45B0592-3720-4234-BDD1-3DA480DDBA16}"/>
               </a:ext>
             </a:extLst>
           </p:cNvPr>
@@ -3175,7 +3175,7 @@
           <p:cNvPr id="3" name="slide-title">
             <a:extLst xmlns:a="http://schemas.openxmlformats.org/drawingml/2006/main">
               <a:ext uri="{FF2B5EF4-FFF2-40B4-BE49-F238E27FC236}">
-                <a16:creationId xmlns:a16="http://schemas.microsoft.com/office/drawing/2014/main" id="{555E4FE3-60D2-4E20-A488-C4E7F156EAF3}"/>
+                <a16:creationId xmlns:a16="http://schemas.microsoft.com/office/drawing/2014/main" id="{1413546F-68E6-4F9B-8E83-CF38019C5161}"/>
               </a:ext>
             </a:extLst>
           </p:cNvPr>
@@ -3220,7 +3220,7 @@
           <p:cNvPr id="4" name="slide-subtitle">
             <a:extLst xmlns:a="http://schemas.openxmlformats.org/drawingml/2006/main">
               <a:ext uri="{FF2B5EF4-FFF2-40B4-BE49-F238E27FC236}">
-                <a16:creationId xmlns:a16="http://schemas.microsoft.com/office/drawing/2014/main" id="{F341CC19-52DB-4D48-8174-E37CEBF6ED55}"/>
+                <a16:creationId xmlns:a16="http://schemas.microsoft.com/office/drawing/2014/main" id="{BBE91D19-B941-4882-B7DA-2B7C146D97A9}"/>
               </a:ext>
             </a:extLst>
           </p:cNvPr>
@@ -3265,7 +3265,7 @@
           <p:cNvPr id="5" name="solution-claim">
             <a:extLst xmlns:a="http://schemas.openxmlformats.org/drawingml/2006/main">
               <a:ext uri="{FF2B5EF4-FFF2-40B4-BE49-F238E27FC236}">
-                <a16:creationId xmlns:a16="http://schemas.microsoft.com/office/drawing/2014/main" id="{4F283D9B-B67A-41EB-A8C1-70AE237A55FF}"/>
+                <a16:creationId xmlns:a16="http://schemas.microsoft.com/office/drawing/2014/main" id="{BABD721A-85B2-4F1D-B87C-6E7F3983EB88}"/>
               </a:ext>
             </a:extLst>
           </p:cNvPr>
@@ -3310,7 +3310,7 @@
           <p:cNvPr id="6" name="solution-copy">
             <a:extLst xmlns:a="http://schemas.openxmlformats.org/drawingml/2006/main">
               <a:ext uri="{FF2B5EF4-FFF2-40B4-BE49-F238E27FC236}">
-                <a16:creationId xmlns:a16="http://schemas.microsoft.com/office/drawing/2014/main" id="{A1F7111E-3A0F-48CF-B364-4572A1C96523}"/>
+                <a16:creationId xmlns:a16="http://schemas.microsoft.com/office/drawing/2014/main" id="{1AC681FF-6E11-4F31-9A3E-FA349B1BAB9B}"/>
               </a:ext>
             </a:extLst>
           </p:cNvPr>
@@ -3355,7 +3355,7 @@
           <p:cNvPr id="7" name="">
             <a:extLst xmlns:a="http://schemas.openxmlformats.org/drawingml/2006/main">
               <a:ext uri="{FF2B5EF4-FFF2-40B4-BE49-F238E27FC236}">
-                <a16:creationId xmlns:a16="http://schemas.microsoft.com/office/drawing/2014/main" id="{09D889EF-587B-4D95-A95D-D3947D919D9F}"/>
+                <a16:creationId xmlns:a16="http://schemas.microsoft.com/office/drawing/2014/main" id="{A1302D97-7725-45CC-8F3C-1B8705309073}"/>
               </a:ext>
             </a:extLst>
           </p:cNvPr>
@@ -3388,7 +3388,7 @@
           <p:cNvPr id="8" name="policy-label-Task budget">
             <a:extLst xmlns:a="http://schemas.openxmlformats.org/drawingml/2006/main">
               <a:ext uri="{FF2B5EF4-FFF2-40B4-BE49-F238E27FC236}">
-                <a16:creationId xmlns:a16="http://schemas.microsoft.com/office/drawing/2014/main" id="{9F7E5E23-478F-414B-BC2F-CA0F7042C476}"/>
+                <a16:creationId xmlns:a16="http://schemas.microsoft.com/office/drawing/2014/main" id="{1A6545BC-CC81-45E9-AE74-5B1F9F5A81F4}"/>
               </a:ext>
             </a:extLst>
           </p:cNvPr>
@@ -3433,7 +3433,7 @@
           <p:cNvPr id="9" name="policy-value-Task budget">
             <a:extLst xmlns:a="http://schemas.openxmlformats.org/drawingml/2006/main">
               <a:ext uri="{FF2B5EF4-FFF2-40B4-BE49-F238E27FC236}">
-                <a16:creationId xmlns:a16="http://schemas.microsoft.com/office/drawing/2014/main" id="{0E79B4AB-C790-4496-879F-B4C485F7B6BB}"/>
+                <a16:creationId xmlns:a16="http://schemas.microsoft.com/office/drawing/2014/main" id="{5CF61BDE-E7AF-46F1-A70A-CB032C0D0503}"/>
               </a:ext>
             </a:extLst>
           </p:cNvPr>
@@ -3478,7 +3478,7 @@
           <p:cNvPr id="10" name="">
             <a:extLst xmlns:a="http://schemas.openxmlformats.org/drawingml/2006/main">
               <a:ext uri="{FF2B5EF4-FFF2-40B4-BE49-F238E27FC236}">
-                <a16:creationId xmlns:a16="http://schemas.microsoft.com/office/drawing/2014/main" id="{19081776-DE62-48BC-BB28-E2ACBDD27842}"/>
+                <a16:creationId xmlns:a16="http://schemas.microsoft.com/office/drawing/2014/main" id="{0BDA6301-DBA7-4F89-9CDE-12AF2934FC22}"/>
               </a:ext>
             </a:extLst>
           </p:cNvPr>
@@ -3511,7 +3511,7 @@
           <p:cNvPr id="11" name="policy-label-Per-call cap">
             <a:extLst xmlns:a="http://schemas.openxmlformats.org/drawingml/2006/main">
               <a:ext uri="{FF2B5EF4-FFF2-40B4-BE49-F238E27FC236}">
-                <a16:creationId xmlns:a16="http://schemas.microsoft.com/office/drawing/2014/main" id="{409200EF-6501-46A5-8DCC-4DBE9AB8391E}"/>
+                <a16:creationId xmlns:a16="http://schemas.microsoft.com/office/drawing/2014/main" id="{576B4FAC-191C-48BA-B377-667BAD19DFB8}"/>
               </a:ext>
             </a:extLst>
           </p:cNvPr>
@@ -3556,7 +3556,7 @@
           <p:cNvPr id="12" name="policy-value-Per-call cap">
             <a:extLst xmlns:a="http://schemas.openxmlformats.org/drawingml/2006/main">
               <a:ext uri="{FF2B5EF4-FFF2-40B4-BE49-F238E27FC236}">
-                <a16:creationId xmlns:a16="http://schemas.microsoft.com/office/drawing/2014/main" id="{E4436069-D58B-452A-8755-BA1CE6545DCE}"/>
+                <a16:creationId xmlns:a16="http://schemas.microsoft.com/office/drawing/2014/main" id="{5370A6A0-060F-4F4A-A090-10E837F61F43}"/>
               </a:ext>
             </a:extLst>
           </p:cNvPr>
@@ -3601,7 +3601,7 @@
           <p:cNvPr id="13" name="">
             <a:extLst xmlns:a="http://schemas.openxmlformats.org/drawingml/2006/main">
               <a:ext uri="{FF2B5EF4-FFF2-40B4-BE49-F238E27FC236}">
-                <a16:creationId xmlns:a16="http://schemas.microsoft.com/office/drawing/2014/main" id="{B8069FAC-1811-477A-954B-BAD49F393A4B}"/>
+                <a16:creationId xmlns:a16="http://schemas.microsoft.com/office/drawing/2014/main" id="{81400159-2BD5-4299-B184-DB4CCAFD1F0A}"/>
               </a:ext>
             </a:extLst>
           </p:cNvPr>
@@ -3634,7 +3634,7 @@
           <p:cNvPr id="14" name="policy-label-Batch control">
             <a:extLst xmlns:a="http://schemas.openxmlformats.org/drawingml/2006/main">
               <a:ext uri="{FF2B5EF4-FFF2-40B4-BE49-F238E27FC236}">
-                <a16:creationId xmlns:a16="http://schemas.microsoft.com/office/drawing/2014/main" id="{43440E0F-F5A9-48E2-A9C8-70416EF3A59C}"/>
+                <a16:creationId xmlns:a16="http://schemas.microsoft.com/office/drawing/2014/main" id="{61C66AC1-63C3-4542-A700-677C5687C142}"/>
               </a:ext>
             </a:extLst>
           </p:cNvPr>
@@ -3679,7 +3679,7 @@
           <p:cNvPr id="15" name="policy-value-Batch control">
             <a:extLst xmlns:a="http://schemas.openxmlformats.org/drawingml/2006/main">
               <a:ext uri="{FF2B5EF4-FFF2-40B4-BE49-F238E27FC236}">
-                <a16:creationId xmlns:a16="http://schemas.microsoft.com/office/drawing/2014/main" id="{5A0AEB0B-80F9-4E60-ACA5-B545846E6157}"/>
+                <a16:creationId xmlns:a16="http://schemas.microsoft.com/office/drawing/2014/main" id="{465533BA-F54D-4B0C-98CD-B6325EEBB1B3}"/>
               </a:ext>
             </a:extLst>
           </p:cNvPr>
@@ -3724,7 +3724,7 @@
           <p:cNvPr id="16" name="">
             <a:extLst xmlns:a="http://schemas.openxmlformats.org/drawingml/2006/main">
               <a:ext uri="{FF2B5EF4-FFF2-40B4-BE49-F238E27FC236}">
-                <a16:creationId xmlns:a16="http://schemas.microsoft.com/office/drawing/2014/main" id="{07BDD2AB-CA38-4F32-8A55-5BB4E84D37CC}"/>
+                <a16:creationId xmlns:a16="http://schemas.microsoft.com/office/drawing/2014/main" id="{75DCC30A-8B60-4650-9D75-324CDADEA224}"/>
               </a:ext>
             </a:extLst>
           </p:cNvPr>
@@ -3757,7 +3757,7 @@
           <p:cNvPr id="17" name="policy-label-Receipt anchor">
             <a:extLst xmlns:a="http://schemas.openxmlformats.org/drawingml/2006/main">
               <a:ext uri="{FF2B5EF4-FFF2-40B4-BE49-F238E27FC236}">
-                <a16:creationId xmlns:a16="http://schemas.microsoft.com/office/drawing/2014/main" id="{41BE2158-5DD2-4A22-B660-36A5AEB1DCBF}"/>
+                <a16:creationId xmlns:a16="http://schemas.microsoft.com/office/drawing/2014/main" id="{5F132A92-DEA5-4ADE-AF46-55E17AFD4C22}"/>
               </a:ext>
             </a:extLst>
           </p:cNvPr>
@@ -3802,7 +3802,7 @@
           <p:cNvPr id="18" name="policy-value-Receipt anchor">
             <a:extLst xmlns:a="http://schemas.openxmlformats.org/drawingml/2006/main">
               <a:ext uri="{FF2B5EF4-FFF2-40B4-BE49-F238E27FC236}">
-                <a16:creationId xmlns:a16="http://schemas.microsoft.com/office/drawing/2014/main" id="{3987C343-125A-4E26-9234-4DA54BC0992B}"/>
+                <a16:creationId xmlns:a16="http://schemas.microsoft.com/office/drawing/2014/main" id="{AE1EA1A5-3417-404F-9909-D5A191B6A75B}"/>
               </a:ext>
             </a:extLst>
           </p:cNvPr>
@@ -3847,7 +3847,7 @@
           <p:cNvPr id="19" name="solution-flow-surface">
             <a:extLst xmlns:a="http://schemas.openxmlformats.org/drawingml/2006/main">
               <a:ext uri="{FF2B5EF4-FFF2-40B4-BE49-F238E27FC236}">
-                <a16:creationId xmlns:a16="http://schemas.microsoft.com/office/drawing/2014/main" id="{75E7260F-C592-48D7-8EC1-3995948B743B}"/>
+                <a16:creationId xmlns:a16="http://schemas.microsoft.com/office/drawing/2014/main" id="{3E0715AD-B4BF-4A54-B24F-6EBF99F0D503}"/>
               </a:ext>
             </a:extLst>
           </p:cNvPr>
@@ -3882,7 +3882,7 @@
           <p:cNvPr id="20" name="signature-large">
             <a:extLst xmlns:a="http://schemas.openxmlformats.org/drawingml/2006/main">
               <a:ext uri="{FF2B5EF4-FFF2-40B4-BE49-F238E27FC236}">
-                <a16:creationId xmlns:a16="http://schemas.microsoft.com/office/drawing/2014/main" id="{D49812A6-5BFD-405F-9CB4-7B6D4C569850}"/>
+                <a16:creationId xmlns:a16="http://schemas.microsoft.com/office/drawing/2014/main" id="{657E2288-01C1-4175-BB86-DBF1410BA3FB}"/>
               </a:ext>
             </a:extLst>
           </p:cNvPr>
@@ -3927,7 +3927,7 @@
           <p:cNvPr id="21" name="flow-arrow">
             <a:extLst xmlns:a="http://schemas.openxmlformats.org/drawingml/2006/main">
               <a:ext uri="{FF2B5EF4-FFF2-40B4-BE49-F238E27FC236}">
-                <a16:creationId xmlns:a16="http://schemas.microsoft.com/office/drawing/2014/main" id="{62AE127B-05FF-4373-9D49-5AA7377DC43D}"/>
+                <a16:creationId xmlns:a16="http://schemas.microsoft.com/office/drawing/2014/main" id="{D22A4C86-E903-4F2A-999C-2507841E3210}"/>
               </a:ext>
             </a:extLst>
           </p:cNvPr>
@@ -3972,7 +3972,7 @@
           <p:cNvPr id="22" name="proofs-large">
             <a:extLst xmlns:a="http://schemas.openxmlformats.org/drawingml/2006/main">
               <a:ext uri="{FF2B5EF4-FFF2-40B4-BE49-F238E27FC236}">
-                <a16:creationId xmlns:a16="http://schemas.microsoft.com/office/drawing/2014/main" id="{D757F68F-F539-492F-9388-EE1147970942}"/>
+                <a16:creationId xmlns:a16="http://schemas.microsoft.com/office/drawing/2014/main" id="{59BA4D2C-3EA6-40E2-8885-0DC7C6CF2E56}"/>
               </a:ext>
             </a:extLst>
           </p:cNvPr>
@@ -4017,7 +4017,7 @@
           <p:cNvPr id="23" name="review-label">
             <a:extLst xmlns:a="http://schemas.openxmlformats.org/drawingml/2006/main">
               <a:ext uri="{FF2B5EF4-FFF2-40B4-BE49-F238E27FC236}">
-                <a16:creationId xmlns:a16="http://schemas.microsoft.com/office/drawing/2014/main" id="{6705894E-714C-473F-B8B6-4CBE474D2C2F}"/>
+                <a16:creationId xmlns:a16="http://schemas.microsoft.com/office/drawing/2014/main" id="{ADC05917-8255-4B7D-B550-14575373E602}"/>
               </a:ext>
             </a:extLst>
           </p:cNvPr>
@@ -4062,7 +4062,7 @@
           <p:cNvPr id="24" name="provider-ProofDesk">
             <a:extLst xmlns:a="http://schemas.openxmlformats.org/drawingml/2006/main">
               <a:ext uri="{FF2B5EF4-FFF2-40B4-BE49-F238E27FC236}">
-                <a16:creationId xmlns:a16="http://schemas.microsoft.com/office/drawing/2014/main" id="{1217D289-F68D-4AB1-B14C-464EDA3A5BC0}"/>
+                <a16:creationId xmlns:a16="http://schemas.microsoft.com/office/drawing/2014/main" id="{193CAE98-087E-452D-B300-1BDD2E706D60}"/>
               </a:ext>
             </a:extLst>
           </p:cNvPr>
@@ -4097,7 +4097,7 @@
           <p:cNvPr id="25" name="">
             <a:extLst xmlns:a="http://schemas.openxmlformats.org/drawingml/2006/main">
               <a:ext uri="{FF2B5EF4-FFF2-40B4-BE49-F238E27FC236}">
-                <a16:creationId xmlns:a16="http://schemas.microsoft.com/office/drawing/2014/main" id="{308852BB-EAC6-4E30-B7B5-35DC52772241}"/>
+                <a16:creationId xmlns:a16="http://schemas.microsoft.com/office/drawing/2014/main" id="{737F9A12-98FD-4EC5-8AEC-D927FD2F7E81}"/>
               </a:ext>
             </a:extLst>
           </p:cNvPr>
@@ -4130,7 +4130,7 @@
           <p:cNvPr id="26" name="">
             <a:extLst xmlns:a="http://schemas.openxmlformats.org/drawingml/2006/main">
               <a:ext uri="{FF2B5EF4-FFF2-40B4-BE49-F238E27FC236}">
-                <a16:creationId xmlns:a16="http://schemas.microsoft.com/office/drawing/2014/main" id="{CDDE5C27-A03E-49EE-957B-436A390D097B}"/>
+                <a16:creationId xmlns:a16="http://schemas.microsoft.com/office/drawing/2014/main" id="{090970E0-E4AB-4EDC-985E-3515A42FFE06}"/>
               </a:ext>
             </a:extLst>
           </p:cNvPr>
@@ -4175,7 +4175,7 @@
           <p:cNvPr id="27" name="">
             <a:extLst xmlns:a="http://schemas.openxmlformats.org/drawingml/2006/main">
               <a:ext uri="{FF2B5EF4-FFF2-40B4-BE49-F238E27FC236}">
-                <a16:creationId xmlns:a16="http://schemas.microsoft.com/office/drawing/2014/main" id="{E0DE54C2-A73E-48E3-ACA8-7381D2406AA5}"/>
+                <a16:creationId xmlns:a16="http://schemas.microsoft.com/office/drawing/2014/main" id="{CFEF5783-9DAA-4BA7-B554-F8841F5548F3}"/>
               </a:ext>
             </a:extLst>
           </p:cNvPr>
@@ -4220,7 +4220,7 @@
           <p:cNvPr id="28" name="provider-KybTrail">
             <a:extLst xmlns:a="http://schemas.openxmlformats.org/drawingml/2006/main">
               <a:ext uri="{FF2B5EF4-FFF2-40B4-BE49-F238E27FC236}">
-                <a16:creationId xmlns:a16="http://schemas.microsoft.com/office/drawing/2014/main" id="{B9D1C855-DFCD-4CCF-A7F8-A01D243200A6}"/>
+                <a16:creationId xmlns:a16="http://schemas.microsoft.com/office/drawing/2014/main" id="{16E2124A-D735-49F5-A2D7-CBA1AA9070D5}"/>
               </a:ext>
             </a:extLst>
           </p:cNvPr>
@@ -4255,7 +4255,7 @@
           <p:cNvPr id="29" name="">
             <a:extLst xmlns:a="http://schemas.openxmlformats.org/drawingml/2006/main">
               <a:ext uri="{FF2B5EF4-FFF2-40B4-BE49-F238E27FC236}">
-                <a16:creationId xmlns:a16="http://schemas.microsoft.com/office/drawing/2014/main" id="{8054E6DB-FC74-4A81-9F6E-5902EECCD71B}"/>
+                <a16:creationId xmlns:a16="http://schemas.microsoft.com/office/drawing/2014/main" id="{61612120-E4BF-44C6-A008-62131515760D}"/>
               </a:ext>
             </a:extLst>
           </p:cNvPr>
@@ -4288,7 +4288,7 @@
           <p:cNvPr id="30" name="">
             <a:extLst xmlns:a="http://schemas.openxmlformats.org/drawingml/2006/main">
               <a:ext uri="{FF2B5EF4-FFF2-40B4-BE49-F238E27FC236}">
-                <a16:creationId xmlns:a16="http://schemas.microsoft.com/office/drawing/2014/main" id="{A5895B59-3F83-4625-9232-810F0E632BF3}"/>
+                <a16:creationId xmlns:a16="http://schemas.microsoft.com/office/drawing/2014/main" id="{48BF6FE9-9284-4F94-9895-C58997D8D33F}"/>
               </a:ext>
             </a:extLst>
           </p:cNvPr>
@@ -4333,7 +4333,7 @@
           <p:cNvPr id="31" name="">
             <a:extLst xmlns:a="http://schemas.openxmlformats.org/drawingml/2006/main">
               <a:ext uri="{FF2B5EF4-FFF2-40B4-BE49-F238E27FC236}">
-                <a16:creationId xmlns:a16="http://schemas.microsoft.com/office/drawing/2014/main" id="{1996AA61-332B-4597-BCB4-4107343B1EFA}"/>
+                <a16:creationId xmlns:a16="http://schemas.microsoft.com/office/drawing/2014/main" id="{11FF11A3-910C-4186-9FDF-B189BA78597A}"/>
               </a:ext>
             </a:extLst>
           </p:cNvPr>
@@ -4378,7 +4378,7 @@
           <p:cNvPr id="32" name="provider-ClearList">
             <a:extLst xmlns:a="http://schemas.openxmlformats.org/drawingml/2006/main">
               <a:ext uri="{FF2B5EF4-FFF2-40B4-BE49-F238E27FC236}">
-                <a16:creationId xmlns:a16="http://schemas.microsoft.com/office/drawing/2014/main" id="{F77DB41A-370E-402D-9A99-98ADA2AA6D3C}"/>
+                <a16:creationId xmlns:a16="http://schemas.microsoft.com/office/drawing/2014/main" id="{7F51FEF9-C4E1-43FD-9587-D2E6D2BAF99E}"/>
               </a:ext>
             </a:extLst>
           </p:cNvPr>
@@ -4413,7 +4413,7 @@
           <p:cNvPr id="33" name="">
             <a:extLst xmlns:a="http://schemas.openxmlformats.org/drawingml/2006/main">
               <a:ext uri="{FF2B5EF4-FFF2-40B4-BE49-F238E27FC236}">
-                <a16:creationId xmlns:a16="http://schemas.microsoft.com/office/drawing/2014/main" id="{F40D1733-13F8-4901-93B2-DD2033D95E4F}"/>
+                <a16:creationId xmlns:a16="http://schemas.microsoft.com/office/drawing/2014/main" id="{0C23E654-5E0B-4B7D-8424-E9DA07156CA4}"/>
               </a:ext>
             </a:extLst>
           </p:cNvPr>
@@ -4446,7 +4446,7 @@
           <p:cNvPr id="34" name="">
             <a:extLst xmlns:a="http://schemas.openxmlformats.org/drawingml/2006/main">
               <a:ext uri="{FF2B5EF4-FFF2-40B4-BE49-F238E27FC236}">
-                <a16:creationId xmlns:a16="http://schemas.microsoft.com/office/drawing/2014/main" id="{42843C94-C545-464A-AFA4-2DE883A56B93}"/>
+                <a16:creationId xmlns:a16="http://schemas.microsoft.com/office/drawing/2014/main" id="{E90C0399-9336-4749-A45E-8C86C912878D}"/>
               </a:ext>
             </a:extLst>
           </p:cNvPr>
@@ -4491,7 +4491,7 @@
           <p:cNvPr id="35" name="">
             <a:extLst xmlns:a="http://schemas.openxmlformats.org/drawingml/2006/main">
               <a:ext uri="{FF2B5EF4-FFF2-40B4-BE49-F238E27FC236}">
-                <a16:creationId xmlns:a16="http://schemas.microsoft.com/office/drawing/2014/main" id="{C5925DDF-56BA-4964-A015-903FD76CE276}"/>
+                <a16:creationId xmlns:a16="http://schemas.microsoft.com/office/drawing/2014/main" id="{021D8C0F-254A-4EB8-AEBD-8C6A44B9FD57}"/>
               </a:ext>
             </a:extLst>
           </p:cNvPr>
@@ -4536,7 +4536,7 @@
           <p:cNvPr id="36" name="provider-AccountLock">
             <a:extLst xmlns:a="http://schemas.openxmlformats.org/drawingml/2006/main">
               <a:ext uri="{FF2B5EF4-FFF2-40B4-BE49-F238E27FC236}">
-                <a16:creationId xmlns:a16="http://schemas.microsoft.com/office/drawing/2014/main" id="{3E3D72FF-CE06-4838-A892-8A589F5940C6}"/>
+                <a16:creationId xmlns:a16="http://schemas.microsoft.com/office/drawing/2014/main" id="{E4E3EEBD-AB89-4C72-9BBC-83CE126EDE54}"/>
               </a:ext>
             </a:extLst>
           </p:cNvPr>
@@ -4571,7 +4571,7 @@
           <p:cNvPr id="37" name="">
             <a:extLst xmlns:a="http://schemas.openxmlformats.org/drawingml/2006/main">
               <a:ext uri="{FF2B5EF4-FFF2-40B4-BE49-F238E27FC236}">
-                <a16:creationId xmlns:a16="http://schemas.microsoft.com/office/drawing/2014/main" id="{D01FE534-893D-408C-A7A7-B2D3B41CD2B5}"/>
+                <a16:creationId xmlns:a16="http://schemas.microsoft.com/office/drawing/2014/main" id="{68D02082-AA80-434C-B406-225D9E85E4C5}"/>
               </a:ext>
             </a:extLst>
           </p:cNvPr>
@@ -4604,7 +4604,7 @@
           <p:cNvPr id="38" name="">
             <a:extLst xmlns:a="http://schemas.openxmlformats.org/drawingml/2006/main">
               <a:ext uri="{FF2B5EF4-FFF2-40B4-BE49-F238E27FC236}">
-                <a16:creationId xmlns:a16="http://schemas.microsoft.com/office/drawing/2014/main" id="{BABBA4C3-CB33-430A-A993-859395748B49}"/>
+                <a16:creationId xmlns:a16="http://schemas.microsoft.com/office/drawing/2014/main" id="{BCF62324-8854-461A-A745-D5ADDD5A8F4F}"/>
               </a:ext>
             </a:extLst>
           </p:cNvPr>
@@ -4649,7 +4649,7 @@
           <p:cNvPr id="39" name="">
             <a:extLst xmlns:a="http://schemas.openxmlformats.org/drawingml/2006/main">
               <a:ext uri="{FF2B5EF4-FFF2-40B4-BE49-F238E27FC236}">
-                <a16:creationId xmlns:a16="http://schemas.microsoft.com/office/drawing/2014/main" id="{6F848CB6-F76F-4D49-A0D5-AC70B5DBCE52}"/>
+                <a16:creationId xmlns:a16="http://schemas.microsoft.com/office/drawing/2014/main" id="{7BF0CF24-185F-46F1-91CA-206E08557758}"/>
               </a:ext>
             </a:extLst>
           </p:cNvPr>
@@ -4694,7 +4694,7 @@
           <p:cNvPr id="40" name="provider-FraudLens">
             <a:extLst xmlns:a="http://schemas.openxmlformats.org/drawingml/2006/main">
               <a:ext uri="{FF2B5EF4-FFF2-40B4-BE49-F238E27FC236}">
-                <a16:creationId xmlns:a16="http://schemas.microsoft.com/office/drawing/2014/main" id="{C6797F0F-5F23-497B-92DA-DE2D85EB124E}"/>
+                <a16:creationId xmlns:a16="http://schemas.microsoft.com/office/drawing/2014/main" id="{AC4C1DD3-4794-4112-8E97-908B3DD5969F}"/>
               </a:ext>
             </a:extLst>
           </p:cNvPr>
@@ -4729,7 +4729,7 @@
           <p:cNvPr id="41" name="">
             <a:extLst xmlns:a="http://schemas.openxmlformats.org/drawingml/2006/main">
               <a:ext uri="{FF2B5EF4-FFF2-40B4-BE49-F238E27FC236}">
-                <a16:creationId xmlns:a16="http://schemas.microsoft.com/office/drawing/2014/main" id="{4F6EA524-2EF7-43CC-B3AC-8551CC1E4154}"/>
+                <a16:creationId xmlns:a16="http://schemas.microsoft.com/office/drawing/2014/main" id="{4AE39B20-9B05-483B-97FD-39579171B2FA}"/>
               </a:ext>
             </a:extLst>
           </p:cNvPr>
@@ -4762,7 +4762,7 @@
           <p:cNvPr id="42" name="">
             <a:extLst xmlns:a="http://schemas.openxmlformats.org/drawingml/2006/main">
               <a:ext uri="{FF2B5EF4-FFF2-40B4-BE49-F238E27FC236}">
-                <a16:creationId xmlns:a16="http://schemas.microsoft.com/office/drawing/2014/main" id="{A00C9051-5602-46F9-804E-CFBE8055501D}"/>
+                <a16:creationId xmlns:a16="http://schemas.microsoft.com/office/drawing/2014/main" id="{4F23BB8C-40E0-4C5D-998C-DA82B7179BB6}"/>
               </a:ext>
             </a:extLst>
           </p:cNvPr>
@@ -4807,7 +4807,7 @@
           <p:cNvPr id="43" name="">
             <a:extLst xmlns:a="http://schemas.openxmlformats.org/drawingml/2006/main">
               <a:ext uri="{FF2B5EF4-FFF2-40B4-BE49-F238E27FC236}">
-                <a16:creationId xmlns:a16="http://schemas.microsoft.com/office/drawing/2014/main" id="{BBA60E7F-94B0-4D08-A3B5-2945817084D9}"/>
+                <a16:creationId xmlns:a16="http://schemas.microsoft.com/office/drawing/2014/main" id="{C98AEB92-7EAD-45AC-AF06-DBA2F37B45F7}"/>
               </a:ext>
             </a:extLst>
           </p:cNvPr>
@@ -4852,7 +4852,7 @@
           <p:cNvPr id="44" name="provider-QuoteMesh">
             <a:extLst xmlns:a="http://schemas.openxmlformats.org/drawingml/2006/main">
               <a:ext uri="{FF2B5EF4-FFF2-40B4-BE49-F238E27FC236}">
-                <a16:creationId xmlns:a16="http://schemas.microsoft.com/office/drawing/2014/main" id="{4DB959C7-917E-4FDD-A238-89FC2443A1B6}"/>
+                <a16:creationId xmlns:a16="http://schemas.microsoft.com/office/drawing/2014/main" id="{935B936E-BC13-45B8-9902-767C35AF1C61}"/>
               </a:ext>
             </a:extLst>
           </p:cNvPr>
@@ -4887,7 +4887,7 @@
           <p:cNvPr id="45" name="">
             <a:extLst xmlns:a="http://schemas.openxmlformats.org/drawingml/2006/main">
               <a:ext uri="{FF2B5EF4-FFF2-40B4-BE49-F238E27FC236}">
-                <a16:creationId xmlns:a16="http://schemas.microsoft.com/office/drawing/2014/main" id="{80EFCFF8-3121-4F14-90A6-A1BE75F14D0C}"/>
+                <a16:creationId xmlns:a16="http://schemas.microsoft.com/office/drawing/2014/main" id="{8C7CE259-A2A8-4746-9054-81774FE274D9}"/>
               </a:ext>
             </a:extLst>
           </p:cNvPr>
@@ -4920,7 +4920,7 @@
           <p:cNvPr id="46" name="">
             <a:extLst xmlns:a="http://schemas.openxmlformats.org/drawingml/2006/main">
               <a:ext uri="{FF2B5EF4-FFF2-40B4-BE49-F238E27FC236}">
-                <a16:creationId xmlns:a16="http://schemas.microsoft.com/office/drawing/2014/main" id="{939D6B91-2C7A-485A-ADB3-121B4C47A98C}"/>
+                <a16:creationId xmlns:a16="http://schemas.microsoft.com/office/drawing/2014/main" id="{A08D9AE2-83ED-458E-B301-A108E1D51F26}"/>
               </a:ext>
             </a:extLst>
           </p:cNvPr>
@@ -4965,7 +4965,7 @@
           <p:cNvPr id="47" name="">
             <a:extLst xmlns:a="http://schemas.openxmlformats.org/drawingml/2006/main">
               <a:ext uri="{FF2B5EF4-FFF2-40B4-BE49-F238E27FC236}">
-                <a16:creationId xmlns:a16="http://schemas.microsoft.com/office/drawing/2014/main" id="{CA4D8D8E-160D-4E9B-B2C6-72AD5805394C}"/>
+                <a16:creationId xmlns:a16="http://schemas.microsoft.com/office/drawing/2014/main" id="{95869C07-A9E0-46D0-90A8-DE6F5BA5DA8E}"/>
               </a:ext>
             </a:extLst>
           </p:cNvPr>
@@ -5010,7 +5010,7 @@
           <p:cNvPr id="48" name="">
             <a:extLst xmlns:a="http://schemas.openxmlformats.org/drawingml/2006/main">
               <a:ext uri="{FF2B5EF4-FFF2-40B4-BE49-F238E27FC236}">
-                <a16:creationId xmlns:a16="http://schemas.microsoft.com/office/drawing/2014/main" id="{4C64A2F5-7662-4FE0-A9D8-2893A9AD43D9}"/>
+                <a16:creationId xmlns:a16="http://schemas.microsoft.com/office/drawing/2014/main" id="{1EAA86D1-DEB7-4D47-98E6-1FC8D96016B6}"/>
               </a:ext>
             </a:extLst>
           </p:cNvPr>
@@ -5043,7 +5043,7 @@
           <p:cNvPr id="49" name="metric-value-total batch spend">
             <a:extLst xmlns:a="http://schemas.openxmlformats.org/drawingml/2006/main">
               <a:ext uri="{FF2B5EF4-FFF2-40B4-BE49-F238E27FC236}">
-                <a16:creationId xmlns:a16="http://schemas.microsoft.com/office/drawing/2014/main" id="{EBE890F0-9D63-4B12-9809-789F0A7DBEBD}"/>
+                <a16:creationId xmlns:a16="http://schemas.microsoft.com/office/drawing/2014/main" id="{0D3BA290-187A-4C7F-8786-9E2755D85816}"/>
               </a:ext>
             </a:extLst>
           </p:cNvPr>
@@ -5088,7 +5088,7 @@
           <p:cNvPr id="50" name="metric-label-total batch spend">
             <a:extLst xmlns:a="http://schemas.openxmlformats.org/drawingml/2006/main">
               <a:ext uri="{FF2B5EF4-FFF2-40B4-BE49-F238E27FC236}">
-                <a16:creationId xmlns:a16="http://schemas.microsoft.com/office/drawing/2014/main" id="{50F3EACC-AE0B-4739-9FC8-7F5C438F45F2}"/>
+                <a16:creationId xmlns:a16="http://schemas.microsoft.com/office/drawing/2014/main" id="{C6D1CD1E-D79D-4F35-8FAB-AB5BDAF28AC5}"/>
               </a:ext>
             </a:extLst>
           </p:cNvPr>
@@ -5133,7 +5133,7 @@
           <p:cNvPr id="51" name="metric-note-total batch spend">
             <a:extLst xmlns:a="http://schemas.openxmlformats.org/drawingml/2006/main">
               <a:ext uri="{FF2B5EF4-FFF2-40B4-BE49-F238E27FC236}">
-                <a16:creationId xmlns:a16="http://schemas.microsoft.com/office/drawing/2014/main" id="{5B16E7FE-F5B4-460A-978C-1B52E09D65B2}"/>
+                <a16:creationId xmlns:a16="http://schemas.microsoft.com/office/drawing/2014/main" id="{557292AB-AF48-4D65-8A34-91DB8D0A1512}"/>
               </a:ext>
             </a:extLst>
           </p:cNvPr>
@@ -5178,7 +5178,7 @@
           <p:cNvPr id="52" name="">
             <a:extLst xmlns:a="http://schemas.openxmlformats.org/drawingml/2006/main">
               <a:ext uri="{FF2B5EF4-FFF2-40B4-BE49-F238E27FC236}">
-                <a16:creationId xmlns:a16="http://schemas.microsoft.com/office/drawing/2014/main" id="{3F89B012-87D7-48AE-9514-E27EAE3BB6CC}"/>
+                <a16:creationId xmlns:a16="http://schemas.microsoft.com/office/drawing/2014/main" id="{4D26D85C-220A-4FF2-88EA-A5767993E7CA}"/>
               </a:ext>
             </a:extLst>
           </p:cNvPr>
@@ -5211,7 +5211,7 @@
           <p:cNvPr id="53" name="metric-value-avg paid action">
             <a:extLst xmlns:a="http://schemas.openxmlformats.org/drawingml/2006/main">
               <a:ext uri="{FF2B5EF4-FFF2-40B4-BE49-F238E27FC236}">
-                <a16:creationId xmlns:a16="http://schemas.microsoft.com/office/drawing/2014/main" id="{33D792A3-6482-470C-9BD2-9C679EC61C32}"/>
+                <a16:creationId xmlns:a16="http://schemas.microsoft.com/office/drawing/2014/main" id="{AFE79947-BE22-4B19-AC74-B080A61B6C14}"/>
               </a:ext>
             </a:extLst>
           </p:cNvPr>
@@ -5256,7 +5256,7 @@
           <p:cNvPr id="54" name="metric-label-avg paid action">
             <a:extLst xmlns:a="http://schemas.openxmlformats.org/drawingml/2006/main">
               <a:ext uri="{FF2B5EF4-FFF2-40B4-BE49-F238E27FC236}">
-                <a16:creationId xmlns:a16="http://schemas.microsoft.com/office/drawing/2014/main" id="{AB611791-E2E5-46B0-B46A-BDA42467E39B}"/>
+                <a16:creationId xmlns:a16="http://schemas.microsoft.com/office/drawing/2014/main" id="{CE193C0E-FB9B-4CAF-90AF-9C99CCD514CE}"/>
               </a:ext>
             </a:extLst>
           </p:cNvPr>
@@ -5301,7 +5301,7 @@
           <p:cNvPr id="55" name="metric-note-avg paid action">
             <a:extLst xmlns:a="http://schemas.openxmlformats.org/drawingml/2006/main">
               <a:ext uri="{FF2B5EF4-FFF2-40B4-BE49-F238E27FC236}">
-                <a16:creationId xmlns:a16="http://schemas.microsoft.com/office/drawing/2014/main" id="{49D8FC5E-D96A-42A5-97A5-035B3E177541}"/>
+                <a16:creationId xmlns:a16="http://schemas.microsoft.com/office/drawing/2014/main" id="{C7098E38-A98A-4445-81C7-CCAEBD8B7F28}"/>
               </a:ext>
             </a:extLst>
           </p:cNvPr>
@@ -5346,7 +5346,7 @@
           <p:cNvPr id="56" name="footer-left">
             <a:extLst xmlns:a="http://schemas.openxmlformats.org/drawingml/2006/main">
               <a:ext uri="{FF2B5EF4-FFF2-40B4-BE49-F238E27FC236}">
-                <a16:creationId xmlns:a16="http://schemas.microsoft.com/office/drawing/2014/main" id="{FEC3F1E1-3BBD-4A7F-8525-4C9156AA6797}"/>
+                <a16:creationId xmlns:a16="http://schemas.microsoft.com/office/drawing/2014/main" id="{96061AF3-3013-4CA1-A921-00E0FA78667D}"/>
               </a:ext>
             </a:extLst>
           </p:cNvPr>
@@ -5391,7 +5391,7 @@
           <p:cNvPr id="57" name="footer-right">
             <a:extLst xmlns:a="http://schemas.openxmlformats.org/drawingml/2006/main">
               <a:ext uri="{FF2B5EF4-FFF2-40B4-BE49-F238E27FC236}">
-                <a16:creationId xmlns:a16="http://schemas.microsoft.com/office/drawing/2014/main" id="{814F8B44-5E11-461E-B336-E10B3324AFC1}"/>
+                <a16:creationId xmlns:a16="http://schemas.microsoft.com/office/drawing/2014/main" id="{10FDA2C9-7173-4D33-A39B-CD8999671A4D}"/>
               </a:ext>
             </a:extLst>
           </p:cNvPr>
@@ -5434,7 +5434,7 @@
     </p:spTree>
     <p:extLst>
       <p:ext uri="{BB962C8B-B14F-4D97-AF65-F5344CB8AC3E}">
-        <p14:creationId xmlns:p14="http://schemas.microsoft.com/office/powerpoint/2010/main" val="2121379843"/>
+        <p14:creationId xmlns:p14="http://schemas.microsoft.com/office/powerpoint/2010/main" val="1234757866"/>
       </p:ext>
     </p:extLst>
   </p:cSld>
@@ -5458,7 +5458,7 @@
           <p:cNvPr id="1" name="slide-background">
             <a:extLst xmlns:a="http://schemas.openxmlformats.org/drawingml/2006/main">
               <a:ext uri="{FF2B5EF4-FFF2-40B4-BE49-F238E27FC236}">
-                <a16:creationId xmlns:a16="http://schemas.microsoft.com/office/drawing/2014/main" id="{1CB87969-C39C-461F-85C2-2E9762625B55}"/>
+                <a16:creationId xmlns:a16="http://schemas.microsoft.com/office/drawing/2014/main" id="{58DB55C3-22E3-4D35-94E7-4854A3C71199}"/>
               </a:ext>
             </a:extLst>
           </p:cNvPr>
@@ -5491,7 +5491,7 @@
           <p:cNvPr id="2" name="kicker">
             <a:extLst xmlns:a="http://schemas.openxmlformats.org/drawingml/2006/main">
               <a:ext uri="{FF2B5EF4-FFF2-40B4-BE49-F238E27FC236}">
-                <a16:creationId xmlns:a16="http://schemas.microsoft.com/office/drawing/2014/main" id="{639725CB-E2D9-4499-8FED-EA09EB268937}"/>
+                <a16:creationId xmlns:a16="http://schemas.microsoft.com/office/drawing/2014/main" id="{94197816-C156-4156-A76A-D292FC85DD84}"/>
               </a:ext>
             </a:extLst>
           </p:cNvPr>
@@ -5536,7 +5536,7 @@
           <p:cNvPr id="3" name="slide-title">
             <a:extLst xmlns:a="http://schemas.openxmlformats.org/drawingml/2006/main">
               <a:ext uri="{FF2B5EF4-FFF2-40B4-BE49-F238E27FC236}">
-                <a16:creationId xmlns:a16="http://schemas.microsoft.com/office/drawing/2014/main" id="{E9432FB6-1825-4492-AD69-33EC41CB43FB}"/>
+                <a16:creationId xmlns:a16="http://schemas.microsoft.com/office/drawing/2014/main" id="{D1004982-E2E2-4C8A-8CE8-583C00B11A80}"/>
               </a:ext>
             </a:extLst>
           </p:cNvPr>
@@ -5581,7 +5581,7 @@
           <p:cNvPr id="4" name="slide-subtitle">
             <a:extLst xmlns:a="http://schemas.openxmlformats.org/drawingml/2006/main">
               <a:ext uri="{FF2B5EF4-FFF2-40B4-BE49-F238E27FC236}">
-                <a16:creationId xmlns:a16="http://schemas.microsoft.com/office/drawing/2014/main" id="{018BA4E9-05D5-46C8-812A-6C2DD3E2DF24}"/>
+                <a16:creationId xmlns:a16="http://schemas.microsoft.com/office/drawing/2014/main" id="{30FAF434-1AF8-4B12-8BDE-AE7987F0CB70}"/>
               </a:ext>
             </a:extLst>
           </p:cNvPr>
@@ -5626,18 +5626,18 @@
           <p:cNvPr id="5" name="">
             <a:extLst xmlns:a="http://schemas.openxmlformats.org/drawingml/2006/main">
               <a:ext uri="{FF2B5EF4-FFF2-40B4-BE49-F238E27FC236}">
-                <a16:creationId xmlns:a16="http://schemas.microsoft.com/office/drawing/2014/main" id="{D634D9A5-2268-44C4-B1E2-E56F0E899ABF}"/>
-              </a:ext>
-            </a:extLst>
-          </p:cNvPr>
-          <p:cNvSpPr>
-            <a:spLocks xmlns:a="http://schemas.openxmlformats.org/drawingml/2006/main" noGrp="1"/>
-          </p:cNvSpPr>
-          <p:nvPr/>
-        </p:nvSpPr>
-        <p:spPr>
-          <a:xfrm xmlns:a="http://schemas.openxmlformats.org/drawingml/2006/main">
-            <a:off x="838200" y="3733800"/>
+                <a16:creationId xmlns:a16="http://schemas.microsoft.com/office/drawing/2014/main" id="{EE25D298-9933-44F3-A906-AA26C70542B8}"/>
+              </a:ext>
+            </a:extLst>
+          </p:cNvPr>
+          <p:cNvSpPr>
+            <a:spLocks xmlns:a="http://schemas.openxmlformats.org/drawingml/2006/main" noGrp="1"/>
+          </p:cNvSpPr>
+          <p:nvPr/>
+        </p:nvSpPr>
+        <p:spPr>
+          <a:xfrm xmlns:a="http://schemas.openxmlformats.org/drawingml/2006/main">
+            <a:off x="838200" y="3848100"/>
             <a:ext cx="171450" cy="171450"/>
           </a:xfrm>
           <a:prstGeom xmlns:a="http://schemas.openxmlformats.org/drawingml/2006/main" prst="rect">
@@ -5659,18 +5659,18 @@
           <p:cNvPr id="6" name="lane-label-Policy">
             <a:extLst xmlns:a="http://schemas.openxmlformats.org/drawingml/2006/main">
               <a:ext uri="{FF2B5EF4-FFF2-40B4-BE49-F238E27FC236}">
-                <a16:creationId xmlns:a16="http://schemas.microsoft.com/office/drawing/2014/main" id="{538AA0D0-2741-4356-89EB-32A38029C273}"/>
-              </a:ext>
-            </a:extLst>
-          </p:cNvPr>
-          <p:cNvSpPr>
-            <a:spLocks xmlns:a="http://schemas.openxmlformats.org/drawingml/2006/main" noGrp="1"/>
-          </p:cNvSpPr>
-          <p:nvPr/>
-        </p:nvSpPr>
-        <p:spPr>
-          <a:xfrm xmlns:a="http://schemas.openxmlformats.org/drawingml/2006/main">
-            <a:off x="1123950" y="3657600"/>
+                <a16:creationId xmlns:a16="http://schemas.microsoft.com/office/drawing/2014/main" id="{F1CCF973-FDD5-4B8C-A3F7-CCEF24E62A32}"/>
+              </a:ext>
+            </a:extLst>
+          </p:cNvPr>
+          <p:cNvSpPr>
+            <a:spLocks xmlns:a="http://schemas.openxmlformats.org/drawingml/2006/main" noGrp="1"/>
+          </p:cNvSpPr>
+          <p:nvPr/>
+        </p:nvSpPr>
+        <p:spPr>
+          <a:xfrm xmlns:a="http://schemas.openxmlformats.org/drawingml/2006/main">
+            <a:off x="1123950" y="3790950"/>
             <a:ext cx="2476500" cy="266700"/>
           </a:xfrm>
           <a:prstGeom xmlns:a="http://schemas.openxmlformats.org/drawingml/2006/main" prst="rect">
@@ -5704,18 +5704,18 @@
           <p:cNvPr id="7" name="">
             <a:extLst xmlns:a="http://schemas.openxmlformats.org/drawingml/2006/main">
               <a:ext uri="{FF2B5EF4-FFF2-40B4-BE49-F238E27FC236}">
-                <a16:creationId xmlns:a16="http://schemas.microsoft.com/office/drawing/2014/main" id="{912DC69A-043F-4152-8611-96FED5CA1808}"/>
-              </a:ext>
-            </a:extLst>
-          </p:cNvPr>
-          <p:cNvSpPr>
-            <a:spLocks xmlns:a="http://schemas.openxmlformats.org/drawingml/2006/main" noGrp="1"/>
-          </p:cNvSpPr>
-          <p:nvPr/>
-        </p:nvSpPr>
-        <p:spPr>
-          <a:xfrm xmlns:a="http://schemas.openxmlformats.org/drawingml/2006/main">
-            <a:off x="819150" y="4076700"/>
+                <a16:creationId xmlns:a16="http://schemas.microsoft.com/office/drawing/2014/main" id="{A3FC737B-8BCE-4781-9494-6D34F4703FC3}"/>
+              </a:ext>
+            </a:extLst>
+          </p:cNvPr>
+          <p:cNvSpPr>
+            <a:spLocks xmlns:a="http://schemas.openxmlformats.org/drawingml/2006/main" noGrp="1"/>
+          </p:cNvSpPr>
+          <p:nvPr/>
+        </p:nvSpPr>
+        <p:spPr>
+          <a:xfrm xmlns:a="http://schemas.openxmlformats.org/drawingml/2006/main">
+            <a:off x="819150" y="4191000"/>
             <a:ext cx="2781300" cy="47625"/>
           </a:xfrm>
           <a:prstGeom xmlns:a="http://schemas.openxmlformats.org/drawingml/2006/main" prst="rect">
@@ -5737,18 +5737,18 @@
           <p:cNvPr id="8" name="lane-detail-Policy">
             <a:extLst xmlns:a="http://schemas.openxmlformats.org/drawingml/2006/main">
               <a:ext uri="{FF2B5EF4-FFF2-40B4-BE49-F238E27FC236}">
-                <a16:creationId xmlns:a16="http://schemas.microsoft.com/office/drawing/2014/main" id="{45A53F9E-3A06-4385-BB92-017119F1C2EC}"/>
-              </a:ext>
-            </a:extLst>
-          </p:cNvPr>
-          <p:cNvSpPr>
-            <a:spLocks xmlns:a="http://schemas.openxmlformats.org/drawingml/2006/main" noGrp="1"/>
-          </p:cNvSpPr>
-          <p:nvPr/>
-        </p:nvSpPr>
-        <p:spPr>
-          <a:xfrm xmlns:a="http://schemas.openxmlformats.org/drawingml/2006/main">
-            <a:off x="819150" y="4267200"/>
+                <a16:creationId xmlns:a16="http://schemas.microsoft.com/office/drawing/2014/main" id="{6FD202EB-1466-4D50-A869-4A07E705B2F2}"/>
+              </a:ext>
+            </a:extLst>
+          </p:cNvPr>
+          <p:cNvSpPr>
+            <a:spLocks xmlns:a="http://schemas.openxmlformats.org/drawingml/2006/main" noGrp="1"/>
+          </p:cNvSpPr>
+          <p:nvPr/>
+        </p:nvSpPr>
+        <p:spPr>
+          <a:xfrm xmlns:a="http://schemas.openxmlformats.org/drawingml/2006/main">
+            <a:off x="819150" y="4381500"/>
             <a:ext cx="2781300" cy="552450"/>
           </a:xfrm>
           <a:prstGeom xmlns:a="http://schemas.openxmlformats.org/drawingml/2006/main" prst="rect">
@@ -5782,18 +5782,18 @@
           <p:cNvPr id="9" name="flow-arrow">
             <a:extLst xmlns:a="http://schemas.openxmlformats.org/drawingml/2006/main">
               <a:ext uri="{FF2B5EF4-FFF2-40B4-BE49-F238E27FC236}">
-                <a16:creationId xmlns:a16="http://schemas.microsoft.com/office/drawing/2014/main" id="{1141171C-18F7-4CB5-82B1-B2F02B3E95F4}"/>
-              </a:ext>
-            </a:extLst>
-          </p:cNvPr>
-          <p:cNvSpPr>
-            <a:spLocks xmlns:a="http://schemas.openxmlformats.org/drawingml/2006/main" noGrp="1"/>
-          </p:cNvSpPr>
-          <p:nvPr/>
-        </p:nvSpPr>
-        <p:spPr>
-          <a:xfrm xmlns:a="http://schemas.openxmlformats.org/drawingml/2006/main">
-            <a:off x="3714750" y="3676650"/>
+                <a16:creationId xmlns:a16="http://schemas.microsoft.com/office/drawing/2014/main" id="{D7F3C4ED-C217-4603-9073-9E8F91C1F19D}"/>
+              </a:ext>
+            </a:extLst>
+          </p:cNvPr>
+          <p:cNvSpPr>
+            <a:spLocks xmlns:a="http://schemas.openxmlformats.org/drawingml/2006/main" noGrp="1"/>
+          </p:cNvSpPr>
+          <p:nvPr/>
+        </p:nvSpPr>
+        <p:spPr>
+          <a:xfrm xmlns:a="http://schemas.openxmlformats.org/drawingml/2006/main">
+            <a:off x="3714750" y="3790950"/>
             <a:ext cx="428625" cy="247650"/>
           </a:xfrm>
           <a:prstGeom xmlns:a="http://schemas.openxmlformats.org/drawingml/2006/main" prst="rect">
@@ -5827,18 +5827,18 @@
           <p:cNvPr id="10" name="">
             <a:extLst xmlns:a="http://schemas.openxmlformats.org/drawingml/2006/main">
               <a:ext uri="{FF2B5EF4-FFF2-40B4-BE49-F238E27FC236}">
-                <a16:creationId xmlns:a16="http://schemas.microsoft.com/office/drawing/2014/main" id="{0902AC24-0A4F-4FFA-9540-F22885788665}"/>
-              </a:ext>
-            </a:extLst>
-          </p:cNvPr>
-          <p:cNvSpPr>
-            <a:spLocks xmlns:a="http://schemas.openxmlformats.org/drawingml/2006/main" noGrp="1"/>
-          </p:cNvSpPr>
-          <p:nvPr/>
-        </p:nvSpPr>
-        <p:spPr>
-          <a:xfrm xmlns:a="http://schemas.openxmlformats.org/drawingml/2006/main">
-            <a:off x="4305300" y="3733800"/>
+                <a16:creationId xmlns:a16="http://schemas.microsoft.com/office/drawing/2014/main" id="{78803404-1D9E-4BA0-820C-CFA36BE77450}"/>
+              </a:ext>
+            </a:extLst>
+          </p:cNvPr>
+          <p:cNvSpPr>
+            <a:spLocks xmlns:a="http://schemas.openxmlformats.org/drawingml/2006/main" noGrp="1"/>
+          </p:cNvSpPr>
+          <p:nvPr/>
+        </p:nvSpPr>
+        <p:spPr>
+          <a:xfrm xmlns:a="http://schemas.openxmlformats.org/drawingml/2006/main">
+            <a:off x="4305300" y="3848100"/>
             <a:ext cx="171450" cy="171450"/>
           </a:xfrm>
           <a:prstGeom xmlns:a="http://schemas.openxmlformats.org/drawingml/2006/main" prst="rect">
@@ -5860,18 +5860,18 @@
           <p:cNvPr id="11" name="lane-label-x402">
             <a:extLst xmlns:a="http://schemas.openxmlformats.org/drawingml/2006/main">
               <a:ext uri="{FF2B5EF4-FFF2-40B4-BE49-F238E27FC236}">
-                <a16:creationId xmlns:a16="http://schemas.microsoft.com/office/drawing/2014/main" id="{49E26B3D-E7B1-4CCC-9BDE-D3E084915084}"/>
-              </a:ext>
-            </a:extLst>
-          </p:cNvPr>
-          <p:cNvSpPr>
-            <a:spLocks xmlns:a="http://schemas.openxmlformats.org/drawingml/2006/main" noGrp="1"/>
-          </p:cNvSpPr>
-          <p:nvPr/>
-        </p:nvSpPr>
-        <p:spPr>
-          <a:xfrm xmlns:a="http://schemas.openxmlformats.org/drawingml/2006/main">
-            <a:off x="4591050" y="3657600"/>
+                <a16:creationId xmlns:a16="http://schemas.microsoft.com/office/drawing/2014/main" id="{828AF480-73C0-486F-8BBD-542FD50F3701}"/>
+              </a:ext>
+            </a:extLst>
+          </p:cNvPr>
+          <p:cNvSpPr>
+            <a:spLocks xmlns:a="http://schemas.openxmlformats.org/drawingml/2006/main" noGrp="1"/>
+          </p:cNvSpPr>
+          <p:nvPr/>
+        </p:nvSpPr>
+        <p:spPr>
+          <a:xfrm xmlns:a="http://schemas.openxmlformats.org/drawingml/2006/main">
+            <a:off x="4591050" y="3790950"/>
             <a:ext cx="2476500" cy="266700"/>
           </a:xfrm>
           <a:prstGeom xmlns:a="http://schemas.openxmlformats.org/drawingml/2006/main" prst="rect">
@@ -5905,18 +5905,18 @@
           <p:cNvPr id="12" name="">
             <a:extLst xmlns:a="http://schemas.openxmlformats.org/drawingml/2006/main">
               <a:ext uri="{FF2B5EF4-FFF2-40B4-BE49-F238E27FC236}">
-                <a16:creationId xmlns:a16="http://schemas.microsoft.com/office/drawing/2014/main" id="{55842B33-BD7E-4D83-8554-B0DC57D8B724}"/>
-              </a:ext>
-            </a:extLst>
-          </p:cNvPr>
-          <p:cNvSpPr>
-            <a:spLocks xmlns:a="http://schemas.openxmlformats.org/drawingml/2006/main" noGrp="1"/>
-          </p:cNvSpPr>
-          <p:nvPr/>
-        </p:nvSpPr>
-        <p:spPr>
-          <a:xfrm xmlns:a="http://schemas.openxmlformats.org/drawingml/2006/main">
-            <a:off x="4286250" y="4076700"/>
+                <a16:creationId xmlns:a16="http://schemas.microsoft.com/office/drawing/2014/main" id="{E7152C43-6EAF-4B92-B8FE-26A7AC4B1A3B}"/>
+              </a:ext>
+            </a:extLst>
+          </p:cNvPr>
+          <p:cNvSpPr>
+            <a:spLocks xmlns:a="http://schemas.openxmlformats.org/drawingml/2006/main" noGrp="1"/>
+          </p:cNvSpPr>
+          <p:nvPr/>
+        </p:nvSpPr>
+        <p:spPr>
+          <a:xfrm xmlns:a="http://schemas.openxmlformats.org/drawingml/2006/main">
+            <a:off x="4286250" y="4191000"/>
             <a:ext cx="2781300" cy="47625"/>
           </a:xfrm>
           <a:prstGeom xmlns:a="http://schemas.openxmlformats.org/drawingml/2006/main" prst="rect">
@@ -5938,18 +5938,18 @@
           <p:cNvPr id="13" name="lane-detail-x402">
             <a:extLst xmlns:a="http://schemas.openxmlformats.org/drawingml/2006/main">
               <a:ext uri="{FF2B5EF4-FFF2-40B4-BE49-F238E27FC236}">
-                <a16:creationId xmlns:a16="http://schemas.microsoft.com/office/drawing/2014/main" id="{462A2484-B9D0-4E5D-A45D-B56618969535}"/>
-              </a:ext>
-            </a:extLst>
-          </p:cNvPr>
-          <p:cNvSpPr>
-            <a:spLocks xmlns:a="http://schemas.openxmlformats.org/drawingml/2006/main" noGrp="1"/>
-          </p:cNvSpPr>
-          <p:nvPr/>
-        </p:nvSpPr>
-        <p:spPr>
-          <a:xfrm xmlns:a="http://schemas.openxmlformats.org/drawingml/2006/main">
-            <a:off x="4286250" y="4267200"/>
+                <a16:creationId xmlns:a16="http://schemas.microsoft.com/office/drawing/2014/main" id="{63FEF088-A6B8-4DD7-8242-E25A2073C0A7}"/>
+              </a:ext>
+            </a:extLst>
+          </p:cNvPr>
+          <p:cNvSpPr>
+            <a:spLocks xmlns:a="http://schemas.openxmlformats.org/drawingml/2006/main" noGrp="1"/>
+          </p:cNvSpPr>
+          <p:nvPr/>
+        </p:nvSpPr>
+        <p:spPr>
+          <a:xfrm xmlns:a="http://schemas.openxmlformats.org/drawingml/2006/main">
+            <a:off x="4286250" y="4381500"/>
             <a:ext cx="2781300" cy="552450"/>
           </a:xfrm>
           <a:prstGeom xmlns:a="http://schemas.openxmlformats.org/drawingml/2006/main" prst="rect">
@@ -5983,18 +5983,18 @@
           <p:cNvPr id="14" name="flow-arrow">
             <a:extLst xmlns:a="http://schemas.openxmlformats.org/drawingml/2006/main">
               <a:ext uri="{FF2B5EF4-FFF2-40B4-BE49-F238E27FC236}">
-                <a16:creationId xmlns:a16="http://schemas.microsoft.com/office/drawing/2014/main" id="{D0C0BA72-BA2E-42DA-9E39-CF51E65DE4A1}"/>
-              </a:ext>
-            </a:extLst>
-          </p:cNvPr>
-          <p:cNvSpPr>
-            <a:spLocks xmlns:a="http://schemas.openxmlformats.org/drawingml/2006/main" noGrp="1"/>
-          </p:cNvSpPr>
-          <p:nvPr/>
-        </p:nvSpPr>
-        <p:spPr>
-          <a:xfrm xmlns:a="http://schemas.openxmlformats.org/drawingml/2006/main">
-            <a:off x="7181850" y="3676650"/>
+                <a16:creationId xmlns:a16="http://schemas.microsoft.com/office/drawing/2014/main" id="{261C7E8E-46C2-46CF-AC44-B7DD98FEE2D4}"/>
+              </a:ext>
+            </a:extLst>
+          </p:cNvPr>
+          <p:cNvSpPr>
+            <a:spLocks xmlns:a="http://schemas.openxmlformats.org/drawingml/2006/main" noGrp="1"/>
+          </p:cNvSpPr>
+          <p:nvPr/>
+        </p:nvSpPr>
+        <p:spPr>
+          <a:xfrm xmlns:a="http://schemas.openxmlformats.org/drawingml/2006/main">
+            <a:off x="7181850" y="3790950"/>
             <a:ext cx="428625" cy="247650"/>
           </a:xfrm>
           <a:prstGeom xmlns:a="http://schemas.openxmlformats.org/drawingml/2006/main" prst="rect">
@@ -6028,18 +6028,18 @@
           <p:cNvPr id="15" name="">
             <a:extLst xmlns:a="http://schemas.openxmlformats.org/drawingml/2006/main">
               <a:ext uri="{FF2B5EF4-FFF2-40B4-BE49-F238E27FC236}">
-                <a16:creationId xmlns:a16="http://schemas.microsoft.com/office/drawing/2014/main" id="{705BD517-6FE5-4D1C-AB36-767AF88B6B80}"/>
-              </a:ext>
-            </a:extLst>
-          </p:cNvPr>
-          <p:cNvSpPr>
-            <a:spLocks xmlns:a="http://schemas.openxmlformats.org/drawingml/2006/main" noGrp="1"/>
-          </p:cNvSpPr>
-          <p:nvPr/>
-        </p:nvSpPr>
-        <p:spPr>
-          <a:xfrm xmlns:a="http://schemas.openxmlformats.org/drawingml/2006/main">
-            <a:off x="7772400" y="3733800"/>
+                <a16:creationId xmlns:a16="http://schemas.microsoft.com/office/drawing/2014/main" id="{4B02AFBF-D83F-4AD1-857A-21415F03040E}"/>
+              </a:ext>
+            </a:extLst>
+          </p:cNvPr>
+          <p:cNvSpPr>
+            <a:spLocks xmlns:a="http://schemas.openxmlformats.org/drawingml/2006/main" noGrp="1"/>
+          </p:cNvSpPr>
+          <p:nvPr/>
+        </p:nvSpPr>
+        <p:spPr>
+          <a:xfrm xmlns:a="http://schemas.openxmlformats.org/drawingml/2006/main">
+            <a:off x="7772400" y="3848100"/>
             <a:ext cx="171450" cy="171450"/>
           </a:xfrm>
           <a:prstGeom xmlns:a="http://schemas.openxmlformats.org/drawingml/2006/main" prst="rect">
@@ -6061,18 +6061,18 @@
           <p:cNvPr id="16" name="lane-label-Gateway">
             <a:extLst xmlns:a="http://schemas.openxmlformats.org/drawingml/2006/main">
               <a:ext uri="{FF2B5EF4-FFF2-40B4-BE49-F238E27FC236}">
-                <a16:creationId xmlns:a16="http://schemas.microsoft.com/office/drawing/2014/main" id="{6C229977-5C88-4135-82F2-0C3F6A3BB8B5}"/>
-              </a:ext>
-            </a:extLst>
-          </p:cNvPr>
-          <p:cNvSpPr>
-            <a:spLocks xmlns:a="http://schemas.openxmlformats.org/drawingml/2006/main" noGrp="1"/>
-          </p:cNvSpPr>
-          <p:nvPr/>
-        </p:nvSpPr>
-        <p:spPr>
-          <a:xfrm xmlns:a="http://schemas.openxmlformats.org/drawingml/2006/main">
-            <a:off x="8058150" y="3657600"/>
+                <a16:creationId xmlns:a16="http://schemas.microsoft.com/office/drawing/2014/main" id="{EFF37EED-8E55-4756-8DA1-2CC9A3D06A29}"/>
+              </a:ext>
+            </a:extLst>
+          </p:cNvPr>
+          <p:cNvSpPr>
+            <a:spLocks xmlns:a="http://schemas.openxmlformats.org/drawingml/2006/main" noGrp="1"/>
+          </p:cNvSpPr>
+          <p:nvPr/>
+        </p:nvSpPr>
+        <p:spPr>
+          <a:xfrm xmlns:a="http://schemas.openxmlformats.org/drawingml/2006/main">
+            <a:off x="8058150" y="3790950"/>
             <a:ext cx="2476500" cy="266700"/>
           </a:xfrm>
           <a:prstGeom xmlns:a="http://schemas.openxmlformats.org/drawingml/2006/main" prst="rect">
@@ -6106,18 +6106,18 @@
           <p:cNvPr id="17" name="">
             <a:extLst xmlns:a="http://schemas.openxmlformats.org/drawingml/2006/main">
               <a:ext uri="{FF2B5EF4-FFF2-40B4-BE49-F238E27FC236}">
-                <a16:creationId xmlns:a16="http://schemas.microsoft.com/office/drawing/2014/main" id="{E892188A-14FE-4C7F-9939-EE310CBE6EB7}"/>
-              </a:ext>
-            </a:extLst>
-          </p:cNvPr>
-          <p:cNvSpPr>
-            <a:spLocks xmlns:a="http://schemas.openxmlformats.org/drawingml/2006/main" noGrp="1"/>
-          </p:cNvSpPr>
-          <p:nvPr/>
-        </p:nvSpPr>
-        <p:spPr>
-          <a:xfrm xmlns:a="http://schemas.openxmlformats.org/drawingml/2006/main">
-            <a:off x="7753350" y="4076700"/>
+                <a16:creationId xmlns:a16="http://schemas.microsoft.com/office/drawing/2014/main" id="{0761354D-5BE5-47F8-A470-AD8D1E148F14}"/>
+              </a:ext>
+            </a:extLst>
+          </p:cNvPr>
+          <p:cNvSpPr>
+            <a:spLocks xmlns:a="http://schemas.openxmlformats.org/drawingml/2006/main" noGrp="1"/>
+          </p:cNvSpPr>
+          <p:nvPr/>
+        </p:nvSpPr>
+        <p:spPr>
+          <a:xfrm xmlns:a="http://schemas.openxmlformats.org/drawingml/2006/main">
+            <a:off x="7753350" y="4191000"/>
             <a:ext cx="2781300" cy="47625"/>
           </a:xfrm>
           <a:prstGeom xmlns:a="http://schemas.openxmlformats.org/drawingml/2006/main" prst="rect">
@@ -6139,18 +6139,18 @@
           <p:cNvPr id="18" name="lane-detail-Gateway">
             <a:extLst xmlns:a="http://schemas.openxmlformats.org/drawingml/2006/main">
               <a:ext uri="{FF2B5EF4-FFF2-40B4-BE49-F238E27FC236}">
-                <a16:creationId xmlns:a16="http://schemas.microsoft.com/office/drawing/2014/main" id="{F12ADD3B-F175-4280-9F00-F2C3B0816F99}"/>
-              </a:ext>
-            </a:extLst>
-          </p:cNvPr>
-          <p:cNvSpPr>
-            <a:spLocks xmlns:a="http://schemas.openxmlformats.org/drawingml/2006/main" noGrp="1"/>
-          </p:cNvSpPr>
-          <p:nvPr/>
-        </p:nvSpPr>
-        <p:spPr>
-          <a:xfrm xmlns:a="http://schemas.openxmlformats.org/drawingml/2006/main">
-            <a:off x="7753350" y="4267200"/>
+                <a16:creationId xmlns:a16="http://schemas.microsoft.com/office/drawing/2014/main" id="{DF61A534-3EEE-4DA1-9288-CF069481DF0F}"/>
+              </a:ext>
+            </a:extLst>
+          </p:cNvPr>
+          <p:cNvSpPr>
+            <a:spLocks xmlns:a="http://schemas.openxmlformats.org/drawingml/2006/main" noGrp="1"/>
+          </p:cNvSpPr>
+          <p:nvPr/>
+        </p:nvSpPr>
+        <p:spPr>
+          <a:xfrm xmlns:a="http://schemas.openxmlformats.org/drawingml/2006/main">
+            <a:off x="7753350" y="4381500"/>
             <a:ext cx="2781300" cy="361950"/>
           </a:xfrm>
           <a:prstGeom xmlns:a="http://schemas.openxmlformats.org/drawingml/2006/main" prst="rect">
@@ -6184,18 +6184,18 @@
           <p:cNvPr id="19" name="flow-arrow">
             <a:extLst xmlns:a="http://schemas.openxmlformats.org/drawingml/2006/main">
               <a:ext uri="{FF2B5EF4-FFF2-40B4-BE49-F238E27FC236}">
-                <a16:creationId xmlns:a16="http://schemas.microsoft.com/office/drawing/2014/main" id="{FBC70BF8-D876-44CB-B45D-C12D2967D839}"/>
-              </a:ext>
-            </a:extLst>
-          </p:cNvPr>
-          <p:cNvSpPr>
-            <a:spLocks xmlns:a="http://schemas.openxmlformats.org/drawingml/2006/main" noGrp="1"/>
-          </p:cNvSpPr>
-          <p:nvPr/>
-        </p:nvSpPr>
-        <p:spPr>
-          <a:xfrm xmlns:a="http://schemas.openxmlformats.org/drawingml/2006/main">
-            <a:off x="10648950" y="3676650"/>
+                <a16:creationId xmlns:a16="http://schemas.microsoft.com/office/drawing/2014/main" id="{ADE36EB7-5286-41CD-A2B4-AE6F84007257}"/>
+              </a:ext>
+            </a:extLst>
+          </p:cNvPr>
+          <p:cNvSpPr>
+            <a:spLocks xmlns:a="http://schemas.openxmlformats.org/drawingml/2006/main" noGrp="1"/>
+          </p:cNvSpPr>
+          <p:nvPr/>
+        </p:nvSpPr>
+        <p:spPr>
+          <a:xfrm xmlns:a="http://schemas.openxmlformats.org/drawingml/2006/main">
+            <a:off x="10648950" y="3790950"/>
             <a:ext cx="428625" cy="247650"/>
           </a:xfrm>
           <a:prstGeom xmlns:a="http://schemas.openxmlformats.org/drawingml/2006/main" prst="rect">
@@ -6229,18 +6229,18 @@
           <p:cNvPr id="20" name="">
             <a:extLst xmlns:a="http://schemas.openxmlformats.org/drawingml/2006/main">
               <a:ext uri="{FF2B5EF4-FFF2-40B4-BE49-F238E27FC236}">
-                <a16:creationId xmlns:a16="http://schemas.microsoft.com/office/drawing/2014/main" id="{94165449-1146-42B8-B5E5-09F134529584}"/>
-              </a:ext>
-            </a:extLst>
-          </p:cNvPr>
-          <p:cNvSpPr>
-            <a:spLocks xmlns:a="http://schemas.openxmlformats.org/drawingml/2006/main" noGrp="1"/>
-          </p:cNvSpPr>
-          <p:nvPr/>
-        </p:nvSpPr>
-        <p:spPr>
-          <a:xfrm xmlns:a="http://schemas.openxmlformats.org/drawingml/2006/main">
-            <a:off x="11239500" y="3733800"/>
+                <a16:creationId xmlns:a16="http://schemas.microsoft.com/office/drawing/2014/main" id="{80C5CC8B-CA04-41BD-BDD8-7841A3A859B6}"/>
+              </a:ext>
+            </a:extLst>
+          </p:cNvPr>
+          <p:cNvSpPr>
+            <a:spLocks xmlns:a="http://schemas.openxmlformats.org/drawingml/2006/main" noGrp="1"/>
+          </p:cNvSpPr>
+          <p:nvPr/>
+        </p:nvSpPr>
+        <p:spPr>
+          <a:xfrm xmlns:a="http://schemas.openxmlformats.org/drawingml/2006/main">
+            <a:off x="11239500" y="3848100"/>
             <a:ext cx="171450" cy="171450"/>
           </a:xfrm>
           <a:prstGeom xmlns:a="http://schemas.openxmlformats.org/drawingml/2006/main" prst="rect">
@@ -6262,18 +6262,18 @@
           <p:cNvPr id="21" name="lane-label-Provider">
             <a:extLst xmlns:a="http://schemas.openxmlformats.org/drawingml/2006/main">
               <a:ext uri="{FF2B5EF4-FFF2-40B4-BE49-F238E27FC236}">
-                <a16:creationId xmlns:a16="http://schemas.microsoft.com/office/drawing/2014/main" id="{C65FEC6B-67C5-44E7-A8ED-F2193D699C02}"/>
-              </a:ext>
-            </a:extLst>
-          </p:cNvPr>
-          <p:cNvSpPr>
-            <a:spLocks xmlns:a="http://schemas.openxmlformats.org/drawingml/2006/main" noGrp="1"/>
-          </p:cNvSpPr>
-          <p:nvPr/>
-        </p:nvSpPr>
-        <p:spPr>
-          <a:xfrm xmlns:a="http://schemas.openxmlformats.org/drawingml/2006/main">
-            <a:off x="11525250" y="3657600"/>
+                <a16:creationId xmlns:a16="http://schemas.microsoft.com/office/drawing/2014/main" id="{2776FBD1-0FC7-4C2D-A6C0-8AB6A4199C34}"/>
+              </a:ext>
+            </a:extLst>
+          </p:cNvPr>
+          <p:cNvSpPr>
+            <a:spLocks xmlns:a="http://schemas.openxmlformats.org/drawingml/2006/main" noGrp="1"/>
+          </p:cNvSpPr>
+          <p:nvPr/>
+        </p:nvSpPr>
+        <p:spPr>
+          <a:xfrm xmlns:a="http://schemas.openxmlformats.org/drawingml/2006/main">
+            <a:off x="11525250" y="3790950"/>
             <a:ext cx="2476500" cy="266700"/>
           </a:xfrm>
           <a:prstGeom xmlns:a="http://schemas.openxmlformats.org/drawingml/2006/main" prst="rect">
@@ -6307,18 +6307,18 @@
           <p:cNvPr id="22" name="">
             <a:extLst xmlns:a="http://schemas.openxmlformats.org/drawingml/2006/main">
               <a:ext uri="{FF2B5EF4-FFF2-40B4-BE49-F238E27FC236}">
-                <a16:creationId xmlns:a16="http://schemas.microsoft.com/office/drawing/2014/main" id="{C6BFC9F8-DAA1-4A68-B8E3-5506D39E55F7}"/>
-              </a:ext>
-            </a:extLst>
-          </p:cNvPr>
-          <p:cNvSpPr>
-            <a:spLocks xmlns:a="http://schemas.openxmlformats.org/drawingml/2006/main" noGrp="1"/>
-          </p:cNvSpPr>
-          <p:nvPr/>
-        </p:nvSpPr>
-        <p:spPr>
-          <a:xfrm xmlns:a="http://schemas.openxmlformats.org/drawingml/2006/main">
-            <a:off x="11220450" y="4076700"/>
+                <a16:creationId xmlns:a16="http://schemas.microsoft.com/office/drawing/2014/main" id="{4EA0F0F3-35A0-437C-B849-0267A7C1D2BB}"/>
+              </a:ext>
+            </a:extLst>
+          </p:cNvPr>
+          <p:cNvSpPr>
+            <a:spLocks xmlns:a="http://schemas.openxmlformats.org/drawingml/2006/main" noGrp="1"/>
+          </p:cNvSpPr>
+          <p:nvPr/>
+        </p:nvSpPr>
+        <p:spPr>
+          <a:xfrm xmlns:a="http://schemas.openxmlformats.org/drawingml/2006/main">
+            <a:off x="11220450" y="4191000"/>
             <a:ext cx="2781300" cy="47625"/>
           </a:xfrm>
           <a:prstGeom xmlns:a="http://schemas.openxmlformats.org/drawingml/2006/main" prst="rect">
@@ -6340,18 +6340,18 @@
           <p:cNvPr id="23" name="lane-detail-Provider">
             <a:extLst xmlns:a="http://schemas.openxmlformats.org/drawingml/2006/main">
               <a:ext uri="{FF2B5EF4-FFF2-40B4-BE49-F238E27FC236}">
-                <a16:creationId xmlns:a16="http://schemas.microsoft.com/office/drawing/2014/main" id="{53A971F3-FF9F-49A1-8D08-4A59DA11CDA7}"/>
-              </a:ext>
-            </a:extLst>
-          </p:cNvPr>
-          <p:cNvSpPr>
-            <a:spLocks xmlns:a="http://schemas.openxmlformats.org/drawingml/2006/main" noGrp="1"/>
-          </p:cNvSpPr>
-          <p:nvPr/>
-        </p:nvSpPr>
-        <p:spPr>
-          <a:xfrm xmlns:a="http://schemas.openxmlformats.org/drawingml/2006/main">
-            <a:off x="11220450" y="4267200"/>
+                <a16:creationId xmlns:a16="http://schemas.microsoft.com/office/drawing/2014/main" id="{472DF801-9FE4-4A40-A307-79BD4E7CFEDA}"/>
+              </a:ext>
+            </a:extLst>
+          </p:cNvPr>
+          <p:cNvSpPr>
+            <a:spLocks xmlns:a="http://schemas.openxmlformats.org/drawingml/2006/main" noGrp="1"/>
+          </p:cNvSpPr>
+          <p:nvPr/>
+        </p:nvSpPr>
+        <p:spPr>
+          <a:xfrm xmlns:a="http://schemas.openxmlformats.org/drawingml/2006/main">
+            <a:off x="11220450" y="4381500"/>
             <a:ext cx="2781300" cy="361950"/>
           </a:xfrm>
           <a:prstGeom xmlns:a="http://schemas.openxmlformats.org/drawingml/2006/main" prst="rect">
@@ -6385,18 +6385,18 @@
           <p:cNvPr id="24" name="flow-arrow">
             <a:extLst xmlns:a="http://schemas.openxmlformats.org/drawingml/2006/main">
               <a:ext uri="{FF2B5EF4-FFF2-40B4-BE49-F238E27FC236}">
-                <a16:creationId xmlns:a16="http://schemas.microsoft.com/office/drawing/2014/main" id="{E8FB6BD3-A8FF-4230-B9BA-02788116612B}"/>
-              </a:ext>
-            </a:extLst>
-          </p:cNvPr>
-          <p:cNvSpPr>
-            <a:spLocks xmlns:a="http://schemas.openxmlformats.org/drawingml/2006/main" noGrp="1"/>
-          </p:cNvSpPr>
-          <p:nvPr/>
-        </p:nvSpPr>
-        <p:spPr>
-          <a:xfrm xmlns:a="http://schemas.openxmlformats.org/drawingml/2006/main">
-            <a:off x="14116050" y="3676650"/>
+                <a16:creationId xmlns:a16="http://schemas.microsoft.com/office/drawing/2014/main" id="{489692F0-5405-4B5C-93F6-EA87E94256B5}"/>
+              </a:ext>
+            </a:extLst>
+          </p:cNvPr>
+          <p:cNvSpPr>
+            <a:spLocks xmlns:a="http://schemas.openxmlformats.org/drawingml/2006/main" noGrp="1"/>
+          </p:cNvSpPr>
+          <p:nvPr/>
+        </p:nvSpPr>
+        <p:spPr>
+          <a:xfrm xmlns:a="http://schemas.openxmlformats.org/drawingml/2006/main">
+            <a:off x="14116050" y="3790950"/>
             <a:ext cx="428625" cy="247650"/>
           </a:xfrm>
           <a:prstGeom xmlns:a="http://schemas.openxmlformats.org/drawingml/2006/main" prst="rect">
@@ -6430,18 +6430,18 @@
           <p:cNvPr id="25" name="">
             <a:extLst xmlns:a="http://schemas.openxmlformats.org/drawingml/2006/main">
               <a:ext uri="{FF2B5EF4-FFF2-40B4-BE49-F238E27FC236}">
-                <a16:creationId xmlns:a16="http://schemas.microsoft.com/office/drawing/2014/main" id="{5ED50915-A228-4B64-B34A-1893547B9067}"/>
-              </a:ext>
-            </a:extLst>
-          </p:cNvPr>
-          <p:cNvSpPr>
-            <a:spLocks xmlns:a="http://schemas.openxmlformats.org/drawingml/2006/main" noGrp="1"/>
-          </p:cNvSpPr>
-          <p:nvPr/>
-        </p:nvSpPr>
-        <p:spPr>
-          <a:xfrm xmlns:a="http://schemas.openxmlformats.org/drawingml/2006/main">
-            <a:off x="14706600" y="3733800"/>
+                <a16:creationId xmlns:a16="http://schemas.microsoft.com/office/drawing/2014/main" id="{21DA8E12-0CA7-462A-B585-3DAED335879E}"/>
+              </a:ext>
+            </a:extLst>
+          </p:cNvPr>
+          <p:cNvSpPr>
+            <a:spLocks xmlns:a="http://schemas.openxmlformats.org/drawingml/2006/main" noGrp="1"/>
+          </p:cNvSpPr>
+          <p:nvPr/>
+        </p:nvSpPr>
+        <p:spPr>
+          <a:xfrm xmlns:a="http://schemas.openxmlformats.org/drawingml/2006/main">
+            <a:off x="14706600" y="3848100"/>
             <a:ext cx="171450" cy="171450"/>
           </a:xfrm>
           <a:prstGeom xmlns:a="http://schemas.openxmlformats.org/drawingml/2006/main" prst="rect">
@@ -6463,18 +6463,18 @@
           <p:cNvPr id="26" name="lane-label-Arc">
             <a:extLst xmlns:a="http://schemas.openxmlformats.org/drawingml/2006/main">
               <a:ext uri="{FF2B5EF4-FFF2-40B4-BE49-F238E27FC236}">
-                <a16:creationId xmlns:a16="http://schemas.microsoft.com/office/drawing/2014/main" id="{916B3DD6-5BEF-4EA8-8023-8EF13FC2FA1C}"/>
-              </a:ext>
-            </a:extLst>
-          </p:cNvPr>
-          <p:cNvSpPr>
-            <a:spLocks xmlns:a="http://schemas.openxmlformats.org/drawingml/2006/main" noGrp="1"/>
-          </p:cNvSpPr>
-          <p:nvPr/>
-        </p:nvSpPr>
-        <p:spPr>
-          <a:xfrm xmlns:a="http://schemas.openxmlformats.org/drawingml/2006/main">
-            <a:off x="14992350" y="3657600"/>
+                <a16:creationId xmlns:a16="http://schemas.microsoft.com/office/drawing/2014/main" id="{E25AA219-156A-4912-A2AE-2C6F29BECBCD}"/>
+              </a:ext>
+            </a:extLst>
+          </p:cNvPr>
+          <p:cNvSpPr>
+            <a:spLocks xmlns:a="http://schemas.openxmlformats.org/drawingml/2006/main" noGrp="1"/>
+          </p:cNvSpPr>
+          <p:nvPr/>
+        </p:nvSpPr>
+        <p:spPr>
+          <a:xfrm xmlns:a="http://schemas.openxmlformats.org/drawingml/2006/main">
+            <a:off x="14992350" y="3790950"/>
             <a:ext cx="2476500" cy="266700"/>
           </a:xfrm>
           <a:prstGeom xmlns:a="http://schemas.openxmlformats.org/drawingml/2006/main" prst="rect">
@@ -6508,18 +6508,18 @@
           <p:cNvPr id="27" name="">
             <a:extLst xmlns:a="http://schemas.openxmlformats.org/drawingml/2006/main">
               <a:ext uri="{FF2B5EF4-FFF2-40B4-BE49-F238E27FC236}">
-                <a16:creationId xmlns:a16="http://schemas.microsoft.com/office/drawing/2014/main" id="{5B6C02B1-9044-4E06-8031-F03442DD0938}"/>
-              </a:ext>
-            </a:extLst>
-          </p:cNvPr>
-          <p:cNvSpPr>
-            <a:spLocks xmlns:a="http://schemas.openxmlformats.org/drawingml/2006/main" noGrp="1"/>
-          </p:cNvSpPr>
-          <p:nvPr/>
-        </p:nvSpPr>
-        <p:spPr>
-          <a:xfrm xmlns:a="http://schemas.openxmlformats.org/drawingml/2006/main">
-            <a:off x="14687550" y="4076700"/>
+                <a16:creationId xmlns:a16="http://schemas.microsoft.com/office/drawing/2014/main" id="{ED0CD89B-CA8F-4688-84A1-55B348B7D388}"/>
+              </a:ext>
+            </a:extLst>
+          </p:cNvPr>
+          <p:cNvSpPr>
+            <a:spLocks xmlns:a="http://schemas.openxmlformats.org/drawingml/2006/main" noGrp="1"/>
+          </p:cNvSpPr>
+          <p:nvPr/>
+        </p:nvSpPr>
+        <p:spPr>
+          <a:xfrm xmlns:a="http://schemas.openxmlformats.org/drawingml/2006/main">
+            <a:off x="14687550" y="4191000"/>
             <a:ext cx="2781300" cy="47625"/>
           </a:xfrm>
           <a:prstGeom xmlns:a="http://schemas.openxmlformats.org/drawingml/2006/main" prst="rect">
@@ -6541,18 +6541,18 @@
           <p:cNvPr id="28" name="lane-detail-Arc">
             <a:extLst xmlns:a="http://schemas.openxmlformats.org/drawingml/2006/main">
               <a:ext uri="{FF2B5EF4-FFF2-40B4-BE49-F238E27FC236}">
-                <a16:creationId xmlns:a16="http://schemas.microsoft.com/office/drawing/2014/main" id="{A246666C-9B1E-4282-BAC1-054C0B71CEBD}"/>
-              </a:ext>
-            </a:extLst>
-          </p:cNvPr>
-          <p:cNvSpPr>
-            <a:spLocks xmlns:a="http://schemas.openxmlformats.org/drawingml/2006/main" noGrp="1"/>
-          </p:cNvSpPr>
-          <p:nvPr/>
-        </p:nvSpPr>
-        <p:spPr>
-          <a:xfrm xmlns:a="http://schemas.openxmlformats.org/drawingml/2006/main">
-            <a:off x="14687550" y="4267200"/>
+                <a16:creationId xmlns:a16="http://schemas.microsoft.com/office/drawing/2014/main" id="{4E6EDB33-51F3-454B-8105-EF691A36FD54}"/>
+              </a:ext>
+            </a:extLst>
+          </p:cNvPr>
+          <p:cNvSpPr>
+            <a:spLocks xmlns:a="http://schemas.openxmlformats.org/drawingml/2006/main" noGrp="1"/>
+          </p:cNvSpPr>
+          <p:nvPr/>
+        </p:nvSpPr>
+        <p:spPr>
+          <a:xfrm xmlns:a="http://schemas.openxmlformats.org/drawingml/2006/main">
+            <a:off x="14687550" y="4381500"/>
             <a:ext cx="2781300" cy="361950"/>
           </a:xfrm>
           <a:prstGeom xmlns:a="http://schemas.openxmlformats.org/drawingml/2006/main" prst="rect">
@@ -6586,23 +6586,23 @@
           <p:cNvPr id="29" name="payment-flow-proof-note">
             <a:extLst xmlns:a="http://schemas.openxmlformats.org/drawingml/2006/main">
               <a:ext uri="{FF2B5EF4-FFF2-40B4-BE49-F238E27FC236}">
-                <a16:creationId xmlns:a16="http://schemas.microsoft.com/office/drawing/2014/main" id="{77BCD088-6233-4BF1-A45D-EE95787E1A72}"/>
-              </a:ext>
-            </a:extLst>
-          </p:cNvPr>
-          <p:cNvSpPr>
-            <a:spLocks xmlns:a="http://schemas.openxmlformats.org/drawingml/2006/main" noGrp="1"/>
-          </p:cNvSpPr>
-          <p:nvPr/>
-        </p:nvSpPr>
-        <p:spPr>
-          <a:xfrm xmlns:a="http://schemas.openxmlformats.org/drawingml/2006/main">
-            <a:off x="819150" y="6496050"/>
-            <a:ext cx="16649700" cy="1209675"/>
+                <a16:creationId xmlns:a16="http://schemas.microsoft.com/office/drawing/2014/main" id="{428F81BC-4F76-40DA-AC0E-AA1590CB58AF}"/>
+              </a:ext>
+            </a:extLst>
+          </p:cNvPr>
+          <p:cNvSpPr>
+            <a:spLocks xmlns:a="http://schemas.openxmlformats.org/drawingml/2006/main" noGrp="1"/>
+          </p:cNvSpPr>
+          <p:nvPr/>
+        </p:nvSpPr>
+        <p:spPr>
+          <a:xfrm xmlns:a="http://schemas.openxmlformats.org/drawingml/2006/main">
+            <a:off x="819150" y="6619875"/>
+            <a:ext cx="16649700" cy="962025"/>
           </a:xfrm>
           <a:prstGeom xmlns:a="http://schemas.openxmlformats.org/drawingml/2006/main" prst="roundRect">
             <a:avLst>
-              <a:gd name="adj" fmla="val 6299"/>
+              <a:gd name="adj" fmla="val 7921"/>
             </a:avLst>
           </a:prstGeom>
           <a:solidFill xmlns:a="http://schemas.openxmlformats.org/drawingml/2006/main">
@@ -6621,18 +6621,18 @@
           <p:cNvPr id="30" name="watch-label">
             <a:extLst xmlns:a="http://schemas.openxmlformats.org/drawingml/2006/main">
               <a:ext uri="{FF2B5EF4-FFF2-40B4-BE49-F238E27FC236}">
-                <a16:creationId xmlns:a16="http://schemas.microsoft.com/office/drawing/2014/main" id="{13653694-C3CE-434A-BB3E-1BE0C979926F}"/>
-              </a:ext>
-            </a:extLst>
-          </p:cNvPr>
-          <p:cNvSpPr>
-            <a:spLocks xmlns:a="http://schemas.openxmlformats.org/drawingml/2006/main" noGrp="1"/>
-          </p:cNvSpPr>
-          <p:nvPr/>
-        </p:nvSpPr>
-        <p:spPr>
-          <a:xfrm xmlns:a="http://schemas.openxmlformats.org/drawingml/2006/main">
-            <a:off x="1143000" y="6724650"/>
+                <a16:creationId xmlns:a16="http://schemas.microsoft.com/office/drawing/2014/main" id="{FA9E24D4-B03A-4FB9-86A8-EDFA18C65682}"/>
+              </a:ext>
+            </a:extLst>
+          </p:cNvPr>
+          <p:cNvSpPr>
+            <a:spLocks xmlns:a="http://schemas.openxmlformats.org/drawingml/2006/main" noGrp="1"/>
+          </p:cNvSpPr>
+          <p:nvPr/>
+        </p:nvSpPr>
+        <p:spPr>
+          <a:xfrm xmlns:a="http://schemas.openxmlformats.org/drawingml/2006/main">
+            <a:off x="1143000" y="6858000"/>
             <a:ext cx="10687050" cy="190500"/>
           </a:xfrm>
           <a:prstGeom xmlns:a="http://schemas.openxmlformats.org/drawingml/2006/main" prst="rect">
@@ -6656,7 +6656,7 @@
                   <a:srgbClr val="B8C2CC"/>
                 </a:solidFill>
               </a:rPr>
-              <a:t>What judges should watch in the video</a:t>
+              <a:t>Proof chain</a:t>
             </a:r>
           </a:p>
         </p:txBody>
@@ -6666,19 +6666,19 @@
           <p:cNvPr id="31" name="watch-copy">
             <a:extLst xmlns:a="http://schemas.openxmlformats.org/drawingml/2006/main">
               <a:ext uri="{FF2B5EF4-FFF2-40B4-BE49-F238E27FC236}">
-                <a16:creationId xmlns:a16="http://schemas.microsoft.com/office/drawing/2014/main" id="{50ED0D87-2A5D-4311-BF4F-B4D9F0584577}"/>
-              </a:ext>
-            </a:extLst>
-          </p:cNvPr>
-          <p:cNvSpPr>
-            <a:spLocks xmlns:a="http://schemas.openxmlformats.org/drawingml/2006/main" noGrp="1"/>
-          </p:cNvSpPr>
-          <p:nvPr/>
-        </p:nvSpPr>
-        <p:spPr>
-          <a:xfrm xmlns:a="http://schemas.openxmlformats.org/drawingml/2006/main">
-            <a:off x="1143000" y="6991350"/>
-            <a:ext cx="10687050" cy="495300"/>
+                <a16:creationId xmlns:a16="http://schemas.microsoft.com/office/drawing/2014/main" id="{00713236-FBCA-4780-8467-F8AF882233D8}"/>
+              </a:ext>
+            </a:extLst>
+          </p:cNvPr>
+          <p:cNvSpPr>
+            <a:spLocks xmlns:a="http://schemas.openxmlformats.org/drawingml/2006/main" noGrp="1"/>
+          </p:cNvSpPr>
+          <p:nvPr/>
+        </p:nvSpPr>
+        <p:spPr>
+          <a:xfrm xmlns:a="http://schemas.openxmlformats.org/drawingml/2006/main">
+            <a:off x="1143000" y="7124700"/>
+            <a:ext cx="10687050" cy="247650"/>
           </a:xfrm>
           <a:prstGeom xmlns:a="http://schemas.openxmlformats.org/drawingml/2006/main" prst="rect">
             <a:avLst/>
@@ -6701,7 +6701,7 @@
                   <a:srgbClr val="FFFFFF"/>
                 </a:solidFill>
               </a:rPr>
-              <a:t>Circle-side payment authorization, then Arc-side receipt verification. The key product change is one signature for the selected proof batch.</a:t>
+              <a:t>One batch payment authorization is followed by provider-signed receipts and an Arc receipt anchor.</a:t>
             </a:r>
           </a:p>
         </p:txBody>
@@ -6711,42 +6711,42 @@
           <p:cNvPr id="32" name="contract-function">
             <a:extLst xmlns:a="http://schemas.openxmlformats.org/drawingml/2006/main">
               <a:ext uri="{FF2B5EF4-FFF2-40B4-BE49-F238E27FC236}">
-                <a16:creationId xmlns:a16="http://schemas.microsoft.com/office/drawing/2014/main" id="{68444B85-86EA-435D-857A-3A3A5482FE05}"/>
-              </a:ext>
-            </a:extLst>
-          </p:cNvPr>
-          <p:cNvSpPr>
-            <a:spLocks xmlns:a="http://schemas.openxmlformats.org/drawingml/2006/main" noGrp="1"/>
-          </p:cNvSpPr>
-          <p:nvPr/>
-        </p:nvSpPr>
-        <p:spPr>
-          <a:xfrm xmlns:a="http://schemas.openxmlformats.org/drawingml/2006/main">
-            <a:off x="12192000" y="7010400"/>
-            <a:ext cx="4953000" cy="190500"/>
-          </a:xfrm>
-          <a:prstGeom xmlns:a="http://schemas.openxmlformats.org/drawingml/2006/main" prst="rect">
-            <a:avLst/>
-          </a:prstGeom>
-        </p:spPr>
-        <p:txBody>
-          <a:bodyPr xmlns:a="http://schemas.openxmlformats.org/drawingml/2006/main" lIns="0" tIns="0" rIns="0" bIns="0"/>
-          <a:lstStyle xmlns:a="http://schemas.openxmlformats.org/drawingml/2006/main"/>
-          <a:p xmlns:a="http://schemas.openxmlformats.org/drawingml/2006/main">
-            <a:pPr>
-              <a:defRPr sz="1500">
+                <a16:creationId xmlns:a16="http://schemas.microsoft.com/office/drawing/2014/main" id="{B3A3A920-ACE4-45EB-AED1-1DB0A73DEA68}"/>
+              </a:ext>
+            </a:extLst>
+          </p:cNvPr>
+          <p:cNvSpPr>
+            <a:spLocks xmlns:a="http://schemas.openxmlformats.org/drawingml/2006/main" noGrp="1"/>
+          </p:cNvSpPr>
+          <p:nvPr/>
+        </p:nvSpPr>
+        <p:spPr>
+          <a:xfrm xmlns:a="http://schemas.openxmlformats.org/drawingml/2006/main">
+            <a:off x="12192000" y="6991350"/>
+            <a:ext cx="4953000" cy="228600"/>
+          </a:xfrm>
+          <a:prstGeom xmlns:a="http://schemas.openxmlformats.org/drawingml/2006/main" prst="rect">
+            <a:avLst/>
+          </a:prstGeom>
+        </p:spPr>
+        <p:txBody>
+          <a:bodyPr xmlns:a="http://schemas.openxmlformats.org/drawingml/2006/main" lIns="0" tIns="0" rIns="0" bIns="0"/>
+          <a:lstStyle xmlns:a="http://schemas.openxmlformats.org/drawingml/2006/main"/>
+          <a:p xmlns:a="http://schemas.openxmlformats.org/drawingml/2006/main">
+            <a:pPr>
+              <a:defRPr sz="1650" b="1">
                 <a:solidFill>
                   <a:srgbClr val="A7F3D0"/>
                 </a:solidFill>
               </a:defRPr>
             </a:pPr>
             <a:r>
-              <a:rPr sz="1500">
+              <a:rPr sz="1650" b="1">
                 <a:solidFill>
                   <a:srgbClr val="A7F3D0"/>
                 </a:solidFill>
               </a:rPr>
-              <a:t>recordSpendsWithProviderSignatures</a:t>
+              <a:t>x402 authorization -&gt; signed receipts -&gt; Arc anchor</a:t>
             </a:r>
           </a:p>
         </p:txBody>
@@ -6756,7 +6756,7 @@
           <p:cNvPr id="33" name="footer-left">
             <a:extLst xmlns:a="http://schemas.openxmlformats.org/drawingml/2006/main">
               <a:ext uri="{FF2B5EF4-FFF2-40B4-BE49-F238E27FC236}">
-                <a16:creationId xmlns:a16="http://schemas.microsoft.com/office/drawing/2014/main" id="{12B1C198-8674-45FA-9D44-D266314AC6FE}"/>
+                <a16:creationId xmlns:a16="http://schemas.microsoft.com/office/drawing/2014/main" id="{B0E0C4D3-64F4-4E89-A6FE-AA10A81DA23C}"/>
               </a:ext>
             </a:extLst>
           </p:cNvPr>
@@ -6801,7 +6801,7 @@
           <p:cNvPr id="34" name="footer-right">
             <a:extLst xmlns:a="http://schemas.openxmlformats.org/drawingml/2006/main">
               <a:ext uri="{FF2B5EF4-FFF2-40B4-BE49-F238E27FC236}">
-                <a16:creationId xmlns:a16="http://schemas.microsoft.com/office/drawing/2014/main" id="{4FF72E96-D364-4FF5-B206-AF2382455914}"/>
+                <a16:creationId xmlns:a16="http://schemas.microsoft.com/office/drawing/2014/main" id="{4423DFB9-4547-4A2F-8615-8410451E32BA}"/>
               </a:ext>
             </a:extLst>
           </p:cNvPr>
@@ -6844,7 +6844,7 @@
     </p:spTree>
     <p:extLst>
       <p:ext uri="{BB962C8B-B14F-4D97-AF65-F5344CB8AC3E}">
-        <p14:creationId xmlns:p14="http://schemas.microsoft.com/office/powerpoint/2010/main" val="1495746510"/>
+        <p14:creationId xmlns:p14="http://schemas.microsoft.com/office/powerpoint/2010/main" val="2056710744"/>
       </p:ext>
     </p:extLst>
   </p:cSld>
@@ -6868,7 +6868,7 @@
           <p:cNvPr id="1" name="slide-background">
             <a:extLst xmlns:a="http://schemas.openxmlformats.org/drawingml/2006/main">
               <a:ext uri="{FF2B5EF4-FFF2-40B4-BE49-F238E27FC236}">
-                <a16:creationId xmlns:a16="http://schemas.microsoft.com/office/drawing/2014/main" id="{74F1B6D4-AE91-4409-B43B-F32351FD7962}"/>
+                <a16:creationId xmlns:a16="http://schemas.microsoft.com/office/drawing/2014/main" id="{4881C885-AC53-41C5-9BFA-62BD77BBA824}"/>
               </a:ext>
             </a:extLst>
           </p:cNvPr>
@@ -6901,7 +6901,7 @@
           <p:cNvPr id="2" name="kicker">
             <a:extLst xmlns:a="http://schemas.openxmlformats.org/drawingml/2006/main">
               <a:ext uri="{FF2B5EF4-FFF2-40B4-BE49-F238E27FC236}">
-                <a16:creationId xmlns:a16="http://schemas.microsoft.com/office/drawing/2014/main" id="{AF41E46A-F5EA-47F7-A32D-C6294E59E24A}"/>
+                <a16:creationId xmlns:a16="http://schemas.microsoft.com/office/drawing/2014/main" id="{1BC2972D-0F80-4BD2-94F3-93EF35D9479F}"/>
               </a:ext>
             </a:extLst>
           </p:cNvPr>
@@ -6946,7 +6946,7 @@
           <p:cNvPr id="3" name="slide-title">
             <a:extLst xmlns:a="http://schemas.openxmlformats.org/drawingml/2006/main">
               <a:ext uri="{FF2B5EF4-FFF2-40B4-BE49-F238E27FC236}">
-                <a16:creationId xmlns:a16="http://schemas.microsoft.com/office/drawing/2014/main" id="{60345466-477D-4361-AD7F-45F4D65C3F8E}"/>
+                <a16:creationId xmlns:a16="http://schemas.microsoft.com/office/drawing/2014/main" id="{8CF7C4D1-B24B-4ED8-839B-7388C8473E5F}"/>
               </a:ext>
             </a:extLst>
           </p:cNvPr>
@@ -6991,7 +6991,7 @@
           <p:cNvPr id="4" name="slide-subtitle">
             <a:extLst xmlns:a="http://schemas.openxmlformats.org/drawingml/2006/main">
               <a:ext uri="{FF2B5EF4-FFF2-40B4-BE49-F238E27FC236}">
-                <a16:creationId xmlns:a16="http://schemas.microsoft.com/office/drawing/2014/main" id="{188C25B6-01AC-4C3D-B11D-AC8B606FE9ED}"/>
+                <a16:creationId xmlns:a16="http://schemas.microsoft.com/office/drawing/2014/main" id="{96B4D639-CCF9-496D-A4A5-93A68FF6959F}"/>
               </a:ext>
             </a:extLst>
           </p:cNvPr>
@@ -7036,7 +7036,7 @@
           <p:cNvPr id="5" name="closing-claim">
             <a:extLst xmlns:a="http://schemas.openxmlformats.org/drawingml/2006/main">
               <a:ext uri="{FF2B5EF4-FFF2-40B4-BE49-F238E27FC236}">
-                <a16:creationId xmlns:a16="http://schemas.microsoft.com/office/drawing/2014/main" id="{134D3A10-925B-4AF4-901B-3670664B0C09}"/>
+                <a16:creationId xmlns:a16="http://schemas.microsoft.com/office/drawing/2014/main" id="{107EA6DA-FEA9-4A99-9DBF-C2C2A5237421}"/>
               </a:ext>
             </a:extLst>
           </p:cNvPr>
@@ -7081,7 +7081,7 @@
           <p:cNvPr id="6" name="closing-copy">
             <a:extLst xmlns:a="http://schemas.openxmlformats.org/drawingml/2006/main">
               <a:ext uri="{FF2B5EF4-FFF2-40B4-BE49-F238E27FC236}">
-                <a16:creationId xmlns:a16="http://schemas.microsoft.com/office/drawing/2014/main" id="{C4017FB1-9672-49B4-BA23-991F97B51311}"/>
+                <a16:creationId xmlns:a16="http://schemas.microsoft.com/office/drawing/2014/main" id="{A65C9560-B312-4398-94C5-C47F2023D49D}"/>
               </a:ext>
             </a:extLst>
           </p:cNvPr>
@@ -7126,7 +7126,7 @@
           <p:cNvPr id="7" name="accent-rule">
             <a:extLst xmlns:a="http://schemas.openxmlformats.org/drawingml/2006/main">
               <a:ext uri="{FF2B5EF4-FFF2-40B4-BE49-F238E27FC236}">
-                <a16:creationId xmlns:a16="http://schemas.microsoft.com/office/drawing/2014/main" id="{6CDD1736-C8D7-487C-BCE8-19536582E248}"/>
+                <a16:creationId xmlns:a16="http://schemas.microsoft.com/office/drawing/2014/main" id="{E6758416-A006-442D-94E0-3F34C6A466A6}"/>
               </a:ext>
             </a:extLst>
           </p:cNvPr>
@@ -7159,7 +7159,7 @@
           <p:cNvPr id="8" name="statement-title-Controlled">
             <a:extLst xmlns:a="http://schemas.openxmlformats.org/drawingml/2006/main">
               <a:ext uri="{FF2B5EF4-FFF2-40B4-BE49-F238E27FC236}">
-                <a16:creationId xmlns:a16="http://schemas.microsoft.com/office/drawing/2014/main" id="{70A85C18-E7CD-4C5A-8803-FF069D10157C}"/>
+                <a16:creationId xmlns:a16="http://schemas.microsoft.com/office/drawing/2014/main" id="{522A0041-4088-45CB-A5E9-70696BF375F7}"/>
               </a:ext>
             </a:extLst>
           </p:cNvPr>
@@ -7204,7 +7204,7 @@
           <p:cNvPr id="9" name="statement-body-Controlled">
             <a:extLst xmlns:a="http://schemas.openxmlformats.org/drawingml/2006/main">
               <a:ext uri="{FF2B5EF4-FFF2-40B4-BE49-F238E27FC236}">
-                <a16:creationId xmlns:a16="http://schemas.microsoft.com/office/drawing/2014/main" id="{BA10A649-45DD-4DAD-8573-EA39CDE788B4}"/>
+                <a16:creationId xmlns:a16="http://schemas.microsoft.com/office/drawing/2014/main" id="{181DB139-7104-4326-AAA4-7174CC3E8E75}"/>
               </a:ext>
             </a:extLst>
           </p:cNvPr>
@@ -7249,7 +7249,7 @@
           <p:cNvPr id="10" name="accent-rule">
             <a:extLst xmlns:a="http://schemas.openxmlformats.org/drawingml/2006/main">
               <a:ext uri="{FF2B5EF4-FFF2-40B4-BE49-F238E27FC236}">
-                <a16:creationId xmlns:a16="http://schemas.microsoft.com/office/drawing/2014/main" id="{125F8D1C-4EC2-4A22-A0CE-25924C224FB5}"/>
+                <a16:creationId xmlns:a16="http://schemas.microsoft.com/office/drawing/2014/main" id="{AB1CD2EE-398A-4148-8B62-D868BB71C7E4}"/>
               </a:ext>
             </a:extLst>
           </p:cNvPr>
@@ -7282,7 +7282,7 @@
           <p:cNvPr id="11" name="statement-title-API-native">
             <a:extLst xmlns:a="http://schemas.openxmlformats.org/drawingml/2006/main">
               <a:ext uri="{FF2B5EF4-FFF2-40B4-BE49-F238E27FC236}">
-                <a16:creationId xmlns:a16="http://schemas.microsoft.com/office/drawing/2014/main" id="{5E4AD49B-3155-4668-BE2D-8FE3C9AD18AF}"/>
+                <a16:creationId xmlns:a16="http://schemas.microsoft.com/office/drawing/2014/main" id="{B6E99DCF-ECD0-4BF9-9C6B-1EEF3C0FBB38}"/>
               </a:ext>
             </a:extLst>
           </p:cNvPr>
@@ -7327,7 +7327,7 @@
           <p:cNvPr id="12" name="statement-body-API-native">
             <a:extLst xmlns:a="http://schemas.openxmlformats.org/drawingml/2006/main">
               <a:ext uri="{FF2B5EF4-FFF2-40B4-BE49-F238E27FC236}">
-                <a16:creationId xmlns:a16="http://schemas.microsoft.com/office/drawing/2014/main" id="{59B1DDE9-40FB-4A0F-A23C-C5C3D44C3105}"/>
+                <a16:creationId xmlns:a16="http://schemas.microsoft.com/office/drawing/2014/main" id="{1254832E-7455-4BBE-8E49-F7F5F0E089E0}"/>
               </a:ext>
             </a:extLst>
           </p:cNvPr>
@@ -7372,7 +7372,7 @@
           <p:cNvPr id="13" name="accent-rule">
             <a:extLst xmlns:a="http://schemas.openxmlformats.org/drawingml/2006/main">
               <a:ext uri="{FF2B5EF4-FFF2-40B4-BE49-F238E27FC236}">
-                <a16:creationId xmlns:a16="http://schemas.microsoft.com/office/drawing/2014/main" id="{8E7AC4FC-5DB2-48F3-93CB-51EDA26F632C}"/>
+                <a16:creationId xmlns:a16="http://schemas.microsoft.com/office/drawing/2014/main" id="{74CEA120-C601-4700-93C9-AF8A0537D34A}"/>
               </a:ext>
             </a:extLst>
           </p:cNvPr>
@@ -7405,7 +7405,7 @@
           <p:cNvPr id="14" name="statement-title-Auditable">
             <a:extLst xmlns:a="http://schemas.openxmlformats.org/drawingml/2006/main">
               <a:ext uri="{FF2B5EF4-FFF2-40B4-BE49-F238E27FC236}">
-                <a16:creationId xmlns:a16="http://schemas.microsoft.com/office/drawing/2014/main" id="{5E95284D-8FA6-4C5B-AE4D-7EAC62F8D3D5}"/>
+                <a16:creationId xmlns:a16="http://schemas.microsoft.com/office/drawing/2014/main" id="{F4ACAA4B-68C2-43BB-861A-1FEE057F1A5F}"/>
               </a:ext>
             </a:extLst>
           </p:cNvPr>
@@ -7450,7 +7450,7 @@
           <p:cNvPr id="15" name="statement-body-Auditable">
             <a:extLst xmlns:a="http://schemas.openxmlformats.org/drawingml/2006/main">
               <a:ext uri="{FF2B5EF4-FFF2-40B4-BE49-F238E27FC236}">
-                <a16:creationId xmlns:a16="http://schemas.microsoft.com/office/drawing/2014/main" id="{69810855-30B0-47B8-80F4-0E16F1F2EBD2}"/>
+                <a16:creationId xmlns:a16="http://schemas.microsoft.com/office/drawing/2014/main" id="{B526C733-24A0-4A66-A9A5-24F11292D5C6}"/>
               </a:ext>
             </a:extLst>
           </p:cNvPr>
@@ -7495,7 +7495,7 @@
           <p:cNvPr id="16" name="accent-rule">
             <a:extLst xmlns:a="http://schemas.openxmlformats.org/drawingml/2006/main">
               <a:ext uri="{FF2B5EF4-FFF2-40B4-BE49-F238E27FC236}">
-                <a16:creationId xmlns:a16="http://schemas.microsoft.com/office/drawing/2014/main" id="{D828F6A3-4C68-4406-A5CC-90DA7792F0D2}"/>
+                <a16:creationId xmlns:a16="http://schemas.microsoft.com/office/drawing/2014/main" id="{D34328C7-11A0-4095-B33D-602441FCD3C3}"/>
               </a:ext>
             </a:extLst>
           </p:cNvPr>
@@ -7528,7 +7528,7 @@
           <p:cNvPr id="17" name="statement-title-Reusable">
             <a:extLst xmlns:a="http://schemas.openxmlformats.org/drawingml/2006/main">
               <a:ext uri="{FF2B5EF4-FFF2-40B4-BE49-F238E27FC236}">
-                <a16:creationId xmlns:a16="http://schemas.microsoft.com/office/drawing/2014/main" id="{7ACDCD6B-8AA5-4AB0-88B0-DFA097756381}"/>
+                <a16:creationId xmlns:a16="http://schemas.microsoft.com/office/drawing/2014/main" id="{3364F69B-BBB1-450C-AC8A-9BE1A942C7A6}"/>
               </a:ext>
             </a:extLst>
           </p:cNvPr>
@@ -7573,7 +7573,7 @@
           <p:cNvPr id="18" name="statement-body-Reusable">
             <a:extLst xmlns:a="http://schemas.openxmlformats.org/drawingml/2006/main">
               <a:ext uri="{FF2B5EF4-FFF2-40B4-BE49-F238E27FC236}">
-                <a16:creationId xmlns:a16="http://schemas.microsoft.com/office/drawing/2014/main" id="{643970A9-8E38-48D3-A582-656070EC2917}"/>
+                <a16:creationId xmlns:a16="http://schemas.microsoft.com/office/drawing/2014/main" id="{830D543F-CE1F-406E-9BA4-572112DAA3A7}"/>
               </a:ext>
             </a:extLst>
           </p:cNvPr>
@@ -7618,7 +7618,7 @@
           <p:cNvPr id="19" name="closing-proof-field">
             <a:extLst xmlns:a="http://schemas.openxmlformats.org/drawingml/2006/main">
               <a:ext uri="{FF2B5EF4-FFF2-40B4-BE49-F238E27FC236}">
-                <a16:creationId xmlns:a16="http://schemas.microsoft.com/office/drawing/2014/main" id="{0928234C-40D3-4B65-A3E9-275A516B2930}"/>
+                <a16:creationId xmlns:a16="http://schemas.microsoft.com/office/drawing/2014/main" id="{A687CB2A-146C-4728-A0E8-1846C8F3ED60}"/>
               </a:ext>
             </a:extLst>
           </p:cNvPr>
@@ -7653,7 +7653,7 @@
           <p:cNvPr id="20" name="closing-proof-label">
             <a:extLst xmlns:a="http://schemas.openxmlformats.org/drawingml/2006/main">
               <a:ext uri="{FF2B5EF4-FFF2-40B4-BE49-F238E27FC236}">
-                <a16:creationId xmlns:a16="http://schemas.microsoft.com/office/drawing/2014/main" id="{E84AD640-5992-4553-8B34-B1342380E079}"/>
+                <a16:creationId xmlns:a16="http://schemas.microsoft.com/office/drawing/2014/main" id="{B31EC9B6-9FC0-43C1-A9B4-0EE15D5755AB}"/>
               </a:ext>
             </a:extLst>
           </p:cNvPr>
@@ -7698,7 +7698,7 @@
           <p:cNvPr id="21" name="closing-proof-headline">
             <a:extLst xmlns:a="http://schemas.openxmlformats.org/drawingml/2006/main">
               <a:ext uri="{FF2B5EF4-FFF2-40B4-BE49-F238E27FC236}">
-                <a16:creationId xmlns:a16="http://schemas.microsoft.com/office/drawing/2014/main" id="{162F2242-96CC-4495-B869-B1CD35F2C30A}"/>
+                <a16:creationId xmlns:a16="http://schemas.microsoft.com/office/drawing/2014/main" id="{4D5BD35D-E8B5-4F89-802F-2D71D6B98102}"/>
               </a:ext>
             </a:extLst>
           </p:cNvPr>
@@ -7743,7 +7743,7 @@
           <p:cNvPr id="22" name="">
             <a:extLst xmlns:a="http://schemas.openxmlformats.org/drawingml/2006/main">
               <a:ext uri="{FF2B5EF4-FFF2-40B4-BE49-F238E27FC236}">
-                <a16:creationId xmlns:a16="http://schemas.microsoft.com/office/drawing/2014/main" id="{A7D0BEFF-8905-47F9-B713-7119871CDB57}"/>
+                <a16:creationId xmlns:a16="http://schemas.microsoft.com/office/drawing/2014/main" id="{9DF342FA-86C3-4430-AF3F-F3D8D38FF553}"/>
               </a:ext>
             </a:extLst>
           </p:cNvPr>
@@ -7776,7 +7776,7 @@
           <p:cNvPr id="23" name="dark-metric-value-max proofs per batch">
             <a:extLst xmlns:a="http://schemas.openxmlformats.org/drawingml/2006/main">
               <a:ext uri="{FF2B5EF4-FFF2-40B4-BE49-F238E27FC236}">
-                <a16:creationId xmlns:a16="http://schemas.microsoft.com/office/drawing/2014/main" id="{24C6ED54-3C09-4749-AEB9-02FF92957C4A}"/>
+                <a16:creationId xmlns:a16="http://schemas.microsoft.com/office/drawing/2014/main" id="{4088E89A-6C08-4EDB-BE64-9568DC8F47E6}"/>
               </a:ext>
             </a:extLst>
           </p:cNvPr>
@@ -7821,7 +7821,7 @@
           <p:cNvPr id="24" name="dark-metric-label-max proofs per batch">
             <a:extLst xmlns:a="http://schemas.openxmlformats.org/drawingml/2006/main">
               <a:ext uri="{FF2B5EF4-FFF2-40B4-BE49-F238E27FC236}">
-                <a16:creationId xmlns:a16="http://schemas.microsoft.com/office/drawing/2014/main" id="{75C31158-9C33-403E-81EE-D17ACD1573CD}"/>
+                <a16:creationId xmlns:a16="http://schemas.microsoft.com/office/drawing/2014/main" id="{CF5AF4CD-306F-4C17-BCB0-60A5E320DF34}"/>
               </a:ext>
             </a:extLst>
           </p:cNvPr>
@@ -7866,7 +7866,7 @@
           <p:cNvPr id="25" name="">
             <a:extLst xmlns:a="http://schemas.openxmlformats.org/drawingml/2006/main">
               <a:ext uri="{FF2B5EF4-FFF2-40B4-BE49-F238E27FC236}">
-                <a16:creationId xmlns:a16="http://schemas.microsoft.com/office/drawing/2014/main" id="{99CEFBD3-60ED-4C6C-8581-25EDCBF8CA96}"/>
+                <a16:creationId xmlns:a16="http://schemas.microsoft.com/office/drawing/2014/main" id="{A71ADDCA-FF3B-4272-817A-1DA899D72311}"/>
               </a:ext>
             </a:extLst>
           </p:cNvPr>
@@ -7899,7 +7899,7 @@
           <p:cNvPr id="26" name="dark-metric-value-verified receipt tx">
             <a:extLst xmlns:a="http://schemas.openxmlformats.org/drawingml/2006/main">
               <a:ext uri="{FF2B5EF4-FFF2-40B4-BE49-F238E27FC236}">
-                <a16:creationId xmlns:a16="http://schemas.microsoft.com/office/drawing/2014/main" id="{ECAF3EC1-B37B-4E0E-B2A3-D02705F46DF9}"/>
+                <a16:creationId xmlns:a16="http://schemas.microsoft.com/office/drawing/2014/main" id="{11C511DB-C1E9-4FC1-A904-6837ADCECE1F}"/>
               </a:ext>
             </a:extLst>
           </p:cNvPr>
@@ -7944,7 +7944,7 @@
           <p:cNvPr id="27" name="dark-metric-label-verified receipt tx">
             <a:extLst xmlns:a="http://schemas.openxmlformats.org/drawingml/2006/main">
               <a:ext uri="{FF2B5EF4-FFF2-40B4-BE49-F238E27FC236}">
-                <a16:creationId xmlns:a16="http://schemas.microsoft.com/office/drawing/2014/main" id="{11A64B88-D80C-4EFE-BC59-60CFBFF90913}"/>
+                <a16:creationId xmlns:a16="http://schemas.microsoft.com/office/drawing/2014/main" id="{2B1A9817-2B1D-4981-952E-2C7DE5C748EE}"/>
               </a:ext>
             </a:extLst>
           </p:cNvPr>
@@ -7989,7 +7989,7 @@
           <p:cNvPr id="28" name="">
             <a:extLst xmlns:a="http://schemas.openxmlformats.org/drawingml/2006/main">
               <a:ext uri="{FF2B5EF4-FFF2-40B4-BE49-F238E27FC236}">
-                <a16:creationId xmlns:a16="http://schemas.microsoft.com/office/drawing/2014/main" id="{AFB74BD1-1E41-46CC-A323-422562F098D9}"/>
+                <a16:creationId xmlns:a16="http://schemas.microsoft.com/office/drawing/2014/main" id="{7D941821-CE9E-4B20-8565-7764CF0739D5}"/>
               </a:ext>
             </a:extLst>
           </p:cNvPr>
@@ -8022,7 +8022,7 @@
           <p:cNvPr id="29" name="dark-metric-value-per paid action">
             <a:extLst xmlns:a="http://schemas.openxmlformats.org/drawingml/2006/main">
               <a:ext uri="{FF2B5EF4-FFF2-40B4-BE49-F238E27FC236}">
-                <a16:creationId xmlns:a16="http://schemas.microsoft.com/office/drawing/2014/main" id="{C18E1CC1-B72A-4A04-B23C-89F389F4C851}"/>
+                <a16:creationId xmlns:a16="http://schemas.microsoft.com/office/drawing/2014/main" id="{8B89B210-52B6-49C6-81C1-B5BCE6ADA86E}"/>
               </a:ext>
             </a:extLst>
           </p:cNvPr>
@@ -8067,7 +8067,7 @@
           <p:cNvPr id="30" name="dark-metric-label-per paid action">
             <a:extLst xmlns:a="http://schemas.openxmlformats.org/drawingml/2006/main">
               <a:ext uri="{FF2B5EF4-FFF2-40B4-BE49-F238E27FC236}">
-                <a16:creationId xmlns:a16="http://schemas.microsoft.com/office/drawing/2014/main" id="{6B637C33-DD08-4A95-A15E-2E3199BC277B}"/>
+                <a16:creationId xmlns:a16="http://schemas.microsoft.com/office/drawing/2014/main" id="{5C788F79-142A-40F0-A1CD-D9B9EA6BD70C}"/>
               </a:ext>
             </a:extLst>
           </p:cNvPr>
@@ -8112,7 +8112,7 @@
           <p:cNvPr id="31" name="">
             <a:extLst xmlns:a="http://schemas.openxmlformats.org/drawingml/2006/main">
               <a:ext uri="{FF2B5EF4-FFF2-40B4-BE49-F238E27FC236}">
-                <a16:creationId xmlns:a16="http://schemas.microsoft.com/office/drawing/2014/main" id="{192AF2C9-BC12-426B-8B7E-23EA32630C2C}"/>
+                <a16:creationId xmlns:a16="http://schemas.microsoft.com/office/drawing/2014/main" id="{C0955175-DF0C-40AC-8FB8-D4FED32E7A1F}"/>
               </a:ext>
             </a:extLst>
           </p:cNvPr>
@@ -8145,7 +8145,7 @@
           <p:cNvPr id="32" name="dark-metric-value-batch authorization">
             <a:extLst xmlns:a="http://schemas.openxmlformats.org/drawingml/2006/main">
               <a:ext uri="{FF2B5EF4-FFF2-40B4-BE49-F238E27FC236}">
-                <a16:creationId xmlns:a16="http://schemas.microsoft.com/office/drawing/2014/main" id="{3450FF6E-0307-487A-9DC2-9C709CB850DD}"/>
+                <a16:creationId xmlns:a16="http://schemas.microsoft.com/office/drawing/2014/main" id="{2AC8BB83-06F5-4C31-8C95-78A9045041BE}"/>
               </a:ext>
             </a:extLst>
           </p:cNvPr>
@@ -8190,7 +8190,7 @@
           <p:cNvPr id="33" name="dark-metric-label-batch authorization">
             <a:extLst xmlns:a="http://schemas.openxmlformats.org/drawingml/2006/main">
               <a:ext uri="{FF2B5EF4-FFF2-40B4-BE49-F238E27FC236}">
-                <a16:creationId xmlns:a16="http://schemas.microsoft.com/office/drawing/2014/main" id="{36087837-402E-479A-A65B-F0858DFB7A2B}"/>
+                <a16:creationId xmlns:a16="http://schemas.microsoft.com/office/drawing/2014/main" id="{517AA2B8-8225-499B-83E0-FA805FC2D390}"/>
               </a:ext>
             </a:extLst>
           </p:cNvPr>
@@ -8235,7 +8235,7 @@
           <p:cNvPr id="34" name="closing-app-url">
             <a:extLst xmlns:a="http://schemas.openxmlformats.org/drawingml/2006/main">
               <a:ext uri="{FF2B5EF4-FFF2-40B4-BE49-F238E27FC236}">
-                <a16:creationId xmlns:a16="http://schemas.microsoft.com/office/drawing/2014/main" id="{1C792924-8B12-4D6D-B6A5-75239024CA1C}"/>
+                <a16:creationId xmlns:a16="http://schemas.microsoft.com/office/drawing/2014/main" id="{561FE241-5514-4188-A769-E62462B040D8}"/>
               </a:ext>
             </a:extLst>
           </p:cNvPr>
@@ -8280,7 +8280,7 @@
           <p:cNvPr id="35" name="closing-proof-links">
             <a:extLst xmlns:a="http://schemas.openxmlformats.org/drawingml/2006/main">
               <a:ext uri="{FF2B5EF4-FFF2-40B4-BE49-F238E27FC236}">
-                <a16:creationId xmlns:a16="http://schemas.microsoft.com/office/drawing/2014/main" id="{889BB70D-BBC5-4B6F-AD74-486A903B0996}"/>
+                <a16:creationId xmlns:a16="http://schemas.microsoft.com/office/drawing/2014/main" id="{B6FCB0BF-6D4B-438B-9A5C-87728C71B714}"/>
               </a:ext>
             </a:extLst>
           </p:cNvPr>
@@ -8325,7 +8325,7 @@
           <p:cNvPr id="36" name="footer-left">
             <a:extLst xmlns:a="http://schemas.openxmlformats.org/drawingml/2006/main">
               <a:ext uri="{FF2B5EF4-FFF2-40B4-BE49-F238E27FC236}">
-                <a16:creationId xmlns:a16="http://schemas.microsoft.com/office/drawing/2014/main" id="{747FD5CA-32D6-4731-A1EC-21526E76CDDC}"/>
+                <a16:creationId xmlns:a16="http://schemas.microsoft.com/office/drawing/2014/main" id="{EF6C3923-CB2F-4AD5-B47C-FB0535D9E599}"/>
               </a:ext>
             </a:extLst>
           </p:cNvPr>
@@ -8370,7 +8370,7 @@
           <p:cNvPr id="37" name="footer-right">
             <a:extLst xmlns:a="http://schemas.openxmlformats.org/drawingml/2006/main">
               <a:ext uri="{FF2B5EF4-FFF2-40B4-BE49-F238E27FC236}">
-                <a16:creationId xmlns:a16="http://schemas.microsoft.com/office/drawing/2014/main" id="{5AF6AA73-A077-41DA-837F-620BC872BC49}"/>
+                <a16:creationId xmlns:a16="http://schemas.microsoft.com/office/drawing/2014/main" id="{0573EB3F-C4C0-425B-B7EA-9AC13AB30878}"/>
               </a:ext>
             </a:extLst>
           </p:cNvPr>
@@ -8413,7 +8413,7 @@
     </p:spTree>
     <p:extLst>
       <p:ext uri="{BB962C8B-B14F-4D97-AF65-F5344CB8AC3E}">
-        <p14:creationId xmlns:p14="http://schemas.microsoft.com/office/powerpoint/2010/main" val="1895527598"/>
+        <p14:creationId xmlns:p14="http://schemas.microsoft.com/office/powerpoint/2010/main" val="608189998"/>
       </p:ext>
     </p:extLst>
   </p:cSld>

</xml_diff>